<commit_message>
fix(portal): hoc sinh hien ngay theo mui gio VN, dong nhat voi cong phu huynh
Trang portal hoc sinh dung iso.slice(0,10) nen thong bao tao buoi toi gio VN
hien thi lech 1 ngay so voi cong phu huynh (fmtDateVN). Doi sang fmtDateVN.

Generated with [Devin](https://devin.ai)

Co-Authored-By: Devin <158243242+devin-ai-integration[bot]@users.noreply.github.com>
</commit_message>
<xml_diff>
--- a/docs/user-guide/SO-CHU-NHIEM-SO-GIOI-THIEU.pptx
+++ b/docs/user-guide/SO-CHU-NHIEM-SO-GIOI-THIEU.pptx
@@ -5,21 +5,21 @@
     <p:sldMasterId id="2147483648" r:id="rId1"/>
   </p:sldMasterIdLst>
   <p:sldIdLst>
-    <p:sldId id="256" r:id="rId7"/>
-    <p:sldId id="257" r:id="rId8"/>
-    <p:sldId id="258" r:id="rId9"/>
-    <p:sldId id="259" r:id="rId10"/>
-    <p:sldId id="260" r:id="rId11"/>
-    <p:sldId id="261" r:id="rId12"/>
-    <p:sldId id="262" r:id="rId13"/>
-    <p:sldId id="263" r:id="rId14"/>
-    <p:sldId id="264" r:id="rId15"/>
-    <p:sldId id="265" r:id="rId16"/>
-    <p:sldId id="266" r:id="rId17"/>
-    <p:sldId id="267" r:id="rId18"/>
-    <p:sldId id="268" r:id="rId19"/>
+    <p:sldId id="256" r:id="rId2"/>
+    <p:sldId id="257" r:id="rId3"/>
+    <p:sldId id="258" r:id="rId4"/>
+    <p:sldId id="259" r:id="rId5"/>
+    <p:sldId id="260" r:id="rId6"/>
+    <p:sldId id="261" r:id="rId7"/>
+    <p:sldId id="262" r:id="rId8"/>
+    <p:sldId id="263" r:id="rId9"/>
+    <p:sldId id="264" r:id="rId10"/>
+    <p:sldId id="265" r:id="rId11"/>
+    <p:sldId id="266" r:id="rId12"/>
+    <p:sldId id="267" r:id="rId13"/>
+    <p:sldId id="268" r:id="rId14"/>
   </p:sldIdLst>
-  <p:sldSz cx="12191695" cy="6858000" type="screen4x3"/>
+  <p:sldSz cx="12192000" cy="6858000"/>
   <p:notesSz cx="6858000" cy="9144000"/>
   <p:defaultTextStyle>
     <a:defPPr>
@@ -116,6 +116,22 @@
       </a:defRPr>
     </a:lvl9pPr>
   </p:defaultTextStyle>
+  <p:extLst>
+    <p:ext uri="{EFAFB233-063F-42B5-8137-9DF3F51BA10A}">
+      <p15:sldGuideLst xmlns:p15="http://schemas.microsoft.com/office/powerpoint/2012/main">
+        <p15:guide id="1" orient="horz" pos="2160">
+          <p15:clr>
+            <a:srgbClr val="A4A3A4"/>
+          </p15:clr>
+        </p15:guide>
+        <p15:guide id="2" pos="2880">
+          <p15:clr>
+            <a:srgbClr val="A4A3A4"/>
+          </p15:clr>
+        </p15:guide>
+      </p15:sldGuideLst>
+    </p:ext>
+  </p:extLst>
 </p:presentation>
 </file>
 
@@ -157,10 +173,9 @@
           <a:lstStyle/>
           <a:p>
             <a:r>
-              <a:rPr lang="en-US" smtClean="0"/>
+              <a:rPr lang="en-US"/>
               <a:t>Click to edit Master title style</a:t>
             </a:r>
-            <a:endParaRPr lang="en-US"/>
           </a:p>
         </p:txBody>
       </p:sp>
@@ -276,10 +291,9 @@
           </a:lstStyle>
           <a:p>
             <a:r>
-              <a:rPr lang="en-US" smtClean="0"/>
+              <a:rPr lang="en-US"/>
               <a:t>Click to edit Master subtitle style</a:t>
             </a:r>
-            <a:endParaRPr lang="en-US"/>
           </a:p>
         </p:txBody>
       </p:sp>
@@ -300,7 +314,7 @@
           <a:p>
             <a:fld id="{5BCAD085-E8A6-8845-BD4E-CB4CCA059FC4}" type="datetimeFigureOut">
               <a:rPr lang="en-US" smtClean="0"/>
-              <a:t>1/27/13</a:t>
+              <a:t>9/21/26</a:t>
             </a:fld>
             <a:endParaRPr lang="en-US"/>
           </a:p>
@@ -394,10 +408,9 @@
           <a:lstStyle/>
           <a:p>
             <a:r>
-              <a:rPr lang="en-US" smtClean="0"/>
+              <a:rPr lang="en-US"/>
               <a:t>Click to edit Master title style</a:t>
             </a:r>
-            <a:endParaRPr lang="en-US"/>
           </a:p>
         </p:txBody>
       </p:sp>
@@ -418,38 +431,37 @@
           <a:p>
             <a:pPr lvl="0"/>
             <a:r>
-              <a:rPr lang="en-US" smtClean="0"/>
+              <a:rPr lang="en-US"/>
               <a:t>Click to edit Master text styles</a:t>
             </a:r>
           </a:p>
           <a:p>
             <a:pPr lvl="1"/>
             <a:r>
-              <a:rPr lang="en-US" smtClean="0"/>
+              <a:rPr lang="en-US"/>
               <a:t>Second level</a:t>
             </a:r>
           </a:p>
           <a:p>
             <a:pPr lvl="2"/>
             <a:r>
-              <a:rPr lang="en-US" smtClean="0"/>
+              <a:rPr lang="en-US"/>
               <a:t>Third level</a:t>
             </a:r>
           </a:p>
           <a:p>
             <a:pPr lvl="3"/>
             <a:r>
-              <a:rPr lang="en-US" smtClean="0"/>
+              <a:rPr lang="en-US"/>
               <a:t>Fourth level</a:t>
             </a:r>
           </a:p>
           <a:p>
             <a:pPr lvl="4"/>
             <a:r>
-              <a:rPr lang="en-US" smtClean="0"/>
+              <a:rPr lang="en-US"/>
               <a:t>Fifth level</a:t>
             </a:r>
-            <a:endParaRPr lang="en-US"/>
           </a:p>
         </p:txBody>
       </p:sp>
@@ -470,7 +482,7 @@
           <a:p>
             <a:fld id="{5BCAD085-E8A6-8845-BD4E-CB4CCA059FC4}" type="datetimeFigureOut">
               <a:rPr lang="en-US" smtClean="0"/>
-              <a:t>1/27/13</a:t>
+              <a:t>9/21/26</a:t>
             </a:fld>
             <a:endParaRPr lang="en-US"/>
           </a:p>
@@ -569,10 +581,9 @@
           <a:lstStyle/>
           <a:p>
             <a:r>
-              <a:rPr lang="en-US" smtClean="0"/>
+              <a:rPr lang="en-US"/>
               <a:t>Click to edit Master title style</a:t>
             </a:r>
-            <a:endParaRPr lang="en-US"/>
           </a:p>
         </p:txBody>
       </p:sp>
@@ -598,38 +609,37 @@
           <a:p>
             <a:pPr lvl="0"/>
             <a:r>
-              <a:rPr lang="en-US" smtClean="0"/>
+              <a:rPr lang="en-US"/>
               <a:t>Click to edit Master text styles</a:t>
             </a:r>
           </a:p>
           <a:p>
             <a:pPr lvl="1"/>
             <a:r>
-              <a:rPr lang="en-US" smtClean="0"/>
+              <a:rPr lang="en-US"/>
               <a:t>Second level</a:t>
             </a:r>
           </a:p>
           <a:p>
             <a:pPr lvl="2"/>
             <a:r>
-              <a:rPr lang="en-US" smtClean="0"/>
+              <a:rPr lang="en-US"/>
               <a:t>Third level</a:t>
             </a:r>
           </a:p>
           <a:p>
             <a:pPr lvl="3"/>
             <a:r>
-              <a:rPr lang="en-US" smtClean="0"/>
+              <a:rPr lang="en-US"/>
               <a:t>Fourth level</a:t>
             </a:r>
           </a:p>
           <a:p>
             <a:pPr lvl="4"/>
             <a:r>
-              <a:rPr lang="en-US" smtClean="0"/>
+              <a:rPr lang="en-US"/>
               <a:t>Fifth level</a:t>
             </a:r>
-            <a:endParaRPr lang="en-US"/>
           </a:p>
         </p:txBody>
       </p:sp>
@@ -650,7 +660,7 @@
           <a:p>
             <a:fld id="{5BCAD085-E8A6-8845-BD4E-CB4CCA059FC4}" type="datetimeFigureOut">
               <a:rPr lang="en-US" smtClean="0"/>
-              <a:t>1/27/13</a:t>
+              <a:t>9/21/26</a:t>
             </a:fld>
             <a:endParaRPr lang="en-US"/>
           </a:p>
@@ -744,10 +754,9 @@
           <a:lstStyle/>
           <a:p>
             <a:r>
-              <a:rPr lang="en-US" smtClean="0"/>
+              <a:rPr lang="en-US"/>
               <a:t>Click to edit Master title style</a:t>
             </a:r>
-            <a:endParaRPr lang="en-US"/>
           </a:p>
         </p:txBody>
       </p:sp>
@@ -768,38 +777,37 @@
           <a:p>
             <a:pPr lvl="0"/>
             <a:r>
-              <a:rPr lang="en-US" smtClean="0"/>
+              <a:rPr lang="en-US"/>
               <a:t>Click to edit Master text styles</a:t>
             </a:r>
           </a:p>
           <a:p>
             <a:pPr lvl="1"/>
             <a:r>
-              <a:rPr lang="en-US" smtClean="0"/>
+              <a:rPr lang="en-US"/>
               <a:t>Second level</a:t>
             </a:r>
           </a:p>
           <a:p>
             <a:pPr lvl="2"/>
             <a:r>
-              <a:rPr lang="en-US" smtClean="0"/>
+              <a:rPr lang="en-US"/>
               <a:t>Third level</a:t>
             </a:r>
           </a:p>
           <a:p>
             <a:pPr lvl="3"/>
             <a:r>
-              <a:rPr lang="en-US" smtClean="0"/>
+              <a:rPr lang="en-US"/>
               <a:t>Fourth level</a:t>
             </a:r>
           </a:p>
           <a:p>
             <a:pPr lvl="4"/>
             <a:r>
-              <a:rPr lang="en-US" smtClean="0"/>
+              <a:rPr lang="en-US"/>
               <a:t>Fifth level</a:t>
             </a:r>
-            <a:endParaRPr lang="en-US"/>
           </a:p>
         </p:txBody>
       </p:sp>
@@ -820,7 +828,7 @@
           <a:p>
             <a:fld id="{5BCAD085-E8A6-8845-BD4E-CB4CCA059FC4}" type="datetimeFigureOut">
               <a:rPr lang="en-US" smtClean="0"/>
-              <a:t>1/27/13</a:t>
+              <a:t>9/21/26</a:t>
             </a:fld>
             <a:endParaRPr lang="en-US"/>
           </a:p>
@@ -923,10 +931,9 @@
           </a:lstStyle>
           <a:p>
             <a:r>
-              <a:rPr lang="en-US" smtClean="0"/>
+              <a:rPr lang="en-US"/>
               <a:t>Click to edit Master title style</a:t>
             </a:r>
-            <a:endParaRPr lang="en-US"/>
           </a:p>
         </p:txBody>
       </p:sp>
@@ -1043,7 +1050,7 @@
           <a:p>
             <a:pPr lvl="0"/>
             <a:r>
-              <a:rPr lang="en-US" smtClean="0"/>
+              <a:rPr lang="en-US"/>
               <a:t>Click to edit Master text styles</a:t>
             </a:r>
           </a:p>
@@ -1066,7 +1073,7 @@
           <a:p>
             <a:fld id="{5BCAD085-E8A6-8845-BD4E-CB4CCA059FC4}" type="datetimeFigureOut">
               <a:rPr lang="en-US" smtClean="0"/>
-              <a:t>1/27/13</a:t>
+              <a:t>9/21/26</a:t>
             </a:fld>
             <a:endParaRPr lang="en-US"/>
           </a:p>
@@ -1160,10 +1167,9 @@
           <a:lstStyle/>
           <a:p>
             <a:r>
-              <a:rPr lang="en-US" smtClean="0"/>
+              <a:rPr lang="en-US"/>
               <a:t>Click to edit Master title style</a:t>
             </a:r>
-            <a:endParaRPr lang="en-US"/>
           </a:p>
         </p:txBody>
       </p:sp>
@@ -1217,38 +1223,37 @@
           <a:p>
             <a:pPr lvl="0"/>
             <a:r>
-              <a:rPr lang="en-US" smtClean="0"/>
+              <a:rPr lang="en-US"/>
               <a:t>Click to edit Master text styles</a:t>
             </a:r>
           </a:p>
           <a:p>
             <a:pPr lvl="1"/>
             <a:r>
-              <a:rPr lang="en-US" smtClean="0"/>
+              <a:rPr lang="en-US"/>
               <a:t>Second level</a:t>
             </a:r>
           </a:p>
           <a:p>
             <a:pPr lvl="2"/>
             <a:r>
-              <a:rPr lang="en-US" smtClean="0"/>
+              <a:rPr lang="en-US"/>
               <a:t>Third level</a:t>
             </a:r>
           </a:p>
           <a:p>
             <a:pPr lvl="3"/>
             <a:r>
-              <a:rPr lang="en-US" smtClean="0"/>
+              <a:rPr lang="en-US"/>
               <a:t>Fourth level</a:t>
             </a:r>
           </a:p>
           <a:p>
             <a:pPr lvl="4"/>
             <a:r>
-              <a:rPr lang="en-US" smtClean="0"/>
+              <a:rPr lang="en-US"/>
               <a:t>Fifth level</a:t>
             </a:r>
-            <a:endParaRPr lang="en-US"/>
           </a:p>
         </p:txBody>
       </p:sp>
@@ -1302,38 +1307,37 @@
           <a:p>
             <a:pPr lvl="0"/>
             <a:r>
-              <a:rPr lang="en-US" smtClean="0"/>
+              <a:rPr lang="en-US"/>
               <a:t>Click to edit Master text styles</a:t>
             </a:r>
           </a:p>
           <a:p>
             <a:pPr lvl="1"/>
             <a:r>
-              <a:rPr lang="en-US" smtClean="0"/>
+              <a:rPr lang="en-US"/>
               <a:t>Second level</a:t>
             </a:r>
           </a:p>
           <a:p>
             <a:pPr lvl="2"/>
             <a:r>
-              <a:rPr lang="en-US" smtClean="0"/>
+              <a:rPr lang="en-US"/>
               <a:t>Third level</a:t>
             </a:r>
           </a:p>
           <a:p>
             <a:pPr lvl="3"/>
             <a:r>
-              <a:rPr lang="en-US" smtClean="0"/>
+              <a:rPr lang="en-US"/>
               <a:t>Fourth level</a:t>
             </a:r>
           </a:p>
           <a:p>
             <a:pPr lvl="4"/>
             <a:r>
-              <a:rPr lang="en-US" smtClean="0"/>
+              <a:rPr lang="en-US"/>
               <a:t>Fifth level</a:t>
             </a:r>
-            <a:endParaRPr lang="en-US"/>
           </a:p>
         </p:txBody>
       </p:sp>
@@ -1354,7 +1358,7 @@
           <a:p>
             <a:fld id="{5BCAD085-E8A6-8845-BD4E-CB4CCA059FC4}" type="datetimeFigureOut">
               <a:rPr lang="en-US" smtClean="0"/>
-              <a:t>1/27/13</a:t>
+              <a:t>9/21/26</a:t>
             </a:fld>
             <a:endParaRPr lang="en-US"/>
           </a:p>
@@ -1452,10 +1456,9 @@
           </a:lstStyle>
           <a:p>
             <a:r>
-              <a:rPr lang="en-US" smtClean="0"/>
+              <a:rPr lang="en-US"/>
               <a:t>Click to edit Master title style</a:t>
             </a:r>
-            <a:endParaRPr lang="en-US"/>
           </a:p>
         </p:txBody>
       </p:sp>
@@ -1518,7 +1521,7 @@
           <a:p>
             <a:pPr lvl="0"/>
             <a:r>
-              <a:rPr lang="en-US" smtClean="0"/>
+              <a:rPr lang="en-US"/>
               <a:t>Click to edit Master text styles</a:t>
             </a:r>
           </a:p>
@@ -1574,38 +1577,37 @@
           <a:p>
             <a:pPr lvl="0"/>
             <a:r>
-              <a:rPr lang="en-US" smtClean="0"/>
+              <a:rPr lang="en-US"/>
               <a:t>Click to edit Master text styles</a:t>
             </a:r>
           </a:p>
           <a:p>
             <a:pPr lvl="1"/>
             <a:r>
-              <a:rPr lang="en-US" smtClean="0"/>
+              <a:rPr lang="en-US"/>
               <a:t>Second level</a:t>
             </a:r>
           </a:p>
           <a:p>
             <a:pPr lvl="2"/>
             <a:r>
-              <a:rPr lang="en-US" smtClean="0"/>
+              <a:rPr lang="en-US"/>
               <a:t>Third level</a:t>
             </a:r>
           </a:p>
           <a:p>
             <a:pPr lvl="3"/>
             <a:r>
-              <a:rPr lang="en-US" smtClean="0"/>
+              <a:rPr lang="en-US"/>
               <a:t>Fourth level</a:t>
             </a:r>
           </a:p>
           <a:p>
             <a:pPr lvl="4"/>
             <a:r>
-              <a:rPr lang="en-US" smtClean="0"/>
+              <a:rPr lang="en-US"/>
               <a:t>Fifth level</a:t>
             </a:r>
-            <a:endParaRPr lang="en-US"/>
           </a:p>
         </p:txBody>
       </p:sp>
@@ -1668,7 +1670,7 @@
           <a:p>
             <a:pPr lvl="0"/>
             <a:r>
-              <a:rPr lang="en-US" smtClean="0"/>
+              <a:rPr lang="en-US"/>
               <a:t>Click to edit Master text styles</a:t>
             </a:r>
           </a:p>
@@ -1724,38 +1726,37 @@
           <a:p>
             <a:pPr lvl="0"/>
             <a:r>
-              <a:rPr lang="en-US" smtClean="0"/>
+              <a:rPr lang="en-US"/>
               <a:t>Click to edit Master text styles</a:t>
             </a:r>
           </a:p>
           <a:p>
             <a:pPr lvl="1"/>
             <a:r>
-              <a:rPr lang="en-US" smtClean="0"/>
+              <a:rPr lang="en-US"/>
               <a:t>Second level</a:t>
             </a:r>
           </a:p>
           <a:p>
             <a:pPr lvl="2"/>
             <a:r>
-              <a:rPr lang="en-US" smtClean="0"/>
+              <a:rPr lang="en-US"/>
               <a:t>Third level</a:t>
             </a:r>
           </a:p>
           <a:p>
             <a:pPr lvl="3"/>
             <a:r>
-              <a:rPr lang="en-US" smtClean="0"/>
+              <a:rPr lang="en-US"/>
               <a:t>Fourth level</a:t>
             </a:r>
           </a:p>
           <a:p>
             <a:pPr lvl="4"/>
             <a:r>
-              <a:rPr lang="en-US" smtClean="0"/>
+              <a:rPr lang="en-US"/>
               <a:t>Fifth level</a:t>
             </a:r>
-            <a:endParaRPr lang="en-US"/>
           </a:p>
         </p:txBody>
       </p:sp>
@@ -1776,7 +1777,7 @@
           <a:p>
             <a:fld id="{5BCAD085-E8A6-8845-BD4E-CB4CCA059FC4}" type="datetimeFigureOut">
               <a:rPr lang="en-US" smtClean="0"/>
-              <a:t>1/27/13</a:t>
+              <a:t>9/21/26</a:t>
             </a:fld>
             <a:endParaRPr lang="en-US"/>
           </a:p>
@@ -1870,10 +1871,9 @@
           <a:lstStyle/>
           <a:p>
             <a:r>
-              <a:rPr lang="en-US" smtClean="0"/>
+              <a:rPr lang="en-US"/>
               <a:t>Click to edit Master title style</a:t>
             </a:r>
-            <a:endParaRPr lang="en-US"/>
           </a:p>
         </p:txBody>
       </p:sp>
@@ -1894,7 +1894,7 @@
           <a:p>
             <a:fld id="{5BCAD085-E8A6-8845-BD4E-CB4CCA059FC4}" type="datetimeFigureOut">
               <a:rPr lang="en-US" smtClean="0"/>
-              <a:t>1/27/13</a:t>
+              <a:t>9/21/26</a:t>
             </a:fld>
             <a:endParaRPr lang="en-US"/>
           </a:p>
@@ -1989,7 +1989,7 @@
           <a:p>
             <a:fld id="{5BCAD085-E8A6-8845-BD4E-CB4CCA059FC4}" type="datetimeFigureOut">
               <a:rPr lang="en-US" smtClean="0"/>
-              <a:t>1/27/13</a:t>
+              <a:t>9/21/26</a:t>
             </a:fld>
             <a:endParaRPr lang="en-US"/>
           </a:p>
@@ -2092,10 +2092,9 @@
           </a:lstStyle>
           <a:p>
             <a:r>
-              <a:rPr lang="en-US" smtClean="0"/>
+              <a:rPr lang="en-US"/>
               <a:t>Click to edit Master title style</a:t>
             </a:r>
-            <a:endParaRPr lang="en-US"/>
           </a:p>
         </p:txBody>
       </p:sp>
@@ -2149,38 +2148,37 @@
           <a:p>
             <a:pPr lvl="0"/>
             <a:r>
-              <a:rPr lang="en-US" smtClean="0"/>
+              <a:rPr lang="en-US"/>
               <a:t>Click to edit Master text styles</a:t>
             </a:r>
           </a:p>
           <a:p>
             <a:pPr lvl="1"/>
             <a:r>
-              <a:rPr lang="en-US" smtClean="0"/>
+              <a:rPr lang="en-US"/>
               <a:t>Second level</a:t>
             </a:r>
           </a:p>
           <a:p>
             <a:pPr lvl="2"/>
             <a:r>
-              <a:rPr lang="en-US" smtClean="0"/>
+              <a:rPr lang="en-US"/>
               <a:t>Third level</a:t>
             </a:r>
           </a:p>
           <a:p>
             <a:pPr lvl="3"/>
             <a:r>
-              <a:rPr lang="en-US" smtClean="0"/>
+              <a:rPr lang="en-US"/>
               <a:t>Fourth level</a:t>
             </a:r>
           </a:p>
           <a:p>
             <a:pPr lvl="4"/>
             <a:r>
-              <a:rPr lang="en-US" smtClean="0"/>
+              <a:rPr lang="en-US"/>
               <a:t>Fifth level</a:t>
             </a:r>
-            <a:endParaRPr lang="en-US"/>
           </a:p>
         </p:txBody>
       </p:sp>
@@ -2243,7 +2241,7 @@
           <a:p>
             <a:pPr lvl="0"/>
             <a:r>
-              <a:rPr lang="en-US" smtClean="0"/>
+              <a:rPr lang="en-US"/>
               <a:t>Click to edit Master text styles</a:t>
             </a:r>
           </a:p>
@@ -2266,7 +2264,7 @@
           <a:p>
             <a:fld id="{5BCAD085-E8A6-8845-BD4E-CB4CCA059FC4}" type="datetimeFigureOut">
               <a:rPr lang="en-US" smtClean="0"/>
-              <a:t>1/27/13</a:t>
+              <a:t>9/21/26</a:t>
             </a:fld>
             <a:endParaRPr lang="en-US"/>
           </a:p>
@@ -2369,10 +2367,9 @@
           </a:lstStyle>
           <a:p>
             <a:r>
-              <a:rPr lang="en-US" smtClean="0"/>
+              <a:rPr lang="en-US"/>
               <a:t>Click to edit Master title style</a:t>
             </a:r>
-            <a:endParaRPr lang="en-US"/>
           </a:p>
         </p:txBody>
       </p:sp>
@@ -2496,7 +2493,7 @@
           <a:p>
             <a:pPr lvl="0"/>
             <a:r>
-              <a:rPr lang="en-US" smtClean="0"/>
+              <a:rPr lang="en-US"/>
               <a:t>Click to edit Master text styles</a:t>
             </a:r>
           </a:p>
@@ -2519,7 +2516,7 @@
           <a:p>
             <a:fld id="{5BCAD085-E8A6-8845-BD4E-CB4CCA059FC4}" type="datetimeFigureOut">
               <a:rPr lang="en-US" smtClean="0"/>
-              <a:t>1/27/13</a:t>
+              <a:t>9/21/26</a:t>
             </a:fld>
             <a:endParaRPr lang="en-US"/>
           </a:p>
@@ -2628,10 +2625,9 @@
           <a:lstStyle/>
           <a:p>
             <a:r>
-              <a:rPr lang="en-US" smtClean="0"/>
+              <a:rPr lang="en-US"/>
               <a:t>Click to edit Master title style</a:t>
             </a:r>
-            <a:endParaRPr lang="en-US"/>
           </a:p>
         </p:txBody>
       </p:sp>
@@ -2662,38 +2658,37 @@
           <a:p>
             <a:pPr lvl="0"/>
             <a:r>
-              <a:rPr lang="en-US" smtClean="0"/>
+              <a:rPr lang="en-US"/>
               <a:t>Click to edit Master text styles</a:t>
             </a:r>
           </a:p>
           <a:p>
             <a:pPr lvl="1"/>
             <a:r>
-              <a:rPr lang="en-US" smtClean="0"/>
+              <a:rPr lang="en-US"/>
               <a:t>Second level</a:t>
             </a:r>
           </a:p>
           <a:p>
             <a:pPr lvl="2"/>
             <a:r>
-              <a:rPr lang="en-US" smtClean="0"/>
+              <a:rPr lang="en-US"/>
               <a:t>Third level</a:t>
             </a:r>
           </a:p>
           <a:p>
             <a:pPr lvl="3"/>
             <a:r>
-              <a:rPr lang="en-US" smtClean="0"/>
+              <a:rPr lang="en-US"/>
               <a:t>Fourth level</a:t>
             </a:r>
           </a:p>
           <a:p>
             <a:pPr lvl="4"/>
             <a:r>
-              <a:rPr lang="en-US" smtClean="0"/>
+              <a:rPr lang="en-US"/>
               <a:t>Fifth level</a:t>
             </a:r>
-            <a:endParaRPr lang="en-US"/>
           </a:p>
         </p:txBody>
       </p:sp>
@@ -2732,7 +2727,7 @@
           <a:p>
             <a:fld id="{5BCAD085-E8A6-8845-BD4E-CB4CCA059FC4}" type="datetimeFigureOut">
               <a:rPr lang="en-US" smtClean="0"/>
-              <a:t>1/27/13</a:t>
+              <a:t>9/21/26</a:t>
             </a:fld>
             <a:endParaRPr lang="en-US"/>
           </a:p>
@@ -3091,7 +3086,7 @@
 </file>
 
 <file path=ppt/slides/slide1.xml><?xml version="1.0" encoding="utf-8"?>
-<p:sld xmlns:a="http://schemas.openxmlformats.org/drawingml/2006/main" xmlns:p="http://schemas.openxmlformats.org/presentationml/2006/main" xmlns:r="http://schemas.openxmlformats.org/officeDocument/2006/relationships">
+<p:sld xmlns:a="http://schemas.openxmlformats.org/drawingml/2006/main" xmlns:r="http://schemas.openxmlformats.org/officeDocument/2006/relationships" xmlns:p="http://schemas.openxmlformats.org/presentationml/2006/main">
   <p:cSld>
     <p:spTree>
       <p:nvGrpSpPr>
@@ -3099,7 +3094,14 @@
         <p:cNvGrpSpPr/>
         <p:nvPr/>
       </p:nvGrpSpPr>
-      <p:grpSpPr/>
+      <p:grpSpPr>
+        <a:xfrm>
+          <a:off x="0" y="0"/>
+          <a:ext cx="0" cy="0"/>
+          <a:chOff x="0" y="0"/>
+          <a:chExt cx="0" cy="0"/>
+        </a:xfrm>
+      </p:grpSpPr>
       <p:sp>
         <p:nvSpPr>
           <p:cNvPr id="2" name="Rectangle 1"/>
@@ -3140,6 +3142,7 @@
           <a:lstStyle/>
           <a:p>
             <a:pPr algn="ctr"/>
+            <a:endParaRPr/>
           </a:p>
         </p:txBody>
       </p:sp>
@@ -3165,7 +3168,6 @@
           </a:bodyPr>
           <a:lstStyle/>
           <a:p>
-            <a:pPr/>
             <a:r>
               <a:rPr sz="4400" b="1">
                 <a:solidFill>
@@ -3176,7 +3178,6 @@
             </a:r>
           </a:p>
           <a:p>
-            <a:pPr/>
             <a:r>
               <a:rPr sz="2000" b="0">
                 <a:solidFill>
@@ -3210,7 +3211,6 @@
           </a:bodyPr>
           <a:lstStyle/>
           <a:p>
-            <a:pPr/>
             <a:r>
               <a:rPr sz="1400" b="0">
                 <a:solidFill>
@@ -3231,7 +3231,7 @@
 </file>
 
 <file path=ppt/slides/slide10.xml><?xml version="1.0" encoding="utf-8"?>
-<p:sld xmlns:a="http://schemas.openxmlformats.org/drawingml/2006/main" xmlns:p="http://schemas.openxmlformats.org/presentationml/2006/main" xmlns:r="http://schemas.openxmlformats.org/officeDocument/2006/relationships">
+<p:sld xmlns:a="http://schemas.openxmlformats.org/drawingml/2006/main" xmlns:r="http://schemas.openxmlformats.org/officeDocument/2006/relationships" xmlns:p="http://schemas.openxmlformats.org/presentationml/2006/main">
   <p:cSld>
     <p:spTree>
       <p:nvGrpSpPr>
@@ -3239,7 +3239,14 @@
         <p:cNvGrpSpPr/>
         <p:nvPr/>
       </p:nvGrpSpPr>
-      <p:grpSpPr/>
+      <p:grpSpPr>
+        <a:xfrm>
+          <a:off x="0" y="0"/>
+          <a:ext cx="0" cy="0"/>
+          <a:chOff x="0" y="0"/>
+          <a:chExt cx="0" cy="0"/>
+        </a:xfrm>
+      </p:grpSpPr>
       <p:sp>
         <p:nvSpPr>
           <p:cNvPr id="2" name="Rectangle 1"/>
@@ -3280,6 +3287,7 @@
           <a:lstStyle/>
           <a:p>
             <a:pPr algn="ctr"/>
+            <a:endParaRPr/>
           </a:p>
         </p:txBody>
       </p:sp>
@@ -3305,7 +3313,6 @@
           </a:bodyPr>
           <a:lstStyle/>
           <a:p>
-            <a:pPr/>
             <a:r>
               <a:rPr sz="2800" b="1">
                 <a:solidFill>
@@ -3339,7 +3346,6 @@
           </a:bodyPr>
           <a:lstStyle/>
           <a:p>
-            <a:pPr/>
             <a:r>
               <a:rPr sz="1500" b="0">
                 <a:solidFill>
@@ -3350,7 +3356,6 @@
             </a:r>
           </a:p>
           <a:p>
-            <a:pPr/>
             <a:r>
               <a:rPr sz="1500" b="0">
                 <a:solidFill>
@@ -3361,7 +3366,6 @@
             </a:r>
           </a:p>
           <a:p>
-            <a:pPr/>
             <a:r>
               <a:rPr sz="1500" b="0">
                 <a:solidFill>
@@ -3372,7 +3376,6 @@
             </a:r>
           </a:p>
           <a:p>
-            <a:pPr/>
             <a:r>
               <a:rPr sz="1500" b="0">
                 <a:solidFill>
@@ -3383,7 +3386,6 @@
             </a:r>
           </a:p>
           <a:p>
-            <a:pPr/>
             <a:r>
               <a:rPr sz="1500" b="0">
                 <a:solidFill>
@@ -3446,7 +3448,6 @@
           </a:bodyPr>
           <a:lstStyle/>
           <a:p>
-            <a:pPr/>
             <a:r>
               <a:rPr sz="1100" b="0">
                 <a:solidFill>
@@ -3467,7 +3468,7 @@
 </file>
 
 <file path=ppt/slides/slide11.xml><?xml version="1.0" encoding="utf-8"?>
-<p:sld xmlns:a="http://schemas.openxmlformats.org/drawingml/2006/main" xmlns:p="http://schemas.openxmlformats.org/presentationml/2006/main" xmlns:r="http://schemas.openxmlformats.org/officeDocument/2006/relationships">
+<p:sld xmlns:a="http://schemas.openxmlformats.org/drawingml/2006/main" xmlns:r="http://schemas.openxmlformats.org/officeDocument/2006/relationships" xmlns:p="http://schemas.openxmlformats.org/presentationml/2006/main">
   <p:cSld>
     <p:spTree>
       <p:nvGrpSpPr>
@@ -3475,7 +3476,14 @@
         <p:cNvGrpSpPr/>
         <p:nvPr/>
       </p:nvGrpSpPr>
-      <p:grpSpPr/>
+      <p:grpSpPr>
+        <a:xfrm>
+          <a:off x="0" y="0"/>
+          <a:ext cx="0" cy="0"/>
+          <a:chOff x="0" y="0"/>
+          <a:chExt cx="0" cy="0"/>
+        </a:xfrm>
+      </p:grpSpPr>
       <p:sp>
         <p:nvSpPr>
           <p:cNvPr id="2" name="Rectangle 1"/>
@@ -3516,6 +3524,7 @@
           <a:lstStyle/>
           <a:p>
             <a:pPr algn="ctr"/>
+            <a:endParaRPr/>
           </a:p>
         </p:txBody>
       </p:sp>
@@ -3541,7 +3550,6 @@
           </a:bodyPr>
           <a:lstStyle/>
           <a:p>
-            <a:pPr/>
             <a:r>
               <a:rPr sz="2800" b="1">
                 <a:solidFill>
@@ -3562,7 +3570,7 @@
         <p:spPr>
           <a:xfrm>
             <a:off x="548640" y="1234440"/>
-            <a:ext cx="5120640" cy="5303520"/>
+            <a:ext cx="5120640" cy="784830"/>
           </a:xfrm>
           <a:prstGeom prst="rect">
             <a:avLst/>
@@ -3575,48 +3583,507 @@
           </a:bodyPr>
           <a:lstStyle/>
           <a:p>
-            <a:pPr/>
-            <a:r>
-              <a:rPr sz="1500" b="0">
-                <a:solidFill>
-                  <a:srgbClr val="1F2937"/>
-                </a:solidFill>
-              </a:rPr>
-              <a:t>- Tuyến 1: LLM cấu hình qua env - Gemini / OpenAI / Anthropic, đổi provider bằng AI_PROVIDER + AI_MODEL</a:t>
-            </a:r>
-          </a:p>
-          <a:p>
-            <a:pPr/>
-            <a:r>
-              <a:rPr sz="1500" b="0">
-                <a:solidFill>
-                  <a:srgbClr val="1F2937"/>
-                </a:solidFill>
-              </a:rPr>
-              <a:t>- Tuyến 2: Devin async - hết quota LLM thì tạo session xử lý, callback trả kết quả</a:t>
-            </a:r>
-          </a:p>
-          <a:p>
-            <a:pPr/>
-            <a:r>
-              <a:rPr sz="1500" b="0">
-                <a:solidFill>
-                  <a:srgbClr val="1F2937"/>
-                </a:solidFill>
-              </a:rPr>
-              <a:t>- Tuyến 3: rule-based fallback - luôn có câu trả lời hữu ích kể cả khi mọi backend chết</a:t>
-            </a:r>
-          </a:p>
-          <a:p>
-            <a:pPr/>
-            <a:r>
-              <a:rPr sz="1500" b="0">
-                <a:solidFill>
-                  <a:srgbClr val="1F2937"/>
-                </a:solidFill>
-              </a:rPr>
-              <a:t>- Ứng dụng: báo cáo hồ sơ lớp, nhận xét giáo án, gợi ý cảnh báo, trợ lý điều hành, phân tích sổ đầu bài, biên bản sinh hoạt, báo cáo Sở</a:t>
-            </a:r>
+            <a:r>
+              <a:rPr sz="1500" b="0" dirty="0">
+                <a:solidFill>
+                  <a:srgbClr val="1F2937"/>
+                </a:solidFill>
+              </a:rPr>
+              <a:t>- </a:t>
+            </a:r>
+            <a:r>
+              <a:rPr sz="1500" b="0" dirty="0" err="1">
+                <a:solidFill>
+                  <a:srgbClr val="1F2937"/>
+                </a:solidFill>
+              </a:rPr>
+              <a:t>Ứng</a:t>
+            </a:r>
+            <a:r>
+              <a:rPr sz="1500" b="0" dirty="0">
+                <a:solidFill>
+                  <a:srgbClr val="1F2937"/>
+                </a:solidFill>
+              </a:rPr>
+              <a:t> </a:t>
+            </a:r>
+            <a:r>
+              <a:rPr sz="1500" b="0" dirty="0" err="1">
+                <a:solidFill>
+                  <a:srgbClr val="1F2937"/>
+                </a:solidFill>
+              </a:rPr>
+              <a:t>dụng</a:t>
+            </a:r>
+            <a:r>
+              <a:rPr sz="1500" b="0" dirty="0">
+                <a:solidFill>
+                  <a:srgbClr val="1F2937"/>
+                </a:solidFill>
+              </a:rPr>
+              <a:t>: </a:t>
+            </a:r>
+            <a:r>
+              <a:rPr sz="1500" b="0" dirty="0" err="1">
+                <a:solidFill>
+                  <a:srgbClr val="1F2937"/>
+                </a:solidFill>
+              </a:rPr>
+              <a:t>báo</a:t>
+            </a:r>
+            <a:r>
+              <a:rPr sz="1500" b="0" dirty="0">
+                <a:solidFill>
+                  <a:srgbClr val="1F2937"/>
+                </a:solidFill>
+              </a:rPr>
+              <a:t> </a:t>
+            </a:r>
+            <a:r>
+              <a:rPr sz="1500" b="0" dirty="0" err="1">
+                <a:solidFill>
+                  <a:srgbClr val="1F2937"/>
+                </a:solidFill>
+              </a:rPr>
+              <a:t>cáo</a:t>
+            </a:r>
+            <a:r>
+              <a:rPr sz="1500" b="0" dirty="0">
+                <a:solidFill>
+                  <a:srgbClr val="1F2937"/>
+                </a:solidFill>
+              </a:rPr>
+              <a:t> </a:t>
+            </a:r>
+            <a:r>
+              <a:rPr sz="1500" b="0" dirty="0" err="1">
+                <a:solidFill>
+                  <a:srgbClr val="1F2937"/>
+                </a:solidFill>
+              </a:rPr>
+              <a:t>hồ</a:t>
+            </a:r>
+            <a:r>
+              <a:rPr sz="1500" b="0" dirty="0">
+                <a:solidFill>
+                  <a:srgbClr val="1F2937"/>
+                </a:solidFill>
+              </a:rPr>
+              <a:t> </a:t>
+            </a:r>
+            <a:r>
+              <a:rPr sz="1500" b="0" dirty="0" err="1">
+                <a:solidFill>
+                  <a:srgbClr val="1F2937"/>
+                </a:solidFill>
+              </a:rPr>
+              <a:t>sơ</a:t>
+            </a:r>
+            <a:r>
+              <a:rPr sz="1500" b="0" dirty="0">
+                <a:solidFill>
+                  <a:srgbClr val="1F2937"/>
+                </a:solidFill>
+              </a:rPr>
+              <a:t> </a:t>
+            </a:r>
+            <a:r>
+              <a:rPr sz="1500" b="0" dirty="0" err="1">
+                <a:solidFill>
+                  <a:srgbClr val="1F2937"/>
+                </a:solidFill>
+              </a:rPr>
+              <a:t>lớp</a:t>
+            </a:r>
+            <a:r>
+              <a:rPr sz="1500" b="0" dirty="0">
+                <a:solidFill>
+                  <a:srgbClr val="1F2937"/>
+                </a:solidFill>
+              </a:rPr>
+              <a:t>, </a:t>
+            </a:r>
+            <a:r>
+              <a:rPr sz="1500" b="0" dirty="0" err="1">
+                <a:solidFill>
+                  <a:srgbClr val="1F2937"/>
+                </a:solidFill>
+              </a:rPr>
+              <a:t>nhận</a:t>
+            </a:r>
+            <a:r>
+              <a:rPr sz="1500" b="0" dirty="0">
+                <a:solidFill>
+                  <a:srgbClr val="1F2937"/>
+                </a:solidFill>
+              </a:rPr>
+              <a:t> </a:t>
+            </a:r>
+            <a:r>
+              <a:rPr sz="1500" b="0" dirty="0" err="1">
+                <a:solidFill>
+                  <a:srgbClr val="1F2937"/>
+                </a:solidFill>
+              </a:rPr>
+              <a:t>xét</a:t>
+            </a:r>
+            <a:r>
+              <a:rPr sz="1500" b="0" dirty="0">
+                <a:solidFill>
+                  <a:srgbClr val="1F2937"/>
+                </a:solidFill>
+              </a:rPr>
+              <a:t> </a:t>
+            </a:r>
+            <a:r>
+              <a:rPr sz="1500" b="0" dirty="0" err="1">
+                <a:solidFill>
+                  <a:srgbClr val="1F2937"/>
+                </a:solidFill>
+              </a:rPr>
+              <a:t>giáo</a:t>
+            </a:r>
+            <a:r>
+              <a:rPr sz="1500" b="0" dirty="0">
+                <a:solidFill>
+                  <a:srgbClr val="1F2937"/>
+                </a:solidFill>
+              </a:rPr>
+              <a:t> </a:t>
+            </a:r>
+            <a:r>
+              <a:rPr sz="1500" b="0" dirty="0" err="1">
+                <a:solidFill>
+                  <a:srgbClr val="1F2937"/>
+                </a:solidFill>
+              </a:rPr>
+              <a:t>án</a:t>
+            </a:r>
+            <a:r>
+              <a:rPr sz="1500" b="0" dirty="0">
+                <a:solidFill>
+                  <a:srgbClr val="1F2937"/>
+                </a:solidFill>
+              </a:rPr>
+              <a:t>, </a:t>
+            </a:r>
+            <a:r>
+              <a:rPr sz="1500" b="0" dirty="0" err="1">
+                <a:solidFill>
+                  <a:srgbClr val="1F2937"/>
+                </a:solidFill>
+              </a:rPr>
+              <a:t>gợi</a:t>
+            </a:r>
+            <a:r>
+              <a:rPr sz="1500" b="0" dirty="0">
+                <a:solidFill>
+                  <a:srgbClr val="1F2937"/>
+                </a:solidFill>
+              </a:rPr>
+              <a:t> </a:t>
+            </a:r>
+            <a:r>
+              <a:rPr sz="1500" b="0" dirty="0" err="1">
+                <a:solidFill>
+                  <a:srgbClr val="1F2937"/>
+                </a:solidFill>
+              </a:rPr>
+              <a:t>ý</a:t>
+            </a:r>
+            <a:r>
+              <a:rPr sz="1500" b="0" dirty="0">
+                <a:solidFill>
+                  <a:srgbClr val="1F2937"/>
+                </a:solidFill>
+              </a:rPr>
+              <a:t> </a:t>
+            </a:r>
+            <a:r>
+              <a:rPr sz="1500" b="0" dirty="0" err="1">
+                <a:solidFill>
+                  <a:srgbClr val="1F2937"/>
+                </a:solidFill>
+              </a:rPr>
+              <a:t>cảnh</a:t>
+            </a:r>
+            <a:r>
+              <a:rPr sz="1500" b="0" dirty="0">
+                <a:solidFill>
+                  <a:srgbClr val="1F2937"/>
+                </a:solidFill>
+              </a:rPr>
+              <a:t> </a:t>
+            </a:r>
+            <a:r>
+              <a:rPr sz="1500" b="0" dirty="0" err="1">
+                <a:solidFill>
+                  <a:srgbClr val="1F2937"/>
+                </a:solidFill>
+              </a:rPr>
+              <a:t>báo</a:t>
+            </a:r>
+            <a:r>
+              <a:rPr sz="1500" b="0" dirty="0">
+                <a:solidFill>
+                  <a:srgbClr val="1F2937"/>
+                </a:solidFill>
+              </a:rPr>
+              <a:t>, </a:t>
+            </a:r>
+            <a:r>
+              <a:rPr sz="1500" b="0" dirty="0" err="1">
+                <a:solidFill>
+                  <a:srgbClr val="1F2937"/>
+                </a:solidFill>
+              </a:rPr>
+              <a:t>trợ</a:t>
+            </a:r>
+            <a:r>
+              <a:rPr sz="1500" b="0" dirty="0">
+                <a:solidFill>
+                  <a:srgbClr val="1F2937"/>
+                </a:solidFill>
+              </a:rPr>
+              <a:t> </a:t>
+            </a:r>
+            <a:r>
+              <a:rPr sz="1500" b="0" dirty="0" err="1">
+                <a:solidFill>
+                  <a:srgbClr val="1F2937"/>
+                </a:solidFill>
+              </a:rPr>
+              <a:t>lý</a:t>
+            </a:r>
+            <a:r>
+              <a:rPr sz="1500" b="0" dirty="0">
+                <a:solidFill>
+                  <a:srgbClr val="1F2937"/>
+                </a:solidFill>
+              </a:rPr>
+              <a:t> </a:t>
+            </a:r>
+            <a:r>
+              <a:rPr sz="1500" b="0" dirty="0" err="1">
+                <a:solidFill>
+                  <a:srgbClr val="1F2937"/>
+                </a:solidFill>
+              </a:rPr>
+              <a:t>điều</a:t>
+            </a:r>
+            <a:r>
+              <a:rPr sz="1500" b="0" dirty="0">
+                <a:solidFill>
+                  <a:srgbClr val="1F2937"/>
+                </a:solidFill>
+              </a:rPr>
+              <a:t> </a:t>
+            </a:r>
+            <a:r>
+              <a:rPr sz="1500" b="0" dirty="0" err="1">
+                <a:solidFill>
+                  <a:srgbClr val="1F2937"/>
+                </a:solidFill>
+              </a:rPr>
+              <a:t>hành</a:t>
+            </a:r>
+            <a:r>
+              <a:rPr sz="1500" b="0" dirty="0">
+                <a:solidFill>
+                  <a:srgbClr val="1F2937"/>
+                </a:solidFill>
+              </a:rPr>
+              <a:t>, </a:t>
+            </a:r>
+            <a:r>
+              <a:rPr sz="1500" b="0" dirty="0" err="1">
+                <a:solidFill>
+                  <a:srgbClr val="1F2937"/>
+                </a:solidFill>
+              </a:rPr>
+              <a:t>phân</a:t>
+            </a:r>
+            <a:r>
+              <a:rPr sz="1500" b="0" dirty="0">
+                <a:solidFill>
+                  <a:srgbClr val="1F2937"/>
+                </a:solidFill>
+              </a:rPr>
+              <a:t> </a:t>
+            </a:r>
+            <a:r>
+              <a:rPr sz="1500" b="0" dirty="0" err="1">
+                <a:solidFill>
+                  <a:srgbClr val="1F2937"/>
+                </a:solidFill>
+              </a:rPr>
+              <a:t>tích</a:t>
+            </a:r>
+            <a:r>
+              <a:rPr sz="1500" b="0" dirty="0">
+                <a:solidFill>
+                  <a:srgbClr val="1F2937"/>
+                </a:solidFill>
+              </a:rPr>
+              <a:t> </a:t>
+            </a:r>
+            <a:r>
+              <a:rPr sz="1500" b="0" dirty="0" err="1">
+                <a:solidFill>
+                  <a:srgbClr val="1F2937"/>
+                </a:solidFill>
+              </a:rPr>
+              <a:t>sổ</a:t>
+            </a:r>
+            <a:r>
+              <a:rPr sz="1500" b="0" dirty="0">
+                <a:solidFill>
+                  <a:srgbClr val="1F2937"/>
+                </a:solidFill>
+              </a:rPr>
+              <a:t> </a:t>
+            </a:r>
+            <a:r>
+              <a:rPr sz="1500" b="0" dirty="0" err="1">
+                <a:solidFill>
+                  <a:srgbClr val="1F2937"/>
+                </a:solidFill>
+              </a:rPr>
+              <a:t>đầu</a:t>
+            </a:r>
+            <a:r>
+              <a:rPr sz="1500" b="0" dirty="0">
+                <a:solidFill>
+                  <a:srgbClr val="1F2937"/>
+                </a:solidFill>
+              </a:rPr>
+              <a:t> </a:t>
+            </a:r>
+            <a:r>
+              <a:rPr sz="1500" b="0" dirty="0" err="1">
+                <a:solidFill>
+                  <a:srgbClr val="1F2937"/>
+                </a:solidFill>
+              </a:rPr>
+              <a:t>bài</a:t>
+            </a:r>
+            <a:r>
+              <a:rPr sz="1500" b="0" dirty="0">
+                <a:solidFill>
+                  <a:srgbClr val="1F2937"/>
+                </a:solidFill>
+              </a:rPr>
+              <a:t>, </a:t>
+            </a:r>
+            <a:r>
+              <a:rPr sz="1500" b="0" dirty="0" err="1">
+                <a:solidFill>
+                  <a:srgbClr val="1F2937"/>
+                </a:solidFill>
+              </a:rPr>
+              <a:t>biên</a:t>
+            </a:r>
+            <a:r>
+              <a:rPr sz="1500" b="0" dirty="0">
+                <a:solidFill>
+                  <a:srgbClr val="1F2937"/>
+                </a:solidFill>
+              </a:rPr>
+              <a:t> </a:t>
+            </a:r>
+            <a:r>
+              <a:rPr sz="1500" b="0" dirty="0" err="1">
+                <a:solidFill>
+                  <a:srgbClr val="1F2937"/>
+                </a:solidFill>
+              </a:rPr>
+              <a:t>bản</a:t>
+            </a:r>
+            <a:r>
+              <a:rPr sz="1500" b="0" dirty="0">
+                <a:solidFill>
+                  <a:srgbClr val="1F2937"/>
+                </a:solidFill>
+              </a:rPr>
+              <a:t> </a:t>
+            </a:r>
+            <a:r>
+              <a:rPr sz="1500" b="0" dirty="0" err="1">
+                <a:solidFill>
+                  <a:srgbClr val="1F2937"/>
+                </a:solidFill>
+              </a:rPr>
+              <a:t>sinh</a:t>
+            </a:r>
+            <a:r>
+              <a:rPr sz="1500" b="0" dirty="0">
+                <a:solidFill>
+                  <a:srgbClr val="1F2937"/>
+                </a:solidFill>
+              </a:rPr>
+              <a:t> </a:t>
+            </a:r>
+            <a:r>
+              <a:rPr sz="1500" b="0" dirty="0" err="1">
+                <a:solidFill>
+                  <a:srgbClr val="1F2937"/>
+                </a:solidFill>
+              </a:rPr>
+              <a:t>hoạt</a:t>
+            </a:r>
+            <a:r>
+              <a:rPr sz="1500" b="0" dirty="0">
+                <a:solidFill>
+                  <a:srgbClr val="1F2937"/>
+                </a:solidFill>
+              </a:rPr>
+              <a:t>, </a:t>
+            </a:r>
+            <a:r>
+              <a:rPr sz="1500" b="0" dirty="0" err="1">
+                <a:solidFill>
+                  <a:srgbClr val="1F2937"/>
+                </a:solidFill>
+              </a:rPr>
+              <a:t>báo</a:t>
+            </a:r>
+            <a:r>
+              <a:rPr sz="1500" b="0" dirty="0">
+                <a:solidFill>
+                  <a:srgbClr val="1F2937"/>
+                </a:solidFill>
+              </a:rPr>
+              <a:t> </a:t>
+            </a:r>
+            <a:r>
+              <a:rPr sz="1500" b="0" dirty="0" err="1">
+                <a:solidFill>
+                  <a:srgbClr val="1F2937"/>
+                </a:solidFill>
+              </a:rPr>
+              <a:t>cáo</a:t>
+            </a:r>
+            <a:r>
+              <a:rPr sz="1500" b="0" dirty="0">
+                <a:solidFill>
+                  <a:srgbClr val="1F2937"/>
+                </a:solidFill>
+              </a:rPr>
+              <a:t> </a:t>
+            </a:r>
+            <a:r>
+              <a:rPr sz="1500" b="0" dirty="0" err="1">
+                <a:solidFill>
+                  <a:srgbClr val="1F2937"/>
+                </a:solidFill>
+              </a:rPr>
+              <a:t>Sở</a:t>
+            </a:r>
+            <a:endParaRPr sz="1500" b="0" dirty="0">
+              <a:solidFill>
+                <a:srgbClr val="1F2937"/>
+              </a:solidFill>
+            </a:endParaRPr>
           </a:p>
         </p:txBody>
       </p:sp>
@@ -3671,7 +4138,6 @@
           </a:bodyPr>
           <a:lstStyle/>
           <a:p>
-            <a:pPr/>
             <a:r>
               <a:rPr sz="1100" b="0">
                 <a:solidFill>
@@ -3692,7 +4158,7 @@
 </file>
 
 <file path=ppt/slides/slide12.xml><?xml version="1.0" encoding="utf-8"?>
-<p:sld xmlns:a="http://schemas.openxmlformats.org/drawingml/2006/main" xmlns:p="http://schemas.openxmlformats.org/presentationml/2006/main" xmlns:r="http://schemas.openxmlformats.org/officeDocument/2006/relationships">
+<p:sld xmlns:a="http://schemas.openxmlformats.org/drawingml/2006/main" xmlns:r="http://schemas.openxmlformats.org/officeDocument/2006/relationships" xmlns:p="http://schemas.openxmlformats.org/presentationml/2006/main">
   <p:cSld>
     <p:spTree>
       <p:nvGrpSpPr>
@@ -3700,7 +4166,14 @@
         <p:cNvGrpSpPr/>
         <p:nvPr/>
       </p:nvGrpSpPr>
-      <p:grpSpPr/>
+      <p:grpSpPr>
+        <a:xfrm>
+          <a:off x="0" y="0"/>
+          <a:ext cx="0" cy="0"/>
+          <a:chOff x="0" y="0"/>
+          <a:chExt cx="0" cy="0"/>
+        </a:xfrm>
+      </p:grpSpPr>
       <p:sp>
         <p:nvSpPr>
           <p:cNvPr id="2" name="Rectangle 1"/>
@@ -3741,6 +4214,7 @@
           <a:lstStyle/>
           <a:p>
             <a:pPr algn="ctr"/>
+            <a:endParaRPr/>
           </a:p>
         </p:txBody>
       </p:sp>
@@ -3766,7 +4240,6 @@
           </a:bodyPr>
           <a:lstStyle/>
           <a:p>
-            <a:pPr/>
             <a:r>
               <a:rPr sz="2800" b="1">
                 <a:solidFill>
@@ -3787,7 +4260,7 @@
         <p:spPr>
           <a:xfrm>
             <a:off x="548640" y="1234440"/>
-            <a:ext cx="5120640" cy="5303520"/>
+            <a:ext cx="5120640" cy="1246495"/>
           </a:xfrm>
           <a:prstGeom prst="rect">
             <a:avLst/>
@@ -3800,58 +4273,584 @@
           </a:bodyPr>
           <a:lstStyle/>
           <a:p>
-            <a:pPr/>
-            <a:r>
-              <a:rPr sz="1500" b="0">
-                <a:solidFill>
-                  <a:srgbClr val="1F2937"/>
-                </a:solidFill>
-              </a:rPr>
-              <a:t>- Xuất sổ chủ nhiệm, báo cáo Sở/Phòng (CSV/Excel), sổ cá nhân GV</a:t>
-            </a:r>
-          </a:p>
-          <a:p>
-            <a:pPr/>
-            <a:r>
-              <a:rPr sz="1500" b="0">
-                <a:solidFill>
-                  <a:srgbClr val="1F2937"/>
-                </a:solidFill>
-              </a:rPr>
-              <a:t>- RBAC ở 3 tầng: UI - route guard - Postgres RLS theo trường/quan hệ</a:t>
-            </a:r>
-          </a:p>
-          <a:p>
-            <a:pPr/>
-            <a:r>
-              <a:rPr sz="1500" b="0">
-                <a:solidFill>
-                  <a:srgbClr val="1F2937"/>
-                </a:solidFill>
-              </a:rPr>
-              <a:t>- Audit log mọi hành động quan trọng, trang xem cho BGH</a:t>
-            </a:r>
-          </a:p>
-          <a:p>
-            <a:pPr/>
-            <a:r>
-              <a:rPr sz="1500" b="0">
-                <a:solidFill>
-                  <a:srgbClr val="1F2937"/>
-                </a:solidFill>
-              </a:rPr>
-              <a:t>- Notification in-app cho mọi hành động ảnh hưởng người khác</a:t>
-            </a:r>
-          </a:p>
-          <a:p>
-            <a:pPr/>
-            <a:r>
-              <a:rPr sz="1500" b="0">
-                <a:solidFill>
-                  <a:srgbClr val="1F2937"/>
-                </a:solidFill>
-              </a:rPr>
-              <a:t>- Responsive mobile, sắp xếp tên theo quy tắc Việt Nam</a:t>
+            <a:r>
+              <a:rPr sz="1500" b="0" dirty="0">
+                <a:solidFill>
+                  <a:srgbClr val="1F2937"/>
+                </a:solidFill>
+              </a:rPr>
+              <a:t>- </a:t>
+            </a:r>
+            <a:r>
+              <a:rPr sz="1500" b="0" dirty="0" err="1">
+                <a:solidFill>
+                  <a:srgbClr val="1F2937"/>
+                </a:solidFill>
+              </a:rPr>
+              <a:t>Xuất</a:t>
+            </a:r>
+            <a:r>
+              <a:rPr sz="1500" b="0" dirty="0">
+                <a:solidFill>
+                  <a:srgbClr val="1F2937"/>
+                </a:solidFill>
+              </a:rPr>
+              <a:t> </a:t>
+            </a:r>
+            <a:r>
+              <a:rPr sz="1500" b="0" dirty="0" err="1">
+                <a:solidFill>
+                  <a:srgbClr val="1F2937"/>
+                </a:solidFill>
+              </a:rPr>
+              <a:t>sổ</a:t>
+            </a:r>
+            <a:r>
+              <a:rPr sz="1500" b="0" dirty="0">
+                <a:solidFill>
+                  <a:srgbClr val="1F2937"/>
+                </a:solidFill>
+              </a:rPr>
+              <a:t> </a:t>
+            </a:r>
+            <a:r>
+              <a:rPr sz="1500" b="0" dirty="0" err="1">
+                <a:solidFill>
+                  <a:srgbClr val="1F2937"/>
+                </a:solidFill>
+              </a:rPr>
+              <a:t>chủ</a:t>
+            </a:r>
+            <a:r>
+              <a:rPr sz="1500" b="0" dirty="0">
+                <a:solidFill>
+                  <a:srgbClr val="1F2937"/>
+                </a:solidFill>
+              </a:rPr>
+              <a:t> </a:t>
+            </a:r>
+            <a:r>
+              <a:rPr sz="1500" b="0" dirty="0" err="1">
+                <a:solidFill>
+                  <a:srgbClr val="1F2937"/>
+                </a:solidFill>
+              </a:rPr>
+              <a:t>nhiệm</a:t>
+            </a:r>
+            <a:r>
+              <a:rPr sz="1500" b="0" dirty="0">
+                <a:solidFill>
+                  <a:srgbClr val="1F2937"/>
+                </a:solidFill>
+              </a:rPr>
+              <a:t>, </a:t>
+            </a:r>
+            <a:r>
+              <a:rPr sz="1500" b="0" dirty="0" err="1">
+                <a:solidFill>
+                  <a:srgbClr val="1F2937"/>
+                </a:solidFill>
+              </a:rPr>
+              <a:t>báo</a:t>
+            </a:r>
+            <a:r>
+              <a:rPr sz="1500" b="0" dirty="0">
+                <a:solidFill>
+                  <a:srgbClr val="1F2937"/>
+                </a:solidFill>
+              </a:rPr>
+              <a:t> </a:t>
+            </a:r>
+            <a:r>
+              <a:rPr sz="1500" b="0" dirty="0" err="1">
+                <a:solidFill>
+                  <a:srgbClr val="1F2937"/>
+                </a:solidFill>
+              </a:rPr>
+              <a:t>cáo</a:t>
+            </a:r>
+            <a:r>
+              <a:rPr sz="1500" b="0" dirty="0">
+                <a:solidFill>
+                  <a:srgbClr val="1F2937"/>
+                </a:solidFill>
+              </a:rPr>
+              <a:t> </a:t>
+            </a:r>
+            <a:r>
+              <a:rPr sz="1500" b="0" dirty="0" err="1">
+                <a:solidFill>
+                  <a:srgbClr val="1F2937"/>
+                </a:solidFill>
+              </a:rPr>
+              <a:t>Sở</a:t>
+            </a:r>
+            <a:r>
+              <a:rPr sz="1500" b="0" dirty="0">
+                <a:solidFill>
+                  <a:srgbClr val="1F2937"/>
+                </a:solidFill>
+              </a:rPr>
+              <a:t>/</a:t>
+            </a:r>
+            <a:r>
+              <a:rPr sz="1500" b="0" dirty="0" err="1">
+                <a:solidFill>
+                  <a:srgbClr val="1F2937"/>
+                </a:solidFill>
+              </a:rPr>
+              <a:t>Phòng</a:t>
+            </a:r>
+            <a:r>
+              <a:rPr sz="1500" b="0" dirty="0">
+                <a:solidFill>
+                  <a:srgbClr val="1F2937"/>
+                </a:solidFill>
+              </a:rPr>
+              <a:t> (CSV/Excel), </a:t>
+            </a:r>
+            <a:r>
+              <a:rPr sz="1500" b="0" dirty="0" err="1">
+                <a:solidFill>
+                  <a:srgbClr val="1F2937"/>
+                </a:solidFill>
+              </a:rPr>
+              <a:t>sổ</a:t>
+            </a:r>
+            <a:r>
+              <a:rPr sz="1500" b="0" dirty="0">
+                <a:solidFill>
+                  <a:srgbClr val="1F2937"/>
+                </a:solidFill>
+              </a:rPr>
+              <a:t> </a:t>
+            </a:r>
+            <a:r>
+              <a:rPr sz="1500" b="0" dirty="0" err="1">
+                <a:solidFill>
+                  <a:srgbClr val="1F2937"/>
+                </a:solidFill>
+              </a:rPr>
+              <a:t>cá</a:t>
+            </a:r>
+            <a:r>
+              <a:rPr sz="1500" b="0" dirty="0">
+                <a:solidFill>
+                  <a:srgbClr val="1F2937"/>
+                </a:solidFill>
+              </a:rPr>
+              <a:t> </a:t>
+            </a:r>
+            <a:r>
+              <a:rPr sz="1500" b="0" dirty="0" err="1">
+                <a:solidFill>
+                  <a:srgbClr val="1F2937"/>
+                </a:solidFill>
+              </a:rPr>
+              <a:t>nhân</a:t>
+            </a:r>
+            <a:r>
+              <a:rPr sz="1500" b="0" dirty="0">
+                <a:solidFill>
+                  <a:srgbClr val="1F2937"/>
+                </a:solidFill>
+              </a:rPr>
+              <a:t> GV</a:t>
+            </a:r>
+          </a:p>
+          <a:p>
+            <a:r>
+              <a:rPr sz="1500" b="0" dirty="0">
+                <a:solidFill>
+                  <a:srgbClr val="1F2937"/>
+                </a:solidFill>
+              </a:rPr>
+              <a:t>- Audit log </a:t>
+            </a:r>
+            <a:r>
+              <a:rPr sz="1500" b="0" dirty="0" err="1">
+                <a:solidFill>
+                  <a:srgbClr val="1F2937"/>
+                </a:solidFill>
+              </a:rPr>
+              <a:t>mọi</a:t>
+            </a:r>
+            <a:r>
+              <a:rPr sz="1500" b="0" dirty="0">
+                <a:solidFill>
+                  <a:srgbClr val="1F2937"/>
+                </a:solidFill>
+              </a:rPr>
+              <a:t> </a:t>
+            </a:r>
+            <a:r>
+              <a:rPr sz="1500" b="0" dirty="0" err="1">
+                <a:solidFill>
+                  <a:srgbClr val="1F2937"/>
+                </a:solidFill>
+              </a:rPr>
+              <a:t>hành</a:t>
+            </a:r>
+            <a:r>
+              <a:rPr sz="1500" b="0" dirty="0">
+                <a:solidFill>
+                  <a:srgbClr val="1F2937"/>
+                </a:solidFill>
+              </a:rPr>
+              <a:t> </a:t>
+            </a:r>
+            <a:r>
+              <a:rPr sz="1500" b="0" dirty="0" err="1">
+                <a:solidFill>
+                  <a:srgbClr val="1F2937"/>
+                </a:solidFill>
+              </a:rPr>
+              <a:t>động</a:t>
+            </a:r>
+            <a:r>
+              <a:rPr sz="1500" b="0" dirty="0">
+                <a:solidFill>
+                  <a:srgbClr val="1F2937"/>
+                </a:solidFill>
+              </a:rPr>
+              <a:t> </a:t>
+            </a:r>
+            <a:r>
+              <a:rPr sz="1500" b="0" dirty="0" err="1">
+                <a:solidFill>
+                  <a:srgbClr val="1F2937"/>
+                </a:solidFill>
+              </a:rPr>
+              <a:t>quan</a:t>
+            </a:r>
+            <a:r>
+              <a:rPr sz="1500" b="0" dirty="0">
+                <a:solidFill>
+                  <a:srgbClr val="1F2937"/>
+                </a:solidFill>
+              </a:rPr>
+              <a:t> </a:t>
+            </a:r>
+            <a:r>
+              <a:rPr sz="1500" b="0" dirty="0" err="1">
+                <a:solidFill>
+                  <a:srgbClr val="1F2937"/>
+                </a:solidFill>
+              </a:rPr>
+              <a:t>trọng</a:t>
+            </a:r>
+            <a:r>
+              <a:rPr sz="1500" b="0" dirty="0">
+                <a:solidFill>
+                  <a:srgbClr val="1F2937"/>
+                </a:solidFill>
+              </a:rPr>
+              <a:t>, </a:t>
+            </a:r>
+            <a:r>
+              <a:rPr sz="1500" b="0" dirty="0" err="1">
+                <a:solidFill>
+                  <a:srgbClr val="1F2937"/>
+                </a:solidFill>
+              </a:rPr>
+              <a:t>trang</a:t>
+            </a:r>
+            <a:r>
+              <a:rPr sz="1500" b="0" dirty="0">
+                <a:solidFill>
+                  <a:srgbClr val="1F2937"/>
+                </a:solidFill>
+              </a:rPr>
+              <a:t> </a:t>
+            </a:r>
+            <a:r>
+              <a:rPr sz="1500" b="0" dirty="0" err="1">
+                <a:solidFill>
+                  <a:srgbClr val="1F2937"/>
+                </a:solidFill>
+              </a:rPr>
+              <a:t>xem</a:t>
+            </a:r>
+            <a:r>
+              <a:rPr sz="1500" b="0" dirty="0">
+                <a:solidFill>
+                  <a:srgbClr val="1F2937"/>
+                </a:solidFill>
+              </a:rPr>
+              <a:t> </a:t>
+            </a:r>
+            <a:r>
+              <a:rPr sz="1500" b="0" dirty="0" err="1">
+                <a:solidFill>
+                  <a:srgbClr val="1F2937"/>
+                </a:solidFill>
+              </a:rPr>
+              <a:t>cho</a:t>
+            </a:r>
+            <a:r>
+              <a:rPr sz="1500" b="0" dirty="0">
+                <a:solidFill>
+                  <a:srgbClr val="1F2937"/>
+                </a:solidFill>
+              </a:rPr>
+              <a:t> BGH</a:t>
+            </a:r>
+          </a:p>
+          <a:p>
+            <a:r>
+              <a:rPr sz="1500" b="0" dirty="0">
+                <a:solidFill>
+                  <a:srgbClr val="1F2937"/>
+                </a:solidFill>
+              </a:rPr>
+              <a:t>- Notification in-app </a:t>
+            </a:r>
+            <a:r>
+              <a:rPr sz="1500" b="0" dirty="0" err="1">
+                <a:solidFill>
+                  <a:srgbClr val="1F2937"/>
+                </a:solidFill>
+              </a:rPr>
+              <a:t>cho</a:t>
+            </a:r>
+            <a:r>
+              <a:rPr sz="1500" b="0" dirty="0">
+                <a:solidFill>
+                  <a:srgbClr val="1F2937"/>
+                </a:solidFill>
+              </a:rPr>
+              <a:t> </a:t>
+            </a:r>
+            <a:r>
+              <a:rPr sz="1500" b="0" dirty="0" err="1">
+                <a:solidFill>
+                  <a:srgbClr val="1F2937"/>
+                </a:solidFill>
+              </a:rPr>
+              <a:t>mọi</a:t>
+            </a:r>
+            <a:r>
+              <a:rPr sz="1500" b="0" dirty="0">
+                <a:solidFill>
+                  <a:srgbClr val="1F2937"/>
+                </a:solidFill>
+              </a:rPr>
+              <a:t> </a:t>
+            </a:r>
+            <a:r>
+              <a:rPr sz="1500" b="0" dirty="0" err="1">
+                <a:solidFill>
+                  <a:srgbClr val="1F2937"/>
+                </a:solidFill>
+              </a:rPr>
+              <a:t>hành</a:t>
+            </a:r>
+            <a:r>
+              <a:rPr sz="1500" b="0" dirty="0">
+                <a:solidFill>
+                  <a:srgbClr val="1F2937"/>
+                </a:solidFill>
+              </a:rPr>
+              <a:t> </a:t>
+            </a:r>
+            <a:r>
+              <a:rPr sz="1500" b="0" dirty="0" err="1">
+                <a:solidFill>
+                  <a:srgbClr val="1F2937"/>
+                </a:solidFill>
+              </a:rPr>
+              <a:t>động</a:t>
+            </a:r>
+            <a:r>
+              <a:rPr sz="1500" b="0" dirty="0">
+                <a:solidFill>
+                  <a:srgbClr val="1F2937"/>
+                </a:solidFill>
+              </a:rPr>
+              <a:t> </a:t>
+            </a:r>
+            <a:r>
+              <a:rPr sz="1500" b="0" dirty="0" err="1">
+                <a:solidFill>
+                  <a:srgbClr val="1F2937"/>
+                </a:solidFill>
+              </a:rPr>
+              <a:t>ảnh</a:t>
+            </a:r>
+            <a:r>
+              <a:rPr sz="1500" b="0" dirty="0">
+                <a:solidFill>
+                  <a:srgbClr val="1F2937"/>
+                </a:solidFill>
+              </a:rPr>
+              <a:t> </a:t>
+            </a:r>
+            <a:r>
+              <a:rPr sz="1500" b="0" dirty="0" err="1">
+                <a:solidFill>
+                  <a:srgbClr val="1F2937"/>
+                </a:solidFill>
+              </a:rPr>
+              <a:t>hưởng</a:t>
+            </a:r>
+            <a:r>
+              <a:rPr sz="1500" b="0" dirty="0">
+                <a:solidFill>
+                  <a:srgbClr val="1F2937"/>
+                </a:solidFill>
+              </a:rPr>
+              <a:t> </a:t>
+            </a:r>
+            <a:r>
+              <a:rPr sz="1500" b="0" dirty="0" err="1">
+                <a:solidFill>
+                  <a:srgbClr val="1F2937"/>
+                </a:solidFill>
+              </a:rPr>
+              <a:t>người</a:t>
+            </a:r>
+            <a:r>
+              <a:rPr sz="1500" b="0" dirty="0">
+                <a:solidFill>
+                  <a:srgbClr val="1F2937"/>
+                </a:solidFill>
+              </a:rPr>
+              <a:t> </a:t>
+            </a:r>
+            <a:r>
+              <a:rPr sz="1500" b="0" dirty="0" err="1">
+                <a:solidFill>
+                  <a:srgbClr val="1F2937"/>
+                </a:solidFill>
+              </a:rPr>
+              <a:t>khác</a:t>
+            </a:r>
+            <a:endParaRPr sz="1500" b="0" dirty="0">
+              <a:solidFill>
+                <a:srgbClr val="1F2937"/>
+              </a:solidFill>
+            </a:endParaRPr>
+          </a:p>
+          <a:p>
+            <a:r>
+              <a:rPr sz="1500" b="0" dirty="0">
+                <a:solidFill>
+                  <a:srgbClr val="1F2937"/>
+                </a:solidFill>
+              </a:rPr>
+              <a:t>- Responsive mobile, </a:t>
+            </a:r>
+            <a:r>
+              <a:rPr sz="1500" b="0" dirty="0" err="1">
+                <a:solidFill>
+                  <a:srgbClr val="1F2937"/>
+                </a:solidFill>
+              </a:rPr>
+              <a:t>sắp</a:t>
+            </a:r>
+            <a:r>
+              <a:rPr sz="1500" b="0" dirty="0">
+                <a:solidFill>
+                  <a:srgbClr val="1F2937"/>
+                </a:solidFill>
+              </a:rPr>
+              <a:t> </a:t>
+            </a:r>
+            <a:r>
+              <a:rPr sz="1500" b="0" dirty="0" err="1">
+                <a:solidFill>
+                  <a:srgbClr val="1F2937"/>
+                </a:solidFill>
+              </a:rPr>
+              <a:t>xếp</a:t>
+            </a:r>
+            <a:r>
+              <a:rPr sz="1500" b="0" dirty="0">
+                <a:solidFill>
+                  <a:srgbClr val="1F2937"/>
+                </a:solidFill>
+              </a:rPr>
+              <a:t> </a:t>
+            </a:r>
+            <a:r>
+              <a:rPr sz="1500" b="0" dirty="0" err="1">
+                <a:solidFill>
+                  <a:srgbClr val="1F2937"/>
+                </a:solidFill>
+              </a:rPr>
+              <a:t>tên</a:t>
+            </a:r>
+            <a:r>
+              <a:rPr sz="1500" b="0" dirty="0">
+                <a:solidFill>
+                  <a:srgbClr val="1F2937"/>
+                </a:solidFill>
+              </a:rPr>
+              <a:t> </a:t>
+            </a:r>
+            <a:r>
+              <a:rPr sz="1500" b="0" dirty="0" err="1">
+                <a:solidFill>
+                  <a:srgbClr val="1F2937"/>
+                </a:solidFill>
+              </a:rPr>
+              <a:t>theo</a:t>
+            </a:r>
+            <a:r>
+              <a:rPr sz="1500" b="0" dirty="0">
+                <a:solidFill>
+                  <a:srgbClr val="1F2937"/>
+                </a:solidFill>
+              </a:rPr>
+              <a:t> </a:t>
+            </a:r>
+            <a:r>
+              <a:rPr sz="1500" b="0" dirty="0" err="1">
+                <a:solidFill>
+                  <a:srgbClr val="1F2937"/>
+                </a:solidFill>
+              </a:rPr>
+              <a:t>quy</a:t>
+            </a:r>
+            <a:r>
+              <a:rPr sz="1500" b="0" dirty="0">
+                <a:solidFill>
+                  <a:srgbClr val="1F2937"/>
+                </a:solidFill>
+              </a:rPr>
+              <a:t> </a:t>
+            </a:r>
+            <a:r>
+              <a:rPr sz="1500" b="0" dirty="0" err="1">
+                <a:solidFill>
+                  <a:srgbClr val="1F2937"/>
+                </a:solidFill>
+              </a:rPr>
+              <a:t>tắc</a:t>
+            </a:r>
+            <a:r>
+              <a:rPr sz="1500" b="0" dirty="0">
+                <a:solidFill>
+                  <a:srgbClr val="1F2937"/>
+                </a:solidFill>
+              </a:rPr>
+              <a:t> </a:t>
+            </a:r>
+            <a:r>
+              <a:rPr sz="1500" b="0" dirty="0" err="1">
+                <a:solidFill>
+                  <a:srgbClr val="1F2937"/>
+                </a:solidFill>
+              </a:rPr>
+              <a:t>Việt</a:t>
+            </a:r>
+            <a:r>
+              <a:rPr sz="1500" b="0" dirty="0">
+                <a:solidFill>
+                  <a:srgbClr val="1F2937"/>
+                </a:solidFill>
+              </a:rPr>
+              <a:t> Nam</a:t>
             </a:r>
           </a:p>
         </p:txBody>
@@ -3907,7 +4906,6 @@
           </a:bodyPr>
           <a:lstStyle/>
           <a:p>
-            <a:pPr/>
             <a:r>
               <a:rPr sz="1100" b="0">
                 <a:solidFill>
@@ -3928,7 +4926,7 @@
 </file>
 
 <file path=ppt/slides/slide13.xml><?xml version="1.0" encoding="utf-8"?>
-<p:sld xmlns:a="http://schemas.openxmlformats.org/drawingml/2006/main" xmlns:p="http://schemas.openxmlformats.org/presentationml/2006/main" xmlns:r="http://schemas.openxmlformats.org/officeDocument/2006/relationships">
+<p:sld xmlns:a="http://schemas.openxmlformats.org/drawingml/2006/main" xmlns:r="http://schemas.openxmlformats.org/officeDocument/2006/relationships" xmlns:p="http://schemas.openxmlformats.org/presentationml/2006/main">
   <p:cSld>
     <p:spTree>
       <p:nvGrpSpPr>
@@ -3936,7 +4934,14 @@
         <p:cNvGrpSpPr/>
         <p:nvPr/>
       </p:nvGrpSpPr>
-      <p:grpSpPr/>
+      <p:grpSpPr>
+        <a:xfrm>
+          <a:off x="0" y="0"/>
+          <a:ext cx="0" cy="0"/>
+          <a:chOff x="0" y="0"/>
+          <a:chExt cx="0" cy="0"/>
+        </a:xfrm>
+      </p:grpSpPr>
       <p:sp>
         <p:nvSpPr>
           <p:cNvPr id="2" name="Rectangle 1"/>
@@ -3977,6 +4982,7 @@
           <a:lstStyle/>
           <a:p>
             <a:pPr algn="ctr"/>
+            <a:endParaRPr/>
           </a:p>
         </p:txBody>
       </p:sp>
@@ -4002,7 +5008,6 @@
           </a:bodyPr>
           <a:lstStyle/>
           <a:p>
-            <a:pPr/>
             <a:r>
               <a:rPr sz="3600" b="1">
                 <a:solidFill>
@@ -4013,7 +5018,6 @@
             </a:r>
           </a:p>
           <a:p>
-            <a:pPr/>
             <a:r>
               <a:rPr sz="2000" b="0">
                 <a:solidFill>
@@ -4024,7 +5028,6 @@
             </a:r>
           </a:p>
           <a:p>
-            <a:pPr/>
             <a:r>
               <a:rPr sz="1600" b="0">
                 <a:solidFill>
@@ -4035,7 +5038,6 @@
             </a:r>
           </a:p>
           <a:p>
-            <a:pPr/>
             <a:r>
               <a:rPr sz="1400" b="0">
                 <a:solidFill>
@@ -4056,7 +5058,7 @@
 </file>
 
 <file path=ppt/slides/slide2.xml><?xml version="1.0" encoding="utf-8"?>
-<p:sld xmlns:a="http://schemas.openxmlformats.org/drawingml/2006/main" xmlns:p="http://schemas.openxmlformats.org/presentationml/2006/main" xmlns:r="http://schemas.openxmlformats.org/officeDocument/2006/relationships">
+<p:sld xmlns:a="http://schemas.openxmlformats.org/drawingml/2006/main" xmlns:r="http://schemas.openxmlformats.org/officeDocument/2006/relationships" xmlns:p="http://schemas.openxmlformats.org/presentationml/2006/main">
   <p:cSld>
     <p:spTree>
       <p:nvGrpSpPr>
@@ -4064,7 +5066,14 @@
         <p:cNvGrpSpPr/>
         <p:nvPr/>
       </p:nvGrpSpPr>
-      <p:grpSpPr/>
+      <p:grpSpPr>
+        <a:xfrm>
+          <a:off x="0" y="0"/>
+          <a:ext cx="0" cy="0"/>
+          <a:chOff x="0" y="0"/>
+          <a:chExt cx="0" cy="0"/>
+        </a:xfrm>
+      </p:grpSpPr>
       <p:sp>
         <p:nvSpPr>
           <p:cNvPr id="2" name="Rectangle 1"/>
@@ -4105,6 +5114,7 @@
           <a:lstStyle/>
           <a:p>
             <a:pPr algn="ctr"/>
+            <a:endParaRPr/>
           </a:p>
         </p:txBody>
       </p:sp>
@@ -4130,7 +5140,6 @@
           </a:bodyPr>
           <a:lstStyle/>
           <a:p>
-            <a:pPr/>
             <a:r>
               <a:rPr sz="2800" b="1">
                 <a:solidFill>
@@ -4164,7 +5173,6 @@
           </a:bodyPr>
           <a:lstStyle/>
           <a:p>
-            <a:pPr/>
             <a:r>
               <a:rPr sz="1500" b="0">
                 <a:solidFill>
@@ -4175,7 +5183,6 @@
             </a:r>
           </a:p>
           <a:p>
-            <a:pPr/>
             <a:r>
               <a:rPr sz="1500" b="0">
                 <a:solidFill>
@@ -4186,7 +5193,6 @@
             </a:r>
           </a:p>
           <a:p>
-            <a:pPr/>
             <a:r>
               <a:rPr sz="1500" b="0">
                 <a:solidFill>
@@ -4197,7 +5203,6 @@
             </a:r>
           </a:p>
           <a:p>
-            <a:pPr/>
             <a:r>
               <a:rPr sz="1500" b="0">
                 <a:solidFill>
@@ -4208,7 +5213,6 @@
             </a:r>
           </a:p>
           <a:p>
-            <a:pPr/>
             <a:r>
               <a:rPr sz="1500" b="0">
                 <a:solidFill>
@@ -4219,7 +5223,6 @@
             </a:r>
           </a:p>
           <a:p>
-            <a:pPr/>
             <a:r>
               <a:rPr sz="1500" b="0">
                 <a:solidFill>
@@ -4282,7 +5285,6 @@
           </a:bodyPr>
           <a:lstStyle/>
           <a:p>
-            <a:pPr/>
             <a:r>
               <a:rPr sz="1100" b="0">
                 <a:solidFill>
@@ -4303,7 +5305,7 @@
 </file>
 
 <file path=ppt/slides/slide3.xml><?xml version="1.0" encoding="utf-8"?>
-<p:sld xmlns:a="http://schemas.openxmlformats.org/drawingml/2006/main" xmlns:p="http://schemas.openxmlformats.org/presentationml/2006/main" xmlns:r="http://schemas.openxmlformats.org/officeDocument/2006/relationships">
+<p:sld xmlns:a="http://schemas.openxmlformats.org/drawingml/2006/main" xmlns:r="http://schemas.openxmlformats.org/officeDocument/2006/relationships" xmlns:p="http://schemas.openxmlformats.org/presentationml/2006/main">
   <p:cSld>
     <p:spTree>
       <p:nvGrpSpPr>
@@ -4311,7 +5313,14 @@
         <p:cNvGrpSpPr/>
         <p:nvPr/>
       </p:nvGrpSpPr>
-      <p:grpSpPr/>
+      <p:grpSpPr>
+        <a:xfrm>
+          <a:off x="0" y="0"/>
+          <a:ext cx="0" cy="0"/>
+          <a:chOff x="0" y="0"/>
+          <a:chExt cx="0" cy="0"/>
+        </a:xfrm>
+      </p:grpSpPr>
       <p:sp>
         <p:nvSpPr>
           <p:cNvPr id="2" name="TextBox 1"/>
@@ -4334,7 +5343,6 @@
           </a:bodyPr>
           <a:lstStyle/>
           <a:p>
-            <a:pPr/>
             <a:r>
               <a:rPr sz="2800" b="1">
                 <a:solidFill>
@@ -4365,10 +5373,34 @@
                 <a:tableStyleId>{5C22544A-7EE6-4342-B048-85BDC9FD1C3A}</a:tableStyleId>
               </a:tblPr>
               <a:tblGrid>
-                <a:gridCol w="2773603"/>
-                <a:gridCol w="2773603"/>
-                <a:gridCol w="2773603"/>
-                <a:gridCol w="2773606"/>
+                <a:gridCol w="2773603">
+                  <a:extLst>
+                    <a:ext uri="{9D8B030D-6E8A-4147-A177-3AD203B41FA5}">
+                      <a16:colId xmlns:a16="http://schemas.microsoft.com/office/drawing/2014/main" val="20000"/>
+                    </a:ext>
+                  </a:extLst>
+                </a:gridCol>
+                <a:gridCol w="2773603">
+                  <a:extLst>
+                    <a:ext uri="{9D8B030D-6E8A-4147-A177-3AD203B41FA5}">
+                      <a16:colId xmlns:a16="http://schemas.microsoft.com/office/drawing/2014/main" val="20001"/>
+                    </a:ext>
+                  </a:extLst>
+                </a:gridCol>
+                <a:gridCol w="2773603">
+                  <a:extLst>
+                    <a:ext uri="{9D8B030D-6E8A-4147-A177-3AD203B41FA5}">
+                      <a16:colId xmlns:a16="http://schemas.microsoft.com/office/drawing/2014/main" val="20002"/>
+                    </a:ext>
+                  </a:extLst>
+                </a:gridCol>
+                <a:gridCol w="2773606">
+                  <a:extLst>
+                    <a:ext uri="{9D8B030D-6E8A-4147-A177-3AD203B41FA5}">
+                      <a16:colId xmlns:a16="http://schemas.microsoft.com/office/drawing/2014/main" val="20003"/>
+                    </a:ext>
+                  </a:extLst>
+                </a:gridCol>
               </a:tblGrid>
               <a:tr h="950976">
                 <a:tc>
@@ -4423,6 +5455,11 @@
                   </a:txBody>
                   <a:tcPr/>
                 </a:tc>
+                <a:extLst>
+                  <a:ext uri="{0D108BD9-81ED-4DB2-BD59-A6C34878D82A}">
+                    <a16:rowId xmlns:a16="http://schemas.microsoft.com/office/drawing/2014/main" val="10000"/>
+                  </a:ext>
+                </a:extLst>
               </a:tr>
               <a:tr h="950976">
                 <a:tc>
@@ -4477,6 +5514,11 @@
                   </a:txBody>
                   <a:tcPr/>
                 </a:tc>
+                <a:extLst>
+                  <a:ext uri="{0D108BD9-81ED-4DB2-BD59-A6C34878D82A}">
+                    <a16:rowId xmlns:a16="http://schemas.microsoft.com/office/drawing/2014/main" val="10001"/>
+                  </a:ext>
+                </a:extLst>
               </a:tr>
               <a:tr h="950976">
                 <a:tc>
@@ -4531,6 +5573,11 @@
                   </a:txBody>
                   <a:tcPr/>
                 </a:tc>
+                <a:extLst>
+                  <a:ext uri="{0D108BD9-81ED-4DB2-BD59-A6C34878D82A}">
+                    <a16:rowId xmlns:a16="http://schemas.microsoft.com/office/drawing/2014/main" val="10002"/>
+                  </a:ext>
+                </a:extLst>
               </a:tr>
               <a:tr h="950976">
                 <a:tc>
@@ -4585,6 +5632,11 @@
                   </a:txBody>
                   <a:tcPr/>
                 </a:tc>
+                <a:extLst>
+                  <a:ext uri="{0D108BD9-81ED-4DB2-BD59-A6C34878D82A}">
+                    <a16:rowId xmlns:a16="http://schemas.microsoft.com/office/drawing/2014/main" val="10003"/>
+                  </a:ext>
+                </a:extLst>
               </a:tr>
               <a:tr h="950976">
                 <a:tc>
@@ -4639,6 +5691,11 @@
                   </a:txBody>
                   <a:tcPr/>
                 </a:tc>
+                <a:extLst>
+                  <a:ext uri="{0D108BD9-81ED-4DB2-BD59-A6C34878D82A}">
+                    <a16:rowId xmlns:a16="http://schemas.microsoft.com/office/drawing/2014/main" val="10004"/>
+                  </a:ext>
+                </a:extLst>
               </a:tr>
             </a:tbl>
           </a:graphicData>
@@ -4653,7 +5710,7 @@
 </file>
 
 <file path=ppt/slides/slide4.xml><?xml version="1.0" encoding="utf-8"?>
-<p:sld xmlns:a="http://schemas.openxmlformats.org/drawingml/2006/main" xmlns:p="http://schemas.openxmlformats.org/presentationml/2006/main" xmlns:r="http://schemas.openxmlformats.org/officeDocument/2006/relationships">
+<p:sld xmlns:a="http://schemas.openxmlformats.org/drawingml/2006/main" xmlns:r="http://schemas.openxmlformats.org/officeDocument/2006/relationships" xmlns:p="http://schemas.openxmlformats.org/presentationml/2006/main">
   <p:cSld>
     <p:spTree>
       <p:nvGrpSpPr>
@@ -4661,7 +5718,14 @@
         <p:cNvGrpSpPr/>
         <p:nvPr/>
       </p:nvGrpSpPr>
-      <p:grpSpPr/>
+      <p:grpSpPr>
+        <a:xfrm>
+          <a:off x="0" y="0"/>
+          <a:ext cx="0" cy="0"/>
+          <a:chOff x="0" y="0"/>
+          <a:chExt cx="0" cy="0"/>
+        </a:xfrm>
+      </p:grpSpPr>
       <p:sp>
         <p:nvSpPr>
           <p:cNvPr id="2" name="Rectangle 1"/>
@@ -4702,6 +5766,7 @@
           <a:lstStyle/>
           <a:p>
             <a:pPr algn="ctr"/>
+            <a:endParaRPr/>
           </a:p>
         </p:txBody>
       </p:sp>
@@ -4727,7 +5792,6 @@
           </a:bodyPr>
           <a:lstStyle/>
           <a:p>
-            <a:pPr/>
             <a:r>
               <a:rPr sz="2800" b="1">
                 <a:solidFill>
@@ -4748,7 +5812,7 @@
         <p:spPr>
           <a:xfrm>
             <a:off x="548640" y="1234440"/>
-            <a:ext cx="5120640" cy="5303520"/>
+            <a:ext cx="5120640" cy="1708160"/>
           </a:xfrm>
           <a:prstGeom prst="rect">
             <a:avLst/>
@@ -4761,70 +5825,916 @@
           </a:bodyPr>
           <a:lstStyle/>
           <a:p>
-            <a:pPr/>
-            <a:r>
-              <a:rPr sz="1500" b="0">
-                <a:solidFill>
-                  <a:srgbClr val="1F2937"/>
-                </a:solidFill>
-              </a:rPr>
-              <a:t>- 4 trạng thái/em: Có mặt, Vắng CP, Vắng KP, Đi muộn + thao tác nhanh</a:t>
-            </a:r>
-          </a:p>
-          <a:p>
-            <a:pPr/>
-            <a:r>
-              <a:rPr sz="1500" b="0">
-                <a:solidFill>
-                  <a:srgbClr val="1F2937"/>
-                </a:solidFill>
-              </a:rPr>
-              <a:t>- Chọn ngày bất kỳ để xem lại / sửa điểm danh ngày cũ</a:t>
-            </a:r>
-          </a:p>
-          <a:p>
-            <a:pPr/>
-            <a:r>
-              <a:rPr sz="1500" b="0">
-                <a:solidFill>
-                  <a:srgbClr val="1F2937"/>
-                </a:solidFill>
-              </a:rPr>
-              <a:t>- Sổ vắng-muộn và lịch sử theo khoảng ngày (from - to)</a:t>
-            </a:r>
-          </a:p>
-          <a:p>
-            <a:pPr/>
-            <a:r>
-              <a:rPr sz="1500" b="0">
-                <a:solidFill>
-                  <a:srgbClr val="1F2937"/>
-                </a:solidFill>
-              </a:rPr>
-              <a:t>- Ma trận HS x ngày phát hiện vắng liên tục</a:t>
-            </a:r>
-          </a:p>
-          <a:p>
-            <a:pPr/>
-            <a:r>
-              <a:rPr sz="1500" b="0">
-                <a:solidFill>
-                  <a:srgbClr val="1F2937"/>
-                </a:solidFill>
-              </a:rPr>
-              <a:t>- Thông báo phụ huynh tự động (email + in-app)</a:t>
-            </a:r>
-          </a:p>
-          <a:p>
-            <a:pPr/>
-            <a:r>
-              <a:rPr sz="1500" b="0">
-                <a:solidFill>
-                  <a:srgbClr val="1F2937"/>
-                </a:solidFill>
-              </a:rPr>
-              <a:t>- Đồng bộ 2 chiều với sổ đầu bài tiết học</a:t>
-            </a:r>
+            <a:r>
+              <a:rPr sz="1500" b="0" dirty="0">
+                <a:solidFill>
+                  <a:srgbClr val="1F2937"/>
+                </a:solidFill>
+              </a:rPr>
+              <a:t>- 4 </a:t>
+            </a:r>
+            <a:r>
+              <a:rPr sz="1500" b="0" dirty="0" err="1">
+                <a:solidFill>
+                  <a:srgbClr val="1F2937"/>
+                </a:solidFill>
+              </a:rPr>
+              <a:t>trạng</a:t>
+            </a:r>
+            <a:r>
+              <a:rPr sz="1500" b="0" dirty="0">
+                <a:solidFill>
+                  <a:srgbClr val="1F2937"/>
+                </a:solidFill>
+              </a:rPr>
+              <a:t> </a:t>
+            </a:r>
+            <a:r>
+              <a:rPr sz="1500" b="0" dirty="0" err="1">
+                <a:solidFill>
+                  <a:srgbClr val="1F2937"/>
+                </a:solidFill>
+              </a:rPr>
+              <a:t>thái</a:t>
+            </a:r>
+            <a:r>
+              <a:rPr sz="1500" b="0" dirty="0">
+                <a:solidFill>
+                  <a:srgbClr val="1F2937"/>
+                </a:solidFill>
+              </a:rPr>
+              <a:t>/</a:t>
+            </a:r>
+            <a:r>
+              <a:rPr lang="en-US" sz="1500" b="0" dirty="0">
+                <a:solidFill>
+                  <a:srgbClr val="1F2937"/>
+                </a:solidFill>
+              </a:rPr>
+              <a:t>HS</a:t>
+            </a:r>
+            <a:r>
+              <a:rPr sz="1500" b="0" dirty="0">
+                <a:solidFill>
+                  <a:srgbClr val="1F2937"/>
+                </a:solidFill>
+              </a:rPr>
+              <a:t>: </a:t>
+            </a:r>
+            <a:r>
+              <a:rPr sz="1500" b="0" dirty="0" err="1">
+                <a:solidFill>
+                  <a:srgbClr val="1F2937"/>
+                </a:solidFill>
+              </a:rPr>
+              <a:t>Có</a:t>
+            </a:r>
+            <a:r>
+              <a:rPr sz="1500" b="0" dirty="0">
+                <a:solidFill>
+                  <a:srgbClr val="1F2937"/>
+                </a:solidFill>
+              </a:rPr>
+              <a:t> </a:t>
+            </a:r>
+            <a:r>
+              <a:rPr sz="1500" b="0" dirty="0" err="1">
+                <a:solidFill>
+                  <a:srgbClr val="1F2937"/>
+                </a:solidFill>
+              </a:rPr>
+              <a:t>mặt</a:t>
+            </a:r>
+            <a:r>
+              <a:rPr sz="1500" b="0" dirty="0">
+                <a:solidFill>
+                  <a:srgbClr val="1F2937"/>
+                </a:solidFill>
+              </a:rPr>
+              <a:t>, </a:t>
+            </a:r>
+            <a:r>
+              <a:rPr sz="1500" b="0" dirty="0" err="1">
+                <a:solidFill>
+                  <a:srgbClr val="1F2937"/>
+                </a:solidFill>
+              </a:rPr>
+              <a:t>Vắng</a:t>
+            </a:r>
+            <a:r>
+              <a:rPr sz="1500" b="0" dirty="0">
+                <a:solidFill>
+                  <a:srgbClr val="1F2937"/>
+                </a:solidFill>
+              </a:rPr>
+              <a:t> CP, </a:t>
+            </a:r>
+            <a:r>
+              <a:rPr sz="1500" b="0" dirty="0" err="1">
+                <a:solidFill>
+                  <a:srgbClr val="1F2937"/>
+                </a:solidFill>
+              </a:rPr>
+              <a:t>Vắng</a:t>
+            </a:r>
+            <a:r>
+              <a:rPr sz="1500" b="0" dirty="0">
+                <a:solidFill>
+                  <a:srgbClr val="1F2937"/>
+                </a:solidFill>
+              </a:rPr>
+              <a:t> KP, </a:t>
+            </a:r>
+            <a:r>
+              <a:rPr sz="1500" b="0" dirty="0" err="1">
+                <a:solidFill>
+                  <a:srgbClr val="1F2937"/>
+                </a:solidFill>
+              </a:rPr>
+              <a:t>Đi</a:t>
+            </a:r>
+            <a:r>
+              <a:rPr sz="1500" b="0" dirty="0">
+                <a:solidFill>
+                  <a:srgbClr val="1F2937"/>
+                </a:solidFill>
+              </a:rPr>
+              <a:t> </a:t>
+            </a:r>
+            <a:r>
+              <a:rPr sz="1500" b="0" dirty="0" err="1">
+                <a:solidFill>
+                  <a:srgbClr val="1F2937"/>
+                </a:solidFill>
+              </a:rPr>
+              <a:t>muộn</a:t>
+            </a:r>
+            <a:r>
+              <a:rPr sz="1500" b="0" dirty="0">
+                <a:solidFill>
+                  <a:srgbClr val="1F2937"/>
+                </a:solidFill>
+              </a:rPr>
+              <a:t> + </a:t>
+            </a:r>
+            <a:r>
+              <a:rPr sz="1500" b="0" dirty="0" err="1">
+                <a:solidFill>
+                  <a:srgbClr val="1F2937"/>
+                </a:solidFill>
+              </a:rPr>
+              <a:t>thao</a:t>
+            </a:r>
+            <a:r>
+              <a:rPr sz="1500" b="0" dirty="0">
+                <a:solidFill>
+                  <a:srgbClr val="1F2937"/>
+                </a:solidFill>
+              </a:rPr>
+              <a:t> </a:t>
+            </a:r>
+            <a:r>
+              <a:rPr sz="1500" b="0" dirty="0" err="1">
+                <a:solidFill>
+                  <a:srgbClr val="1F2937"/>
+                </a:solidFill>
+              </a:rPr>
+              <a:t>tác</a:t>
+            </a:r>
+            <a:r>
+              <a:rPr sz="1500" b="0" dirty="0">
+                <a:solidFill>
+                  <a:srgbClr val="1F2937"/>
+                </a:solidFill>
+              </a:rPr>
+              <a:t> </a:t>
+            </a:r>
+            <a:r>
+              <a:rPr sz="1500" b="0" dirty="0" err="1">
+                <a:solidFill>
+                  <a:srgbClr val="1F2937"/>
+                </a:solidFill>
+              </a:rPr>
+              <a:t>nhanh</a:t>
+            </a:r>
+            <a:endParaRPr sz="1500" b="0" dirty="0">
+              <a:solidFill>
+                <a:srgbClr val="1F2937"/>
+              </a:solidFill>
+            </a:endParaRPr>
+          </a:p>
+          <a:p>
+            <a:r>
+              <a:rPr sz="1500" b="0" dirty="0">
+                <a:solidFill>
+                  <a:srgbClr val="1F2937"/>
+                </a:solidFill>
+              </a:rPr>
+              <a:t>- </a:t>
+            </a:r>
+            <a:r>
+              <a:rPr sz="1500" b="0" dirty="0" err="1">
+                <a:solidFill>
+                  <a:srgbClr val="1F2937"/>
+                </a:solidFill>
+              </a:rPr>
+              <a:t>Chọn</a:t>
+            </a:r>
+            <a:r>
+              <a:rPr sz="1500" b="0" dirty="0">
+                <a:solidFill>
+                  <a:srgbClr val="1F2937"/>
+                </a:solidFill>
+              </a:rPr>
+              <a:t> </a:t>
+            </a:r>
+            <a:r>
+              <a:rPr sz="1500" b="0" dirty="0" err="1">
+                <a:solidFill>
+                  <a:srgbClr val="1F2937"/>
+                </a:solidFill>
+              </a:rPr>
+              <a:t>ngày</a:t>
+            </a:r>
+            <a:r>
+              <a:rPr sz="1500" b="0" dirty="0">
+                <a:solidFill>
+                  <a:srgbClr val="1F2937"/>
+                </a:solidFill>
+              </a:rPr>
+              <a:t> </a:t>
+            </a:r>
+            <a:r>
+              <a:rPr sz="1500" b="0" dirty="0" err="1">
+                <a:solidFill>
+                  <a:srgbClr val="1F2937"/>
+                </a:solidFill>
+              </a:rPr>
+              <a:t>bất</a:t>
+            </a:r>
+            <a:r>
+              <a:rPr sz="1500" b="0" dirty="0">
+                <a:solidFill>
+                  <a:srgbClr val="1F2937"/>
+                </a:solidFill>
+              </a:rPr>
+              <a:t> </a:t>
+            </a:r>
+            <a:r>
+              <a:rPr sz="1500" b="0" dirty="0" err="1">
+                <a:solidFill>
+                  <a:srgbClr val="1F2937"/>
+                </a:solidFill>
+              </a:rPr>
+              <a:t>kỳ</a:t>
+            </a:r>
+            <a:r>
+              <a:rPr sz="1500" b="0" dirty="0">
+                <a:solidFill>
+                  <a:srgbClr val="1F2937"/>
+                </a:solidFill>
+              </a:rPr>
+              <a:t> </a:t>
+            </a:r>
+            <a:r>
+              <a:rPr sz="1500" b="0" dirty="0" err="1">
+                <a:solidFill>
+                  <a:srgbClr val="1F2937"/>
+                </a:solidFill>
+              </a:rPr>
+              <a:t>để</a:t>
+            </a:r>
+            <a:r>
+              <a:rPr sz="1500" b="0" dirty="0">
+                <a:solidFill>
+                  <a:srgbClr val="1F2937"/>
+                </a:solidFill>
+              </a:rPr>
+              <a:t> </a:t>
+            </a:r>
+            <a:r>
+              <a:rPr sz="1500" b="0" dirty="0" err="1">
+                <a:solidFill>
+                  <a:srgbClr val="1F2937"/>
+                </a:solidFill>
+              </a:rPr>
+              <a:t>xem</a:t>
+            </a:r>
+            <a:r>
+              <a:rPr sz="1500" b="0" dirty="0">
+                <a:solidFill>
+                  <a:srgbClr val="1F2937"/>
+                </a:solidFill>
+              </a:rPr>
+              <a:t> </a:t>
+            </a:r>
+            <a:r>
+              <a:rPr sz="1500" b="0" dirty="0" err="1">
+                <a:solidFill>
+                  <a:srgbClr val="1F2937"/>
+                </a:solidFill>
+              </a:rPr>
+              <a:t>lại</a:t>
+            </a:r>
+            <a:r>
+              <a:rPr sz="1500" b="0" dirty="0">
+                <a:solidFill>
+                  <a:srgbClr val="1F2937"/>
+                </a:solidFill>
+              </a:rPr>
+              <a:t> / </a:t>
+            </a:r>
+            <a:r>
+              <a:rPr sz="1500" b="0" dirty="0" err="1">
+                <a:solidFill>
+                  <a:srgbClr val="1F2937"/>
+                </a:solidFill>
+              </a:rPr>
+              <a:t>sửa</a:t>
+            </a:r>
+            <a:r>
+              <a:rPr sz="1500" b="0" dirty="0">
+                <a:solidFill>
+                  <a:srgbClr val="1F2937"/>
+                </a:solidFill>
+              </a:rPr>
+              <a:t> </a:t>
+            </a:r>
+            <a:r>
+              <a:rPr sz="1500" b="0" dirty="0" err="1">
+                <a:solidFill>
+                  <a:srgbClr val="1F2937"/>
+                </a:solidFill>
+              </a:rPr>
+              <a:t>điểm</a:t>
+            </a:r>
+            <a:r>
+              <a:rPr sz="1500" b="0" dirty="0">
+                <a:solidFill>
+                  <a:srgbClr val="1F2937"/>
+                </a:solidFill>
+              </a:rPr>
+              <a:t> </a:t>
+            </a:r>
+            <a:r>
+              <a:rPr sz="1500" b="0" dirty="0" err="1">
+                <a:solidFill>
+                  <a:srgbClr val="1F2937"/>
+                </a:solidFill>
+              </a:rPr>
+              <a:t>danh</a:t>
+            </a:r>
+            <a:r>
+              <a:rPr sz="1500" b="0" dirty="0">
+                <a:solidFill>
+                  <a:srgbClr val="1F2937"/>
+                </a:solidFill>
+              </a:rPr>
+              <a:t> </a:t>
+            </a:r>
+            <a:r>
+              <a:rPr sz="1500" b="0" dirty="0" err="1">
+                <a:solidFill>
+                  <a:srgbClr val="1F2937"/>
+                </a:solidFill>
+              </a:rPr>
+              <a:t>ngày</a:t>
+            </a:r>
+            <a:r>
+              <a:rPr sz="1500" b="0" dirty="0">
+                <a:solidFill>
+                  <a:srgbClr val="1F2937"/>
+                </a:solidFill>
+              </a:rPr>
+              <a:t> </a:t>
+            </a:r>
+            <a:r>
+              <a:rPr sz="1500" b="0" dirty="0" err="1">
+                <a:solidFill>
+                  <a:srgbClr val="1F2937"/>
+                </a:solidFill>
+              </a:rPr>
+              <a:t>cũ</a:t>
+            </a:r>
+            <a:endParaRPr sz="1500" b="0" dirty="0">
+              <a:solidFill>
+                <a:srgbClr val="1F2937"/>
+              </a:solidFill>
+            </a:endParaRPr>
+          </a:p>
+          <a:p>
+            <a:r>
+              <a:rPr sz="1500" b="0" dirty="0">
+                <a:solidFill>
+                  <a:srgbClr val="1F2937"/>
+                </a:solidFill>
+              </a:rPr>
+              <a:t>- </a:t>
+            </a:r>
+            <a:r>
+              <a:rPr sz="1500" b="0" dirty="0" err="1">
+                <a:solidFill>
+                  <a:srgbClr val="1F2937"/>
+                </a:solidFill>
+              </a:rPr>
+              <a:t>Sổ</a:t>
+            </a:r>
+            <a:r>
+              <a:rPr sz="1500" b="0" dirty="0">
+                <a:solidFill>
+                  <a:srgbClr val="1F2937"/>
+                </a:solidFill>
+              </a:rPr>
+              <a:t> </a:t>
+            </a:r>
+            <a:r>
+              <a:rPr sz="1500" b="0" dirty="0" err="1">
+                <a:solidFill>
+                  <a:srgbClr val="1F2937"/>
+                </a:solidFill>
+              </a:rPr>
+              <a:t>vắng-muộn</a:t>
+            </a:r>
+            <a:r>
+              <a:rPr sz="1500" b="0" dirty="0">
+                <a:solidFill>
+                  <a:srgbClr val="1F2937"/>
+                </a:solidFill>
+              </a:rPr>
+              <a:t> </a:t>
+            </a:r>
+            <a:r>
+              <a:rPr sz="1500" b="0" dirty="0" err="1">
+                <a:solidFill>
+                  <a:srgbClr val="1F2937"/>
+                </a:solidFill>
+              </a:rPr>
+              <a:t>và</a:t>
+            </a:r>
+            <a:r>
+              <a:rPr sz="1500" b="0" dirty="0">
+                <a:solidFill>
+                  <a:srgbClr val="1F2937"/>
+                </a:solidFill>
+              </a:rPr>
+              <a:t> </a:t>
+            </a:r>
+            <a:r>
+              <a:rPr sz="1500" b="0" dirty="0" err="1">
+                <a:solidFill>
+                  <a:srgbClr val="1F2937"/>
+                </a:solidFill>
+              </a:rPr>
+              <a:t>lịch</a:t>
+            </a:r>
+            <a:r>
+              <a:rPr sz="1500" b="0" dirty="0">
+                <a:solidFill>
+                  <a:srgbClr val="1F2937"/>
+                </a:solidFill>
+              </a:rPr>
+              <a:t> </a:t>
+            </a:r>
+            <a:r>
+              <a:rPr sz="1500" b="0" dirty="0" err="1">
+                <a:solidFill>
+                  <a:srgbClr val="1F2937"/>
+                </a:solidFill>
+              </a:rPr>
+              <a:t>sử</a:t>
+            </a:r>
+            <a:r>
+              <a:rPr sz="1500" b="0" dirty="0">
+                <a:solidFill>
+                  <a:srgbClr val="1F2937"/>
+                </a:solidFill>
+              </a:rPr>
+              <a:t> </a:t>
+            </a:r>
+            <a:r>
+              <a:rPr sz="1500" b="0" dirty="0" err="1">
+                <a:solidFill>
+                  <a:srgbClr val="1F2937"/>
+                </a:solidFill>
+              </a:rPr>
+              <a:t>theo</a:t>
+            </a:r>
+            <a:r>
+              <a:rPr sz="1500" b="0" dirty="0">
+                <a:solidFill>
+                  <a:srgbClr val="1F2937"/>
+                </a:solidFill>
+              </a:rPr>
+              <a:t> </a:t>
+            </a:r>
+            <a:r>
+              <a:rPr sz="1500" b="0" dirty="0" err="1">
+                <a:solidFill>
+                  <a:srgbClr val="1F2937"/>
+                </a:solidFill>
+              </a:rPr>
+              <a:t>khoảng</a:t>
+            </a:r>
+            <a:r>
+              <a:rPr sz="1500" b="0" dirty="0">
+                <a:solidFill>
+                  <a:srgbClr val="1F2937"/>
+                </a:solidFill>
+              </a:rPr>
+              <a:t> </a:t>
+            </a:r>
+            <a:r>
+              <a:rPr sz="1500" b="0" dirty="0" err="1">
+                <a:solidFill>
+                  <a:srgbClr val="1F2937"/>
+                </a:solidFill>
+              </a:rPr>
+              <a:t>ngày</a:t>
+            </a:r>
+            <a:r>
+              <a:rPr sz="1500" b="0" dirty="0">
+                <a:solidFill>
+                  <a:srgbClr val="1F2937"/>
+                </a:solidFill>
+              </a:rPr>
+              <a:t> (from - to)</a:t>
+            </a:r>
+          </a:p>
+          <a:p>
+            <a:r>
+              <a:rPr sz="1500" b="0" dirty="0">
+                <a:solidFill>
+                  <a:srgbClr val="1F2937"/>
+                </a:solidFill>
+              </a:rPr>
+              <a:t>- Ma </a:t>
+            </a:r>
+            <a:r>
+              <a:rPr sz="1500" b="0" dirty="0" err="1">
+                <a:solidFill>
+                  <a:srgbClr val="1F2937"/>
+                </a:solidFill>
+              </a:rPr>
+              <a:t>trận</a:t>
+            </a:r>
+            <a:r>
+              <a:rPr sz="1500" b="0" dirty="0">
+                <a:solidFill>
+                  <a:srgbClr val="1F2937"/>
+                </a:solidFill>
+              </a:rPr>
+              <a:t> HS x </a:t>
+            </a:r>
+            <a:r>
+              <a:rPr sz="1500" b="0" dirty="0" err="1">
+                <a:solidFill>
+                  <a:srgbClr val="1F2937"/>
+                </a:solidFill>
+              </a:rPr>
+              <a:t>ngày</a:t>
+            </a:r>
+            <a:r>
+              <a:rPr sz="1500" b="0" dirty="0">
+                <a:solidFill>
+                  <a:srgbClr val="1F2937"/>
+                </a:solidFill>
+              </a:rPr>
+              <a:t> </a:t>
+            </a:r>
+            <a:r>
+              <a:rPr sz="1500" b="0" dirty="0" err="1">
+                <a:solidFill>
+                  <a:srgbClr val="1F2937"/>
+                </a:solidFill>
+              </a:rPr>
+              <a:t>phát</a:t>
+            </a:r>
+            <a:r>
+              <a:rPr sz="1500" b="0" dirty="0">
+                <a:solidFill>
+                  <a:srgbClr val="1F2937"/>
+                </a:solidFill>
+              </a:rPr>
+              <a:t> </a:t>
+            </a:r>
+            <a:r>
+              <a:rPr sz="1500" b="0" dirty="0" err="1">
+                <a:solidFill>
+                  <a:srgbClr val="1F2937"/>
+                </a:solidFill>
+              </a:rPr>
+              <a:t>hiện</a:t>
+            </a:r>
+            <a:r>
+              <a:rPr sz="1500" b="0" dirty="0">
+                <a:solidFill>
+                  <a:srgbClr val="1F2937"/>
+                </a:solidFill>
+              </a:rPr>
+              <a:t> </a:t>
+            </a:r>
+            <a:r>
+              <a:rPr sz="1500" b="0" dirty="0" err="1">
+                <a:solidFill>
+                  <a:srgbClr val="1F2937"/>
+                </a:solidFill>
+              </a:rPr>
+              <a:t>vắng</a:t>
+            </a:r>
+            <a:r>
+              <a:rPr sz="1500" b="0" dirty="0">
+                <a:solidFill>
+                  <a:srgbClr val="1F2937"/>
+                </a:solidFill>
+              </a:rPr>
+              <a:t> </a:t>
+            </a:r>
+            <a:r>
+              <a:rPr sz="1500" b="0" dirty="0" err="1">
+                <a:solidFill>
+                  <a:srgbClr val="1F2937"/>
+                </a:solidFill>
+              </a:rPr>
+              <a:t>liên</a:t>
+            </a:r>
+            <a:r>
+              <a:rPr sz="1500" b="0" dirty="0">
+                <a:solidFill>
+                  <a:srgbClr val="1F2937"/>
+                </a:solidFill>
+              </a:rPr>
+              <a:t> </a:t>
+            </a:r>
+            <a:r>
+              <a:rPr sz="1500" b="0" dirty="0" err="1">
+                <a:solidFill>
+                  <a:srgbClr val="1F2937"/>
+                </a:solidFill>
+              </a:rPr>
+              <a:t>tục</a:t>
+            </a:r>
+            <a:endParaRPr sz="1500" b="0" dirty="0">
+              <a:solidFill>
+                <a:srgbClr val="1F2937"/>
+              </a:solidFill>
+            </a:endParaRPr>
+          </a:p>
+          <a:p>
+            <a:r>
+              <a:rPr sz="1500" b="0" dirty="0">
+                <a:solidFill>
+                  <a:srgbClr val="1F2937"/>
+                </a:solidFill>
+              </a:rPr>
+              <a:t>- </a:t>
+            </a:r>
+            <a:r>
+              <a:rPr sz="1500" b="0" dirty="0" err="1">
+                <a:solidFill>
+                  <a:srgbClr val="1F2937"/>
+                </a:solidFill>
+              </a:rPr>
+              <a:t>Thông</a:t>
+            </a:r>
+            <a:r>
+              <a:rPr sz="1500" b="0" dirty="0">
+                <a:solidFill>
+                  <a:srgbClr val="1F2937"/>
+                </a:solidFill>
+              </a:rPr>
+              <a:t> </a:t>
+            </a:r>
+            <a:r>
+              <a:rPr sz="1500" b="0" dirty="0" err="1">
+                <a:solidFill>
+                  <a:srgbClr val="1F2937"/>
+                </a:solidFill>
+              </a:rPr>
+              <a:t>báo</a:t>
+            </a:r>
+            <a:r>
+              <a:rPr sz="1500" b="0" dirty="0">
+                <a:solidFill>
+                  <a:srgbClr val="1F2937"/>
+                </a:solidFill>
+              </a:rPr>
+              <a:t> </a:t>
+            </a:r>
+            <a:r>
+              <a:rPr sz="1500" b="0" dirty="0" err="1">
+                <a:solidFill>
+                  <a:srgbClr val="1F2937"/>
+                </a:solidFill>
+              </a:rPr>
+              <a:t>phụ</a:t>
+            </a:r>
+            <a:r>
+              <a:rPr sz="1500" b="0" dirty="0">
+                <a:solidFill>
+                  <a:srgbClr val="1F2937"/>
+                </a:solidFill>
+              </a:rPr>
+              <a:t> </a:t>
+            </a:r>
+            <a:r>
+              <a:rPr sz="1500" b="0" dirty="0" err="1">
+                <a:solidFill>
+                  <a:srgbClr val="1F2937"/>
+                </a:solidFill>
+              </a:rPr>
+              <a:t>huynh</a:t>
+            </a:r>
+            <a:r>
+              <a:rPr sz="1500" b="0" dirty="0">
+                <a:solidFill>
+                  <a:srgbClr val="1F2937"/>
+                </a:solidFill>
+              </a:rPr>
+              <a:t> </a:t>
+            </a:r>
+            <a:r>
+              <a:rPr sz="1500" b="0" dirty="0" err="1">
+                <a:solidFill>
+                  <a:srgbClr val="1F2937"/>
+                </a:solidFill>
+              </a:rPr>
+              <a:t>tự</a:t>
+            </a:r>
+            <a:r>
+              <a:rPr sz="1500" b="0" dirty="0">
+                <a:solidFill>
+                  <a:srgbClr val="1F2937"/>
+                </a:solidFill>
+              </a:rPr>
+              <a:t> </a:t>
+            </a:r>
+            <a:r>
+              <a:rPr sz="1500" b="0" dirty="0" err="1">
+                <a:solidFill>
+                  <a:srgbClr val="1F2937"/>
+                </a:solidFill>
+              </a:rPr>
+              <a:t>động</a:t>
+            </a:r>
+            <a:r>
+              <a:rPr sz="1500" b="0" dirty="0">
+                <a:solidFill>
+                  <a:srgbClr val="1F2937"/>
+                </a:solidFill>
+              </a:rPr>
+              <a:t> (email + in-app)</a:t>
+            </a:r>
+          </a:p>
+          <a:p>
+            <a:r>
+              <a:rPr sz="1500" b="0" dirty="0">
+                <a:solidFill>
+                  <a:srgbClr val="1F2937"/>
+                </a:solidFill>
+              </a:rPr>
+              <a:t>- </a:t>
+            </a:r>
+            <a:r>
+              <a:rPr sz="1500" b="0" dirty="0" err="1">
+                <a:solidFill>
+                  <a:srgbClr val="1F2937"/>
+                </a:solidFill>
+              </a:rPr>
+              <a:t>Đồng</a:t>
+            </a:r>
+            <a:r>
+              <a:rPr sz="1500" b="0" dirty="0">
+                <a:solidFill>
+                  <a:srgbClr val="1F2937"/>
+                </a:solidFill>
+              </a:rPr>
+              <a:t> </a:t>
+            </a:r>
+            <a:r>
+              <a:rPr sz="1500" b="0" dirty="0" err="1">
+                <a:solidFill>
+                  <a:srgbClr val="1F2937"/>
+                </a:solidFill>
+              </a:rPr>
+              <a:t>bộ</a:t>
+            </a:r>
+            <a:r>
+              <a:rPr sz="1500" b="0" dirty="0">
+                <a:solidFill>
+                  <a:srgbClr val="1F2937"/>
+                </a:solidFill>
+              </a:rPr>
+              <a:t> 2 </a:t>
+            </a:r>
+            <a:r>
+              <a:rPr sz="1500" b="0" dirty="0" err="1">
+                <a:solidFill>
+                  <a:srgbClr val="1F2937"/>
+                </a:solidFill>
+              </a:rPr>
+              <a:t>chiều</a:t>
+            </a:r>
+            <a:r>
+              <a:rPr sz="1500" b="0" dirty="0">
+                <a:solidFill>
+                  <a:srgbClr val="1F2937"/>
+                </a:solidFill>
+              </a:rPr>
+              <a:t> </a:t>
+            </a:r>
+            <a:r>
+              <a:rPr sz="1500" b="0" dirty="0" err="1">
+                <a:solidFill>
+                  <a:srgbClr val="1F2937"/>
+                </a:solidFill>
+              </a:rPr>
+              <a:t>với</a:t>
+            </a:r>
+            <a:r>
+              <a:rPr sz="1500" b="0" dirty="0">
+                <a:solidFill>
+                  <a:srgbClr val="1F2937"/>
+                </a:solidFill>
+              </a:rPr>
+              <a:t> </a:t>
+            </a:r>
+            <a:r>
+              <a:rPr sz="1500" b="0" dirty="0" err="1">
+                <a:solidFill>
+                  <a:srgbClr val="1F2937"/>
+                </a:solidFill>
+              </a:rPr>
+              <a:t>sổ</a:t>
+            </a:r>
+            <a:r>
+              <a:rPr sz="1500" b="0" dirty="0">
+                <a:solidFill>
+                  <a:srgbClr val="1F2937"/>
+                </a:solidFill>
+              </a:rPr>
+              <a:t> </a:t>
+            </a:r>
+            <a:r>
+              <a:rPr sz="1500" b="0" dirty="0" err="1">
+                <a:solidFill>
+                  <a:srgbClr val="1F2937"/>
+                </a:solidFill>
+              </a:rPr>
+              <a:t>đầu</a:t>
+            </a:r>
+            <a:r>
+              <a:rPr sz="1500" b="0" dirty="0">
+                <a:solidFill>
+                  <a:srgbClr val="1F2937"/>
+                </a:solidFill>
+              </a:rPr>
+              <a:t> </a:t>
+            </a:r>
+            <a:r>
+              <a:rPr sz="1500" b="0" dirty="0" err="1">
+                <a:solidFill>
+                  <a:srgbClr val="1F2937"/>
+                </a:solidFill>
+              </a:rPr>
+              <a:t>bài</a:t>
+            </a:r>
+            <a:r>
+              <a:rPr sz="1500" b="0" dirty="0">
+                <a:solidFill>
+                  <a:srgbClr val="1F2937"/>
+                </a:solidFill>
+              </a:rPr>
+              <a:t> </a:t>
+            </a:r>
+            <a:r>
+              <a:rPr sz="1500" b="0" dirty="0" err="1">
+                <a:solidFill>
+                  <a:srgbClr val="1F2937"/>
+                </a:solidFill>
+              </a:rPr>
+              <a:t>tiết</a:t>
+            </a:r>
+            <a:r>
+              <a:rPr sz="1500" b="0" dirty="0">
+                <a:solidFill>
+                  <a:srgbClr val="1F2937"/>
+                </a:solidFill>
+              </a:rPr>
+              <a:t> </a:t>
+            </a:r>
+            <a:r>
+              <a:rPr sz="1500" b="0" dirty="0" err="1">
+                <a:solidFill>
+                  <a:srgbClr val="1F2937"/>
+                </a:solidFill>
+              </a:rPr>
+              <a:t>học</a:t>
+            </a:r>
+            <a:endParaRPr sz="1500" b="0" dirty="0">
+              <a:solidFill>
+                <a:srgbClr val="1F2937"/>
+              </a:solidFill>
+            </a:endParaRPr>
           </a:p>
         </p:txBody>
       </p:sp>
@@ -4879,7 +6789,6 @@
           </a:bodyPr>
           <a:lstStyle/>
           <a:p>
-            <a:pPr/>
             <a:r>
               <a:rPr sz="1100" b="0">
                 <a:solidFill>
@@ -4900,7 +6809,7 @@
 </file>
 
 <file path=ppt/slides/slide5.xml><?xml version="1.0" encoding="utf-8"?>
-<p:sld xmlns:a="http://schemas.openxmlformats.org/drawingml/2006/main" xmlns:p="http://schemas.openxmlformats.org/presentationml/2006/main" xmlns:r="http://schemas.openxmlformats.org/officeDocument/2006/relationships">
+<p:sld xmlns:a="http://schemas.openxmlformats.org/drawingml/2006/main" xmlns:r="http://schemas.openxmlformats.org/officeDocument/2006/relationships" xmlns:p="http://schemas.openxmlformats.org/presentationml/2006/main">
   <p:cSld>
     <p:spTree>
       <p:nvGrpSpPr>
@@ -4908,7 +6817,14 @@
         <p:cNvGrpSpPr/>
         <p:nvPr/>
       </p:nvGrpSpPr>
-      <p:grpSpPr/>
+      <p:grpSpPr>
+        <a:xfrm>
+          <a:off x="0" y="0"/>
+          <a:ext cx="0" cy="0"/>
+          <a:chOff x="0" y="0"/>
+          <a:chExt cx="0" cy="0"/>
+        </a:xfrm>
+      </p:grpSpPr>
       <p:sp>
         <p:nvSpPr>
           <p:cNvPr id="2" name="Rectangle 1"/>
@@ -4949,6 +6865,7 @@
           <a:lstStyle/>
           <a:p>
             <a:pPr algn="ctr"/>
+            <a:endParaRPr/>
           </a:p>
         </p:txBody>
       </p:sp>
@@ -4974,7 +6891,6 @@
           </a:bodyPr>
           <a:lstStyle/>
           <a:p>
-            <a:pPr/>
             <a:r>
               <a:rPr sz="2800" b="1">
                 <a:solidFill>
@@ -5008,7 +6924,6 @@
           </a:bodyPr>
           <a:lstStyle/>
           <a:p>
-            <a:pPr/>
             <a:r>
               <a:rPr sz="1500" b="0">
                 <a:solidFill>
@@ -5019,7 +6934,6 @@
             </a:r>
           </a:p>
           <a:p>
-            <a:pPr/>
             <a:r>
               <a:rPr sz="1500" b="0">
                 <a:solidFill>
@@ -5030,7 +6944,6 @@
             </a:r>
           </a:p>
           <a:p>
-            <a:pPr/>
             <a:r>
               <a:rPr sz="1500" b="0">
                 <a:solidFill>
@@ -5041,7 +6954,6 @@
             </a:r>
           </a:p>
           <a:p>
-            <a:pPr/>
             <a:r>
               <a:rPr sz="1500" b="0">
                 <a:solidFill>
@@ -5052,7 +6964,6 @@
             </a:r>
           </a:p>
           <a:p>
-            <a:pPr/>
             <a:r>
               <a:rPr sz="1500" b="0">
                 <a:solidFill>
@@ -5115,7 +7026,6 @@
           </a:bodyPr>
           <a:lstStyle/>
           <a:p>
-            <a:pPr/>
             <a:r>
               <a:rPr sz="1100" b="0">
                 <a:solidFill>
@@ -5136,7 +7046,7 @@
 </file>
 
 <file path=ppt/slides/slide6.xml><?xml version="1.0" encoding="utf-8"?>
-<p:sld xmlns:a="http://schemas.openxmlformats.org/drawingml/2006/main" xmlns:p="http://schemas.openxmlformats.org/presentationml/2006/main" xmlns:r="http://schemas.openxmlformats.org/officeDocument/2006/relationships">
+<p:sld xmlns:a="http://schemas.openxmlformats.org/drawingml/2006/main" xmlns:r="http://schemas.openxmlformats.org/officeDocument/2006/relationships" xmlns:p="http://schemas.openxmlformats.org/presentationml/2006/main">
   <p:cSld>
     <p:spTree>
       <p:nvGrpSpPr>
@@ -5144,7 +7054,14 @@
         <p:cNvGrpSpPr/>
         <p:nvPr/>
       </p:nvGrpSpPr>
-      <p:grpSpPr/>
+      <p:grpSpPr>
+        <a:xfrm>
+          <a:off x="0" y="0"/>
+          <a:ext cx="0" cy="0"/>
+          <a:chOff x="0" y="0"/>
+          <a:chExt cx="0" cy="0"/>
+        </a:xfrm>
+      </p:grpSpPr>
       <p:sp>
         <p:nvSpPr>
           <p:cNvPr id="2" name="Rectangle 1"/>
@@ -5185,6 +7102,7 @@
           <a:lstStyle/>
           <a:p>
             <a:pPr algn="ctr"/>
+            <a:endParaRPr/>
           </a:p>
         </p:txBody>
       </p:sp>
@@ -5210,7 +7128,6 @@
           </a:bodyPr>
           <a:lstStyle/>
           <a:p>
-            <a:pPr/>
             <a:r>
               <a:rPr sz="2800" b="1">
                 <a:solidFill>
@@ -5244,7 +7161,6 @@
           </a:bodyPr>
           <a:lstStyle/>
           <a:p>
-            <a:pPr/>
             <a:r>
               <a:rPr sz="1500" b="0">
                 <a:solidFill>
@@ -5255,7 +7171,6 @@
             </a:r>
           </a:p>
           <a:p>
-            <a:pPr/>
             <a:r>
               <a:rPr sz="1500" b="0">
                 <a:solidFill>
@@ -5266,7 +7181,6 @@
             </a:r>
           </a:p>
           <a:p>
-            <a:pPr/>
             <a:r>
               <a:rPr sz="1500" b="0">
                 <a:solidFill>
@@ -5277,7 +7191,6 @@
             </a:r>
           </a:p>
           <a:p>
-            <a:pPr/>
             <a:r>
               <a:rPr sz="1500" b="0">
                 <a:solidFill>
@@ -5288,7 +7201,6 @@
             </a:r>
           </a:p>
           <a:p>
-            <a:pPr/>
             <a:r>
               <a:rPr sz="1500" b="0">
                 <a:solidFill>
@@ -5299,7 +7211,6 @@
             </a:r>
           </a:p>
           <a:p>
-            <a:pPr/>
             <a:r>
               <a:rPr sz="1500" b="0">
                 <a:solidFill>
@@ -5362,7 +7273,6 @@
           </a:bodyPr>
           <a:lstStyle/>
           <a:p>
-            <a:pPr/>
             <a:r>
               <a:rPr sz="1100" b="0">
                 <a:solidFill>
@@ -5383,7 +7293,7 @@
 </file>
 
 <file path=ppt/slides/slide7.xml><?xml version="1.0" encoding="utf-8"?>
-<p:sld xmlns:a="http://schemas.openxmlformats.org/drawingml/2006/main" xmlns:p="http://schemas.openxmlformats.org/presentationml/2006/main" xmlns:r="http://schemas.openxmlformats.org/officeDocument/2006/relationships">
+<p:sld xmlns:a="http://schemas.openxmlformats.org/drawingml/2006/main" xmlns:r="http://schemas.openxmlformats.org/officeDocument/2006/relationships" xmlns:p="http://schemas.openxmlformats.org/presentationml/2006/main">
   <p:cSld>
     <p:spTree>
       <p:nvGrpSpPr>
@@ -5391,7 +7301,14 @@
         <p:cNvGrpSpPr/>
         <p:nvPr/>
       </p:nvGrpSpPr>
-      <p:grpSpPr/>
+      <p:grpSpPr>
+        <a:xfrm>
+          <a:off x="0" y="0"/>
+          <a:ext cx="0" cy="0"/>
+          <a:chOff x="0" y="0"/>
+          <a:chExt cx="0" cy="0"/>
+        </a:xfrm>
+      </p:grpSpPr>
       <p:sp>
         <p:nvSpPr>
           <p:cNvPr id="2" name="Rectangle 1"/>
@@ -5432,6 +7349,7 @@
           <a:lstStyle/>
           <a:p>
             <a:pPr algn="ctr"/>
+            <a:endParaRPr/>
           </a:p>
         </p:txBody>
       </p:sp>
@@ -5457,7 +7375,6 @@
           </a:bodyPr>
           <a:lstStyle/>
           <a:p>
-            <a:pPr/>
             <a:r>
               <a:rPr sz="2800" b="1">
                 <a:solidFill>
@@ -5491,7 +7408,6 @@
           </a:bodyPr>
           <a:lstStyle/>
           <a:p>
-            <a:pPr/>
             <a:r>
               <a:rPr sz="1500" b="0">
                 <a:solidFill>
@@ -5502,7 +7418,6 @@
             </a:r>
           </a:p>
           <a:p>
-            <a:pPr/>
             <a:r>
               <a:rPr sz="1500" b="0">
                 <a:solidFill>
@@ -5513,7 +7428,6 @@
             </a:r>
           </a:p>
           <a:p>
-            <a:pPr/>
             <a:r>
               <a:rPr sz="1500" b="0">
                 <a:solidFill>
@@ -5524,7 +7438,6 @@
             </a:r>
           </a:p>
           <a:p>
-            <a:pPr/>
             <a:r>
               <a:rPr sz="1500" b="0">
                 <a:solidFill>
@@ -5535,7 +7448,6 @@
             </a:r>
           </a:p>
           <a:p>
-            <a:pPr/>
             <a:r>
               <a:rPr sz="1500" b="0">
                 <a:solidFill>
@@ -5598,7 +7510,6 @@
           </a:bodyPr>
           <a:lstStyle/>
           <a:p>
-            <a:pPr/>
             <a:r>
               <a:rPr sz="1100" b="0">
                 <a:solidFill>
@@ -5619,7 +7530,7 @@
 </file>
 
 <file path=ppt/slides/slide8.xml><?xml version="1.0" encoding="utf-8"?>
-<p:sld xmlns:a="http://schemas.openxmlformats.org/drawingml/2006/main" xmlns:p="http://schemas.openxmlformats.org/presentationml/2006/main" xmlns:r="http://schemas.openxmlformats.org/officeDocument/2006/relationships">
+<p:sld xmlns:a="http://schemas.openxmlformats.org/drawingml/2006/main" xmlns:r="http://schemas.openxmlformats.org/officeDocument/2006/relationships" xmlns:p="http://schemas.openxmlformats.org/presentationml/2006/main">
   <p:cSld>
     <p:spTree>
       <p:nvGrpSpPr>
@@ -5627,7 +7538,14 @@
         <p:cNvGrpSpPr/>
         <p:nvPr/>
       </p:nvGrpSpPr>
-      <p:grpSpPr/>
+      <p:grpSpPr>
+        <a:xfrm>
+          <a:off x="0" y="0"/>
+          <a:ext cx="0" cy="0"/>
+          <a:chOff x="0" y="0"/>
+          <a:chExt cx="0" cy="0"/>
+        </a:xfrm>
+      </p:grpSpPr>
       <p:sp>
         <p:nvSpPr>
           <p:cNvPr id="2" name="Rectangle 1"/>
@@ -5668,6 +7586,7 @@
           <a:lstStyle/>
           <a:p>
             <a:pPr algn="ctr"/>
+            <a:endParaRPr/>
           </a:p>
         </p:txBody>
       </p:sp>
@@ -5693,7 +7612,6 @@
           </a:bodyPr>
           <a:lstStyle/>
           <a:p>
-            <a:pPr/>
             <a:r>
               <a:rPr sz="2800" b="1">
                 <a:solidFill>
@@ -5727,7 +7645,6 @@
           </a:bodyPr>
           <a:lstStyle/>
           <a:p>
-            <a:pPr/>
             <a:r>
               <a:rPr sz="1500" b="0">
                 <a:solidFill>
@@ -5738,7 +7655,6 @@
             </a:r>
           </a:p>
           <a:p>
-            <a:pPr/>
             <a:r>
               <a:rPr sz="1500" b="0">
                 <a:solidFill>
@@ -5749,7 +7665,6 @@
             </a:r>
           </a:p>
           <a:p>
-            <a:pPr/>
             <a:r>
               <a:rPr sz="1500" b="0">
                 <a:solidFill>
@@ -5760,7 +7675,6 @@
             </a:r>
           </a:p>
           <a:p>
-            <a:pPr/>
             <a:r>
               <a:rPr sz="1500" b="0">
                 <a:solidFill>
@@ -5771,7 +7685,6 @@
             </a:r>
           </a:p>
           <a:p>
-            <a:pPr/>
             <a:r>
               <a:rPr sz="1500" b="0">
                 <a:solidFill>
@@ -5834,7 +7747,6 @@
           </a:bodyPr>
           <a:lstStyle/>
           <a:p>
-            <a:pPr/>
             <a:r>
               <a:rPr sz="1100" b="0">
                 <a:solidFill>
@@ -5855,7 +7767,7 @@
 </file>
 
 <file path=ppt/slides/slide9.xml><?xml version="1.0" encoding="utf-8"?>
-<p:sld xmlns:a="http://schemas.openxmlformats.org/drawingml/2006/main" xmlns:p="http://schemas.openxmlformats.org/presentationml/2006/main" xmlns:r="http://schemas.openxmlformats.org/officeDocument/2006/relationships">
+<p:sld xmlns:a="http://schemas.openxmlformats.org/drawingml/2006/main" xmlns:r="http://schemas.openxmlformats.org/officeDocument/2006/relationships" xmlns:p="http://schemas.openxmlformats.org/presentationml/2006/main">
   <p:cSld>
     <p:spTree>
       <p:nvGrpSpPr>
@@ -5863,7 +7775,14 @@
         <p:cNvGrpSpPr/>
         <p:nvPr/>
       </p:nvGrpSpPr>
-      <p:grpSpPr/>
+      <p:grpSpPr>
+        <a:xfrm>
+          <a:off x="0" y="0"/>
+          <a:ext cx="0" cy="0"/>
+          <a:chOff x="0" y="0"/>
+          <a:chExt cx="0" cy="0"/>
+        </a:xfrm>
+      </p:grpSpPr>
       <p:sp>
         <p:nvSpPr>
           <p:cNvPr id="2" name="Rectangle 1"/>
@@ -5904,6 +7823,7 @@
           <a:lstStyle/>
           <a:p>
             <a:pPr algn="ctr"/>
+            <a:endParaRPr/>
           </a:p>
         </p:txBody>
       </p:sp>
@@ -5929,7 +7849,6 @@
           </a:bodyPr>
           <a:lstStyle/>
           <a:p>
-            <a:pPr/>
             <a:r>
               <a:rPr sz="2800" b="1">
                 <a:solidFill>
@@ -5963,7 +7882,6 @@
           </a:bodyPr>
           <a:lstStyle/>
           <a:p>
-            <a:pPr/>
             <a:r>
               <a:rPr sz="1500" b="0">
                 <a:solidFill>
@@ -5974,7 +7892,6 @@
             </a:r>
           </a:p>
           <a:p>
-            <a:pPr/>
             <a:r>
               <a:rPr sz="1500" b="0">
                 <a:solidFill>
@@ -5985,7 +7902,6 @@
             </a:r>
           </a:p>
           <a:p>
-            <a:pPr/>
             <a:r>
               <a:rPr sz="1500" b="0">
                 <a:solidFill>
@@ -5996,7 +7912,6 @@
             </a:r>
           </a:p>
           <a:p>
-            <a:pPr/>
             <a:r>
               <a:rPr sz="1500" b="0">
                 <a:solidFill>
@@ -6007,7 +7922,6 @@
             </a:r>
           </a:p>
           <a:p>
-            <a:pPr/>
             <a:r>
               <a:rPr sz="1500" b="0">
                 <a:solidFill>
@@ -6070,7 +7984,6 @@
           </a:bodyPr>
           <a:lstStyle/>
           <a:p>
-            <a:pPr/>
             <a:r>
               <a:rPr sz="1100" b="0">
                 <a:solidFill>

</xml_diff>

<commit_message>
Docs: update user guide + regenerate PPT/DOCX for CR-016 changes
- Notifications page (/notifications) for all staff roles
- Absence notes in daily roster; period-log read-only for other teachers
- Grade entry scoped to teaching assignment; atomic save
- Signoff workflow: submit/reject-with-reason/bulk actions
- Parent portal: multi-child picker, compose message, own-message thread
- New ke_toan section; corrected PHT scope; role table in slides synced

Generated with [Devin](https://devin.ai)

Co-Authored-By: Devin <158243242+devin-ai-integration[bot]@users.noreply.github.com>
</commit_message>
<xml_diff>
--- a/docs/user-guide/SO-CHU-NHIEM-SO-GIOI-THIEU.pptx
+++ b/docs/user-guide/SO-CHU-NHIEM-SO-GIOI-THIEU.pptx
@@ -5,21 +5,21 @@
     <p:sldMasterId id="2147483648" r:id="rId1"/>
   </p:sldMasterIdLst>
   <p:sldIdLst>
-    <p:sldId id="256" r:id="rId2"/>
-    <p:sldId id="257" r:id="rId3"/>
-    <p:sldId id="258" r:id="rId4"/>
-    <p:sldId id="259" r:id="rId5"/>
-    <p:sldId id="260" r:id="rId6"/>
-    <p:sldId id="261" r:id="rId7"/>
-    <p:sldId id="262" r:id="rId8"/>
-    <p:sldId id="263" r:id="rId9"/>
-    <p:sldId id="264" r:id="rId10"/>
-    <p:sldId id="265" r:id="rId11"/>
-    <p:sldId id="266" r:id="rId12"/>
-    <p:sldId id="267" r:id="rId13"/>
-    <p:sldId id="268" r:id="rId14"/>
+    <p:sldId id="256" r:id="rId7"/>
+    <p:sldId id="257" r:id="rId8"/>
+    <p:sldId id="258" r:id="rId9"/>
+    <p:sldId id="259" r:id="rId10"/>
+    <p:sldId id="260" r:id="rId11"/>
+    <p:sldId id="261" r:id="rId12"/>
+    <p:sldId id="262" r:id="rId13"/>
+    <p:sldId id="263" r:id="rId14"/>
+    <p:sldId id="264" r:id="rId15"/>
+    <p:sldId id="265" r:id="rId16"/>
+    <p:sldId id="266" r:id="rId17"/>
+    <p:sldId id="267" r:id="rId18"/>
+    <p:sldId id="268" r:id="rId19"/>
   </p:sldIdLst>
-  <p:sldSz cx="12192000" cy="6858000"/>
+  <p:sldSz cx="12191695" cy="6858000" type="screen4x3"/>
   <p:notesSz cx="6858000" cy="9144000"/>
   <p:defaultTextStyle>
     <a:defPPr>
@@ -116,22 +116,6 @@
       </a:defRPr>
     </a:lvl9pPr>
   </p:defaultTextStyle>
-  <p:extLst>
-    <p:ext uri="{EFAFB233-063F-42B5-8137-9DF3F51BA10A}">
-      <p15:sldGuideLst xmlns:p15="http://schemas.microsoft.com/office/powerpoint/2012/main">
-        <p15:guide id="1" orient="horz" pos="2160">
-          <p15:clr>
-            <a:srgbClr val="A4A3A4"/>
-          </p15:clr>
-        </p15:guide>
-        <p15:guide id="2" pos="2880">
-          <p15:clr>
-            <a:srgbClr val="A4A3A4"/>
-          </p15:clr>
-        </p15:guide>
-      </p15:sldGuideLst>
-    </p:ext>
-  </p:extLst>
 </p:presentation>
 </file>
 
@@ -173,9 +157,10 @@
           <a:lstStyle/>
           <a:p>
             <a:r>
-              <a:rPr lang="en-US"/>
+              <a:rPr lang="en-US" smtClean="0"/>
               <a:t>Click to edit Master title style</a:t>
             </a:r>
+            <a:endParaRPr lang="en-US"/>
           </a:p>
         </p:txBody>
       </p:sp>
@@ -291,9 +276,10 @@
           </a:lstStyle>
           <a:p>
             <a:r>
-              <a:rPr lang="en-US"/>
+              <a:rPr lang="en-US" smtClean="0"/>
               <a:t>Click to edit Master subtitle style</a:t>
             </a:r>
+            <a:endParaRPr lang="en-US"/>
           </a:p>
         </p:txBody>
       </p:sp>
@@ -314,7 +300,7 @@
           <a:p>
             <a:fld id="{5BCAD085-E8A6-8845-BD4E-CB4CCA059FC4}" type="datetimeFigureOut">
               <a:rPr lang="en-US" smtClean="0"/>
-              <a:t>9/21/26</a:t>
+              <a:t>1/27/13</a:t>
             </a:fld>
             <a:endParaRPr lang="en-US"/>
           </a:p>
@@ -408,9 +394,10 @@
           <a:lstStyle/>
           <a:p>
             <a:r>
-              <a:rPr lang="en-US"/>
+              <a:rPr lang="en-US" smtClean="0"/>
               <a:t>Click to edit Master title style</a:t>
             </a:r>
+            <a:endParaRPr lang="en-US"/>
           </a:p>
         </p:txBody>
       </p:sp>
@@ -431,37 +418,38 @@
           <a:p>
             <a:pPr lvl="0"/>
             <a:r>
-              <a:rPr lang="en-US"/>
+              <a:rPr lang="en-US" smtClean="0"/>
               <a:t>Click to edit Master text styles</a:t>
             </a:r>
           </a:p>
           <a:p>
             <a:pPr lvl="1"/>
             <a:r>
-              <a:rPr lang="en-US"/>
+              <a:rPr lang="en-US" smtClean="0"/>
               <a:t>Second level</a:t>
             </a:r>
           </a:p>
           <a:p>
             <a:pPr lvl="2"/>
             <a:r>
-              <a:rPr lang="en-US"/>
+              <a:rPr lang="en-US" smtClean="0"/>
               <a:t>Third level</a:t>
             </a:r>
           </a:p>
           <a:p>
             <a:pPr lvl="3"/>
             <a:r>
-              <a:rPr lang="en-US"/>
+              <a:rPr lang="en-US" smtClean="0"/>
               <a:t>Fourth level</a:t>
             </a:r>
           </a:p>
           <a:p>
             <a:pPr lvl="4"/>
             <a:r>
-              <a:rPr lang="en-US"/>
+              <a:rPr lang="en-US" smtClean="0"/>
               <a:t>Fifth level</a:t>
             </a:r>
+            <a:endParaRPr lang="en-US"/>
           </a:p>
         </p:txBody>
       </p:sp>
@@ -482,7 +470,7 @@
           <a:p>
             <a:fld id="{5BCAD085-E8A6-8845-BD4E-CB4CCA059FC4}" type="datetimeFigureOut">
               <a:rPr lang="en-US" smtClean="0"/>
-              <a:t>9/21/26</a:t>
+              <a:t>1/27/13</a:t>
             </a:fld>
             <a:endParaRPr lang="en-US"/>
           </a:p>
@@ -581,9 +569,10 @@
           <a:lstStyle/>
           <a:p>
             <a:r>
-              <a:rPr lang="en-US"/>
+              <a:rPr lang="en-US" smtClean="0"/>
               <a:t>Click to edit Master title style</a:t>
             </a:r>
+            <a:endParaRPr lang="en-US"/>
           </a:p>
         </p:txBody>
       </p:sp>
@@ -609,37 +598,38 @@
           <a:p>
             <a:pPr lvl="0"/>
             <a:r>
-              <a:rPr lang="en-US"/>
+              <a:rPr lang="en-US" smtClean="0"/>
               <a:t>Click to edit Master text styles</a:t>
             </a:r>
           </a:p>
           <a:p>
             <a:pPr lvl="1"/>
             <a:r>
-              <a:rPr lang="en-US"/>
+              <a:rPr lang="en-US" smtClean="0"/>
               <a:t>Second level</a:t>
             </a:r>
           </a:p>
           <a:p>
             <a:pPr lvl="2"/>
             <a:r>
-              <a:rPr lang="en-US"/>
+              <a:rPr lang="en-US" smtClean="0"/>
               <a:t>Third level</a:t>
             </a:r>
           </a:p>
           <a:p>
             <a:pPr lvl="3"/>
             <a:r>
-              <a:rPr lang="en-US"/>
+              <a:rPr lang="en-US" smtClean="0"/>
               <a:t>Fourth level</a:t>
             </a:r>
           </a:p>
           <a:p>
             <a:pPr lvl="4"/>
             <a:r>
-              <a:rPr lang="en-US"/>
+              <a:rPr lang="en-US" smtClean="0"/>
               <a:t>Fifth level</a:t>
             </a:r>
+            <a:endParaRPr lang="en-US"/>
           </a:p>
         </p:txBody>
       </p:sp>
@@ -660,7 +650,7 @@
           <a:p>
             <a:fld id="{5BCAD085-E8A6-8845-BD4E-CB4CCA059FC4}" type="datetimeFigureOut">
               <a:rPr lang="en-US" smtClean="0"/>
-              <a:t>9/21/26</a:t>
+              <a:t>1/27/13</a:t>
             </a:fld>
             <a:endParaRPr lang="en-US"/>
           </a:p>
@@ -754,9 +744,10 @@
           <a:lstStyle/>
           <a:p>
             <a:r>
-              <a:rPr lang="en-US"/>
+              <a:rPr lang="en-US" smtClean="0"/>
               <a:t>Click to edit Master title style</a:t>
             </a:r>
+            <a:endParaRPr lang="en-US"/>
           </a:p>
         </p:txBody>
       </p:sp>
@@ -777,37 +768,38 @@
           <a:p>
             <a:pPr lvl="0"/>
             <a:r>
-              <a:rPr lang="en-US"/>
+              <a:rPr lang="en-US" smtClean="0"/>
               <a:t>Click to edit Master text styles</a:t>
             </a:r>
           </a:p>
           <a:p>
             <a:pPr lvl="1"/>
             <a:r>
-              <a:rPr lang="en-US"/>
+              <a:rPr lang="en-US" smtClean="0"/>
               <a:t>Second level</a:t>
             </a:r>
           </a:p>
           <a:p>
             <a:pPr lvl="2"/>
             <a:r>
-              <a:rPr lang="en-US"/>
+              <a:rPr lang="en-US" smtClean="0"/>
               <a:t>Third level</a:t>
             </a:r>
           </a:p>
           <a:p>
             <a:pPr lvl="3"/>
             <a:r>
-              <a:rPr lang="en-US"/>
+              <a:rPr lang="en-US" smtClean="0"/>
               <a:t>Fourth level</a:t>
             </a:r>
           </a:p>
           <a:p>
             <a:pPr lvl="4"/>
             <a:r>
-              <a:rPr lang="en-US"/>
+              <a:rPr lang="en-US" smtClean="0"/>
               <a:t>Fifth level</a:t>
             </a:r>
+            <a:endParaRPr lang="en-US"/>
           </a:p>
         </p:txBody>
       </p:sp>
@@ -828,7 +820,7 @@
           <a:p>
             <a:fld id="{5BCAD085-E8A6-8845-BD4E-CB4CCA059FC4}" type="datetimeFigureOut">
               <a:rPr lang="en-US" smtClean="0"/>
-              <a:t>9/21/26</a:t>
+              <a:t>1/27/13</a:t>
             </a:fld>
             <a:endParaRPr lang="en-US"/>
           </a:p>
@@ -931,9 +923,10 @@
           </a:lstStyle>
           <a:p>
             <a:r>
-              <a:rPr lang="en-US"/>
+              <a:rPr lang="en-US" smtClean="0"/>
               <a:t>Click to edit Master title style</a:t>
             </a:r>
+            <a:endParaRPr lang="en-US"/>
           </a:p>
         </p:txBody>
       </p:sp>
@@ -1050,7 +1043,7 @@
           <a:p>
             <a:pPr lvl="0"/>
             <a:r>
-              <a:rPr lang="en-US"/>
+              <a:rPr lang="en-US" smtClean="0"/>
               <a:t>Click to edit Master text styles</a:t>
             </a:r>
           </a:p>
@@ -1073,7 +1066,7 @@
           <a:p>
             <a:fld id="{5BCAD085-E8A6-8845-BD4E-CB4CCA059FC4}" type="datetimeFigureOut">
               <a:rPr lang="en-US" smtClean="0"/>
-              <a:t>9/21/26</a:t>
+              <a:t>1/27/13</a:t>
             </a:fld>
             <a:endParaRPr lang="en-US"/>
           </a:p>
@@ -1167,9 +1160,10 @@
           <a:lstStyle/>
           <a:p>
             <a:r>
-              <a:rPr lang="en-US"/>
+              <a:rPr lang="en-US" smtClean="0"/>
               <a:t>Click to edit Master title style</a:t>
             </a:r>
+            <a:endParaRPr lang="en-US"/>
           </a:p>
         </p:txBody>
       </p:sp>
@@ -1223,37 +1217,38 @@
           <a:p>
             <a:pPr lvl="0"/>
             <a:r>
-              <a:rPr lang="en-US"/>
+              <a:rPr lang="en-US" smtClean="0"/>
               <a:t>Click to edit Master text styles</a:t>
             </a:r>
           </a:p>
           <a:p>
             <a:pPr lvl="1"/>
             <a:r>
-              <a:rPr lang="en-US"/>
+              <a:rPr lang="en-US" smtClean="0"/>
               <a:t>Second level</a:t>
             </a:r>
           </a:p>
           <a:p>
             <a:pPr lvl="2"/>
             <a:r>
-              <a:rPr lang="en-US"/>
+              <a:rPr lang="en-US" smtClean="0"/>
               <a:t>Third level</a:t>
             </a:r>
           </a:p>
           <a:p>
             <a:pPr lvl="3"/>
             <a:r>
-              <a:rPr lang="en-US"/>
+              <a:rPr lang="en-US" smtClean="0"/>
               <a:t>Fourth level</a:t>
             </a:r>
           </a:p>
           <a:p>
             <a:pPr lvl="4"/>
             <a:r>
-              <a:rPr lang="en-US"/>
+              <a:rPr lang="en-US" smtClean="0"/>
               <a:t>Fifth level</a:t>
             </a:r>
+            <a:endParaRPr lang="en-US"/>
           </a:p>
         </p:txBody>
       </p:sp>
@@ -1307,37 +1302,38 @@
           <a:p>
             <a:pPr lvl="0"/>
             <a:r>
-              <a:rPr lang="en-US"/>
+              <a:rPr lang="en-US" smtClean="0"/>
               <a:t>Click to edit Master text styles</a:t>
             </a:r>
           </a:p>
           <a:p>
             <a:pPr lvl="1"/>
             <a:r>
-              <a:rPr lang="en-US"/>
+              <a:rPr lang="en-US" smtClean="0"/>
               <a:t>Second level</a:t>
             </a:r>
           </a:p>
           <a:p>
             <a:pPr lvl="2"/>
             <a:r>
-              <a:rPr lang="en-US"/>
+              <a:rPr lang="en-US" smtClean="0"/>
               <a:t>Third level</a:t>
             </a:r>
           </a:p>
           <a:p>
             <a:pPr lvl="3"/>
             <a:r>
-              <a:rPr lang="en-US"/>
+              <a:rPr lang="en-US" smtClean="0"/>
               <a:t>Fourth level</a:t>
             </a:r>
           </a:p>
           <a:p>
             <a:pPr lvl="4"/>
             <a:r>
-              <a:rPr lang="en-US"/>
+              <a:rPr lang="en-US" smtClean="0"/>
               <a:t>Fifth level</a:t>
             </a:r>
+            <a:endParaRPr lang="en-US"/>
           </a:p>
         </p:txBody>
       </p:sp>
@@ -1358,7 +1354,7 @@
           <a:p>
             <a:fld id="{5BCAD085-E8A6-8845-BD4E-CB4CCA059FC4}" type="datetimeFigureOut">
               <a:rPr lang="en-US" smtClean="0"/>
-              <a:t>9/21/26</a:t>
+              <a:t>1/27/13</a:t>
             </a:fld>
             <a:endParaRPr lang="en-US"/>
           </a:p>
@@ -1456,9 +1452,10 @@
           </a:lstStyle>
           <a:p>
             <a:r>
-              <a:rPr lang="en-US"/>
+              <a:rPr lang="en-US" smtClean="0"/>
               <a:t>Click to edit Master title style</a:t>
             </a:r>
+            <a:endParaRPr lang="en-US"/>
           </a:p>
         </p:txBody>
       </p:sp>
@@ -1521,7 +1518,7 @@
           <a:p>
             <a:pPr lvl="0"/>
             <a:r>
-              <a:rPr lang="en-US"/>
+              <a:rPr lang="en-US" smtClean="0"/>
               <a:t>Click to edit Master text styles</a:t>
             </a:r>
           </a:p>
@@ -1577,37 +1574,38 @@
           <a:p>
             <a:pPr lvl="0"/>
             <a:r>
-              <a:rPr lang="en-US"/>
+              <a:rPr lang="en-US" smtClean="0"/>
               <a:t>Click to edit Master text styles</a:t>
             </a:r>
           </a:p>
           <a:p>
             <a:pPr lvl="1"/>
             <a:r>
-              <a:rPr lang="en-US"/>
+              <a:rPr lang="en-US" smtClean="0"/>
               <a:t>Second level</a:t>
             </a:r>
           </a:p>
           <a:p>
             <a:pPr lvl="2"/>
             <a:r>
-              <a:rPr lang="en-US"/>
+              <a:rPr lang="en-US" smtClean="0"/>
               <a:t>Third level</a:t>
             </a:r>
           </a:p>
           <a:p>
             <a:pPr lvl="3"/>
             <a:r>
-              <a:rPr lang="en-US"/>
+              <a:rPr lang="en-US" smtClean="0"/>
               <a:t>Fourth level</a:t>
             </a:r>
           </a:p>
           <a:p>
             <a:pPr lvl="4"/>
             <a:r>
-              <a:rPr lang="en-US"/>
+              <a:rPr lang="en-US" smtClean="0"/>
               <a:t>Fifth level</a:t>
             </a:r>
+            <a:endParaRPr lang="en-US"/>
           </a:p>
         </p:txBody>
       </p:sp>
@@ -1670,7 +1668,7 @@
           <a:p>
             <a:pPr lvl="0"/>
             <a:r>
-              <a:rPr lang="en-US"/>
+              <a:rPr lang="en-US" smtClean="0"/>
               <a:t>Click to edit Master text styles</a:t>
             </a:r>
           </a:p>
@@ -1726,37 +1724,38 @@
           <a:p>
             <a:pPr lvl="0"/>
             <a:r>
-              <a:rPr lang="en-US"/>
+              <a:rPr lang="en-US" smtClean="0"/>
               <a:t>Click to edit Master text styles</a:t>
             </a:r>
           </a:p>
           <a:p>
             <a:pPr lvl="1"/>
             <a:r>
-              <a:rPr lang="en-US"/>
+              <a:rPr lang="en-US" smtClean="0"/>
               <a:t>Second level</a:t>
             </a:r>
           </a:p>
           <a:p>
             <a:pPr lvl="2"/>
             <a:r>
-              <a:rPr lang="en-US"/>
+              <a:rPr lang="en-US" smtClean="0"/>
               <a:t>Third level</a:t>
             </a:r>
           </a:p>
           <a:p>
             <a:pPr lvl="3"/>
             <a:r>
-              <a:rPr lang="en-US"/>
+              <a:rPr lang="en-US" smtClean="0"/>
               <a:t>Fourth level</a:t>
             </a:r>
           </a:p>
           <a:p>
             <a:pPr lvl="4"/>
             <a:r>
-              <a:rPr lang="en-US"/>
+              <a:rPr lang="en-US" smtClean="0"/>
               <a:t>Fifth level</a:t>
             </a:r>
+            <a:endParaRPr lang="en-US"/>
           </a:p>
         </p:txBody>
       </p:sp>
@@ -1777,7 +1776,7 @@
           <a:p>
             <a:fld id="{5BCAD085-E8A6-8845-BD4E-CB4CCA059FC4}" type="datetimeFigureOut">
               <a:rPr lang="en-US" smtClean="0"/>
-              <a:t>9/21/26</a:t>
+              <a:t>1/27/13</a:t>
             </a:fld>
             <a:endParaRPr lang="en-US"/>
           </a:p>
@@ -1871,9 +1870,10 @@
           <a:lstStyle/>
           <a:p>
             <a:r>
-              <a:rPr lang="en-US"/>
+              <a:rPr lang="en-US" smtClean="0"/>
               <a:t>Click to edit Master title style</a:t>
             </a:r>
+            <a:endParaRPr lang="en-US"/>
           </a:p>
         </p:txBody>
       </p:sp>
@@ -1894,7 +1894,7 @@
           <a:p>
             <a:fld id="{5BCAD085-E8A6-8845-BD4E-CB4CCA059FC4}" type="datetimeFigureOut">
               <a:rPr lang="en-US" smtClean="0"/>
-              <a:t>9/21/26</a:t>
+              <a:t>1/27/13</a:t>
             </a:fld>
             <a:endParaRPr lang="en-US"/>
           </a:p>
@@ -1989,7 +1989,7 @@
           <a:p>
             <a:fld id="{5BCAD085-E8A6-8845-BD4E-CB4CCA059FC4}" type="datetimeFigureOut">
               <a:rPr lang="en-US" smtClean="0"/>
-              <a:t>9/21/26</a:t>
+              <a:t>1/27/13</a:t>
             </a:fld>
             <a:endParaRPr lang="en-US"/>
           </a:p>
@@ -2092,9 +2092,10 @@
           </a:lstStyle>
           <a:p>
             <a:r>
-              <a:rPr lang="en-US"/>
+              <a:rPr lang="en-US" smtClean="0"/>
               <a:t>Click to edit Master title style</a:t>
             </a:r>
+            <a:endParaRPr lang="en-US"/>
           </a:p>
         </p:txBody>
       </p:sp>
@@ -2148,37 +2149,38 @@
           <a:p>
             <a:pPr lvl="0"/>
             <a:r>
-              <a:rPr lang="en-US"/>
+              <a:rPr lang="en-US" smtClean="0"/>
               <a:t>Click to edit Master text styles</a:t>
             </a:r>
           </a:p>
           <a:p>
             <a:pPr lvl="1"/>
             <a:r>
-              <a:rPr lang="en-US"/>
+              <a:rPr lang="en-US" smtClean="0"/>
               <a:t>Second level</a:t>
             </a:r>
           </a:p>
           <a:p>
             <a:pPr lvl="2"/>
             <a:r>
-              <a:rPr lang="en-US"/>
+              <a:rPr lang="en-US" smtClean="0"/>
               <a:t>Third level</a:t>
             </a:r>
           </a:p>
           <a:p>
             <a:pPr lvl="3"/>
             <a:r>
-              <a:rPr lang="en-US"/>
+              <a:rPr lang="en-US" smtClean="0"/>
               <a:t>Fourth level</a:t>
             </a:r>
           </a:p>
           <a:p>
             <a:pPr lvl="4"/>
             <a:r>
-              <a:rPr lang="en-US"/>
+              <a:rPr lang="en-US" smtClean="0"/>
               <a:t>Fifth level</a:t>
             </a:r>
+            <a:endParaRPr lang="en-US"/>
           </a:p>
         </p:txBody>
       </p:sp>
@@ -2241,7 +2243,7 @@
           <a:p>
             <a:pPr lvl="0"/>
             <a:r>
-              <a:rPr lang="en-US"/>
+              <a:rPr lang="en-US" smtClean="0"/>
               <a:t>Click to edit Master text styles</a:t>
             </a:r>
           </a:p>
@@ -2264,7 +2266,7 @@
           <a:p>
             <a:fld id="{5BCAD085-E8A6-8845-BD4E-CB4CCA059FC4}" type="datetimeFigureOut">
               <a:rPr lang="en-US" smtClean="0"/>
-              <a:t>9/21/26</a:t>
+              <a:t>1/27/13</a:t>
             </a:fld>
             <a:endParaRPr lang="en-US"/>
           </a:p>
@@ -2367,9 +2369,10 @@
           </a:lstStyle>
           <a:p>
             <a:r>
-              <a:rPr lang="en-US"/>
+              <a:rPr lang="en-US" smtClean="0"/>
               <a:t>Click to edit Master title style</a:t>
             </a:r>
+            <a:endParaRPr lang="en-US"/>
           </a:p>
         </p:txBody>
       </p:sp>
@@ -2493,7 +2496,7 @@
           <a:p>
             <a:pPr lvl="0"/>
             <a:r>
-              <a:rPr lang="en-US"/>
+              <a:rPr lang="en-US" smtClean="0"/>
               <a:t>Click to edit Master text styles</a:t>
             </a:r>
           </a:p>
@@ -2516,7 +2519,7 @@
           <a:p>
             <a:fld id="{5BCAD085-E8A6-8845-BD4E-CB4CCA059FC4}" type="datetimeFigureOut">
               <a:rPr lang="en-US" smtClean="0"/>
-              <a:t>9/21/26</a:t>
+              <a:t>1/27/13</a:t>
             </a:fld>
             <a:endParaRPr lang="en-US"/>
           </a:p>
@@ -2625,9 +2628,10 @@
           <a:lstStyle/>
           <a:p>
             <a:r>
-              <a:rPr lang="en-US"/>
+              <a:rPr lang="en-US" smtClean="0"/>
               <a:t>Click to edit Master title style</a:t>
             </a:r>
+            <a:endParaRPr lang="en-US"/>
           </a:p>
         </p:txBody>
       </p:sp>
@@ -2658,37 +2662,38 @@
           <a:p>
             <a:pPr lvl="0"/>
             <a:r>
-              <a:rPr lang="en-US"/>
+              <a:rPr lang="en-US" smtClean="0"/>
               <a:t>Click to edit Master text styles</a:t>
             </a:r>
           </a:p>
           <a:p>
             <a:pPr lvl="1"/>
             <a:r>
-              <a:rPr lang="en-US"/>
+              <a:rPr lang="en-US" smtClean="0"/>
               <a:t>Second level</a:t>
             </a:r>
           </a:p>
           <a:p>
             <a:pPr lvl="2"/>
             <a:r>
-              <a:rPr lang="en-US"/>
+              <a:rPr lang="en-US" smtClean="0"/>
               <a:t>Third level</a:t>
             </a:r>
           </a:p>
           <a:p>
             <a:pPr lvl="3"/>
             <a:r>
-              <a:rPr lang="en-US"/>
+              <a:rPr lang="en-US" smtClean="0"/>
               <a:t>Fourth level</a:t>
             </a:r>
           </a:p>
           <a:p>
             <a:pPr lvl="4"/>
             <a:r>
-              <a:rPr lang="en-US"/>
+              <a:rPr lang="en-US" smtClean="0"/>
               <a:t>Fifth level</a:t>
             </a:r>
+            <a:endParaRPr lang="en-US"/>
           </a:p>
         </p:txBody>
       </p:sp>
@@ -2727,7 +2732,7 @@
           <a:p>
             <a:fld id="{5BCAD085-E8A6-8845-BD4E-CB4CCA059FC4}" type="datetimeFigureOut">
               <a:rPr lang="en-US" smtClean="0"/>
-              <a:t>9/21/26</a:t>
+              <a:t>1/27/13</a:t>
             </a:fld>
             <a:endParaRPr lang="en-US"/>
           </a:p>
@@ -3086,7 +3091,7 @@
 </file>
 
 <file path=ppt/slides/slide1.xml><?xml version="1.0" encoding="utf-8"?>
-<p:sld xmlns:a="http://schemas.openxmlformats.org/drawingml/2006/main" xmlns:r="http://schemas.openxmlformats.org/officeDocument/2006/relationships" xmlns:p="http://schemas.openxmlformats.org/presentationml/2006/main">
+<p:sld xmlns:a="http://schemas.openxmlformats.org/drawingml/2006/main" xmlns:p="http://schemas.openxmlformats.org/presentationml/2006/main" xmlns:r="http://schemas.openxmlformats.org/officeDocument/2006/relationships">
   <p:cSld>
     <p:spTree>
       <p:nvGrpSpPr>
@@ -3094,14 +3099,7 @@
         <p:cNvGrpSpPr/>
         <p:nvPr/>
       </p:nvGrpSpPr>
-      <p:grpSpPr>
-        <a:xfrm>
-          <a:off x="0" y="0"/>
-          <a:ext cx="0" cy="0"/>
-          <a:chOff x="0" y="0"/>
-          <a:chExt cx="0" cy="0"/>
-        </a:xfrm>
-      </p:grpSpPr>
+      <p:grpSpPr/>
       <p:sp>
         <p:nvSpPr>
           <p:cNvPr id="2" name="Rectangle 1"/>
@@ -3142,7 +3140,6 @@
           <a:lstStyle/>
           <a:p>
             <a:pPr algn="ctr"/>
-            <a:endParaRPr/>
           </a:p>
         </p:txBody>
       </p:sp>
@@ -3168,6 +3165,7 @@
           </a:bodyPr>
           <a:lstStyle/>
           <a:p>
+            <a:pPr/>
             <a:r>
               <a:rPr sz="4400" b="1">
                 <a:solidFill>
@@ -3178,6 +3176,7 @@
             </a:r>
           </a:p>
           <a:p>
+            <a:pPr/>
             <a:r>
               <a:rPr sz="2000" b="0">
                 <a:solidFill>
@@ -3211,6 +3210,7 @@
           </a:bodyPr>
           <a:lstStyle/>
           <a:p>
+            <a:pPr/>
             <a:r>
               <a:rPr sz="1400" b="0">
                 <a:solidFill>
@@ -3231,7 +3231,7 @@
 </file>
 
 <file path=ppt/slides/slide10.xml><?xml version="1.0" encoding="utf-8"?>
-<p:sld xmlns:a="http://schemas.openxmlformats.org/drawingml/2006/main" xmlns:r="http://schemas.openxmlformats.org/officeDocument/2006/relationships" xmlns:p="http://schemas.openxmlformats.org/presentationml/2006/main">
+<p:sld xmlns:a="http://schemas.openxmlformats.org/drawingml/2006/main" xmlns:p="http://schemas.openxmlformats.org/presentationml/2006/main" xmlns:r="http://schemas.openxmlformats.org/officeDocument/2006/relationships">
   <p:cSld>
     <p:spTree>
       <p:nvGrpSpPr>
@@ -3239,14 +3239,7 @@
         <p:cNvGrpSpPr/>
         <p:nvPr/>
       </p:nvGrpSpPr>
-      <p:grpSpPr>
-        <a:xfrm>
-          <a:off x="0" y="0"/>
-          <a:ext cx="0" cy="0"/>
-          <a:chOff x="0" y="0"/>
-          <a:chExt cx="0" cy="0"/>
-        </a:xfrm>
-      </p:grpSpPr>
+      <p:grpSpPr/>
       <p:sp>
         <p:nvSpPr>
           <p:cNvPr id="2" name="Rectangle 1"/>
@@ -3287,7 +3280,6 @@
           <a:lstStyle/>
           <a:p>
             <a:pPr algn="ctr"/>
-            <a:endParaRPr/>
           </a:p>
         </p:txBody>
       </p:sp>
@@ -3313,6 +3305,7 @@
           </a:bodyPr>
           <a:lstStyle/>
           <a:p>
+            <a:pPr/>
             <a:r>
               <a:rPr sz="2800" b="1">
                 <a:solidFill>
@@ -3346,36 +3339,51 @@
           </a:bodyPr>
           <a:lstStyle/>
           <a:p>
+            <a:pPr/>
             <a:r>
               <a:rPr sz="1500" b="0">
                 <a:solidFill>
                   <a:srgbClr val="1F2937"/>
                 </a:solidFill>
               </a:rPr>
-              <a:t>- Phụ huynh: thông báo lớp, nhắn tin 2 chiều với GVCN</a:t>
-            </a:r>
-          </a:p>
-          <a:p>
+              <a:t>- Phụ huynh nhiều con: bộ chọn con trên đầu portal, dữ liệu tách theo từng em</a:t>
+            </a:r>
+          </a:p>
+          <a:p>
+            <a:pPr/>
             <a:r>
               <a:rPr sz="1500" b="0">
                 <a:solidFill>
                   <a:srgbClr val="1F2937"/>
                 </a:solidFill>
               </a:rPr>
+              <a:t>- Nhắn tin 2 chiều với GVCN: soạn mới + trả lời, thấy cả tin đã gửi</a:t>
+            </a:r>
+          </a:p>
+          <a:p>
+            <a:pPr/>
+            <a:r>
+              <a:rPr sz="1500" b="0">
+                <a:solidFill>
+                  <a:srgbClr val="1F2937"/>
+                </a:solidFill>
+              </a:rPr>
               <a:t>- Đặt lịch hẹn trực tuyến - GVCN xác nhận</a:t>
             </a:r>
           </a:p>
           <a:p>
+            <a:pPr/>
             <a:r>
               <a:rPr sz="1500" b="0">
                 <a:solidFill>
                   <a:srgbClr val="1F2937"/>
                 </a:solidFill>
               </a:rPr>
-              <a:t>- Đăng ký hoạt động giáo dục cho con</a:t>
-            </a:r>
-          </a:p>
-          <a:p>
+              <a:t>- Đăng ký / báo vắng hoạt động giáo dục cho con</a:t>
+            </a:r>
+          </a:p>
+          <a:p>
+            <a:pPr/>
             <a:r>
               <a:rPr sz="1500" b="0">
                 <a:solidFill>
@@ -3386,13 +3394,14 @@
             </a:r>
           </a:p>
           <a:p>
+            <a:pPr/>
             <a:r>
               <a:rPr sz="1500" b="0">
                 <a:solidFill>
                   <a:srgbClr val="1F2937"/>
                 </a:solidFill>
               </a:rPr>
-              <a:t>- Portal riêng, không cần quyền vào hệ thống nội bộ</a:t>
+              <a:t>- Mọi thao tác kiểm tra quyền sở hữu con ở server - không ghi được hồ sơ em khác</a:t>
             </a:r>
           </a:p>
         </p:txBody>
@@ -3448,6 +3457,7 @@
           </a:bodyPr>
           <a:lstStyle/>
           <a:p>
+            <a:pPr/>
             <a:r>
               <a:rPr sz="1100" b="0">
                 <a:solidFill>
@@ -3468,7 +3478,7 @@
 </file>
 
 <file path=ppt/slides/slide11.xml><?xml version="1.0" encoding="utf-8"?>
-<p:sld xmlns:a="http://schemas.openxmlformats.org/drawingml/2006/main" xmlns:r="http://schemas.openxmlformats.org/officeDocument/2006/relationships" xmlns:p="http://schemas.openxmlformats.org/presentationml/2006/main">
+<p:sld xmlns:a="http://schemas.openxmlformats.org/drawingml/2006/main" xmlns:p="http://schemas.openxmlformats.org/presentationml/2006/main" xmlns:r="http://schemas.openxmlformats.org/officeDocument/2006/relationships">
   <p:cSld>
     <p:spTree>
       <p:nvGrpSpPr>
@@ -3476,14 +3486,7 @@
         <p:cNvGrpSpPr/>
         <p:nvPr/>
       </p:nvGrpSpPr>
-      <p:grpSpPr>
-        <a:xfrm>
-          <a:off x="0" y="0"/>
-          <a:ext cx="0" cy="0"/>
-          <a:chOff x="0" y="0"/>
-          <a:chExt cx="0" cy="0"/>
-        </a:xfrm>
-      </p:grpSpPr>
+      <p:grpSpPr/>
       <p:sp>
         <p:nvSpPr>
           <p:cNvPr id="2" name="Rectangle 1"/>
@@ -3524,7 +3527,6 @@
           <a:lstStyle/>
           <a:p>
             <a:pPr algn="ctr"/>
-            <a:endParaRPr/>
           </a:p>
         </p:txBody>
       </p:sp>
@@ -3550,6 +3552,7 @@
           </a:bodyPr>
           <a:lstStyle/>
           <a:p>
+            <a:pPr/>
             <a:r>
               <a:rPr sz="2800" b="1">
                 <a:solidFill>
@@ -3570,7 +3573,7 @@
         <p:spPr>
           <a:xfrm>
             <a:off x="548640" y="1234440"/>
-            <a:ext cx="5120640" cy="784830"/>
+            <a:ext cx="5120640" cy="5303520"/>
           </a:xfrm>
           <a:prstGeom prst="rect">
             <a:avLst/>
@@ -3583,507 +3586,48 @@
           </a:bodyPr>
           <a:lstStyle/>
           <a:p>
-            <a:r>
-              <a:rPr sz="1500" b="0" dirty="0">
+            <a:pPr/>
+            <a:r>
+              <a:rPr sz="1500" b="0">
                 <a:solidFill>
                   <a:srgbClr val="1F2937"/>
                 </a:solidFill>
               </a:rPr>
-              <a:t>- </a:t>
-            </a:r>
-            <a:r>
-              <a:rPr sz="1500" b="0" dirty="0" err="1">
+              <a:t>- Tuyến 1: LLM cấu hình qua env - Gemini / OpenAI / Anthropic, đổi provider bằng AI_PROVIDER + AI_MODEL</a:t>
+            </a:r>
+          </a:p>
+          <a:p>
+            <a:pPr/>
+            <a:r>
+              <a:rPr sz="1500" b="0">
                 <a:solidFill>
                   <a:srgbClr val="1F2937"/>
                 </a:solidFill>
               </a:rPr>
-              <a:t>Ứng</a:t>
-            </a:r>
-            <a:r>
-              <a:rPr sz="1500" b="0" dirty="0">
+              <a:t>- Tuyến 2: Devin async - hết quota LLM thì tạo session xử lý, callback trả kết quả</a:t>
+            </a:r>
+          </a:p>
+          <a:p>
+            <a:pPr/>
+            <a:r>
+              <a:rPr sz="1500" b="0">
                 <a:solidFill>
                   <a:srgbClr val="1F2937"/>
                 </a:solidFill>
               </a:rPr>
-              <a:t> </a:t>
-            </a:r>
-            <a:r>
-              <a:rPr sz="1500" b="0" dirty="0" err="1">
+              <a:t>- Tuyến 3: rule-based fallback - luôn có câu trả lời hữu ích kể cả khi mọi backend chết</a:t>
+            </a:r>
+          </a:p>
+          <a:p>
+            <a:pPr/>
+            <a:r>
+              <a:rPr sz="1500" b="0">
                 <a:solidFill>
                   <a:srgbClr val="1F2937"/>
                 </a:solidFill>
               </a:rPr>
-              <a:t>dụng</a:t>
-            </a:r>
-            <a:r>
-              <a:rPr sz="1500" b="0" dirty="0">
-                <a:solidFill>
-                  <a:srgbClr val="1F2937"/>
-                </a:solidFill>
-              </a:rPr>
-              <a:t>: </a:t>
-            </a:r>
-            <a:r>
-              <a:rPr sz="1500" b="0" dirty="0" err="1">
-                <a:solidFill>
-                  <a:srgbClr val="1F2937"/>
-                </a:solidFill>
-              </a:rPr>
-              <a:t>báo</a:t>
-            </a:r>
-            <a:r>
-              <a:rPr sz="1500" b="0" dirty="0">
-                <a:solidFill>
-                  <a:srgbClr val="1F2937"/>
-                </a:solidFill>
-              </a:rPr>
-              <a:t> </a:t>
-            </a:r>
-            <a:r>
-              <a:rPr sz="1500" b="0" dirty="0" err="1">
-                <a:solidFill>
-                  <a:srgbClr val="1F2937"/>
-                </a:solidFill>
-              </a:rPr>
-              <a:t>cáo</a:t>
-            </a:r>
-            <a:r>
-              <a:rPr sz="1500" b="0" dirty="0">
-                <a:solidFill>
-                  <a:srgbClr val="1F2937"/>
-                </a:solidFill>
-              </a:rPr>
-              <a:t> </a:t>
-            </a:r>
-            <a:r>
-              <a:rPr sz="1500" b="0" dirty="0" err="1">
-                <a:solidFill>
-                  <a:srgbClr val="1F2937"/>
-                </a:solidFill>
-              </a:rPr>
-              <a:t>hồ</a:t>
-            </a:r>
-            <a:r>
-              <a:rPr sz="1500" b="0" dirty="0">
-                <a:solidFill>
-                  <a:srgbClr val="1F2937"/>
-                </a:solidFill>
-              </a:rPr>
-              <a:t> </a:t>
-            </a:r>
-            <a:r>
-              <a:rPr sz="1500" b="0" dirty="0" err="1">
-                <a:solidFill>
-                  <a:srgbClr val="1F2937"/>
-                </a:solidFill>
-              </a:rPr>
-              <a:t>sơ</a:t>
-            </a:r>
-            <a:r>
-              <a:rPr sz="1500" b="0" dirty="0">
-                <a:solidFill>
-                  <a:srgbClr val="1F2937"/>
-                </a:solidFill>
-              </a:rPr>
-              <a:t> </a:t>
-            </a:r>
-            <a:r>
-              <a:rPr sz="1500" b="0" dirty="0" err="1">
-                <a:solidFill>
-                  <a:srgbClr val="1F2937"/>
-                </a:solidFill>
-              </a:rPr>
-              <a:t>lớp</a:t>
-            </a:r>
-            <a:r>
-              <a:rPr sz="1500" b="0" dirty="0">
-                <a:solidFill>
-                  <a:srgbClr val="1F2937"/>
-                </a:solidFill>
-              </a:rPr>
-              <a:t>, </a:t>
-            </a:r>
-            <a:r>
-              <a:rPr sz="1500" b="0" dirty="0" err="1">
-                <a:solidFill>
-                  <a:srgbClr val="1F2937"/>
-                </a:solidFill>
-              </a:rPr>
-              <a:t>nhận</a:t>
-            </a:r>
-            <a:r>
-              <a:rPr sz="1500" b="0" dirty="0">
-                <a:solidFill>
-                  <a:srgbClr val="1F2937"/>
-                </a:solidFill>
-              </a:rPr>
-              <a:t> </a:t>
-            </a:r>
-            <a:r>
-              <a:rPr sz="1500" b="0" dirty="0" err="1">
-                <a:solidFill>
-                  <a:srgbClr val="1F2937"/>
-                </a:solidFill>
-              </a:rPr>
-              <a:t>xét</a:t>
-            </a:r>
-            <a:r>
-              <a:rPr sz="1500" b="0" dirty="0">
-                <a:solidFill>
-                  <a:srgbClr val="1F2937"/>
-                </a:solidFill>
-              </a:rPr>
-              <a:t> </a:t>
-            </a:r>
-            <a:r>
-              <a:rPr sz="1500" b="0" dirty="0" err="1">
-                <a:solidFill>
-                  <a:srgbClr val="1F2937"/>
-                </a:solidFill>
-              </a:rPr>
-              <a:t>giáo</a:t>
-            </a:r>
-            <a:r>
-              <a:rPr sz="1500" b="0" dirty="0">
-                <a:solidFill>
-                  <a:srgbClr val="1F2937"/>
-                </a:solidFill>
-              </a:rPr>
-              <a:t> </a:t>
-            </a:r>
-            <a:r>
-              <a:rPr sz="1500" b="0" dirty="0" err="1">
-                <a:solidFill>
-                  <a:srgbClr val="1F2937"/>
-                </a:solidFill>
-              </a:rPr>
-              <a:t>án</a:t>
-            </a:r>
-            <a:r>
-              <a:rPr sz="1500" b="0" dirty="0">
-                <a:solidFill>
-                  <a:srgbClr val="1F2937"/>
-                </a:solidFill>
-              </a:rPr>
-              <a:t>, </a:t>
-            </a:r>
-            <a:r>
-              <a:rPr sz="1500" b="0" dirty="0" err="1">
-                <a:solidFill>
-                  <a:srgbClr val="1F2937"/>
-                </a:solidFill>
-              </a:rPr>
-              <a:t>gợi</a:t>
-            </a:r>
-            <a:r>
-              <a:rPr sz="1500" b="0" dirty="0">
-                <a:solidFill>
-                  <a:srgbClr val="1F2937"/>
-                </a:solidFill>
-              </a:rPr>
-              <a:t> </a:t>
-            </a:r>
-            <a:r>
-              <a:rPr sz="1500" b="0" dirty="0" err="1">
-                <a:solidFill>
-                  <a:srgbClr val="1F2937"/>
-                </a:solidFill>
-              </a:rPr>
-              <a:t>ý</a:t>
-            </a:r>
-            <a:r>
-              <a:rPr sz="1500" b="0" dirty="0">
-                <a:solidFill>
-                  <a:srgbClr val="1F2937"/>
-                </a:solidFill>
-              </a:rPr>
-              <a:t> </a:t>
-            </a:r>
-            <a:r>
-              <a:rPr sz="1500" b="0" dirty="0" err="1">
-                <a:solidFill>
-                  <a:srgbClr val="1F2937"/>
-                </a:solidFill>
-              </a:rPr>
-              <a:t>cảnh</a:t>
-            </a:r>
-            <a:r>
-              <a:rPr sz="1500" b="0" dirty="0">
-                <a:solidFill>
-                  <a:srgbClr val="1F2937"/>
-                </a:solidFill>
-              </a:rPr>
-              <a:t> </a:t>
-            </a:r>
-            <a:r>
-              <a:rPr sz="1500" b="0" dirty="0" err="1">
-                <a:solidFill>
-                  <a:srgbClr val="1F2937"/>
-                </a:solidFill>
-              </a:rPr>
-              <a:t>báo</a:t>
-            </a:r>
-            <a:r>
-              <a:rPr sz="1500" b="0" dirty="0">
-                <a:solidFill>
-                  <a:srgbClr val="1F2937"/>
-                </a:solidFill>
-              </a:rPr>
-              <a:t>, </a:t>
-            </a:r>
-            <a:r>
-              <a:rPr sz="1500" b="0" dirty="0" err="1">
-                <a:solidFill>
-                  <a:srgbClr val="1F2937"/>
-                </a:solidFill>
-              </a:rPr>
-              <a:t>trợ</a:t>
-            </a:r>
-            <a:r>
-              <a:rPr sz="1500" b="0" dirty="0">
-                <a:solidFill>
-                  <a:srgbClr val="1F2937"/>
-                </a:solidFill>
-              </a:rPr>
-              <a:t> </a:t>
-            </a:r>
-            <a:r>
-              <a:rPr sz="1500" b="0" dirty="0" err="1">
-                <a:solidFill>
-                  <a:srgbClr val="1F2937"/>
-                </a:solidFill>
-              </a:rPr>
-              <a:t>lý</a:t>
-            </a:r>
-            <a:r>
-              <a:rPr sz="1500" b="0" dirty="0">
-                <a:solidFill>
-                  <a:srgbClr val="1F2937"/>
-                </a:solidFill>
-              </a:rPr>
-              <a:t> </a:t>
-            </a:r>
-            <a:r>
-              <a:rPr sz="1500" b="0" dirty="0" err="1">
-                <a:solidFill>
-                  <a:srgbClr val="1F2937"/>
-                </a:solidFill>
-              </a:rPr>
-              <a:t>điều</a:t>
-            </a:r>
-            <a:r>
-              <a:rPr sz="1500" b="0" dirty="0">
-                <a:solidFill>
-                  <a:srgbClr val="1F2937"/>
-                </a:solidFill>
-              </a:rPr>
-              <a:t> </a:t>
-            </a:r>
-            <a:r>
-              <a:rPr sz="1500" b="0" dirty="0" err="1">
-                <a:solidFill>
-                  <a:srgbClr val="1F2937"/>
-                </a:solidFill>
-              </a:rPr>
-              <a:t>hành</a:t>
-            </a:r>
-            <a:r>
-              <a:rPr sz="1500" b="0" dirty="0">
-                <a:solidFill>
-                  <a:srgbClr val="1F2937"/>
-                </a:solidFill>
-              </a:rPr>
-              <a:t>, </a:t>
-            </a:r>
-            <a:r>
-              <a:rPr sz="1500" b="0" dirty="0" err="1">
-                <a:solidFill>
-                  <a:srgbClr val="1F2937"/>
-                </a:solidFill>
-              </a:rPr>
-              <a:t>phân</a:t>
-            </a:r>
-            <a:r>
-              <a:rPr sz="1500" b="0" dirty="0">
-                <a:solidFill>
-                  <a:srgbClr val="1F2937"/>
-                </a:solidFill>
-              </a:rPr>
-              <a:t> </a:t>
-            </a:r>
-            <a:r>
-              <a:rPr sz="1500" b="0" dirty="0" err="1">
-                <a:solidFill>
-                  <a:srgbClr val="1F2937"/>
-                </a:solidFill>
-              </a:rPr>
-              <a:t>tích</a:t>
-            </a:r>
-            <a:r>
-              <a:rPr sz="1500" b="0" dirty="0">
-                <a:solidFill>
-                  <a:srgbClr val="1F2937"/>
-                </a:solidFill>
-              </a:rPr>
-              <a:t> </a:t>
-            </a:r>
-            <a:r>
-              <a:rPr sz="1500" b="0" dirty="0" err="1">
-                <a:solidFill>
-                  <a:srgbClr val="1F2937"/>
-                </a:solidFill>
-              </a:rPr>
-              <a:t>sổ</a:t>
-            </a:r>
-            <a:r>
-              <a:rPr sz="1500" b="0" dirty="0">
-                <a:solidFill>
-                  <a:srgbClr val="1F2937"/>
-                </a:solidFill>
-              </a:rPr>
-              <a:t> </a:t>
-            </a:r>
-            <a:r>
-              <a:rPr sz="1500" b="0" dirty="0" err="1">
-                <a:solidFill>
-                  <a:srgbClr val="1F2937"/>
-                </a:solidFill>
-              </a:rPr>
-              <a:t>đầu</a:t>
-            </a:r>
-            <a:r>
-              <a:rPr sz="1500" b="0" dirty="0">
-                <a:solidFill>
-                  <a:srgbClr val="1F2937"/>
-                </a:solidFill>
-              </a:rPr>
-              <a:t> </a:t>
-            </a:r>
-            <a:r>
-              <a:rPr sz="1500" b="0" dirty="0" err="1">
-                <a:solidFill>
-                  <a:srgbClr val="1F2937"/>
-                </a:solidFill>
-              </a:rPr>
-              <a:t>bài</a:t>
-            </a:r>
-            <a:r>
-              <a:rPr sz="1500" b="0" dirty="0">
-                <a:solidFill>
-                  <a:srgbClr val="1F2937"/>
-                </a:solidFill>
-              </a:rPr>
-              <a:t>, </a:t>
-            </a:r>
-            <a:r>
-              <a:rPr sz="1500" b="0" dirty="0" err="1">
-                <a:solidFill>
-                  <a:srgbClr val="1F2937"/>
-                </a:solidFill>
-              </a:rPr>
-              <a:t>biên</a:t>
-            </a:r>
-            <a:r>
-              <a:rPr sz="1500" b="0" dirty="0">
-                <a:solidFill>
-                  <a:srgbClr val="1F2937"/>
-                </a:solidFill>
-              </a:rPr>
-              <a:t> </a:t>
-            </a:r>
-            <a:r>
-              <a:rPr sz="1500" b="0" dirty="0" err="1">
-                <a:solidFill>
-                  <a:srgbClr val="1F2937"/>
-                </a:solidFill>
-              </a:rPr>
-              <a:t>bản</a:t>
-            </a:r>
-            <a:r>
-              <a:rPr sz="1500" b="0" dirty="0">
-                <a:solidFill>
-                  <a:srgbClr val="1F2937"/>
-                </a:solidFill>
-              </a:rPr>
-              <a:t> </a:t>
-            </a:r>
-            <a:r>
-              <a:rPr sz="1500" b="0" dirty="0" err="1">
-                <a:solidFill>
-                  <a:srgbClr val="1F2937"/>
-                </a:solidFill>
-              </a:rPr>
-              <a:t>sinh</a:t>
-            </a:r>
-            <a:r>
-              <a:rPr sz="1500" b="0" dirty="0">
-                <a:solidFill>
-                  <a:srgbClr val="1F2937"/>
-                </a:solidFill>
-              </a:rPr>
-              <a:t> </a:t>
-            </a:r>
-            <a:r>
-              <a:rPr sz="1500" b="0" dirty="0" err="1">
-                <a:solidFill>
-                  <a:srgbClr val="1F2937"/>
-                </a:solidFill>
-              </a:rPr>
-              <a:t>hoạt</a:t>
-            </a:r>
-            <a:r>
-              <a:rPr sz="1500" b="0" dirty="0">
-                <a:solidFill>
-                  <a:srgbClr val="1F2937"/>
-                </a:solidFill>
-              </a:rPr>
-              <a:t>, </a:t>
-            </a:r>
-            <a:r>
-              <a:rPr sz="1500" b="0" dirty="0" err="1">
-                <a:solidFill>
-                  <a:srgbClr val="1F2937"/>
-                </a:solidFill>
-              </a:rPr>
-              <a:t>báo</a:t>
-            </a:r>
-            <a:r>
-              <a:rPr sz="1500" b="0" dirty="0">
-                <a:solidFill>
-                  <a:srgbClr val="1F2937"/>
-                </a:solidFill>
-              </a:rPr>
-              <a:t> </a:t>
-            </a:r>
-            <a:r>
-              <a:rPr sz="1500" b="0" dirty="0" err="1">
-                <a:solidFill>
-                  <a:srgbClr val="1F2937"/>
-                </a:solidFill>
-              </a:rPr>
-              <a:t>cáo</a:t>
-            </a:r>
-            <a:r>
-              <a:rPr sz="1500" b="0" dirty="0">
-                <a:solidFill>
-                  <a:srgbClr val="1F2937"/>
-                </a:solidFill>
-              </a:rPr>
-              <a:t> </a:t>
-            </a:r>
-            <a:r>
-              <a:rPr sz="1500" b="0" dirty="0" err="1">
-                <a:solidFill>
-                  <a:srgbClr val="1F2937"/>
-                </a:solidFill>
-              </a:rPr>
-              <a:t>Sở</a:t>
-            </a:r>
-            <a:endParaRPr sz="1500" b="0" dirty="0">
-              <a:solidFill>
-                <a:srgbClr val="1F2937"/>
-              </a:solidFill>
-            </a:endParaRPr>
+              <a:t>- Ứng dụng: báo cáo hồ sơ lớp, nhận xét giáo án, gợi ý cảnh báo, trợ lý điều hành, phân tích sổ đầu bài, biên bản sinh hoạt, báo cáo Sở</a:t>
+            </a:r>
           </a:p>
         </p:txBody>
       </p:sp>
@@ -4138,6 +3682,7 @@
           </a:bodyPr>
           <a:lstStyle/>
           <a:p>
+            <a:pPr/>
             <a:r>
               <a:rPr sz="1100" b="0">
                 <a:solidFill>
@@ -4158,7 +3703,7 @@
 </file>
 
 <file path=ppt/slides/slide12.xml><?xml version="1.0" encoding="utf-8"?>
-<p:sld xmlns:a="http://schemas.openxmlformats.org/drawingml/2006/main" xmlns:r="http://schemas.openxmlformats.org/officeDocument/2006/relationships" xmlns:p="http://schemas.openxmlformats.org/presentationml/2006/main">
+<p:sld xmlns:a="http://schemas.openxmlformats.org/drawingml/2006/main" xmlns:p="http://schemas.openxmlformats.org/presentationml/2006/main" xmlns:r="http://schemas.openxmlformats.org/officeDocument/2006/relationships">
   <p:cSld>
     <p:spTree>
       <p:nvGrpSpPr>
@@ -4166,14 +3711,7 @@
         <p:cNvGrpSpPr/>
         <p:nvPr/>
       </p:nvGrpSpPr>
-      <p:grpSpPr>
-        <a:xfrm>
-          <a:off x="0" y="0"/>
-          <a:ext cx="0" cy="0"/>
-          <a:chOff x="0" y="0"/>
-          <a:chExt cx="0" cy="0"/>
-        </a:xfrm>
-      </p:grpSpPr>
+      <p:grpSpPr/>
       <p:sp>
         <p:nvSpPr>
           <p:cNvPr id="2" name="Rectangle 1"/>
@@ -4214,7 +3752,6 @@
           <a:lstStyle/>
           <a:p>
             <a:pPr algn="ctr"/>
-            <a:endParaRPr/>
           </a:p>
         </p:txBody>
       </p:sp>
@@ -4240,6 +3777,7 @@
           </a:bodyPr>
           <a:lstStyle/>
           <a:p>
+            <a:pPr/>
             <a:r>
               <a:rPr sz="2800" b="1">
                 <a:solidFill>
@@ -4260,7 +3798,7 @@
         <p:spPr>
           <a:xfrm>
             <a:off x="548640" y="1234440"/>
-            <a:ext cx="5120640" cy="1246495"/>
+            <a:ext cx="5120640" cy="5303520"/>
           </a:xfrm>
           <a:prstGeom prst="rect">
             <a:avLst/>
@@ -4273,584 +3811,58 @@
           </a:bodyPr>
           <a:lstStyle/>
           <a:p>
-            <a:r>
-              <a:rPr sz="1500" b="0" dirty="0">
+            <a:pPr/>
+            <a:r>
+              <a:rPr sz="1500" b="0">
                 <a:solidFill>
                   <a:srgbClr val="1F2937"/>
                 </a:solidFill>
               </a:rPr>
-              <a:t>- </a:t>
-            </a:r>
-            <a:r>
-              <a:rPr sz="1500" b="0" dirty="0" err="1">
+              <a:t>- Xuất sổ chủ nhiệm, báo cáo Sở/Phòng (CSV/Excel), sổ cá nhân GV</a:t>
+            </a:r>
+          </a:p>
+          <a:p>
+            <a:pPr/>
+            <a:r>
+              <a:rPr sz="1500" b="0">
                 <a:solidFill>
                   <a:srgbClr val="1F2937"/>
                 </a:solidFill>
               </a:rPr>
-              <a:t>Xuất</a:t>
-            </a:r>
-            <a:r>
-              <a:rPr sz="1500" b="0" dirty="0">
+              <a:t>- RBAC 3 tầng: UI - route guard - Postgres RLS theo vai trò + quan hệ (lớp CN, tiết dạy, con mình)</a:t>
+            </a:r>
+          </a:p>
+          <a:p>
+            <a:pPr/>
+            <a:r>
+              <a:rPr sz="1500" b="0">
                 <a:solidFill>
                   <a:srgbClr val="1F2937"/>
                 </a:solidFill>
               </a:rPr>
-              <a:t> </a:t>
-            </a:r>
-            <a:r>
-              <a:rPr sz="1500" b="0" dirty="0" err="1">
+              <a:t>- Audit log mọi hành động quan trọng, trang xem cho BGH</a:t>
+            </a:r>
+          </a:p>
+          <a:p>
+            <a:pPr/>
+            <a:r>
+              <a:rPr sz="1500" b="0">
                 <a:solidFill>
                   <a:srgbClr val="1F2937"/>
                 </a:solidFill>
               </a:rPr>
-              <a:t>sổ</a:t>
-            </a:r>
-            <a:r>
-              <a:rPr sz="1500" b="0" dirty="0">
+              <a:t>- Trang Thông báo chung cho mọi vai trò - chuông trên topbar, đánh dấu đã đọc, link nhảy tới màn hình liên quan</a:t>
+            </a:r>
+          </a:p>
+          <a:p>
+            <a:pPr/>
+            <a:r>
+              <a:rPr sz="1500" b="0">
                 <a:solidFill>
                   <a:srgbClr val="1F2937"/>
                 </a:solidFill>
               </a:rPr>
-              <a:t> </a:t>
-            </a:r>
-            <a:r>
-              <a:rPr sz="1500" b="0" dirty="0" err="1">
-                <a:solidFill>
-                  <a:srgbClr val="1F2937"/>
-                </a:solidFill>
-              </a:rPr>
-              <a:t>chủ</a:t>
-            </a:r>
-            <a:r>
-              <a:rPr sz="1500" b="0" dirty="0">
-                <a:solidFill>
-                  <a:srgbClr val="1F2937"/>
-                </a:solidFill>
-              </a:rPr>
-              <a:t> </a:t>
-            </a:r>
-            <a:r>
-              <a:rPr sz="1500" b="0" dirty="0" err="1">
-                <a:solidFill>
-                  <a:srgbClr val="1F2937"/>
-                </a:solidFill>
-              </a:rPr>
-              <a:t>nhiệm</a:t>
-            </a:r>
-            <a:r>
-              <a:rPr sz="1500" b="0" dirty="0">
-                <a:solidFill>
-                  <a:srgbClr val="1F2937"/>
-                </a:solidFill>
-              </a:rPr>
-              <a:t>, </a:t>
-            </a:r>
-            <a:r>
-              <a:rPr sz="1500" b="0" dirty="0" err="1">
-                <a:solidFill>
-                  <a:srgbClr val="1F2937"/>
-                </a:solidFill>
-              </a:rPr>
-              <a:t>báo</a:t>
-            </a:r>
-            <a:r>
-              <a:rPr sz="1500" b="0" dirty="0">
-                <a:solidFill>
-                  <a:srgbClr val="1F2937"/>
-                </a:solidFill>
-              </a:rPr>
-              <a:t> </a:t>
-            </a:r>
-            <a:r>
-              <a:rPr sz="1500" b="0" dirty="0" err="1">
-                <a:solidFill>
-                  <a:srgbClr val="1F2937"/>
-                </a:solidFill>
-              </a:rPr>
-              <a:t>cáo</a:t>
-            </a:r>
-            <a:r>
-              <a:rPr sz="1500" b="0" dirty="0">
-                <a:solidFill>
-                  <a:srgbClr val="1F2937"/>
-                </a:solidFill>
-              </a:rPr>
-              <a:t> </a:t>
-            </a:r>
-            <a:r>
-              <a:rPr sz="1500" b="0" dirty="0" err="1">
-                <a:solidFill>
-                  <a:srgbClr val="1F2937"/>
-                </a:solidFill>
-              </a:rPr>
-              <a:t>Sở</a:t>
-            </a:r>
-            <a:r>
-              <a:rPr sz="1500" b="0" dirty="0">
-                <a:solidFill>
-                  <a:srgbClr val="1F2937"/>
-                </a:solidFill>
-              </a:rPr>
-              <a:t>/</a:t>
-            </a:r>
-            <a:r>
-              <a:rPr sz="1500" b="0" dirty="0" err="1">
-                <a:solidFill>
-                  <a:srgbClr val="1F2937"/>
-                </a:solidFill>
-              </a:rPr>
-              <a:t>Phòng</a:t>
-            </a:r>
-            <a:r>
-              <a:rPr sz="1500" b="0" dirty="0">
-                <a:solidFill>
-                  <a:srgbClr val="1F2937"/>
-                </a:solidFill>
-              </a:rPr>
-              <a:t> (CSV/Excel), </a:t>
-            </a:r>
-            <a:r>
-              <a:rPr sz="1500" b="0" dirty="0" err="1">
-                <a:solidFill>
-                  <a:srgbClr val="1F2937"/>
-                </a:solidFill>
-              </a:rPr>
-              <a:t>sổ</a:t>
-            </a:r>
-            <a:r>
-              <a:rPr sz="1500" b="0" dirty="0">
-                <a:solidFill>
-                  <a:srgbClr val="1F2937"/>
-                </a:solidFill>
-              </a:rPr>
-              <a:t> </a:t>
-            </a:r>
-            <a:r>
-              <a:rPr sz="1500" b="0" dirty="0" err="1">
-                <a:solidFill>
-                  <a:srgbClr val="1F2937"/>
-                </a:solidFill>
-              </a:rPr>
-              <a:t>cá</a:t>
-            </a:r>
-            <a:r>
-              <a:rPr sz="1500" b="0" dirty="0">
-                <a:solidFill>
-                  <a:srgbClr val="1F2937"/>
-                </a:solidFill>
-              </a:rPr>
-              <a:t> </a:t>
-            </a:r>
-            <a:r>
-              <a:rPr sz="1500" b="0" dirty="0" err="1">
-                <a:solidFill>
-                  <a:srgbClr val="1F2937"/>
-                </a:solidFill>
-              </a:rPr>
-              <a:t>nhân</a:t>
-            </a:r>
-            <a:r>
-              <a:rPr sz="1500" b="0" dirty="0">
-                <a:solidFill>
-                  <a:srgbClr val="1F2937"/>
-                </a:solidFill>
-              </a:rPr>
-              <a:t> GV</a:t>
-            </a:r>
-          </a:p>
-          <a:p>
-            <a:r>
-              <a:rPr sz="1500" b="0" dirty="0">
-                <a:solidFill>
-                  <a:srgbClr val="1F2937"/>
-                </a:solidFill>
-              </a:rPr>
-              <a:t>- Audit log </a:t>
-            </a:r>
-            <a:r>
-              <a:rPr sz="1500" b="0" dirty="0" err="1">
-                <a:solidFill>
-                  <a:srgbClr val="1F2937"/>
-                </a:solidFill>
-              </a:rPr>
-              <a:t>mọi</a:t>
-            </a:r>
-            <a:r>
-              <a:rPr sz="1500" b="0" dirty="0">
-                <a:solidFill>
-                  <a:srgbClr val="1F2937"/>
-                </a:solidFill>
-              </a:rPr>
-              <a:t> </a:t>
-            </a:r>
-            <a:r>
-              <a:rPr sz="1500" b="0" dirty="0" err="1">
-                <a:solidFill>
-                  <a:srgbClr val="1F2937"/>
-                </a:solidFill>
-              </a:rPr>
-              <a:t>hành</a:t>
-            </a:r>
-            <a:r>
-              <a:rPr sz="1500" b="0" dirty="0">
-                <a:solidFill>
-                  <a:srgbClr val="1F2937"/>
-                </a:solidFill>
-              </a:rPr>
-              <a:t> </a:t>
-            </a:r>
-            <a:r>
-              <a:rPr sz="1500" b="0" dirty="0" err="1">
-                <a:solidFill>
-                  <a:srgbClr val="1F2937"/>
-                </a:solidFill>
-              </a:rPr>
-              <a:t>động</a:t>
-            </a:r>
-            <a:r>
-              <a:rPr sz="1500" b="0" dirty="0">
-                <a:solidFill>
-                  <a:srgbClr val="1F2937"/>
-                </a:solidFill>
-              </a:rPr>
-              <a:t> </a:t>
-            </a:r>
-            <a:r>
-              <a:rPr sz="1500" b="0" dirty="0" err="1">
-                <a:solidFill>
-                  <a:srgbClr val="1F2937"/>
-                </a:solidFill>
-              </a:rPr>
-              <a:t>quan</a:t>
-            </a:r>
-            <a:r>
-              <a:rPr sz="1500" b="0" dirty="0">
-                <a:solidFill>
-                  <a:srgbClr val="1F2937"/>
-                </a:solidFill>
-              </a:rPr>
-              <a:t> </a:t>
-            </a:r>
-            <a:r>
-              <a:rPr sz="1500" b="0" dirty="0" err="1">
-                <a:solidFill>
-                  <a:srgbClr val="1F2937"/>
-                </a:solidFill>
-              </a:rPr>
-              <a:t>trọng</a:t>
-            </a:r>
-            <a:r>
-              <a:rPr sz="1500" b="0" dirty="0">
-                <a:solidFill>
-                  <a:srgbClr val="1F2937"/>
-                </a:solidFill>
-              </a:rPr>
-              <a:t>, </a:t>
-            </a:r>
-            <a:r>
-              <a:rPr sz="1500" b="0" dirty="0" err="1">
-                <a:solidFill>
-                  <a:srgbClr val="1F2937"/>
-                </a:solidFill>
-              </a:rPr>
-              <a:t>trang</a:t>
-            </a:r>
-            <a:r>
-              <a:rPr sz="1500" b="0" dirty="0">
-                <a:solidFill>
-                  <a:srgbClr val="1F2937"/>
-                </a:solidFill>
-              </a:rPr>
-              <a:t> </a:t>
-            </a:r>
-            <a:r>
-              <a:rPr sz="1500" b="0" dirty="0" err="1">
-                <a:solidFill>
-                  <a:srgbClr val="1F2937"/>
-                </a:solidFill>
-              </a:rPr>
-              <a:t>xem</a:t>
-            </a:r>
-            <a:r>
-              <a:rPr sz="1500" b="0" dirty="0">
-                <a:solidFill>
-                  <a:srgbClr val="1F2937"/>
-                </a:solidFill>
-              </a:rPr>
-              <a:t> </a:t>
-            </a:r>
-            <a:r>
-              <a:rPr sz="1500" b="0" dirty="0" err="1">
-                <a:solidFill>
-                  <a:srgbClr val="1F2937"/>
-                </a:solidFill>
-              </a:rPr>
-              <a:t>cho</a:t>
-            </a:r>
-            <a:r>
-              <a:rPr sz="1500" b="0" dirty="0">
-                <a:solidFill>
-                  <a:srgbClr val="1F2937"/>
-                </a:solidFill>
-              </a:rPr>
-              <a:t> BGH</a:t>
-            </a:r>
-          </a:p>
-          <a:p>
-            <a:r>
-              <a:rPr sz="1500" b="0" dirty="0">
-                <a:solidFill>
-                  <a:srgbClr val="1F2937"/>
-                </a:solidFill>
-              </a:rPr>
-              <a:t>- Notification in-app </a:t>
-            </a:r>
-            <a:r>
-              <a:rPr sz="1500" b="0" dirty="0" err="1">
-                <a:solidFill>
-                  <a:srgbClr val="1F2937"/>
-                </a:solidFill>
-              </a:rPr>
-              <a:t>cho</a:t>
-            </a:r>
-            <a:r>
-              <a:rPr sz="1500" b="0" dirty="0">
-                <a:solidFill>
-                  <a:srgbClr val="1F2937"/>
-                </a:solidFill>
-              </a:rPr>
-              <a:t> </a:t>
-            </a:r>
-            <a:r>
-              <a:rPr sz="1500" b="0" dirty="0" err="1">
-                <a:solidFill>
-                  <a:srgbClr val="1F2937"/>
-                </a:solidFill>
-              </a:rPr>
-              <a:t>mọi</a:t>
-            </a:r>
-            <a:r>
-              <a:rPr sz="1500" b="0" dirty="0">
-                <a:solidFill>
-                  <a:srgbClr val="1F2937"/>
-                </a:solidFill>
-              </a:rPr>
-              <a:t> </a:t>
-            </a:r>
-            <a:r>
-              <a:rPr sz="1500" b="0" dirty="0" err="1">
-                <a:solidFill>
-                  <a:srgbClr val="1F2937"/>
-                </a:solidFill>
-              </a:rPr>
-              <a:t>hành</a:t>
-            </a:r>
-            <a:r>
-              <a:rPr sz="1500" b="0" dirty="0">
-                <a:solidFill>
-                  <a:srgbClr val="1F2937"/>
-                </a:solidFill>
-              </a:rPr>
-              <a:t> </a:t>
-            </a:r>
-            <a:r>
-              <a:rPr sz="1500" b="0" dirty="0" err="1">
-                <a:solidFill>
-                  <a:srgbClr val="1F2937"/>
-                </a:solidFill>
-              </a:rPr>
-              <a:t>động</a:t>
-            </a:r>
-            <a:r>
-              <a:rPr sz="1500" b="0" dirty="0">
-                <a:solidFill>
-                  <a:srgbClr val="1F2937"/>
-                </a:solidFill>
-              </a:rPr>
-              <a:t> </a:t>
-            </a:r>
-            <a:r>
-              <a:rPr sz="1500" b="0" dirty="0" err="1">
-                <a:solidFill>
-                  <a:srgbClr val="1F2937"/>
-                </a:solidFill>
-              </a:rPr>
-              <a:t>ảnh</a:t>
-            </a:r>
-            <a:r>
-              <a:rPr sz="1500" b="0" dirty="0">
-                <a:solidFill>
-                  <a:srgbClr val="1F2937"/>
-                </a:solidFill>
-              </a:rPr>
-              <a:t> </a:t>
-            </a:r>
-            <a:r>
-              <a:rPr sz="1500" b="0" dirty="0" err="1">
-                <a:solidFill>
-                  <a:srgbClr val="1F2937"/>
-                </a:solidFill>
-              </a:rPr>
-              <a:t>hưởng</a:t>
-            </a:r>
-            <a:r>
-              <a:rPr sz="1500" b="0" dirty="0">
-                <a:solidFill>
-                  <a:srgbClr val="1F2937"/>
-                </a:solidFill>
-              </a:rPr>
-              <a:t> </a:t>
-            </a:r>
-            <a:r>
-              <a:rPr sz="1500" b="0" dirty="0" err="1">
-                <a:solidFill>
-                  <a:srgbClr val="1F2937"/>
-                </a:solidFill>
-              </a:rPr>
-              <a:t>người</a:t>
-            </a:r>
-            <a:r>
-              <a:rPr sz="1500" b="0" dirty="0">
-                <a:solidFill>
-                  <a:srgbClr val="1F2937"/>
-                </a:solidFill>
-              </a:rPr>
-              <a:t> </a:t>
-            </a:r>
-            <a:r>
-              <a:rPr sz="1500" b="0" dirty="0" err="1">
-                <a:solidFill>
-                  <a:srgbClr val="1F2937"/>
-                </a:solidFill>
-              </a:rPr>
-              <a:t>khác</a:t>
-            </a:r>
-            <a:endParaRPr sz="1500" b="0" dirty="0">
-              <a:solidFill>
-                <a:srgbClr val="1F2937"/>
-              </a:solidFill>
-            </a:endParaRPr>
-          </a:p>
-          <a:p>
-            <a:r>
-              <a:rPr sz="1500" b="0" dirty="0">
-                <a:solidFill>
-                  <a:srgbClr val="1F2937"/>
-                </a:solidFill>
-              </a:rPr>
-              <a:t>- Responsive mobile, </a:t>
-            </a:r>
-            <a:r>
-              <a:rPr sz="1500" b="0" dirty="0" err="1">
-                <a:solidFill>
-                  <a:srgbClr val="1F2937"/>
-                </a:solidFill>
-              </a:rPr>
-              <a:t>sắp</a:t>
-            </a:r>
-            <a:r>
-              <a:rPr sz="1500" b="0" dirty="0">
-                <a:solidFill>
-                  <a:srgbClr val="1F2937"/>
-                </a:solidFill>
-              </a:rPr>
-              <a:t> </a:t>
-            </a:r>
-            <a:r>
-              <a:rPr sz="1500" b="0" dirty="0" err="1">
-                <a:solidFill>
-                  <a:srgbClr val="1F2937"/>
-                </a:solidFill>
-              </a:rPr>
-              <a:t>xếp</a:t>
-            </a:r>
-            <a:r>
-              <a:rPr sz="1500" b="0" dirty="0">
-                <a:solidFill>
-                  <a:srgbClr val="1F2937"/>
-                </a:solidFill>
-              </a:rPr>
-              <a:t> </a:t>
-            </a:r>
-            <a:r>
-              <a:rPr sz="1500" b="0" dirty="0" err="1">
-                <a:solidFill>
-                  <a:srgbClr val="1F2937"/>
-                </a:solidFill>
-              </a:rPr>
-              <a:t>tên</a:t>
-            </a:r>
-            <a:r>
-              <a:rPr sz="1500" b="0" dirty="0">
-                <a:solidFill>
-                  <a:srgbClr val="1F2937"/>
-                </a:solidFill>
-              </a:rPr>
-              <a:t> </a:t>
-            </a:r>
-            <a:r>
-              <a:rPr sz="1500" b="0" dirty="0" err="1">
-                <a:solidFill>
-                  <a:srgbClr val="1F2937"/>
-                </a:solidFill>
-              </a:rPr>
-              <a:t>theo</a:t>
-            </a:r>
-            <a:r>
-              <a:rPr sz="1500" b="0" dirty="0">
-                <a:solidFill>
-                  <a:srgbClr val="1F2937"/>
-                </a:solidFill>
-              </a:rPr>
-              <a:t> </a:t>
-            </a:r>
-            <a:r>
-              <a:rPr sz="1500" b="0" dirty="0" err="1">
-                <a:solidFill>
-                  <a:srgbClr val="1F2937"/>
-                </a:solidFill>
-              </a:rPr>
-              <a:t>quy</a:t>
-            </a:r>
-            <a:r>
-              <a:rPr sz="1500" b="0" dirty="0">
-                <a:solidFill>
-                  <a:srgbClr val="1F2937"/>
-                </a:solidFill>
-              </a:rPr>
-              <a:t> </a:t>
-            </a:r>
-            <a:r>
-              <a:rPr sz="1500" b="0" dirty="0" err="1">
-                <a:solidFill>
-                  <a:srgbClr val="1F2937"/>
-                </a:solidFill>
-              </a:rPr>
-              <a:t>tắc</a:t>
-            </a:r>
-            <a:r>
-              <a:rPr sz="1500" b="0" dirty="0">
-                <a:solidFill>
-                  <a:srgbClr val="1F2937"/>
-                </a:solidFill>
-              </a:rPr>
-              <a:t> </a:t>
-            </a:r>
-            <a:r>
-              <a:rPr sz="1500" b="0" dirty="0" err="1">
-                <a:solidFill>
-                  <a:srgbClr val="1F2937"/>
-                </a:solidFill>
-              </a:rPr>
-              <a:t>Việt</a:t>
-            </a:r>
-            <a:r>
-              <a:rPr sz="1500" b="0" dirty="0">
-                <a:solidFill>
-                  <a:srgbClr val="1F2937"/>
-                </a:solidFill>
-              </a:rPr>
-              <a:t> Nam</a:t>
+              <a:t>- Responsive mobile, sắp xếp tên theo quy tắc Việt Nam</a:t>
             </a:r>
           </a:p>
         </p:txBody>
@@ -4906,6 +3918,7 @@
           </a:bodyPr>
           <a:lstStyle/>
           <a:p>
+            <a:pPr/>
             <a:r>
               <a:rPr sz="1100" b="0">
                 <a:solidFill>
@@ -4926,7 +3939,7 @@
 </file>
 
 <file path=ppt/slides/slide13.xml><?xml version="1.0" encoding="utf-8"?>
-<p:sld xmlns:a="http://schemas.openxmlformats.org/drawingml/2006/main" xmlns:r="http://schemas.openxmlformats.org/officeDocument/2006/relationships" xmlns:p="http://schemas.openxmlformats.org/presentationml/2006/main">
+<p:sld xmlns:a="http://schemas.openxmlformats.org/drawingml/2006/main" xmlns:p="http://schemas.openxmlformats.org/presentationml/2006/main" xmlns:r="http://schemas.openxmlformats.org/officeDocument/2006/relationships">
   <p:cSld>
     <p:spTree>
       <p:nvGrpSpPr>
@@ -4934,14 +3947,7 @@
         <p:cNvGrpSpPr/>
         <p:nvPr/>
       </p:nvGrpSpPr>
-      <p:grpSpPr>
-        <a:xfrm>
-          <a:off x="0" y="0"/>
-          <a:ext cx="0" cy="0"/>
-          <a:chOff x="0" y="0"/>
-          <a:chExt cx="0" cy="0"/>
-        </a:xfrm>
-      </p:grpSpPr>
+      <p:grpSpPr/>
       <p:sp>
         <p:nvSpPr>
           <p:cNvPr id="2" name="Rectangle 1"/>
@@ -4982,7 +3988,6 @@
           <a:lstStyle/>
           <a:p>
             <a:pPr algn="ctr"/>
-            <a:endParaRPr/>
           </a:p>
         </p:txBody>
       </p:sp>
@@ -5008,6 +4013,7 @@
           </a:bodyPr>
           <a:lstStyle/>
           <a:p>
+            <a:pPr/>
             <a:r>
               <a:rPr sz="3600" b="1">
                 <a:solidFill>
@@ -5018,6 +4024,7 @@
             </a:r>
           </a:p>
           <a:p>
+            <a:pPr/>
             <a:r>
               <a:rPr sz="2000" b="0">
                 <a:solidFill>
@@ -5028,6 +4035,7 @@
             </a:r>
           </a:p>
           <a:p>
+            <a:pPr/>
             <a:r>
               <a:rPr sz="1600" b="0">
                 <a:solidFill>
@@ -5038,6 +4046,7 @@
             </a:r>
           </a:p>
           <a:p>
+            <a:pPr/>
             <a:r>
               <a:rPr sz="1400" b="0">
                 <a:solidFill>
@@ -5058,7 +4067,7 @@
 </file>
 
 <file path=ppt/slides/slide2.xml><?xml version="1.0" encoding="utf-8"?>
-<p:sld xmlns:a="http://schemas.openxmlformats.org/drawingml/2006/main" xmlns:r="http://schemas.openxmlformats.org/officeDocument/2006/relationships" xmlns:p="http://schemas.openxmlformats.org/presentationml/2006/main">
+<p:sld xmlns:a="http://schemas.openxmlformats.org/drawingml/2006/main" xmlns:p="http://schemas.openxmlformats.org/presentationml/2006/main" xmlns:r="http://schemas.openxmlformats.org/officeDocument/2006/relationships">
   <p:cSld>
     <p:spTree>
       <p:nvGrpSpPr>
@@ -5066,14 +4075,7 @@
         <p:cNvGrpSpPr/>
         <p:nvPr/>
       </p:nvGrpSpPr>
-      <p:grpSpPr>
-        <a:xfrm>
-          <a:off x="0" y="0"/>
-          <a:ext cx="0" cy="0"/>
-          <a:chOff x="0" y="0"/>
-          <a:chExt cx="0" cy="0"/>
-        </a:xfrm>
-      </p:grpSpPr>
+      <p:grpSpPr/>
       <p:sp>
         <p:nvSpPr>
           <p:cNvPr id="2" name="Rectangle 1"/>
@@ -5114,7 +4116,6 @@
           <a:lstStyle/>
           <a:p>
             <a:pPr algn="ctr"/>
-            <a:endParaRPr/>
           </a:p>
         </p:txBody>
       </p:sp>
@@ -5140,6 +4141,7 @@
           </a:bodyPr>
           <a:lstStyle/>
           <a:p>
+            <a:pPr/>
             <a:r>
               <a:rPr sz="2800" b="1">
                 <a:solidFill>
@@ -5173,6 +4175,7 @@
           </a:bodyPr>
           <a:lstStyle/>
           <a:p>
+            <a:pPr/>
             <a:r>
               <a:rPr sz="1500" b="0">
                 <a:solidFill>
@@ -5183,6 +4186,7 @@
             </a:r>
           </a:p>
           <a:p>
+            <a:pPr/>
             <a:r>
               <a:rPr sz="1500" b="0">
                 <a:solidFill>
@@ -5193,6 +4197,7 @@
             </a:r>
           </a:p>
           <a:p>
+            <a:pPr/>
             <a:r>
               <a:rPr sz="1500" b="0">
                 <a:solidFill>
@@ -5203,6 +4208,7 @@
             </a:r>
           </a:p>
           <a:p>
+            <a:pPr/>
             <a:r>
               <a:rPr sz="1500" b="0">
                 <a:solidFill>
@@ -5213,6 +4219,7 @@
             </a:r>
           </a:p>
           <a:p>
+            <a:pPr/>
             <a:r>
               <a:rPr sz="1500" b="0">
                 <a:solidFill>
@@ -5223,6 +4230,7 @@
             </a:r>
           </a:p>
           <a:p>
+            <a:pPr/>
             <a:r>
               <a:rPr sz="1500" b="0">
                 <a:solidFill>
@@ -5285,6 +4293,7 @@
           </a:bodyPr>
           <a:lstStyle/>
           <a:p>
+            <a:pPr/>
             <a:r>
               <a:rPr sz="1100" b="0">
                 <a:solidFill>
@@ -5305,7 +4314,7 @@
 </file>
 
 <file path=ppt/slides/slide3.xml><?xml version="1.0" encoding="utf-8"?>
-<p:sld xmlns:a="http://schemas.openxmlformats.org/drawingml/2006/main" xmlns:r="http://schemas.openxmlformats.org/officeDocument/2006/relationships" xmlns:p="http://schemas.openxmlformats.org/presentationml/2006/main">
+<p:sld xmlns:a="http://schemas.openxmlformats.org/drawingml/2006/main" xmlns:p="http://schemas.openxmlformats.org/presentationml/2006/main" xmlns:r="http://schemas.openxmlformats.org/officeDocument/2006/relationships">
   <p:cSld>
     <p:spTree>
       <p:nvGrpSpPr>
@@ -5313,14 +4322,7 @@
         <p:cNvGrpSpPr/>
         <p:nvPr/>
       </p:nvGrpSpPr>
-      <p:grpSpPr>
-        <a:xfrm>
-          <a:off x="0" y="0"/>
-          <a:ext cx="0" cy="0"/>
-          <a:chOff x="0" y="0"/>
-          <a:chExt cx="0" cy="0"/>
-        </a:xfrm>
-      </p:grpSpPr>
+      <p:grpSpPr/>
       <p:sp>
         <p:nvSpPr>
           <p:cNvPr id="2" name="TextBox 1"/>
@@ -5343,6 +4345,7 @@
           </a:bodyPr>
           <a:lstStyle/>
           <a:p>
+            <a:pPr/>
             <a:r>
               <a:rPr sz="2800" b="1">
                 <a:solidFill>
@@ -5373,34 +4376,10 @@
                 <a:tableStyleId>{5C22544A-7EE6-4342-B048-85BDC9FD1C3A}</a:tableStyleId>
               </a:tblPr>
               <a:tblGrid>
-                <a:gridCol w="2773603">
-                  <a:extLst>
-                    <a:ext uri="{9D8B030D-6E8A-4147-A177-3AD203B41FA5}">
-                      <a16:colId xmlns:a16="http://schemas.microsoft.com/office/drawing/2014/main" val="20000"/>
-                    </a:ext>
-                  </a:extLst>
-                </a:gridCol>
-                <a:gridCol w="2773603">
-                  <a:extLst>
-                    <a:ext uri="{9D8B030D-6E8A-4147-A177-3AD203B41FA5}">
-                      <a16:colId xmlns:a16="http://schemas.microsoft.com/office/drawing/2014/main" val="20001"/>
-                    </a:ext>
-                  </a:extLst>
-                </a:gridCol>
-                <a:gridCol w="2773603">
-                  <a:extLst>
-                    <a:ext uri="{9D8B030D-6E8A-4147-A177-3AD203B41FA5}">
-                      <a16:colId xmlns:a16="http://schemas.microsoft.com/office/drawing/2014/main" val="20002"/>
-                    </a:ext>
-                  </a:extLst>
-                </a:gridCol>
-                <a:gridCol w="2773606">
-                  <a:extLst>
-                    <a:ext uri="{9D8B030D-6E8A-4147-A177-3AD203B41FA5}">
-                      <a16:colId xmlns:a16="http://schemas.microsoft.com/office/drawing/2014/main" val="20003"/>
-                    </a:ext>
-                  </a:extLst>
-                </a:gridCol>
+                <a:gridCol w="2773603"/>
+                <a:gridCol w="2773603"/>
+                <a:gridCol w="2773603"/>
+                <a:gridCol w="2773606"/>
               </a:tblGrid>
               <a:tr h="950976">
                 <a:tc>
@@ -5449,17 +4428,12 @@
                     <a:p>
                       <a:r>
                         <a:rPr sz="1400"/>
-                        <a:t>Điểm các lớp dạy, giáo án</a:t>
+                        <a:t>Điểm/sổ đầu bài đúng lớp-môn được phân công</a:t>
                       </a:r>
                     </a:p>
                   </a:txBody>
                   <a:tcPr/>
                 </a:tc>
-                <a:extLst>
-                  <a:ext uri="{0D108BD9-81ED-4DB2-BD59-A6C34878D82A}">
-                    <a16:rowId xmlns:a16="http://schemas.microsoft.com/office/drawing/2014/main" val="10000"/>
-                  </a:ext>
-                </a:extLst>
               </a:tr>
               <a:tr h="950976">
                 <a:tc>
@@ -5508,17 +4482,12 @@
                     <a:p>
                       <a:r>
                         <a:rPr sz="1400"/>
-                        <a:t>Toàn trường: duyệt, TKB, radar, AI</a:t>
+                        <a:t>Toàn trường: ký sổ, phân công, duyệt, radar</a:t>
                       </a:r>
                     </a:p>
                   </a:txBody>
                   <a:tcPr/>
                 </a:tc>
-                <a:extLst>
-                  <a:ext uri="{0D108BD9-81ED-4DB2-BD59-A6C34878D82A}">
-                    <a16:rowId xmlns:a16="http://schemas.microsoft.com/office/drawing/2014/main" val="10001"/>
-                  </a:ext>
-                </a:extLst>
               </a:tr>
               <a:tr h="950976">
                 <a:tc>
@@ -5541,7 +4510,7 @@
                     <a:p>
                       <a:r>
                         <a:rPr sz="1400"/>
-                        <a:t>Như BGH, giới hạn campus</a:t>
+                        <a:t>Vận hành trường - không ký sổ/phân công</a:t>
                       </a:r>
                     </a:p>
                   </a:txBody>
@@ -5567,17 +4536,12 @@
                     <a:p>
                       <a:r>
                         <a:rPr sz="1400"/>
-                        <a:t>Nhân sự, TT15 cơ sở vật chất</a:t>
+                        <a:t>Nhân sự, CSVC, NQ37 - không xem hồ sơ HS</a:t>
                       </a:r>
                     </a:p>
                   </a:txBody>
                   <a:tcPr/>
                 </a:tc>
-                <a:extLst>
-                  <a:ext uri="{0D108BD9-81ED-4DB2-BD59-A6C34878D82A}">
-                    <a16:rowId xmlns:a16="http://schemas.microsoft.com/office/drawing/2014/main" val="10002"/>
-                  </a:ext>
-                </a:extLst>
               </a:tr>
               <a:tr h="950976">
                 <a:tc>
@@ -5632,11 +4596,6 @@
                   </a:txBody>
                   <a:tcPr/>
                 </a:tc>
-                <a:extLst>
-                  <a:ext uri="{0D108BD9-81ED-4DB2-BD59-A6C34878D82A}">
-                    <a16:rowId xmlns:a16="http://schemas.microsoft.com/office/drawing/2014/main" val="10003"/>
-                  </a:ext>
-                </a:extLst>
               </a:tr>
               <a:tr h="950976">
                 <a:tc>
@@ -5659,7 +4618,7 @@
                     <a:p>
                       <a:r>
                         <a:rPr sz="1400"/>
-                        <a:t>Con mình: tin nhắn, lịch hẹn, đăng ký</a:t>
+                        <a:t>Con mình (nhiều con): tin nhắn, lịch hẹn, đăng ký</a:t>
                       </a:r>
                     </a:p>
                   </a:txBody>
@@ -5691,11 +4650,6 @@
                   </a:txBody>
                   <a:tcPr/>
                 </a:tc>
-                <a:extLst>
-                  <a:ext uri="{0D108BD9-81ED-4DB2-BD59-A6C34878D82A}">
-                    <a16:rowId xmlns:a16="http://schemas.microsoft.com/office/drawing/2014/main" val="10004"/>
-                  </a:ext>
-                </a:extLst>
               </a:tr>
             </a:tbl>
           </a:graphicData>
@@ -5710,7 +4664,7 @@
 </file>
 
 <file path=ppt/slides/slide4.xml><?xml version="1.0" encoding="utf-8"?>
-<p:sld xmlns:a="http://schemas.openxmlformats.org/drawingml/2006/main" xmlns:r="http://schemas.openxmlformats.org/officeDocument/2006/relationships" xmlns:p="http://schemas.openxmlformats.org/presentationml/2006/main">
+<p:sld xmlns:a="http://schemas.openxmlformats.org/drawingml/2006/main" xmlns:p="http://schemas.openxmlformats.org/presentationml/2006/main" xmlns:r="http://schemas.openxmlformats.org/officeDocument/2006/relationships">
   <p:cSld>
     <p:spTree>
       <p:nvGrpSpPr>
@@ -5718,14 +4672,7 @@
         <p:cNvGrpSpPr/>
         <p:nvPr/>
       </p:nvGrpSpPr>
-      <p:grpSpPr>
-        <a:xfrm>
-          <a:off x="0" y="0"/>
-          <a:ext cx="0" cy="0"/>
-          <a:chOff x="0" y="0"/>
-          <a:chExt cx="0" cy="0"/>
-        </a:xfrm>
-      </p:grpSpPr>
+      <p:grpSpPr/>
       <p:sp>
         <p:nvSpPr>
           <p:cNvPr id="2" name="Rectangle 1"/>
@@ -5766,7 +4713,6 @@
           <a:lstStyle/>
           <a:p>
             <a:pPr algn="ctr"/>
-            <a:endParaRPr/>
           </a:p>
         </p:txBody>
       </p:sp>
@@ -5792,6 +4738,7 @@
           </a:bodyPr>
           <a:lstStyle/>
           <a:p>
+            <a:pPr/>
             <a:r>
               <a:rPr sz="2800" b="1">
                 <a:solidFill>
@@ -5812,7 +4759,7 @@
         <p:spPr>
           <a:xfrm>
             <a:off x="548640" y="1234440"/>
-            <a:ext cx="5120640" cy="1708160"/>
+            <a:ext cx="5120640" cy="5303520"/>
           </a:xfrm>
           <a:prstGeom prst="rect">
             <a:avLst/>
@@ -5825,916 +4772,70 @@
           </a:bodyPr>
           <a:lstStyle/>
           <a:p>
-            <a:r>
-              <a:rPr sz="1500" b="0" dirty="0">
+            <a:pPr/>
+            <a:r>
+              <a:rPr sz="1500" b="0">
                 <a:solidFill>
                   <a:srgbClr val="1F2937"/>
                 </a:solidFill>
               </a:rPr>
-              <a:t>- 4 </a:t>
-            </a:r>
-            <a:r>
-              <a:rPr sz="1500" b="0" dirty="0" err="1">
+              <a:t>- 4 trạng thái/em: Có mặt, Vắng CP, Vắng KP, Đi muộn + ghi chú lý do ngay trên dòng</a:t>
+            </a:r>
+          </a:p>
+          <a:p>
+            <a:pPr/>
+            <a:r>
+              <a:rPr sz="1500" b="0">
                 <a:solidFill>
                   <a:srgbClr val="1F2937"/>
                 </a:solidFill>
               </a:rPr>
-              <a:t>trạng</a:t>
-            </a:r>
-            <a:r>
-              <a:rPr sz="1500" b="0" dirty="0">
+              <a:t>- Chọn ngày bất kỳ để xem lại / sửa điểm danh ngày cũ</a:t>
+            </a:r>
+          </a:p>
+          <a:p>
+            <a:pPr/>
+            <a:r>
+              <a:rPr sz="1500" b="0">
                 <a:solidFill>
                   <a:srgbClr val="1F2937"/>
                 </a:solidFill>
               </a:rPr>
-              <a:t> </a:t>
-            </a:r>
-            <a:r>
-              <a:rPr sz="1500" b="0" dirty="0" err="1">
+              <a:t>- Sổ vắng-muộn và lịch sử theo khoảng ngày (from - to)</a:t>
+            </a:r>
+          </a:p>
+          <a:p>
+            <a:pPr/>
+            <a:r>
+              <a:rPr sz="1500" b="0">
                 <a:solidFill>
                   <a:srgbClr val="1F2937"/>
                 </a:solidFill>
               </a:rPr>
-              <a:t>thái</a:t>
-            </a:r>
-            <a:r>
-              <a:rPr sz="1500" b="0" dirty="0">
+              <a:t>- Ma trận HS x ngày phát hiện vắng liên tục</a:t>
+            </a:r>
+          </a:p>
+          <a:p>
+            <a:pPr/>
+            <a:r>
+              <a:rPr sz="1500" b="0">
                 <a:solidFill>
                   <a:srgbClr val="1F2937"/>
                 </a:solidFill>
               </a:rPr>
-              <a:t>/</a:t>
-            </a:r>
-            <a:r>
-              <a:rPr lang="en-US" sz="1500" b="0" dirty="0">
+              <a:t>- Thông báo phụ huynh tự động (email + in-app)</a:t>
+            </a:r>
+          </a:p>
+          <a:p>
+            <a:pPr/>
+            <a:r>
+              <a:rPr sz="1500" b="0">
                 <a:solidFill>
                   <a:srgbClr val="1F2937"/>
                 </a:solidFill>
               </a:rPr>
-              <a:t>HS</a:t>
-            </a:r>
-            <a:r>
-              <a:rPr sz="1500" b="0" dirty="0">
-                <a:solidFill>
-                  <a:srgbClr val="1F2937"/>
-                </a:solidFill>
-              </a:rPr>
-              <a:t>: </a:t>
-            </a:r>
-            <a:r>
-              <a:rPr sz="1500" b="0" dirty="0" err="1">
-                <a:solidFill>
-                  <a:srgbClr val="1F2937"/>
-                </a:solidFill>
-              </a:rPr>
-              <a:t>Có</a:t>
-            </a:r>
-            <a:r>
-              <a:rPr sz="1500" b="0" dirty="0">
-                <a:solidFill>
-                  <a:srgbClr val="1F2937"/>
-                </a:solidFill>
-              </a:rPr>
-              <a:t> </a:t>
-            </a:r>
-            <a:r>
-              <a:rPr sz="1500" b="0" dirty="0" err="1">
-                <a:solidFill>
-                  <a:srgbClr val="1F2937"/>
-                </a:solidFill>
-              </a:rPr>
-              <a:t>mặt</a:t>
-            </a:r>
-            <a:r>
-              <a:rPr sz="1500" b="0" dirty="0">
-                <a:solidFill>
-                  <a:srgbClr val="1F2937"/>
-                </a:solidFill>
-              </a:rPr>
-              <a:t>, </a:t>
-            </a:r>
-            <a:r>
-              <a:rPr sz="1500" b="0" dirty="0" err="1">
-                <a:solidFill>
-                  <a:srgbClr val="1F2937"/>
-                </a:solidFill>
-              </a:rPr>
-              <a:t>Vắng</a:t>
-            </a:r>
-            <a:r>
-              <a:rPr sz="1500" b="0" dirty="0">
-                <a:solidFill>
-                  <a:srgbClr val="1F2937"/>
-                </a:solidFill>
-              </a:rPr>
-              <a:t> CP, </a:t>
-            </a:r>
-            <a:r>
-              <a:rPr sz="1500" b="0" dirty="0" err="1">
-                <a:solidFill>
-                  <a:srgbClr val="1F2937"/>
-                </a:solidFill>
-              </a:rPr>
-              <a:t>Vắng</a:t>
-            </a:r>
-            <a:r>
-              <a:rPr sz="1500" b="0" dirty="0">
-                <a:solidFill>
-                  <a:srgbClr val="1F2937"/>
-                </a:solidFill>
-              </a:rPr>
-              <a:t> KP, </a:t>
-            </a:r>
-            <a:r>
-              <a:rPr sz="1500" b="0" dirty="0" err="1">
-                <a:solidFill>
-                  <a:srgbClr val="1F2937"/>
-                </a:solidFill>
-              </a:rPr>
-              <a:t>Đi</a:t>
-            </a:r>
-            <a:r>
-              <a:rPr sz="1500" b="0" dirty="0">
-                <a:solidFill>
-                  <a:srgbClr val="1F2937"/>
-                </a:solidFill>
-              </a:rPr>
-              <a:t> </a:t>
-            </a:r>
-            <a:r>
-              <a:rPr sz="1500" b="0" dirty="0" err="1">
-                <a:solidFill>
-                  <a:srgbClr val="1F2937"/>
-                </a:solidFill>
-              </a:rPr>
-              <a:t>muộn</a:t>
-            </a:r>
-            <a:r>
-              <a:rPr sz="1500" b="0" dirty="0">
-                <a:solidFill>
-                  <a:srgbClr val="1F2937"/>
-                </a:solidFill>
-              </a:rPr>
-              <a:t> + </a:t>
-            </a:r>
-            <a:r>
-              <a:rPr sz="1500" b="0" dirty="0" err="1">
-                <a:solidFill>
-                  <a:srgbClr val="1F2937"/>
-                </a:solidFill>
-              </a:rPr>
-              <a:t>thao</a:t>
-            </a:r>
-            <a:r>
-              <a:rPr sz="1500" b="0" dirty="0">
-                <a:solidFill>
-                  <a:srgbClr val="1F2937"/>
-                </a:solidFill>
-              </a:rPr>
-              <a:t> </a:t>
-            </a:r>
-            <a:r>
-              <a:rPr sz="1500" b="0" dirty="0" err="1">
-                <a:solidFill>
-                  <a:srgbClr val="1F2937"/>
-                </a:solidFill>
-              </a:rPr>
-              <a:t>tác</a:t>
-            </a:r>
-            <a:r>
-              <a:rPr sz="1500" b="0" dirty="0">
-                <a:solidFill>
-                  <a:srgbClr val="1F2937"/>
-                </a:solidFill>
-              </a:rPr>
-              <a:t> </a:t>
-            </a:r>
-            <a:r>
-              <a:rPr sz="1500" b="0" dirty="0" err="1">
-                <a:solidFill>
-                  <a:srgbClr val="1F2937"/>
-                </a:solidFill>
-              </a:rPr>
-              <a:t>nhanh</a:t>
-            </a:r>
-            <a:endParaRPr sz="1500" b="0" dirty="0">
-              <a:solidFill>
-                <a:srgbClr val="1F2937"/>
-              </a:solidFill>
-            </a:endParaRPr>
-          </a:p>
-          <a:p>
-            <a:r>
-              <a:rPr sz="1500" b="0" dirty="0">
-                <a:solidFill>
-                  <a:srgbClr val="1F2937"/>
-                </a:solidFill>
-              </a:rPr>
-              <a:t>- </a:t>
-            </a:r>
-            <a:r>
-              <a:rPr sz="1500" b="0" dirty="0" err="1">
-                <a:solidFill>
-                  <a:srgbClr val="1F2937"/>
-                </a:solidFill>
-              </a:rPr>
-              <a:t>Chọn</a:t>
-            </a:r>
-            <a:r>
-              <a:rPr sz="1500" b="0" dirty="0">
-                <a:solidFill>
-                  <a:srgbClr val="1F2937"/>
-                </a:solidFill>
-              </a:rPr>
-              <a:t> </a:t>
-            </a:r>
-            <a:r>
-              <a:rPr sz="1500" b="0" dirty="0" err="1">
-                <a:solidFill>
-                  <a:srgbClr val="1F2937"/>
-                </a:solidFill>
-              </a:rPr>
-              <a:t>ngày</a:t>
-            </a:r>
-            <a:r>
-              <a:rPr sz="1500" b="0" dirty="0">
-                <a:solidFill>
-                  <a:srgbClr val="1F2937"/>
-                </a:solidFill>
-              </a:rPr>
-              <a:t> </a:t>
-            </a:r>
-            <a:r>
-              <a:rPr sz="1500" b="0" dirty="0" err="1">
-                <a:solidFill>
-                  <a:srgbClr val="1F2937"/>
-                </a:solidFill>
-              </a:rPr>
-              <a:t>bất</a:t>
-            </a:r>
-            <a:r>
-              <a:rPr sz="1500" b="0" dirty="0">
-                <a:solidFill>
-                  <a:srgbClr val="1F2937"/>
-                </a:solidFill>
-              </a:rPr>
-              <a:t> </a:t>
-            </a:r>
-            <a:r>
-              <a:rPr sz="1500" b="0" dirty="0" err="1">
-                <a:solidFill>
-                  <a:srgbClr val="1F2937"/>
-                </a:solidFill>
-              </a:rPr>
-              <a:t>kỳ</a:t>
-            </a:r>
-            <a:r>
-              <a:rPr sz="1500" b="0" dirty="0">
-                <a:solidFill>
-                  <a:srgbClr val="1F2937"/>
-                </a:solidFill>
-              </a:rPr>
-              <a:t> </a:t>
-            </a:r>
-            <a:r>
-              <a:rPr sz="1500" b="0" dirty="0" err="1">
-                <a:solidFill>
-                  <a:srgbClr val="1F2937"/>
-                </a:solidFill>
-              </a:rPr>
-              <a:t>để</a:t>
-            </a:r>
-            <a:r>
-              <a:rPr sz="1500" b="0" dirty="0">
-                <a:solidFill>
-                  <a:srgbClr val="1F2937"/>
-                </a:solidFill>
-              </a:rPr>
-              <a:t> </a:t>
-            </a:r>
-            <a:r>
-              <a:rPr sz="1500" b="0" dirty="0" err="1">
-                <a:solidFill>
-                  <a:srgbClr val="1F2937"/>
-                </a:solidFill>
-              </a:rPr>
-              <a:t>xem</a:t>
-            </a:r>
-            <a:r>
-              <a:rPr sz="1500" b="0" dirty="0">
-                <a:solidFill>
-                  <a:srgbClr val="1F2937"/>
-                </a:solidFill>
-              </a:rPr>
-              <a:t> </a:t>
-            </a:r>
-            <a:r>
-              <a:rPr sz="1500" b="0" dirty="0" err="1">
-                <a:solidFill>
-                  <a:srgbClr val="1F2937"/>
-                </a:solidFill>
-              </a:rPr>
-              <a:t>lại</a:t>
-            </a:r>
-            <a:r>
-              <a:rPr sz="1500" b="0" dirty="0">
-                <a:solidFill>
-                  <a:srgbClr val="1F2937"/>
-                </a:solidFill>
-              </a:rPr>
-              <a:t> / </a:t>
-            </a:r>
-            <a:r>
-              <a:rPr sz="1500" b="0" dirty="0" err="1">
-                <a:solidFill>
-                  <a:srgbClr val="1F2937"/>
-                </a:solidFill>
-              </a:rPr>
-              <a:t>sửa</a:t>
-            </a:r>
-            <a:r>
-              <a:rPr sz="1500" b="0" dirty="0">
-                <a:solidFill>
-                  <a:srgbClr val="1F2937"/>
-                </a:solidFill>
-              </a:rPr>
-              <a:t> </a:t>
-            </a:r>
-            <a:r>
-              <a:rPr sz="1500" b="0" dirty="0" err="1">
-                <a:solidFill>
-                  <a:srgbClr val="1F2937"/>
-                </a:solidFill>
-              </a:rPr>
-              <a:t>điểm</a:t>
-            </a:r>
-            <a:r>
-              <a:rPr sz="1500" b="0" dirty="0">
-                <a:solidFill>
-                  <a:srgbClr val="1F2937"/>
-                </a:solidFill>
-              </a:rPr>
-              <a:t> </a:t>
-            </a:r>
-            <a:r>
-              <a:rPr sz="1500" b="0" dirty="0" err="1">
-                <a:solidFill>
-                  <a:srgbClr val="1F2937"/>
-                </a:solidFill>
-              </a:rPr>
-              <a:t>danh</a:t>
-            </a:r>
-            <a:r>
-              <a:rPr sz="1500" b="0" dirty="0">
-                <a:solidFill>
-                  <a:srgbClr val="1F2937"/>
-                </a:solidFill>
-              </a:rPr>
-              <a:t> </a:t>
-            </a:r>
-            <a:r>
-              <a:rPr sz="1500" b="0" dirty="0" err="1">
-                <a:solidFill>
-                  <a:srgbClr val="1F2937"/>
-                </a:solidFill>
-              </a:rPr>
-              <a:t>ngày</a:t>
-            </a:r>
-            <a:r>
-              <a:rPr sz="1500" b="0" dirty="0">
-                <a:solidFill>
-                  <a:srgbClr val="1F2937"/>
-                </a:solidFill>
-              </a:rPr>
-              <a:t> </a:t>
-            </a:r>
-            <a:r>
-              <a:rPr sz="1500" b="0" dirty="0" err="1">
-                <a:solidFill>
-                  <a:srgbClr val="1F2937"/>
-                </a:solidFill>
-              </a:rPr>
-              <a:t>cũ</a:t>
-            </a:r>
-            <a:endParaRPr sz="1500" b="0" dirty="0">
-              <a:solidFill>
-                <a:srgbClr val="1F2937"/>
-              </a:solidFill>
-            </a:endParaRPr>
-          </a:p>
-          <a:p>
-            <a:r>
-              <a:rPr sz="1500" b="0" dirty="0">
-                <a:solidFill>
-                  <a:srgbClr val="1F2937"/>
-                </a:solidFill>
-              </a:rPr>
-              <a:t>- </a:t>
-            </a:r>
-            <a:r>
-              <a:rPr sz="1500" b="0" dirty="0" err="1">
-                <a:solidFill>
-                  <a:srgbClr val="1F2937"/>
-                </a:solidFill>
-              </a:rPr>
-              <a:t>Sổ</a:t>
-            </a:r>
-            <a:r>
-              <a:rPr sz="1500" b="0" dirty="0">
-                <a:solidFill>
-                  <a:srgbClr val="1F2937"/>
-                </a:solidFill>
-              </a:rPr>
-              <a:t> </a:t>
-            </a:r>
-            <a:r>
-              <a:rPr sz="1500" b="0" dirty="0" err="1">
-                <a:solidFill>
-                  <a:srgbClr val="1F2937"/>
-                </a:solidFill>
-              </a:rPr>
-              <a:t>vắng-muộn</a:t>
-            </a:r>
-            <a:r>
-              <a:rPr sz="1500" b="0" dirty="0">
-                <a:solidFill>
-                  <a:srgbClr val="1F2937"/>
-                </a:solidFill>
-              </a:rPr>
-              <a:t> </a:t>
-            </a:r>
-            <a:r>
-              <a:rPr sz="1500" b="0" dirty="0" err="1">
-                <a:solidFill>
-                  <a:srgbClr val="1F2937"/>
-                </a:solidFill>
-              </a:rPr>
-              <a:t>và</a:t>
-            </a:r>
-            <a:r>
-              <a:rPr sz="1500" b="0" dirty="0">
-                <a:solidFill>
-                  <a:srgbClr val="1F2937"/>
-                </a:solidFill>
-              </a:rPr>
-              <a:t> </a:t>
-            </a:r>
-            <a:r>
-              <a:rPr sz="1500" b="0" dirty="0" err="1">
-                <a:solidFill>
-                  <a:srgbClr val="1F2937"/>
-                </a:solidFill>
-              </a:rPr>
-              <a:t>lịch</a:t>
-            </a:r>
-            <a:r>
-              <a:rPr sz="1500" b="0" dirty="0">
-                <a:solidFill>
-                  <a:srgbClr val="1F2937"/>
-                </a:solidFill>
-              </a:rPr>
-              <a:t> </a:t>
-            </a:r>
-            <a:r>
-              <a:rPr sz="1500" b="0" dirty="0" err="1">
-                <a:solidFill>
-                  <a:srgbClr val="1F2937"/>
-                </a:solidFill>
-              </a:rPr>
-              <a:t>sử</a:t>
-            </a:r>
-            <a:r>
-              <a:rPr sz="1500" b="0" dirty="0">
-                <a:solidFill>
-                  <a:srgbClr val="1F2937"/>
-                </a:solidFill>
-              </a:rPr>
-              <a:t> </a:t>
-            </a:r>
-            <a:r>
-              <a:rPr sz="1500" b="0" dirty="0" err="1">
-                <a:solidFill>
-                  <a:srgbClr val="1F2937"/>
-                </a:solidFill>
-              </a:rPr>
-              <a:t>theo</a:t>
-            </a:r>
-            <a:r>
-              <a:rPr sz="1500" b="0" dirty="0">
-                <a:solidFill>
-                  <a:srgbClr val="1F2937"/>
-                </a:solidFill>
-              </a:rPr>
-              <a:t> </a:t>
-            </a:r>
-            <a:r>
-              <a:rPr sz="1500" b="0" dirty="0" err="1">
-                <a:solidFill>
-                  <a:srgbClr val="1F2937"/>
-                </a:solidFill>
-              </a:rPr>
-              <a:t>khoảng</a:t>
-            </a:r>
-            <a:r>
-              <a:rPr sz="1500" b="0" dirty="0">
-                <a:solidFill>
-                  <a:srgbClr val="1F2937"/>
-                </a:solidFill>
-              </a:rPr>
-              <a:t> </a:t>
-            </a:r>
-            <a:r>
-              <a:rPr sz="1500" b="0" dirty="0" err="1">
-                <a:solidFill>
-                  <a:srgbClr val="1F2937"/>
-                </a:solidFill>
-              </a:rPr>
-              <a:t>ngày</a:t>
-            </a:r>
-            <a:r>
-              <a:rPr sz="1500" b="0" dirty="0">
-                <a:solidFill>
-                  <a:srgbClr val="1F2937"/>
-                </a:solidFill>
-              </a:rPr>
-              <a:t> (from - to)</a:t>
-            </a:r>
-          </a:p>
-          <a:p>
-            <a:r>
-              <a:rPr sz="1500" b="0" dirty="0">
-                <a:solidFill>
-                  <a:srgbClr val="1F2937"/>
-                </a:solidFill>
-              </a:rPr>
-              <a:t>- Ma </a:t>
-            </a:r>
-            <a:r>
-              <a:rPr sz="1500" b="0" dirty="0" err="1">
-                <a:solidFill>
-                  <a:srgbClr val="1F2937"/>
-                </a:solidFill>
-              </a:rPr>
-              <a:t>trận</a:t>
-            </a:r>
-            <a:r>
-              <a:rPr sz="1500" b="0" dirty="0">
-                <a:solidFill>
-                  <a:srgbClr val="1F2937"/>
-                </a:solidFill>
-              </a:rPr>
-              <a:t> HS x </a:t>
-            </a:r>
-            <a:r>
-              <a:rPr sz="1500" b="0" dirty="0" err="1">
-                <a:solidFill>
-                  <a:srgbClr val="1F2937"/>
-                </a:solidFill>
-              </a:rPr>
-              <a:t>ngày</a:t>
-            </a:r>
-            <a:r>
-              <a:rPr sz="1500" b="0" dirty="0">
-                <a:solidFill>
-                  <a:srgbClr val="1F2937"/>
-                </a:solidFill>
-              </a:rPr>
-              <a:t> </a:t>
-            </a:r>
-            <a:r>
-              <a:rPr sz="1500" b="0" dirty="0" err="1">
-                <a:solidFill>
-                  <a:srgbClr val="1F2937"/>
-                </a:solidFill>
-              </a:rPr>
-              <a:t>phát</a:t>
-            </a:r>
-            <a:r>
-              <a:rPr sz="1500" b="0" dirty="0">
-                <a:solidFill>
-                  <a:srgbClr val="1F2937"/>
-                </a:solidFill>
-              </a:rPr>
-              <a:t> </a:t>
-            </a:r>
-            <a:r>
-              <a:rPr sz="1500" b="0" dirty="0" err="1">
-                <a:solidFill>
-                  <a:srgbClr val="1F2937"/>
-                </a:solidFill>
-              </a:rPr>
-              <a:t>hiện</a:t>
-            </a:r>
-            <a:r>
-              <a:rPr sz="1500" b="0" dirty="0">
-                <a:solidFill>
-                  <a:srgbClr val="1F2937"/>
-                </a:solidFill>
-              </a:rPr>
-              <a:t> </a:t>
-            </a:r>
-            <a:r>
-              <a:rPr sz="1500" b="0" dirty="0" err="1">
-                <a:solidFill>
-                  <a:srgbClr val="1F2937"/>
-                </a:solidFill>
-              </a:rPr>
-              <a:t>vắng</a:t>
-            </a:r>
-            <a:r>
-              <a:rPr sz="1500" b="0" dirty="0">
-                <a:solidFill>
-                  <a:srgbClr val="1F2937"/>
-                </a:solidFill>
-              </a:rPr>
-              <a:t> </a:t>
-            </a:r>
-            <a:r>
-              <a:rPr sz="1500" b="0" dirty="0" err="1">
-                <a:solidFill>
-                  <a:srgbClr val="1F2937"/>
-                </a:solidFill>
-              </a:rPr>
-              <a:t>liên</a:t>
-            </a:r>
-            <a:r>
-              <a:rPr sz="1500" b="0" dirty="0">
-                <a:solidFill>
-                  <a:srgbClr val="1F2937"/>
-                </a:solidFill>
-              </a:rPr>
-              <a:t> </a:t>
-            </a:r>
-            <a:r>
-              <a:rPr sz="1500" b="0" dirty="0" err="1">
-                <a:solidFill>
-                  <a:srgbClr val="1F2937"/>
-                </a:solidFill>
-              </a:rPr>
-              <a:t>tục</a:t>
-            </a:r>
-            <a:endParaRPr sz="1500" b="0" dirty="0">
-              <a:solidFill>
-                <a:srgbClr val="1F2937"/>
-              </a:solidFill>
-            </a:endParaRPr>
-          </a:p>
-          <a:p>
-            <a:r>
-              <a:rPr sz="1500" b="0" dirty="0">
-                <a:solidFill>
-                  <a:srgbClr val="1F2937"/>
-                </a:solidFill>
-              </a:rPr>
-              <a:t>- </a:t>
-            </a:r>
-            <a:r>
-              <a:rPr sz="1500" b="0" dirty="0" err="1">
-                <a:solidFill>
-                  <a:srgbClr val="1F2937"/>
-                </a:solidFill>
-              </a:rPr>
-              <a:t>Thông</a:t>
-            </a:r>
-            <a:r>
-              <a:rPr sz="1500" b="0" dirty="0">
-                <a:solidFill>
-                  <a:srgbClr val="1F2937"/>
-                </a:solidFill>
-              </a:rPr>
-              <a:t> </a:t>
-            </a:r>
-            <a:r>
-              <a:rPr sz="1500" b="0" dirty="0" err="1">
-                <a:solidFill>
-                  <a:srgbClr val="1F2937"/>
-                </a:solidFill>
-              </a:rPr>
-              <a:t>báo</a:t>
-            </a:r>
-            <a:r>
-              <a:rPr sz="1500" b="0" dirty="0">
-                <a:solidFill>
-                  <a:srgbClr val="1F2937"/>
-                </a:solidFill>
-              </a:rPr>
-              <a:t> </a:t>
-            </a:r>
-            <a:r>
-              <a:rPr sz="1500" b="0" dirty="0" err="1">
-                <a:solidFill>
-                  <a:srgbClr val="1F2937"/>
-                </a:solidFill>
-              </a:rPr>
-              <a:t>phụ</a:t>
-            </a:r>
-            <a:r>
-              <a:rPr sz="1500" b="0" dirty="0">
-                <a:solidFill>
-                  <a:srgbClr val="1F2937"/>
-                </a:solidFill>
-              </a:rPr>
-              <a:t> </a:t>
-            </a:r>
-            <a:r>
-              <a:rPr sz="1500" b="0" dirty="0" err="1">
-                <a:solidFill>
-                  <a:srgbClr val="1F2937"/>
-                </a:solidFill>
-              </a:rPr>
-              <a:t>huynh</a:t>
-            </a:r>
-            <a:r>
-              <a:rPr sz="1500" b="0" dirty="0">
-                <a:solidFill>
-                  <a:srgbClr val="1F2937"/>
-                </a:solidFill>
-              </a:rPr>
-              <a:t> </a:t>
-            </a:r>
-            <a:r>
-              <a:rPr sz="1500" b="0" dirty="0" err="1">
-                <a:solidFill>
-                  <a:srgbClr val="1F2937"/>
-                </a:solidFill>
-              </a:rPr>
-              <a:t>tự</a:t>
-            </a:r>
-            <a:r>
-              <a:rPr sz="1500" b="0" dirty="0">
-                <a:solidFill>
-                  <a:srgbClr val="1F2937"/>
-                </a:solidFill>
-              </a:rPr>
-              <a:t> </a:t>
-            </a:r>
-            <a:r>
-              <a:rPr sz="1500" b="0" dirty="0" err="1">
-                <a:solidFill>
-                  <a:srgbClr val="1F2937"/>
-                </a:solidFill>
-              </a:rPr>
-              <a:t>động</a:t>
-            </a:r>
-            <a:r>
-              <a:rPr sz="1500" b="0" dirty="0">
-                <a:solidFill>
-                  <a:srgbClr val="1F2937"/>
-                </a:solidFill>
-              </a:rPr>
-              <a:t> (email + in-app)</a:t>
-            </a:r>
-          </a:p>
-          <a:p>
-            <a:r>
-              <a:rPr sz="1500" b="0" dirty="0">
-                <a:solidFill>
-                  <a:srgbClr val="1F2937"/>
-                </a:solidFill>
-              </a:rPr>
-              <a:t>- </a:t>
-            </a:r>
-            <a:r>
-              <a:rPr sz="1500" b="0" dirty="0" err="1">
-                <a:solidFill>
-                  <a:srgbClr val="1F2937"/>
-                </a:solidFill>
-              </a:rPr>
-              <a:t>Đồng</a:t>
-            </a:r>
-            <a:r>
-              <a:rPr sz="1500" b="0" dirty="0">
-                <a:solidFill>
-                  <a:srgbClr val="1F2937"/>
-                </a:solidFill>
-              </a:rPr>
-              <a:t> </a:t>
-            </a:r>
-            <a:r>
-              <a:rPr sz="1500" b="0" dirty="0" err="1">
-                <a:solidFill>
-                  <a:srgbClr val="1F2937"/>
-                </a:solidFill>
-              </a:rPr>
-              <a:t>bộ</a:t>
-            </a:r>
-            <a:r>
-              <a:rPr sz="1500" b="0" dirty="0">
-                <a:solidFill>
-                  <a:srgbClr val="1F2937"/>
-                </a:solidFill>
-              </a:rPr>
-              <a:t> 2 </a:t>
-            </a:r>
-            <a:r>
-              <a:rPr sz="1500" b="0" dirty="0" err="1">
-                <a:solidFill>
-                  <a:srgbClr val="1F2937"/>
-                </a:solidFill>
-              </a:rPr>
-              <a:t>chiều</a:t>
-            </a:r>
-            <a:r>
-              <a:rPr sz="1500" b="0" dirty="0">
-                <a:solidFill>
-                  <a:srgbClr val="1F2937"/>
-                </a:solidFill>
-              </a:rPr>
-              <a:t> </a:t>
-            </a:r>
-            <a:r>
-              <a:rPr sz="1500" b="0" dirty="0" err="1">
-                <a:solidFill>
-                  <a:srgbClr val="1F2937"/>
-                </a:solidFill>
-              </a:rPr>
-              <a:t>với</a:t>
-            </a:r>
-            <a:r>
-              <a:rPr sz="1500" b="0" dirty="0">
-                <a:solidFill>
-                  <a:srgbClr val="1F2937"/>
-                </a:solidFill>
-              </a:rPr>
-              <a:t> </a:t>
-            </a:r>
-            <a:r>
-              <a:rPr sz="1500" b="0" dirty="0" err="1">
-                <a:solidFill>
-                  <a:srgbClr val="1F2937"/>
-                </a:solidFill>
-              </a:rPr>
-              <a:t>sổ</a:t>
-            </a:r>
-            <a:r>
-              <a:rPr sz="1500" b="0" dirty="0">
-                <a:solidFill>
-                  <a:srgbClr val="1F2937"/>
-                </a:solidFill>
-              </a:rPr>
-              <a:t> </a:t>
-            </a:r>
-            <a:r>
-              <a:rPr sz="1500" b="0" dirty="0" err="1">
-                <a:solidFill>
-                  <a:srgbClr val="1F2937"/>
-                </a:solidFill>
-              </a:rPr>
-              <a:t>đầu</a:t>
-            </a:r>
-            <a:r>
-              <a:rPr sz="1500" b="0" dirty="0">
-                <a:solidFill>
-                  <a:srgbClr val="1F2937"/>
-                </a:solidFill>
-              </a:rPr>
-              <a:t> </a:t>
-            </a:r>
-            <a:r>
-              <a:rPr sz="1500" b="0" dirty="0" err="1">
-                <a:solidFill>
-                  <a:srgbClr val="1F2937"/>
-                </a:solidFill>
-              </a:rPr>
-              <a:t>bài</a:t>
-            </a:r>
-            <a:r>
-              <a:rPr sz="1500" b="0" dirty="0">
-                <a:solidFill>
-                  <a:srgbClr val="1F2937"/>
-                </a:solidFill>
-              </a:rPr>
-              <a:t> </a:t>
-            </a:r>
-            <a:r>
-              <a:rPr sz="1500" b="0" dirty="0" err="1">
-                <a:solidFill>
-                  <a:srgbClr val="1F2937"/>
-                </a:solidFill>
-              </a:rPr>
-              <a:t>tiết</a:t>
-            </a:r>
-            <a:r>
-              <a:rPr sz="1500" b="0" dirty="0">
-                <a:solidFill>
-                  <a:srgbClr val="1F2937"/>
-                </a:solidFill>
-              </a:rPr>
-              <a:t> </a:t>
-            </a:r>
-            <a:r>
-              <a:rPr sz="1500" b="0" dirty="0" err="1">
-                <a:solidFill>
-                  <a:srgbClr val="1F2937"/>
-                </a:solidFill>
-              </a:rPr>
-              <a:t>học</a:t>
-            </a:r>
-            <a:endParaRPr sz="1500" b="0" dirty="0">
-              <a:solidFill>
-                <a:srgbClr val="1F2937"/>
-              </a:solidFill>
-            </a:endParaRPr>
+              <a:t>- Đồng bộ 2 chiều với sổ đầu bài tiết học</a:t>
+            </a:r>
           </a:p>
         </p:txBody>
       </p:sp>
@@ -6789,13 +4890,14 @@
           </a:bodyPr>
           <a:lstStyle/>
           <a:p>
+            <a:pPr/>
             <a:r>
               <a:rPr sz="1100" b="0">
                 <a:solidFill>
                   <a:srgbClr val="6B7280"/>
                 </a:solidFill>
               </a:rPr>
-              <a:t>Điểm danh hàng ngày - 6 thẻ tổng + chọn ngày</a:t>
+              <a:t>Điểm danh hàng ngày - 6 thẻ tổng + ghi chú vắng</a:t>
             </a:r>
           </a:p>
         </p:txBody>
@@ -6809,7 +4911,7 @@
 </file>
 
 <file path=ppt/slides/slide5.xml><?xml version="1.0" encoding="utf-8"?>
-<p:sld xmlns:a="http://schemas.openxmlformats.org/drawingml/2006/main" xmlns:r="http://schemas.openxmlformats.org/officeDocument/2006/relationships" xmlns:p="http://schemas.openxmlformats.org/presentationml/2006/main">
+<p:sld xmlns:a="http://schemas.openxmlformats.org/drawingml/2006/main" xmlns:p="http://schemas.openxmlformats.org/presentationml/2006/main" xmlns:r="http://schemas.openxmlformats.org/officeDocument/2006/relationships">
   <p:cSld>
     <p:spTree>
       <p:nvGrpSpPr>
@@ -6817,14 +4919,7 @@
         <p:cNvGrpSpPr/>
         <p:nvPr/>
       </p:nvGrpSpPr>
-      <p:grpSpPr>
-        <a:xfrm>
-          <a:off x="0" y="0"/>
-          <a:ext cx="0" cy="0"/>
-          <a:chOff x="0" y="0"/>
-          <a:chExt cx="0" cy="0"/>
-        </a:xfrm>
-      </p:grpSpPr>
+      <p:grpSpPr/>
       <p:sp>
         <p:nvSpPr>
           <p:cNvPr id="2" name="Rectangle 1"/>
@@ -6865,7 +4960,6 @@
           <a:lstStyle/>
           <a:p>
             <a:pPr algn="ctr"/>
-            <a:endParaRPr/>
           </a:p>
         </p:txBody>
       </p:sp>
@@ -6891,6 +4985,7 @@
           </a:bodyPr>
           <a:lstStyle/>
           <a:p>
+            <a:pPr/>
             <a:r>
               <a:rPr sz="2800" b="1">
                 <a:solidFill>
@@ -6924,6 +5019,7 @@
           </a:bodyPr>
           <a:lstStyle/>
           <a:p>
+            <a:pPr/>
             <a:r>
               <a:rPr sz="1500" b="0">
                 <a:solidFill>
@@ -6934,6 +5030,7 @@
             </a:r>
           </a:p>
           <a:p>
+            <a:pPr/>
             <a:r>
               <a:rPr sz="1500" b="0">
                 <a:solidFill>
@@ -6944,33 +5041,47 @@
             </a:r>
           </a:p>
           <a:p>
+            <a:pPr/>
             <a:r>
               <a:rPr sz="1500" b="0">
                 <a:solidFill>
                   <a:srgbClr val="1F2937"/>
                 </a:solidFill>
               </a:rPr>
+              <a:t>- GV chỉ ghi điểm lớp + môn mình được phân công (RLS kiểm tra ở DB)</a:t>
+            </a:r>
+          </a:p>
+          <a:p>
+            <a:pPr/>
+            <a:r>
+              <a:rPr sz="1500" b="0">
+                <a:solidFill>
+                  <a:srgbClr val="1F2937"/>
+                </a:solidFill>
+              </a:rPr>
+              <a:t>- Lưu điểm nguyên tử qua transaction - không mất dữ liệu khi lỗi giữa chừng</a:t>
+            </a:r>
+          </a:p>
+          <a:p>
+            <a:pPr/>
+            <a:r>
+              <a:rPr sz="1500" b="0">
+                <a:solidFill>
+                  <a:srgbClr val="1F2937"/>
+                </a:solidFill>
+              </a:rPr>
               <a:t>- ĐTBm tự tính đúng hệ số TT22, hiển thị HK1 / HK2 / cả năm</a:t>
             </a:r>
           </a:p>
           <a:p>
+            <a:pPr/>
             <a:r>
               <a:rPr sz="1500" b="0">
                 <a:solidFill>
                   <a:srgbClr val="1F2937"/>
                 </a:solidFill>
               </a:rPr>
-              <a:t>- Import/export Excel, tải template mẫu</a:t>
-            </a:r>
-          </a:p>
-          <a:p>
-            <a:r>
-              <a:rPr sz="1500" b="0">
-                <a:solidFill>
-                  <a:srgbClr val="1F2937"/>
-                </a:solidFill>
-              </a:rPr>
-              <a:t>- Môn đánh giá bằng nhận xét hiển thị Đạt / Chưa đạt</a:t>
+              <a:t>- Import/export Excel, tải template mẫu; môn nhận xét hiển thị Đạt / Chưa đạt</a:t>
             </a:r>
           </a:p>
         </p:txBody>
@@ -7026,6 +5137,7 @@
           </a:bodyPr>
           <a:lstStyle/>
           <a:p>
+            <a:pPr/>
             <a:r>
               <a:rPr sz="1100" b="0">
                 <a:solidFill>
@@ -7046,7 +5158,7 @@
 </file>
 
 <file path=ppt/slides/slide6.xml><?xml version="1.0" encoding="utf-8"?>
-<p:sld xmlns:a="http://schemas.openxmlformats.org/drawingml/2006/main" xmlns:r="http://schemas.openxmlformats.org/officeDocument/2006/relationships" xmlns:p="http://schemas.openxmlformats.org/presentationml/2006/main">
+<p:sld xmlns:a="http://schemas.openxmlformats.org/drawingml/2006/main" xmlns:p="http://schemas.openxmlformats.org/presentationml/2006/main" xmlns:r="http://schemas.openxmlformats.org/officeDocument/2006/relationships">
   <p:cSld>
     <p:spTree>
       <p:nvGrpSpPr>
@@ -7054,14 +5166,7 @@
         <p:cNvGrpSpPr/>
         <p:nvPr/>
       </p:nvGrpSpPr>
-      <p:grpSpPr>
-        <a:xfrm>
-          <a:off x="0" y="0"/>
-          <a:ext cx="0" cy="0"/>
-          <a:chOff x="0" y="0"/>
-          <a:chExt cx="0" cy="0"/>
-        </a:xfrm>
-      </p:grpSpPr>
+      <p:grpSpPr/>
       <p:sp>
         <p:nvSpPr>
           <p:cNvPr id="2" name="Rectangle 1"/>
@@ -7102,7 +5207,6 @@
           <a:lstStyle/>
           <a:p>
             <a:pPr algn="ctr"/>
-            <a:endParaRPr/>
           </a:p>
         </p:txBody>
       </p:sp>
@@ -7128,6 +5232,7 @@
           </a:bodyPr>
           <a:lstStyle/>
           <a:p>
+            <a:pPr/>
             <a:r>
               <a:rPr sz="2800" b="1">
                 <a:solidFill>
@@ -7161,6 +5266,7 @@
           </a:bodyPr>
           <a:lstStyle/>
           <a:p>
+            <a:pPr/>
             <a:r>
               <a:rPr sz="1500" b="0">
                 <a:solidFill>
@@ -7171,6 +5277,7 @@
             </a:r>
           </a:p>
           <a:p>
+            <a:pPr/>
             <a:r>
               <a:rPr sz="1500" b="0">
                 <a:solidFill>
@@ -7181,16 +5288,18 @@
             </a:r>
           </a:p>
           <a:p>
+            <a:pPr/>
             <a:r>
               <a:rPr sz="1500" b="0">
                 <a:solidFill>
                   <a:srgbClr val="1F2937"/>
                 </a:solidFill>
               </a:rPr>
-              <a:t>- Sổ đầu bài tách 3 trường: tên bài / nội dung / nhận xét GV</a:t>
-            </a:r>
-          </a:p>
-          <a:p>
+              <a:t>- Sổ đầu bài: chỉ GV được phân công tiết đó mới ghi - tiết người khác chỉ đọc</a:t>
+            </a:r>
+          </a:p>
+          <a:p>
+            <a:pPr/>
             <a:r>
               <a:rPr sz="1500" b="0">
                 <a:solidFill>
@@ -7201,6 +5310,7 @@
             </a:r>
           </a:p>
           <a:p>
+            <a:pPr/>
             <a:r>
               <a:rPr sz="1500" b="0">
                 <a:solidFill>
@@ -7211,6 +5321,7 @@
             </a:r>
           </a:p>
           <a:p>
+            <a:pPr/>
             <a:r>
               <a:rPr sz="1500" b="0">
                 <a:solidFill>
@@ -7273,6 +5384,7 @@
           </a:bodyPr>
           <a:lstStyle/>
           <a:p>
+            <a:pPr/>
             <a:r>
               <a:rPr sz="1100" b="0">
                 <a:solidFill>
@@ -7293,7 +5405,7 @@
 </file>
 
 <file path=ppt/slides/slide7.xml><?xml version="1.0" encoding="utf-8"?>
-<p:sld xmlns:a="http://schemas.openxmlformats.org/drawingml/2006/main" xmlns:r="http://schemas.openxmlformats.org/officeDocument/2006/relationships" xmlns:p="http://schemas.openxmlformats.org/presentationml/2006/main">
+<p:sld xmlns:a="http://schemas.openxmlformats.org/drawingml/2006/main" xmlns:p="http://schemas.openxmlformats.org/presentationml/2006/main" xmlns:r="http://schemas.openxmlformats.org/officeDocument/2006/relationships">
   <p:cSld>
     <p:spTree>
       <p:nvGrpSpPr>
@@ -7301,14 +5413,7 @@
         <p:cNvGrpSpPr/>
         <p:nvPr/>
       </p:nvGrpSpPr>
-      <p:grpSpPr>
-        <a:xfrm>
-          <a:off x="0" y="0"/>
-          <a:ext cx="0" cy="0"/>
-          <a:chOff x="0" y="0"/>
-          <a:chExt cx="0" cy="0"/>
-        </a:xfrm>
-      </p:grpSpPr>
+      <p:grpSpPr/>
       <p:sp>
         <p:nvSpPr>
           <p:cNvPr id="2" name="Rectangle 1"/>
@@ -7349,7 +5454,6 @@
           <a:lstStyle/>
           <a:p>
             <a:pPr algn="ctr"/>
-            <a:endParaRPr/>
           </a:p>
         </p:txBody>
       </p:sp>
@@ -7375,6 +5479,7 @@
           </a:bodyPr>
           <a:lstStyle/>
           <a:p>
+            <a:pPr/>
             <a:r>
               <a:rPr sz="2800" b="1">
                 <a:solidFill>
@@ -7408,6 +5513,7 @@
           </a:bodyPr>
           <a:lstStyle/>
           <a:p>
+            <a:pPr/>
             <a:r>
               <a:rPr sz="1500" b="0">
                 <a:solidFill>
@@ -7418,6 +5524,7 @@
             </a:r>
           </a:p>
           <a:p>
+            <a:pPr/>
             <a:r>
               <a:rPr sz="1500" b="0">
                 <a:solidFill>
@@ -7428,6 +5535,7 @@
             </a:r>
           </a:p>
           <a:p>
+            <a:pPr/>
             <a:r>
               <a:rPr sz="1500" b="0">
                 <a:solidFill>
@@ -7438,6 +5546,7 @@
             </a:r>
           </a:p>
           <a:p>
+            <a:pPr/>
             <a:r>
               <a:rPr sz="1500" b="0">
                 <a:solidFill>
@@ -7448,6 +5557,7 @@
             </a:r>
           </a:p>
           <a:p>
+            <a:pPr/>
             <a:r>
               <a:rPr sz="1500" b="0">
                 <a:solidFill>
@@ -7510,6 +5620,7 @@
           </a:bodyPr>
           <a:lstStyle/>
           <a:p>
+            <a:pPr/>
             <a:r>
               <a:rPr sz="1100" b="0">
                 <a:solidFill>
@@ -7530,7 +5641,7 @@
 </file>
 
 <file path=ppt/slides/slide8.xml><?xml version="1.0" encoding="utf-8"?>
-<p:sld xmlns:a="http://schemas.openxmlformats.org/drawingml/2006/main" xmlns:r="http://schemas.openxmlformats.org/officeDocument/2006/relationships" xmlns:p="http://schemas.openxmlformats.org/presentationml/2006/main">
+<p:sld xmlns:a="http://schemas.openxmlformats.org/drawingml/2006/main" xmlns:p="http://schemas.openxmlformats.org/presentationml/2006/main" xmlns:r="http://schemas.openxmlformats.org/officeDocument/2006/relationships">
   <p:cSld>
     <p:spTree>
       <p:nvGrpSpPr>
@@ -7538,14 +5649,7 @@
         <p:cNvGrpSpPr/>
         <p:nvPr/>
       </p:nvGrpSpPr>
-      <p:grpSpPr>
-        <a:xfrm>
-          <a:off x="0" y="0"/>
-          <a:ext cx="0" cy="0"/>
-          <a:chOff x="0" y="0"/>
-          <a:chExt cx="0" cy="0"/>
-        </a:xfrm>
-      </p:grpSpPr>
+      <p:grpSpPr/>
       <p:sp>
         <p:nvSpPr>
           <p:cNvPr id="2" name="Rectangle 1"/>
@@ -7586,7 +5690,6 @@
           <a:lstStyle/>
           <a:p>
             <a:pPr algn="ctr"/>
-            <a:endParaRPr/>
           </a:p>
         </p:txBody>
       </p:sp>
@@ -7612,6 +5715,7 @@
           </a:bodyPr>
           <a:lstStyle/>
           <a:p>
+            <a:pPr/>
             <a:r>
               <a:rPr sz="2800" b="1">
                 <a:solidFill>
@@ -7645,6 +5749,7 @@
           </a:bodyPr>
           <a:lstStyle/>
           <a:p>
+            <a:pPr/>
             <a:r>
               <a:rPr sz="1500" b="0">
                 <a:solidFill>
@@ -7655,6 +5760,7 @@
             </a:r>
           </a:p>
           <a:p>
+            <a:pPr/>
             <a:r>
               <a:rPr sz="1500" b="0">
                 <a:solidFill>
@@ -7665,6 +5771,7 @@
             </a:r>
           </a:p>
           <a:p>
+            <a:pPr/>
             <a:r>
               <a:rPr sz="1500" b="0">
                 <a:solidFill>
@@ -7675,6 +5782,7 @@
             </a:r>
           </a:p>
           <a:p>
+            <a:pPr/>
             <a:r>
               <a:rPr sz="1500" b="0">
                 <a:solidFill>
@@ -7685,6 +5793,7 @@
             </a:r>
           </a:p>
           <a:p>
+            <a:pPr/>
             <a:r>
               <a:rPr sz="1500" b="0">
                 <a:solidFill>
@@ -7747,6 +5856,7 @@
           </a:bodyPr>
           <a:lstStyle/>
           <a:p>
+            <a:pPr/>
             <a:r>
               <a:rPr sz="1100" b="0">
                 <a:solidFill>
@@ -7767,7 +5877,7 @@
 </file>
 
 <file path=ppt/slides/slide9.xml><?xml version="1.0" encoding="utf-8"?>
-<p:sld xmlns:a="http://schemas.openxmlformats.org/drawingml/2006/main" xmlns:r="http://schemas.openxmlformats.org/officeDocument/2006/relationships" xmlns:p="http://schemas.openxmlformats.org/presentationml/2006/main">
+<p:sld xmlns:a="http://schemas.openxmlformats.org/drawingml/2006/main" xmlns:p="http://schemas.openxmlformats.org/presentationml/2006/main" xmlns:r="http://schemas.openxmlformats.org/officeDocument/2006/relationships">
   <p:cSld>
     <p:spTree>
       <p:nvGrpSpPr>
@@ -7775,14 +5885,7 @@
         <p:cNvGrpSpPr/>
         <p:nvPr/>
       </p:nvGrpSpPr>
-      <p:grpSpPr>
-        <a:xfrm>
-          <a:off x="0" y="0"/>
-          <a:ext cx="0" cy="0"/>
-          <a:chOff x="0" y="0"/>
-          <a:chExt cx="0" cy="0"/>
-        </a:xfrm>
-      </p:grpSpPr>
+      <p:grpSpPr/>
       <p:sp>
         <p:nvSpPr>
           <p:cNvPr id="2" name="Rectangle 1"/>
@@ -7823,7 +5926,6 @@
           <a:lstStyle/>
           <a:p>
             <a:pPr algn="ctr"/>
-            <a:endParaRPr/>
           </a:p>
         </p:txBody>
       </p:sp>
@@ -7849,6 +5951,7 @@
           </a:bodyPr>
           <a:lstStyle/>
           <a:p>
+            <a:pPr/>
             <a:r>
               <a:rPr sz="2800" b="1">
                 <a:solidFill>
@@ -7882,6 +5985,7 @@
           </a:bodyPr>
           <a:lstStyle/>
           <a:p>
+            <a:pPr/>
             <a:r>
               <a:rPr sz="1500" b="0">
                 <a:solidFill>
@@ -7892,6 +5996,7 @@
             </a:r>
           </a:p>
           <a:p>
+            <a:pPr/>
             <a:r>
               <a:rPr sz="1500" b="0">
                 <a:solidFill>
@@ -7902,6 +6007,7 @@
             </a:r>
           </a:p>
           <a:p>
+            <a:pPr/>
             <a:r>
               <a:rPr sz="1500" b="0">
                 <a:solidFill>
@@ -7912,16 +6018,29 @@
             </a:r>
           </a:p>
           <a:p>
+            <a:pPr/>
             <a:r>
               <a:rPr sz="1500" b="0">
                 <a:solidFill>
                   <a:srgbClr val="1F2937"/>
                 </a:solidFill>
               </a:rPr>
-              <a:t>- Ký duyệt sổ chủ nhiệm, khóa sổ theo đợt</a:t>
-            </a:r>
-          </a:p>
-          <a:p>
+              <a:t>- Ký sổ chủ nhiệm: tạo đợt ký - duyệt/từ chối kèm lý do - ký hàng loạt; GVCN không tự ký</a:t>
+            </a:r>
+          </a:p>
+          <a:p>
+            <a:pPr/>
+            <a:r>
+              <a:rPr sz="1500" b="0">
+                <a:solidFill>
+                  <a:srgbClr val="1F2937"/>
+                </a:solidFill>
+              </a:rPr>
+              <a:t>- Chỉ BGH phân công GVCN &amp; lớp năm học</a:t>
+            </a:r>
+          </a:p>
+          <a:p>
+            <a:pPr/>
             <a:r>
               <a:rPr sz="1500" b="0">
                 <a:solidFill>
@@ -7984,6 +6103,7 @@
           </a:bodyPr>
           <a:lstStyle/>
           <a:p>
+            <a:pPr/>
             <a:r>
               <a:rPr sz="1100" b="0">
                 <a:solidFill>

</xml_diff>

<commit_message>
fix(register): stale client state khi doi lop/ngay - key remount + perf suite
- RosterClient remount theo classId (key={cls.id}): danh sach HS, to,
  ban can su, lien ket PH gio doi dung theo lop da chon
- Cung pattern: plans, suggestions, kpi, seating-history, conduct/records,
  academics/support - tat ca client component init state tu props gio
  remount khi scope doi
- W32 regression: doi lop tren roster bang chip click that, verify URL +
  noi dung bang + HS cua lop moi
- qa-perf.mjs: suite do TTFB (<1s) + full-load (<3s) + interaction latency
  tren production cho 5 role, 54/54 PASS

Generated with [Devin](https://devin.ai)

Co-Authored-By: Devin <158243242+devin-ai-integration[bot]@users.noreply.github.com>
</commit_message>
<xml_diff>
--- a/docs/user-guide/SO-CHU-NHIEM-SO-GIOI-THIEU.pptx
+++ b/docs/user-guide/SO-CHU-NHIEM-SO-GIOI-THIEU.pptx
@@ -5,21 +5,21 @@
     <p:sldMasterId id="2147483648" r:id="rId1"/>
   </p:sldMasterIdLst>
   <p:sldIdLst>
-    <p:sldId id="256" r:id="rId7"/>
-    <p:sldId id="257" r:id="rId8"/>
-    <p:sldId id="258" r:id="rId9"/>
-    <p:sldId id="259" r:id="rId10"/>
-    <p:sldId id="260" r:id="rId11"/>
-    <p:sldId id="261" r:id="rId12"/>
-    <p:sldId id="262" r:id="rId13"/>
-    <p:sldId id="263" r:id="rId14"/>
-    <p:sldId id="264" r:id="rId15"/>
-    <p:sldId id="265" r:id="rId16"/>
-    <p:sldId id="266" r:id="rId17"/>
-    <p:sldId id="267" r:id="rId18"/>
-    <p:sldId id="268" r:id="rId19"/>
+    <p:sldId id="256" r:id="rId2"/>
+    <p:sldId id="257" r:id="rId3"/>
+    <p:sldId id="258" r:id="rId4"/>
+    <p:sldId id="259" r:id="rId5"/>
+    <p:sldId id="260" r:id="rId6"/>
+    <p:sldId id="261" r:id="rId7"/>
+    <p:sldId id="262" r:id="rId8"/>
+    <p:sldId id="263" r:id="rId9"/>
+    <p:sldId id="264" r:id="rId10"/>
+    <p:sldId id="265" r:id="rId11"/>
+    <p:sldId id="266" r:id="rId12"/>
+    <p:sldId id="267" r:id="rId13"/>
+    <p:sldId id="268" r:id="rId14"/>
   </p:sldIdLst>
-  <p:sldSz cx="12191695" cy="6858000" type="screen4x3"/>
+  <p:sldSz cx="12192000" cy="6858000"/>
   <p:notesSz cx="6858000" cy="9144000"/>
   <p:defaultTextStyle>
     <a:defPPr>
@@ -116,6 +116,22 @@
       </a:defRPr>
     </a:lvl9pPr>
   </p:defaultTextStyle>
+  <p:extLst>
+    <p:ext uri="{EFAFB233-063F-42B5-8137-9DF3F51BA10A}">
+      <p15:sldGuideLst xmlns:p15="http://schemas.microsoft.com/office/powerpoint/2012/main">
+        <p15:guide id="1" orient="horz" pos="2160">
+          <p15:clr>
+            <a:srgbClr val="A4A3A4"/>
+          </p15:clr>
+        </p15:guide>
+        <p15:guide id="2" pos="2880">
+          <p15:clr>
+            <a:srgbClr val="A4A3A4"/>
+          </p15:clr>
+        </p15:guide>
+      </p15:sldGuideLst>
+    </p:ext>
+  </p:extLst>
 </p:presentation>
 </file>
 
@@ -157,10 +173,9 @@
           <a:lstStyle/>
           <a:p>
             <a:r>
-              <a:rPr lang="en-US" smtClean="0"/>
+              <a:rPr lang="en-US"/>
               <a:t>Click to edit Master title style</a:t>
             </a:r>
-            <a:endParaRPr lang="en-US"/>
           </a:p>
         </p:txBody>
       </p:sp>
@@ -276,10 +291,9 @@
           </a:lstStyle>
           <a:p>
             <a:r>
-              <a:rPr lang="en-US" smtClean="0"/>
+              <a:rPr lang="en-US"/>
               <a:t>Click to edit Master subtitle style</a:t>
             </a:r>
-            <a:endParaRPr lang="en-US"/>
           </a:p>
         </p:txBody>
       </p:sp>
@@ -300,7 +314,7 @@
           <a:p>
             <a:fld id="{5BCAD085-E8A6-8845-BD4E-CB4CCA059FC4}" type="datetimeFigureOut">
               <a:rPr lang="en-US" smtClean="0"/>
-              <a:t>1/27/13</a:t>
+              <a:t>9/23/26</a:t>
             </a:fld>
             <a:endParaRPr lang="en-US"/>
           </a:p>
@@ -394,10 +408,9 @@
           <a:lstStyle/>
           <a:p>
             <a:r>
-              <a:rPr lang="en-US" smtClean="0"/>
+              <a:rPr lang="en-US"/>
               <a:t>Click to edit Master title style</a:t>
             </a:r>
-            <a:endParaRPr lang="en-US"/>
           </a:p>
         </p:txBody>
       </p:sp>
@@ -418,38 +431,37 @@
           <a:p>
             <a:pPr lvl="0"/>
             <a:r>
-              <a:rPr lang="en-US" smtClean="0"/>
+              <a:rPr lang="en-US"/>
               <a:t>Click to edit Master text styles</a:t>
             </a:r>
           </a:p>
           <a:p>
             <a:pPr lvl="1"/>
             <a:r>
-              <a:rPr lang="en-US" smtClean="0"/>
+              <a:rPr lang="en-US"/>
               <a:t>Second level</a:t>
             </a:r>
           </a:p>
           <a:p>
             <a:pPr lvl="2"/>
             <a:r>
-              <a:rPr lang="en-US" smtClean="0"/>
+              <a:rPr lang="en-US"/>
               <a:t>Third level</a:t>
             </a:r>
           </a:p>
           <a:p>
             <a:pPr lvl="3"/>
             <a:r>
-              <a:rPr lang="en-US" smtClean="0"/>
+              <a:rPr lang="en-US"/>
               <a:t>Fourth level</a:t>
             </a:r>
           </a:p>
           <a:p>
             <a:pPr lvl="4"/>
             <a:r>
-              <a:rPr lang="en-US" smtClean="0"/>
+              <a:rPr lang="en-US"/>
               <a:t>Fifth level</a:t>
             </a:r>
-            <a:endParaRPr lang="en-US"/>
           </a:p>
         </p:txBody>
       </p:sp>
@@ -470,7 +482,7 @@
           <a:p>
             <a:fld id="{5BCAD085-E8A6-8845-BD4E-CB4CCA059FC4}" type="datetimeFigureOut">
               <a:rPr lang="en-US" smtClean="0"/>
-              <a:t>1/27/13</a:t>
+              <a:t>9/23/26</a:t>
             </a:fld>
             <a:endParaRPr lang="en-US"/>
           </a:p>
@@ -569,10 +581,9 @@
           <a:lstStyle/>
           <a:p>
             <a:r>
-              <a:rPr lang="en-US" smtClean="0"/>
+              <a:rPr lang="en-US"/>
               <a:t>Click to edit Master title style</a:t>
             </a:r>
-            <a:endParaRPr lang="en-US"/>
           </a:p>
         </p:txBody>
       </p:sp>
@@ -598,38 +609,37 @@
           <a:p>
             <a:pPr lvl="0"/>
             <a:r>
-              <a:rPr lang="en-US" smtClean="0"/>
+              <a:rPr lang="en-US"/>
               <a:t>Click to edit Master text styles</a:t>
             </a:r>
           </a:p>
           <a:p>
             <a:pPr lvl="1"/>
             <a:r>
-              <a:rPr lang="en-US" smtClean="0"/>
+              <a:rPr lang="en-US"/>
               <a:t>Second level</a:t>
             </a:r>
           </a:p>
           <a:p>
             <a:pPr lvl="2"/>
             <a:r>
-              <a:rPr lang="en-US" smtClean="0"/>
+              <a:rPr lang="en-US"/>
               <a:t>Third level</a:t>
             </a:r>
           </a:p>
           <a:p>
             <a:pPr lvl="3"/>
             <a:r>
-              <a:rPr lang="en-US" smtClean="0"/>
+              <a:rPr lang="en-US"/>
               <a:t>Fourth level</a:t>
             </a:r>
           </a:p>
           <a:p>
             <a:pPr lvl="4"/>
             <a:r>
-              <a:rPr lang="en-US" smtClean="0"/>
+              <a:rPr lang="en-US"/>
               <a:t>Fifth level</a:t>
             </a:r>
-            <a:endParaRPr lang="en-US"/>
           </a:p>
         </p:txBody>
       </p:sp>
@@ -650,7 +660,7 @@
           <a:p>
             <a:fld id="{5BCAD085-E8A6-8845-BD4E-CB4CCA059FC4}" type="datetimeFigureOut">
               <a:rPr lang="en-US" smtClean="0"/>
-              <a:t>1/27/13</a:t>
+              <a:t>9/23/26</a:t>
             </a:fld>
             <a:endParaRPr lang="en-US"/>
           </a:p>
@@ -744,10 +754,9 @@
           <a:lstStyle/>
           <a:p>
             <a:r>
-              <a:rPr lang="en-US" smtClean="0"/>
+              <a:rPr lang="en-US"/>
               <a:t>Click to edit Master title style</a:t>
             </a:r>
-            <a:endParaRPr lang="en-US"/>
           </a:p>
         </p:txBody>
       </p:sp>
@@ -768,38 +777,37 @@
           <a:p>
             <a:pPr lvl="0"/>
             <a:r>
-              <a:rPr lang="en-US" smtClean="0"/>
+              <a:rPr lang="en-US"/>
               <a:t>Click to edit Master text styles</a:t>
             </a:r>
           </a:p>
           <a:p>
             <a:pPr lvl="1"/>
             <a:r>
-              <a:rPr lang="en-US" smtClean="0"/>
+              <a:rPr lang="en-US"/>
               <a:t>Second level</a:t>
             </a:r>
           </a:p>
           <a:p>
             <a:pPr lvl="2"/>
             <a:r>
-              <a:rPr lang="en-US" smtClean="0"/>
+              <a:rPr lang="en-US"/>
               <a:t>Third level</a:t>
             </a:r>
           </a:p>
           <a:p>
             <a:pPr lvl="3"/>
             <a:r>
-              <a:rPr lang="en-US" smtClean="0"/>
+              <a:rPr lang="en-US"/>
               <a:t>Fourth level</a:t>
             </a:r>
           </a:p>
           <a:p>
             <a:pPr lvl="4"/>
             <a:r>
-              <a:rPr lang="en-US" smtClean="0"/>
+              <a:rPr lang="en-US"/>
               <a:t>Fifth level</a:t>
             </a:r>
-            <a:endParaRPr lang="en-US"/>
           </a:p>
         </p:txBody>
       </p:sp>
@@ -820,7 +828,7 @@
           <a:p>
             <a:fld id="{5BCAD085-E8A6-8845-BD4E-CB4CCA059FC4}" type="datetimeFigureOut">
               <a:rPr lang="en-US" smtClean="0"/>
-              <a:t>1/27/13</a:t>
+              <a:t>9/23/26</a:t>
             </a:fld>
             <a:endParaRPr lang="en-US"/>
           </a:p>
@@ -923,10 +931,9 @@
           </a:lstStyle>
           <a:p>
             <a:r>
-              <a:rPr lang="en-US" smtClean="0"/>
+              <a:rPr lang="en-US"/>
               <a:t>Click to edit Master title style</a:t>
             </a:r>
-            <a:endParaRPr lang="en-US"/>
           </a:p>
         </p:txBody>
       </p:sp>
@@ -1043,7 +1050,7 @@
           <a:p>
             <a:pPr lvl="0"/>
             <a:r>
-              <a:rPr lang="en-US" smtClean="0"/>
+              <a:rPr lang="en-US"/>
               <a:t>Click to edit Master text styles</a:t>
             </a:r>
           </a:p>
@@ -1066,7 +1073,7 @@
           <a:p>
             <a:fld id="{5BCAD085-E8A6-8845-BD4E-CB4CCA059FC4}" type="datetimeFigureOut">
               <a:rPr lang="en-US" smtClean="0"/>
-              <a:t>1/27/13</a:t>
+              <a:t>9/23/26</a:t>
             </a:fld>
             <a:endParaRPr lang="en-US"/>
           </a:p>
@@ -1160,10 +1167,9 @@
           <a:lstStyle/>
           <a:p>
             <a:r>
-              <a:rPr lang="en-US" smtClean="0"/>
+              <a:rPr lang="en-US"/>
               <a:t>Click to edit Master title style</a:t>
             </a:r>
-            <a:endParaRPr lang="en-US"/>
           </a:p>
         </p:txBody>
       </p:sp>
@@ -1217,38 +1223,37 @@
           <a:p>
             <a:pPr lvl="0"/>
             <a:r>
-              <a:rPr lang="en-US" smtClean="0"/>
+              <a:rPr lang="en-US"/>
               <a:t>Click to edit Master text styles</a:t>
             </a:r>
           </a:p>
           <a:p>
             <a:pPr lvl="1"/>
             <a:r>
-              <a:rPr lang="en-US" smtClean="0"/>
+              <a:rPr lang="en-US"/>
               <a:t>Second level</a:t>
             </a:r>
           </a:p>
           <a:p>
             <a:pPr lvl="2"/>
             <a:r>
-              <a:rPr lang="en-US" smtClean="0"/>
+              <a:rPr lang="en-US"/>
               <a:t>Third level</a:t>
             </a:r>
           </a:p>
           <a:p>
             <a:pPr lvl="3"/>
             <a:r>
-              <a:rPr lang="en-US" smtClean="0"/>
+              <a:rPr lang="en-US"/>
               <a:t>Fourth level</a:t>
             </a:r>
           </a:p>
           <a:p>
             <a:pPr lvl="4"/>
             <a:r>
-              <a:rPr lang="en-US" smtClean="0"/>
+              <a:rPr lang="en-US"/>
               <a:t>Fifth level</a:t>
             </a:r>
-            <a:endParaRPr lang="en-US"/>
           </a:p>
         </p:txBody>
       </p:sp>
@@ -1302,38 +1307,37 @@
           <a:p>
             <a:pPr lvl="0"/>
             <a:r>
-              <a:rPr lang="en-US" smtClean="0"/>
+              <a:rPr lang="en-US"/>
               <a:t>Click to edit Master text styles</a:t>
             </a:r>
           </a:p>
           <a:p>
             <a:pPr lvl="1"/>
             <a:r>
-              <a:rPr lang="en-US" smtClean="0"/>
+              <a:rPr lang="en-US"/>
               <a:t>Second level</a:t>
             </a:r>
           </a:p>
           <a:p>
             <a:pPr lvl="2"/>
             <a:r>
-              <a:rPr lang="en-US" smtClean="0"/>
+              <a:rPr lang="en-US"/>
               <a:t>Third level</a:t>
             </a:r>
           </a:p>
           <a:p>
             <a:pPr lvl="3"/>
             <a:r>
-              <a:rPr lang="en-US" smtClean="0"/>
+              <a:rPr lang="en-US"/>
               <a:t>Fourth level</a:t>
             </a:r>
           </a:p>
           <a:p>
             <a:pPr lvl="4"/>
             <a:r>
-              <a:rPr lang="en-US" smtClean="0"/>
+              <a:rPr lang="en-US"/>
               <a:t>Fifth level</a:t>
             </a:r>
-            <a:endParaRPr lang="en-US"/>
           </a:p>
         </p:txBody>
       </p:sp>
@@ -1354,7 +1358,7 @@
           <a:p>
             <a:fld id="{5BCAD085-E8A6-8845-BD4E-CB4CCA059FC4}" type="datetimeFigureOut">
               <a:rPr lang="en-US" smtClean="0"/>
-              <a:t>1/27/13</a:t>
+              <a:t>9/23/26</a:t>
             </a:fld>
             <a:endParaRPr lang="en-US"/>
           </a:p>
@@ -1452,10 +1456,9 @@
           </a:lstStyle>
           <a:p>
             <a:r>
-              <a:rPr lang="en-US" smtClean="0"/>
+              <a:rPr lang="en-US"/>
               <a:t>Click to edit Master title style</a:t>
             </a:r>
-            <a:endParaRPr lang="en-US"/>
           </a:p>
         </p:txBody>
       </p:sp>
@@ -1518,7 +1521,7 @@
           <a:p>
             <a:pPr lvl="0"/>
             <a:r>
-              <a:rPr lang="en-US" smtClean="0"/>
+              <a:rPr lang="en-US"/>
               <a:t>Click to edit Master text styles</a:t>
             </a:r>
           </a:p>
@@ -1574,38 +1577,37 @@
           <a:p>
             <a:pPr lvl="0"/>
             <a:r>
-              <a:rPr lang="en-US" smtClean="0"/>
+              <a:rPr lang="en-US"/>
               <a:t>Click to edit Master text styles</a:t>
             </a:r>
           </a:p>
           <a:p>
             <a:pPr lvl="1"/>
             <a:r>
-              <a:rPr lang="en-US" smtClean="0"/>
+              <a:rPr lang="en-US"/>
               <a:t>Second level</a:t>
             </a:r>
           </a:p>
           <a:p>
             <a:pPr lvl="2"/>
             <a:r>
-              <a:rPr lang="en-US" smtClean="0"/>
+              <a:rPr lang="en-US"/>
               <a:t>Third level</a:t>
             </a:r>
           </a:p>
           <a:p>
             <a:pPr lvl="3"/>
             <a:r>
-              <a:rPr lang="en-US" smtClean="0"/>
+              <a:rPr lang="en-US"/>
               <a:t>Fourth level</a:t>
             </a:r>
           </a:p>
           <a:p>
             <a:pPr lvl="4"/>
             <a:r>
-              <a:rPr lang="en-US" smtClean="0"/>
+              <a:rPr lang="en-US"/>
               <a:t>Fifth level</a:t>
             </a:r>
-            <a:endParaRPr lang="en-US"/>
           </a:p>
         </p:txBody>
       </p:sp>
@@ -1668,7 +1670,7 @@
           <a:p>
             <a:pPr lvl="0"/>
             <a:r>
-              <a:rPr lang="en-US" smtClean="0"/>
+              <a:rPr lang="en-US"/>
               <a:t>Click to edit Master text styles</a:t>
             </a:r>
           </a:p>
@@ -1724,38 +1726,37 @@
           <a:p>
             <a:pPr lvl="0"/>
             <a:r>
-              <a:rPr lang="en-US" smtClean="0"/>
+              <a:rPr lang="en-US"/>
               <a:t>Click to edit Master text styles</a:t>
             </a:r>
           </a:p>
           <a:p>
             <a:pPr lvl="1"/>
             <a:r>
-              <a:rPr lang="en-US" smtClean="0"/>
+              <a:rPr lang="en-US"/>
               <a:t>Second level</a:t>
             </a:r>
           </a:p>
           <a:p>
             <a:pPr lvl="2"/>
             <a:r>
-              <a:rPr lang="en-US" smtClean="0"/>
+              <a:rPr lang="en-US"/>
               <a:t>Third level</a:t>
             </a:r>
           </a:p>
           <a:p>
             <a:pPr lvl="3"/>
             <a:r>
-              <a:rPr lang="en-US" smtClean="0"/>
+              <a:rPr lang="en-US"/>
               <a:t>Fourth level</a:t>
             </a:r>
           </a:p>
           <a:p>
             <a:pPr lvl="4"/>
             <a:r>
-              <a:rPr lang="en-US" smtClean="0"/>
+              <a:rPr lang="en-US"/>
               <a:t>Fifth level</a:t>
             </a:r>
-            <a:endParaRPr lang="en-US"/>
           </a:p>
         </p:txBody>
       </p:sp>
@@ -1776,7 +1777,7 @@
           <a:p>
             <a:fld id="{5BCAD085-E8A6-8845-BD4E-CB4CCA059FC4}" type="datetimeFigureOut">
               <a:rPr lang="en-US" smtClean="0"/>
-              <a:t>1/27/13</a:t>
+              <a:t>9/23/26</a:t>
             </a:fld>
             <a:endParaRPr lang="en-US"/>
           </a:p>
@@ -1870,10 +1871,9 @@
           <a:lstStyle/>
           <a:p>
             <a:r>
-              <a:rPr lang="en-US" smtClean="0"/>
+              <a:rPr lang="en-US"/>
               <a:t>Click to edit Master title style</a:t>
             </a:r>
-            <a:endParaRPr lang="en-US"/>
           </a:p>
         </p:txBody>
       </p:sp>
@@ -1894,7 +1894,7 @@
           <a:p>
             <a:fld id="{5BCAD085-E8A6-8845-BD4E-CB4CCA059FC4}" type="datetimeFigureOut">
               <a:rPr lang="en-US" smtClean="0"/>
-              <a:t>1/27/13</a:t>
+              <a:t>9/23/26</a:t>
             </a:fld>
             <a:endParaRPr lang="en-US"/>
           </a:p>
@@ -1989,7 +1989,7 @@
           <a:p>
             <a:fld id="{5BCAD085-E8A6-8845-BD4E-CB4CCA059FC4}" type="datetimeFigureOut">
               <a:rPr lang="en-US" smtClean="0"/>
-              <a:t>1/27/13</a:t>
+              <a:t>9/23/26</a:t>
             </a:fld>
             <a:endParaRPr lang="en-US"/>
           </a:p>
@@ -2092,10 +2092,9 @@
           </a:lstStyle>
           <a:p>
             <a:r>
-              <a:rPr lang="en-US" smtClean="0"/>
+              <a:rPr lang="en-US"/>
               <a:t>Click to edit Master title style</a:t>
             </a:r>
-            <a:endParaRPr lang="en-US"/>
           </a:p>
         </p:txBody>
       </p:sp>
@@ -2149,38 +2148,37 @@
           <a:p>
             <a:pPr lvl="0"/>
             <a:r>
-              <a:rPr lang="en-US" smtClean="0"/>
+              <a:rPr lang="en-US"/>
               <a:t>Click to edit Master text styles</a:t>
             </a:r>
           </a:p>
           <a:p>
             <a:pPr lvl="1"/>
             <a:r>
-              <a:rPr lang="en-US" smtClean="0"/>
+              <a:rPr lang="en-US"/>
               <a:t>Second level</a:t>
             </a:r>
           </a:p>
           <a:p>
             <a:pPr lvl="2"/>
             <a:r>
-              <a:rPr lang="en-US" smtClean="0"/>
+              <a:rPr lang="en-US"/>
               <a:t>Third level</a:t>
             </a:r>
           </a:p>
           <a:p>
             <a:pPr lvl="3"/>
             <a:r>
-              <a:rPr lang="en-US" smtClean="0"/>
+              <a:rPr lang="en-US"/>
               <a:t>Fourth level</a:t>
             </a:r>
           </a:p>
           <a:p>
             <a:pPr lvl="4"/>
             <a:r>
-              <a:rPr lang="en-US" smtClean="0"/>
+              <a:rPr lang="en-US"/>
               <a:t>Fifth level</a:t>
             </a:r>
-            <a:endParaRPr lang="en-US"/>
           </a:p>
         </p:txBody>
       </p:sp>
@@ -2243,7 +2241,7 @@
           <a:p>
             <a:pPr lvl="0"/>
             <a:r>
-              <a:rPr lang="en-US" smtClean="0"/>
+              <a:rPr lang="en-US"/>
               <a:t>Click to edit Master text styles</a:t>
             </a:r>
           </a:p>
@@ -2266,7 +2264,7 @@
           <a:p>
             <a:fld id="{5BCAD085-E8A6-8845-BD4E-CB4CCA059FC4}" type="datetimeFigureOut">
               <a:rPr lang="en-US" smtClean="0"/>
-              <a:t>1/27/13</a:t>
+              <a:t>9/23/26</a:t>
             </a:fld>
             <a:endParaRPr lang="en-US"/>
           </a:p>
@@ -2369,10 +2367,9 @@
           </a:lstStyle>
           <a:p>
             <a:r>
-              <a:rPr lang="en-US" smtClean="0"/>
+              <a:rPr lang="en-US"/>
               <a:t>Click to edit Master title style</a:t>
             </a:r>
-            <a:endParaRPr lang="en-US"/>
           </a:p>
         </p:txBody>
       </p:sp>
@@ -2496,7 +2493,7 @@
           <a:p>
             <a:pPr lvl="0"/>
             <a:r>
-              <a:rPr lang="en-US" smtClean="0"/>
+              <a:rPr lang="en-US"/>
               <a:t>Click to edit Master text styles</a:t>
             </a:r>
           </a:p>
@@ -2519,7 +2516,7 @@
           <a:p>
             <a:fld id="{5BCAD085-E8A6-8845-BD4E-CB4CCA059FC4}" type="datetimeFigureOut">
               <a:rPr lang="en-US" smtClean="0"/>
-              <a:t>1/27/13</a:t>
+              <a:t>9/23/26</a:t>
             </a:fld>
             <a:endParaRPr lang="en-US"/>
           </a:p>
@@ -2628,10 +2625,9 @@
           <a:lstStyle/>
           <a:p>
             <a:r>
-              <a:rPr lang="en-US" smtClean="0"/>
+              <a:rPr lang="en-US"/>
               <a:t>Click to edit Master title style</a:t>
             </a:r>
-            <a:endParaRPr lang="en-US"/>
           </a:p>
         </p:txBody>
       </p:sp>
@@ -2662,38 +2658,37 @@
           <a:p>
             <a:pPr lvl="0"/>
             <a:r>
-              <a:rPr lang="en-US" smtClean="0"/>
+              <a:rPr lang="en-US"/>
               <a:t>Click to edit Master text styles</a:t>
             </a:r>
           </a:p>
           <a:p>
             <a:pPr lvl="1"/>
             <a:r>
-              <a:rPr lang="en-US" smtClean="0"/>
+              <a:rPr lang="en-US"/>
               <a:t>Second level</a:t>
             </a:r>
           </a:p>
           <a:p>
             <a:pPr lvl="2"/>
             <a:r>
-              <a:rPr lang="en-US" smtClean="0"/>
+              <a:rPr lang="en-US"/>
               <a:t>Third level</a:t>
             </a:r>
           </a:p>
           <a:p>
             <a:pPr lvl="3"/>
             <a:r>
-              <a:rPr lang="en-US" smtClean="0"/>
+              <a:rPr lang="en-US"/>
               <a:t>Fourth level</a:t>
             </a:r>
           </a:p>
           <a:p>
             <a:pPr lvl="4"/>
             <a:r>
-              <a:rPr lang="en-US" smtClean="0"/>
+              <a:rPr lang="en-US"/>
               <a:t>Fifth level</a:t>
             </a:r>
-            <a:endParaRPr lang="en-US"/>
           </a:p>
         </p:txBody>
       </p:sp>
@@ -2732,7 +2727,7 @@
           <a:p>
             <a:fld id="{5BCAD085-E8A6-8845-BD4E-CB4CCA059FC4}" type="datetimeFigureOut">
               <a:rPr lang="en-US" smtClean="0"/>
-              <a:t>1/27/13</a:t>
+              <a:t>9/23/26</a:t>
             </a:fld>
             <a:endParaRPr lang="en-US"/>
           </a:p>
@@ -3091,7 +3086,7 @@
 </file>
 
 <file path=ppt/slides/slide1.xml><?xml version="1.0" encoding="utf-8"?>
-<p:sld xmlns:a="http://schemas.openxmlformats.org/drawingml/2006/main" xmlns:p="http://schemas.openxmlformats.org/presentationml/2006/main" xmlns:r="http://schemas.openxmlformats.org/officeDocument/2006/relationships">
+<p:sld xmlns:a="http://schemas.openxmlformats.org/drawingml/2006/main" xmlns:r="http://schemas.openxmlformats.org/officeDocument/2006/relationships" xmlns:p="http://schemas.openxmlformats.org/presentationml/2006/main">
   <p:cSld>
     <p:spTree>
       <p:nvGrpSpPr>
@@ -3099,7 +3094,14 @@
         <p:cNvGrpSpPr/>
         <p:nvPr/>
       </p:nvGrpSpPr>
-      <p:grpSpPr/>
+      <p:grpSpPr>
+        <a:xfrm>
+          <a:off x="0" y="0"/>
+          <a:ext cx="0" cy="0"/>
+          <a:chOff x="0" y="0"/>
+          <a:chExt cx="0" cy="0"/>
+        </a:xfrm>
+      </p:grpSpPr>
       <p:sp>
         <p:nvSpPr>
           <p:cNvPr id="2" name="Rectangle 1"/>
@@ -3140,6 +3142,7 @@
           <a:lstStyle/>
           <a:p>
             <a:pPr algn="ctr"/>
+            <a:endParaRPr/>
           </a:p>
         </p:txBody>
       </p:sp>
@@ -3165,7 +3168,6 @@
           </a:bodyPr>
           <a:lstStyle/>
           <a:p>
-            <a:pPr/>
             <a:r>
               <a:rPr sz="4400" b="1">
                 <a:solidFill>
@@ -3176,7 +3178,6 @@
             </a:r>
           </a:p>
           <a:p>
-            <a:pPr/>
             <a:r>
               <a:rPr sz="2000" b="0">
                 <a:solidFill>
@@ -3210,7 +3211,6 @@
           </a:bodyPr>
           <a:lstStyle/>
           <a:p>
-            <a:pPr/>
             <a:r>
               <a:rPr sz="1400" b="0">
                 <a:solidFill>
@@ -3231,7 +3231,7 @@
 </file>
 
 <file path=ppt/slides/slide10.xml><?xml version="1.0" encoding="utf-8"?>
-<p:sld xmlns:a="http://schemas.openxmlformats.org/drawingml/2006/main" xmlns:p="http://schemas.openxmlformats.org/presentationml/2006/main" xmlns:r="http://schemas.openxmlformats.org/officeDocument/2006/relationships">
+<p:sld xmlns:a="http://schemas.openxmlformats.org/drawingml/2006/main" xmlns:r="http://schemas.openxmlformats.org/officeDocument/2006/relationships" xmlns:p="http://schemas.openxmlformats.org/presentationml/2006/main">
   <p:cSld>
     <p:spTree>
       <p:nvGrpSpPr>
@@ -3239,7 +3239,14 @@
         <p:cNvGrpSpPr/>
         <p:nvPr/>
       </p:nvGrpSpPr>
-      <p:grpSpPr/>
+      <p:grpSpPr>
+        <a:xfrm>
+          <a:off x="0" y="0"/>
+          <a:ext cx="0" cy="0"/>
+          <a:chOff x="0" y="0"/>
+          <a:chExt cx="0" cy="0"/>
+        </a:xfrm>
+      </p:grpSpPr>
       <p:sp>
         <p:nvSpPr>
           <p:cNvPr id="2" name="Rectangle 1"/>
@@ -3280,6 +3287,7 @@
           <a:lstStyle/>
           <a:p>
             <a:pPr algn="ctr"/>
+            <a:endParaRPr/>
           </a:p>
         </p:txBody>
       </p:sp>
@@ -3305,7 +3313,6 @@
           </a:bodyPr>
           <a:lstStyle/>
           <a:p>
-            <a:pPr/>
             <a:r>
               <a:rPr sz="2800" b="1">
                 <a:solidFill>
@@ -3339,7 +3346,6 @@
           </a:bodyPr>
           <a:lstStyle/>
           <a:p>
-            <a:pPr/>
             <a:r>
               <a:rPr sz="1500" b="0">
                 <a:solidFill>
@@ -3350,7 +3356,6 @@
             </a:r>
           </a:p>
           <a:p>
-            <a:pPr/>
             <a:r>
               <a:rPr sz="1500" b="0">
                 <a:solidFill>
@@ -3361,7 +3366,6 @@
             </a:r>
           </a:p>
           <a:p>
-            <a:pPr/>
             <a:r>
               <a:rPr sz="1500" b="0">
                 <a:solidFill>
@@ -3372,7 +3376,6 @@
             </a:r>
           </a:p>
           <a:p>
-            <a:pPr/>
             <a:r>
               <a:rPr sz="1500" b="0">
                 <a:solidFill>
@@ -3383,7 +3386,6 @@
             </a:r>
           </a:p>
           <a:p>
-            <a:pPr/>
             <a:r>
               <a:rPr sz="1500" b="0">
                 <a:solidFill>
@@ -3394,7 +3396,6 @@
             </a:r>
           </a:p>
           <a:p>
-            <a:pPr/>
             <a:r>
               <a:rPr sz="1500" b="0">
                 <a:solidFill>
@@ -3457,7 +3458,6 @@
           </a:bodyPr>
           <a:lstStyle/>
           <a:p>
-            <a:pPr/>
             <a:r>
               <a:rPr sz="1100" b="0">
                 <a:solidFill>
@@ -3478,7 +3478,7 @@
 </file>
 
 <file path=ppt/slides/slide11.xml><?xml version="1.0" encoding="utf-8"?>
-<p:sld xmlns:a="http://schemas.openxmlformats.org/drawingml/2006/main" xmlns:p="http://schemas.openxmlformats.org/presentationml/2006/main" xmlns:r="http://schemas.openxmlformats.org/officeDocument/2006/relationships">
+<p:sld xmlns:a="http://schemas.openxmlformats.org/drawingml/2006/main" xmlns:r="http://schemas.openxmlformats.org/officeDocument/2006/relationships" xmlns:p="http://schemas.openxmlformats.org/presentationml/2006/main">
   <p:cSld>
     <p:spTree>
       <p:nvGrpSpPr>
@@ -3486,7 +3486,14 @@
         <p:cNvGrpSpPr/>
         <p:nvPr/>
       </p:nvGrpSpPr>
-      <p:grpSpPr/>
+      <p:grpSpPr>
+        <a:xfrm>
+          <a:off x="0" y="0"/>
+          <a:ext cx="0" cy="0"/>
+          <a:chOff x="0" y="0"/>
+          <a:chExt cx="0" cy="0"/>
+        </a:xfrm>
+      </p:grpSpPr>
       <p:sp>
         <p:nvSpPr>
           <p:cNvPr id="2" name="Rectangle 1"/>
@@ -3527,6 +3534,7 @@
           <a:lstStyle/>
           <a:p>
             <a:pPr algn="ctr"/>
+            <a:endParaRPr/>
           </a:p>
         </p:txBody>
       </p:sp>
@@ -3552,7 +3560,6 @@
           </a:bodyPr>
           <a:lstStyle/>
           <a:p>
-            <a:pPr/>
             <a:r>
               <a:rPr sz="2800" b="1">
                 <a:solidFill>
@@ -3573,7 +3580,7 @@
         <p:spPr>
           <a:xfrm>
             <a:off x="548640" y="1234440"/>
-            <a:ext cx="5120640" cy="5303520"/>
+            <a:ext cx="5120640" cy="784830"/>
           </a:xfrm>
           <a:prstGeom prst="rect">
             <a:avLst/>
@@ -3586,48 +3593,507 @@
           </a:bodyPr>
           <a:lstStyle/>
           <a:p>
-            <a:pPr/>
-            <a:r>
-              <a:rPr sz="1500" b="0">
-                <a:solidFill>
-                  <a:srgbClr val="1F2937"/>
-                </a:solidFill>
-              </a:rPr>
-              <a:t>- Tuyến 1: LLM cấu hình qua env - Gemini / OpenAI / Anthropic, đổi provider bằng AI_PROVIDER + AI_MODEL</a:t>
-            </a:r>
-          </a:p>
-          <a:p>
-            <a:pPr/>
-            <a:r>
-              <a:rPr sz="1500" b="0">
-                <a:solidFill>
-                  <a:srgbClr val="1F2937"/>
-                </a:solidFill>
-              </a:rPr>
-              <a:t>- Tuyến 2: Devin async - hết quota LLM thì tạo session xử lý, callback trả kết quả</a:t>
-            </a:r>
-          </a:p>
-          <a:p>
-            <a:pPr/>
-            <a:r>
-              <a:rPr sz="1500" b="0">
-                <a:solidFill>
-                  <a:srgbClr val="1F2937"/>
-                </a:solidFill>
-              </a:rPr>
-              <a:t>- Tuyến 3: rule-based fallback - luôn có câu trả lời hữu ích kể cả khi mọi backend chết</a:t>
-            </a:r>
-          </a:p>
-          <a:p>
-            <a:pPr/>
-            <a:r>
-              <a:rPr sz="1500" b="0">
-                <a:solidFill>
-                  <a:srgbClr val="1F2937"/>
-                </a:solidFill>
-              </a:rPr>
-              <a:t>- Ứng dụng: báo cáo hồ sơ lớp, nhận xét giáo án, gợi ý cảnh báo, trợ lý điều hành, phân tích sổ đầu bài, biên bản sinh hoạt, báo cáo Sở</a:t>
-            </a:r>
+            <a:r>
+              <a:rPr sz="1500" b="0" dirty="0">
+                <a:solidFill>
+                  <a:srgbClr val="1F2937"/>
+                </a:solidFill>
+              </a:rPr>
+              <a:t>- </a:t>
+            </a:r>
+            <a:r>
+              <a:rPr sz="1500" b="0" dirty="0" err="1">
+                <a:solidFill>
+                  <a:srgbClr val="1F2937"/>
+                </a:solidFill>
+              </a:rPr>
+              <a:t>Ứng</a:t>
+            </a:r>
+            <a:r>
+              <a:rPr sz="1500" b="0" dirty="0">
+                <a:solidFill>
+                  <a:srgbClr val="1F2937"/>
+                </a:solidFill>
+              </a:rPr>
+              <a:t> </a:t>
+            </a:r>
+            <a:r>
+              <a:rPr sz="1500" b="0" dirty="0" err="1">
+                <a:solidFill>
+                  <a:srgbClr val="1F2937"/>
+                </a:solidFill>
+              </a:rPr>
+              <a:t>dụng</a:t>
+            </a:r>
+            <a:r>
+              <a:rPr sz="1500" b="0" dirty="0">
+                <a:solidFill>
+                  <a:srgbClr val="1F2937"/>
+                </a:solidFill>
+              </a:rPr>
+              <a:t>: </a:t>
+            </a:r>
+            <a:r>
+              <a:rPr sz="1500" b="0" dirty="0" err="1">
+                <a:solidFill>
+                  <a:srgbClr val="1F2937"/>
+                </a:solidFill>
+              </a:rPr>
+              <a:t>báo</a:t>
+            </a:r>
+            <a:r>
+              <a:rPr sz="1500" b="0" dirty="0">
+                <a:solidFill>
+                  <a:srgbClr val="1F2937"/>
+                </a:solidFill>
+              </a:rPr>
+              <a:t> </a:t>
+            </a:r>
+            <a:r>
+              <a:rPr sz="1500" b="0" dirty="0" err="1">
+                <a:solidFill>
+                  <a:srgbClr val="1F2937"/>
+                </a:solidFill>
+              </a:rPr>
+              <a:t>cáo</a:t>
+            </a:r>
+            <a:r>
+              <a:rPr sz="1500" b="0" dirty="0">
+                <a:solidFill>
+                  <a:srgbClr val="1F2937"/>
+                </a:solidFill>
+              </a:rPr>
+              <a:t> </a:t>
+            </a:r>
+            <a:r>
+              <a:rPr sz="1500" b="0" dirty="0" err="1">
+                <a:solidFill>
+                  <a:srgbClr val="1F2937"/>
+                </a:solidFill>
+              </a:rPr>
+              <a:t>hồ</a:t>
+            </a:r>
+            <a:r>
+              <a:rPr sz="1500" b="0" dirty="0">
+                <a:solidFill>
+                  <a:srgbClr val="1F2937"/>
+                </a:solidFill>
+              </a:rPr>
+              <a:t> </a:t>
+            </a:r>
+            <a:r>
+              <a:rPr sz="1500" b="0" dirty="0" err="1">
+                <a:solidFill>
+                  <a:srgbClr val="1F2937"/>
+                </a:solidFill>
+              </a:rPr>
+              <a:t>sơ</a:t>
+            </a:r>
+            <a:r>
+              <a:rPr sz="1500" b="0" dirty="0">
+                <a:solidFill>
+                  <a:srgbClr val="1F2937"/>
+                </a:solidFill>
+              </a:rPr>
+              <a:t> </a:t>
+            </a:r>
+            <a:r>
+              <a:rPr sz="1500" b="0" dirty="0" err="1">
+                <a:solidFill>
+                  <a:srgbClr val="1F2937"/>
+                </a:solidFill>
+              </a:rPr>
+              <a:t>lớp</a:t>
+            </a:r>
+            <a:r>
+              <a:rPr sz="1500" b="0" dirty="0">
+                <a:solidFill>
+                  <a:srgbClr val="1F2937"/>
+                </a:solidFill>
+              </a:rPr>
+              <a:t>, </a:t>
+            </a:r>
+            <a:r>
+              <a:rPr sz="1500" b="0" dirty="0" err="1">
+                <a:solidFill>
+                  <a:srgbClr val="1F2937"/>
+                </a:solidFill>
+              </a:rPr>
+              <a:t>nhận</a:t>
+            </a:r>
+            <a:r>
+              <a:rPr sz="1500" b="0" dirty="0">
+                <a:solidFill>
+                  <a:srgbClr val="1F2937"/>
+                </a:solidFill>
+              </a:rPr>
+              <a:t> </a:t>
+            </a:r>
+            <a:r>
+              <a:rPr sz="1500" b="0" dirty="0" err="1">
+                <a:solidFill>
+                  <a:srgbClr val="1F2937"/>
+                </a:solidFill>
+              </a:rPr>
+              <a:t>xét</a:t>
+            </a:r>
+            <a:r>
+              <a:rPr sz="1500" b="0" dirty="0">
+                <a:solidFill>
+                  <a:srgbClr val="1F2937"/>
+                </a:solidFill>
+              </a:rPr>
+              <a:t> </a:t>
+            </a:r>
+            <a:r>
+              <a:rPr sz="1500" b="0" dirty="0" err="1">
+                <a:solidFill>
+                  <a:srgbClr val="1F2937"/>
+                </a:solidFill>
+              </a:rPr>
+              <a:t>giáo</a:t>
+            </a:r>
+            <a:r>
+              <a:rPr sz="1500" b="0" dirty="0">
+                <a:solidFill>
+                  <a:srgbClr val="1F2937"/>
+                </a:solidFill>
+              </a:rPr>
+              <a:t> </a:t>
+            </a:r>
+            <a:r>
+              <a:rPr sz="1500" b="0" dirty="0" err="1">
+                <a:solidFill>
+                  <a:srgbClr val="1F2937"/>
+                </a:solidFill>
+              </a:rPr>
+              <a:t>án</a:t>
+            </a:r>
+            <a:r>
+              <a:rPr sz="1500" b="0" dirty="0">
+                <a:solidFill>
+                  <a:srgbClr val="1F2937"/>
+                </a:solidFill>
+              </a:rPr>
+              <a:t>, </a:t>
+            </a:r>
+            <a:r>
+              <a:rPr sz="1500" b="0" dirty="0" err="1">
+                <a:solidFill>
+                  <a:srgbClr val="1F2937"/>
+                </a:solidFill>
+              </a:rPr>
+              <a:t>gợi</a:t>
+            </a:r>
+            <a:r>
+              <a:rPr sz="1500" b="0" dirty="0">
+                <a:solidFill>
+                  <a:srgbClr val="1F2937"/>
+                </a:solidFill>
+              </a:rPr>
+              <a:t> </a:t>
+            </a:r>
+            <a:r>
+              <a:rPr sz="1500" b="0" dirty="0" err="1">
+                <a:solidFill>
+                  <a:srgbClr val="1F2937"/>
+                </a:solidFill>
+              </a:rPr>
+              <a:t>ý</a:t>
+            </a:r>
+            <a:r>
+              <a:rPr sz="1500" b="0" dirty="0">
+                <a:solidFill>
+                  <a:srgbClr val="1F2937"/>
+                </a:solidFill>
+              </a:rPr>
+              <a:t> </a:t>
+            </a:r>
+            <a:r>
+              <a:rPr sz="1500" b="0" dirty="0" err="1">
+                <a:solidFill>
+                  <a:srgbClr val="1F2937"/>
+                </a:solidFill>
+              </a:rPr>
+              <a:t>cảnh</a:t>
+            </a:r>
+            <a:r>
+              <a:rPr sz="1500" b="0" dirty="0">
+                <a:solidFill>
+                  <a:srgbClr val="1F2937"/>
+                </a:solidFill>
+              </a:rPr>
+              <a:t> </a:t>
+            </a:r>
+            <a:r>
+              <a:rPr sz="1500" b="0" dirty="0" err="1">
+                <a:solidFill>
+                  <a:srgbClr val="1F2937"/>
+                </a:solidFill>
+              </a:rPr>
+              <a:t>báo</a:t>
+            </a:r>
+            <a:r>
+              <a:rPr sz="1500" b="0" dirty="0">
+                <a:solidFill>
+                  <a:srgbClr val="1F2937"/>
+                </a:solidFill>
+              </a:rPr>
+              <a:t>, </a:t>
+            </a:r>
+            <a:r>
+              <a:rPr sz="1500" b="0" dirty="0" err="1">
+                <a:solidFill>
+                  <a:srgbClr val="1F2937"/>
+                </a:solidFill>
+              </a:rPr>
+              <a:t>trợ</a:t>
+            </a:r>
+            <a:r>
+              <a:rPr sz="1500" b="0" dirty="0">
+                <a:solidFill>
+                  <a:srgbClr val="1F2937"/>
+                </a:solidFill>
+              </a:rPr>
+              <a:t> </a:t>
+            </a:r>
+            <a:r>
+              <a:rPr sz="1500" b="0" dirty="0" err="1">
+                <a:solidFill>
+                  <a:srgbClr val="1F2937"/>
+                </a:solidFill>
+              </a:rPr>
+              <a:t>lý</a:t>
+            </a:r>
+            <a:r>
+              <a:rPr sz="1500" b="0" dirty="0">
+                <a:solidFill>
+                  <a:srgbClr val="1F2937"/>
+                </a:solidFill>
+              </a:rPr>
+              <a:t> </a:t>
+            </a:r>
+            <a:r>
+              <a:rPr sz="1500" b="0" dirty="0" err="1">
+                <a:solidFill>
+                  <a:srgbClr val="1F2937"/>
+                </a:solidFill>
+              </a:rPr>
+              <a:t>điều</a:t>
+            </a:r>
+            <a:r>
+              <a:rPr sz="1500" b="0" dirty="0">
+                <a:solidFill>
+                  <a:srgbClr val="1F2937"/>
+                </a:solidFill>
+              </a:rPr>
+              <a:t> </a:t>
+            </a:r>
+            <a:r>
+              <a:rPr sz="1500" b="0" dirty="0" err="1">
+                <a:solidFill>
+                  <a:srgbClr val="1F2937"/>
+                </a:solidFill>
+              </a:rPr>
+              <a:t>hành</a:t>
+            </a:r>
+            <a:r>
+              <a:rPr sz="1500" b="0" dirty="0">
+                <a:solidFill>
+                  <a:srgbClr val="1F2937"/>
+                </a:solidFill>
+              </a:rPr>
+              <a:t>, </a:t>
+            </a:r>
+            <a:r>
+              <a:rPr sz="1500" b="0" dirty="0" err="1">
+                <a:solidFill>
+                  <a:srgbClr val="1F2937"/>
+                </a:solidFill>
+              </a:rPr>
+              <a:t>phân</a:t>
+            </a:r>
+            <a:r>
+              <a:rPr sz="1500" b="0" dirty="0">
+                <a:solidFill>
+                  <a:srgbClr val="1F2937"/>
+                </a:solidFill>
+              </a:rPr>
+              <a:t> </a:t>
+            </a:r>
+            <a:r>
+              <a:rPr sz="1500" b="0" dirty="0" err="1">
+                <a:solidFill>
+                  <a:srgbClr val="1F2937"/>
+                </a:solidFill>
+              </a:rPr>
+              <a:t>tích</a:t>
+            </a:r>
+            <a:r>
+              <a:rPr sz="1500" b="0" dirty="0">
+                <a:solidFill>
+                  <a:srgbClr val="1F2937"/>
+                </a:solidFill>
+              </a:rPr>
+              <a:t> </a:t>
+            </a:r>
+            <a:r>
+              <a:rPr sz="1500" b="0" dirty="0" err="1">
+                <a:solidFill>
+                  <a:srgbClr val="1F2937"/>
+                </a:solidFill>
+              </a:rPr>
+              <a:t>sổ</a:t>
+            </a:r>
+            <a:r>
+              <a:rPr sz="1500" b="0" dirty="0">
+                <a:solidFill>
+                  <a:srgbClr val="1F2937"/>
+                </a:solidFill>
+              </a:rPr>
+              <a:t> </a:t>
+            </a:r>
+            <a:r>
+              <a:rPr sz="1500" b="0" dirty="0" err="1">
+                <a:solidFill>
+                  <a:srgbClr val="1F2937"/>
+                </a:solidFill>
+              </a:rPr>
+              <a:t>đầu</a:t>
+            </a:r>
+            <a:r>
+              <a:rPr sz="1500" b="0" dirty="0">
+                <a:solidFill>
+                  <a:srgbClr val="1F2937"/>
+                </a:solidFill>
+              </a:rPr>
+              <a:t> </a:t>
+            </a:r>
+            <a:r>
+              <a:rPr sz="1500" b="0" dirty="0" err="1">
+                <a:solidFill>
+                  <a:srgbClr val="1F2937"/>
+                </a:solidFill>
+              </a:rPr>
+              <a:t>bài</a:t>
+            </a:r>
+            <a:r>
+              <a:rPr sz="1500" b="0" dirty="0">
+                <a:solidFill>
+                  <a:srgbClr val="1F2937"/>
+                </a:solidFill>
+              </a:rPr>
+              <a:t>, </a:t>
+            </a:r>
+            <a:r>
+              <a:rPr sz="1500" b="0" dirty="0" err="1">
+                <a:solidFill>
+                  <a:srgbClr val="1F2937"/>
+                </a:solidFill>
+              </a:rPr>
+              <a:t>biên</a:t>
+            </a:r>
+            <a:r>
+              <a:rPr sz="1500" b="0" dirty="0">
+                <a:solidFill>
+                  <a:srgbClr val="1F2937"/>
+                </a:solidFill>
+              </a:rPr>
+              <a:t> </a:t>
+            </a:r>
+            <a:r>
+              <a:rPr sz="1500" b="0" dirty="0" err="1">
+                <a:solidFill>
+                  <a:srgbClr val="1F2937"/>
+                </a:solidFill>
+              </a:rPr>
+              <a:t>bản</a:t>
+            </a:r>
+            <a:r>
+              <a:rPr sz="1500" b="0" dirty="0">
+                <a:solidFill>
+                  <a:srgbClr val="1F2937"/>
+                </a:solidFill>
+              </a:rPr>
+              <a:t> </a:t>
+            </a:r>
+            <a:r>
+              <a:rPr sz="1500" b="0" dirty="0" err="1">
+                <a:solidFill>
+                  <a:srgbClr val="1F2937"/>
+                </a:solidFill>
+              </a:rPr>
+              <a:t>sinh</a:t>
+            </a:r>
+            <a:r>
+              <a:rPr sz="1500" b="0" dirty="0">
+                <a:solidFill>
+                  <a:srgbClr val="1F2937"/>
+                </a:solidFill>
+              </a:rPr>
+              <a:t> </a:t>
+            </a:r>
+            <a:r>
+              <a:rPr sz="1500" b="0" dirty="0" err="1">
+                <a:solidFill>
+                  <a:srgbClr val="1F2937"/>
+                </a:solidFill>
+              </a:rPr>
+              <a:t>hoạt</a:t>
+            </a:r>
+            <a:r>
+              <a:rPr sz="1500" b="0" dirty="0">
+                <a:solidFill>
+                  <a:srgbClr val="1F2937"/>
+                </a:solidFill>
+              </a:rPr>
+              <a:t>, </a:t>
+            </a:r>
+            <a:r>
+              <a:rPr sz="1500" b="0" dirty="0" err="1">
+                <a:solidFill>
+                  <a:srgbClr val="1F2937"/>
+                </a:solidFill>
+              </a:rPr>
+              <a:t>báo</a:t>
+            </a:r>
+            <a:r>
+              <a:rPr sz="1500" b="0" dirty="0">
+                <a:solidFill>
+                  <a:srgbClr val="1F2937"/>
+                </a:solidFill>
+              </a:rPr>
+              <a:t> </a:t>
+            </a:r>
+            <a:r>
+              <a:rPr sz="1500" b="0" dirty="0" err="1">
+                <a:solidFill>
+                  <a:srgbClr val="1F2937"/>
+                </a:solidFill>
+              </a:rPr>
+              <a:t>cáo</a:t>
+            </a:r>
+            <a:r>
+              <a:rPr sz="1500" b="0" dirty="0">
+                <a:solidFill>
+                  <a:srgbClr val="1F2937"/>
+                </a:solidFill>
+              </a:rPr>
+              <a:t> </a:t>
+            </a:r>
+            <a:r>
+              <a:rPr sz="1500" b="0" dirty="0" err="1">
+                <a:solidFill>
+                  <a:srgbClr val="1F2937"/>
+                </a:solidFill>
+              </a:rPr>
+              <a:t>Sở</a:t>
+            </a:r>
+            <a:endParaRPr sz="1500" b="0" dirty="0">
+              <a:solidFill>
+                <a:srgbClr val="1F2937"/>
+              </a:solidFill>
+            </a:endParaRPr>
           </a:p>
         </p:txBody>
       </p:sp>
@@ -3682,7 +4148,6 @@
           </a:bodyPr>
           <a:lstStyle/>
           <a:p>
-            <a:pPr/>
             <a:r>
               <a:rPr sz="1100" b="0">
                 <a:solidFill>
@@ -3703,7 +4168,7 @@
 </file>
 
 <file path=ppt/slides/slide12.xml><?xml version="1.0" encoding="utf-8"?>
-<p:sld xmlns:a="http://schemas.openxmlformats.org/drawingml/2006/main" xmlns:p="http://schemas.openxmlformats.org/presentationml/2006/main" xmlns:r="http://schemas.openxmlformats.org/officeDocument/2006/relationships">
+<p:sld xmlns:a="http://schemas.openxmlformats.org/drawingml/2006/main" xmlns:r="http://schemas.openxmlformats.org/officeDocument/2006/relationships" xmlns:p="http://schemas.openxmlformats.org/presentationml/2006/main">
   <p:cSld>
     <p:spTree>
       <p:nvGrpSpPr>
@@ -3711,7 +4176,14 @@
         <p:cNvGrpSpPr/>
         <p:nvPr/>
       </p:nvGrpSpPr>
-      <p:grpSpPr/>
+      <p:grpSpPr>
+        <a:xfrm>
+          <a:off x="0" y="0"/>
+          <a:ext cx="0" cy="0"/>
+          <a:chOff x="0" y="0"/>
+          <a:chExt cx="0" cy="0"/>
+        </a:xfrm>
+      </p:grpSpPr>
       <p:sp>
         <p:nvSpPr>
           <p:cNvPr id="2" name="Rectangle 1"/>
@@ -3752,6 +4224,7 @@
           <a:lstStyle/>
           <a:p>
             <a:pPr algn="ctr"/>
+            <a:endParaRPr/>
           </a:p>
         </p:txBody>
       </p:sp>
@@ -3777,7 +4250,6 @@
           </a:bodyPr>
           <a:lstStyle/>
           <a:p>
-            <a:pPr/>
             <a:r>
               <a:rPr sz="2800" b="1">
                 <a:solidFill>
@@ -3811,7 +4283,6 @@
           </a:bodyPr>
           <a:lstStyle/>
           <a:p>
-            <a:pPr/>
             <a:r>
               <a:rPr sz="1500" b="0">
                 <a:solidFill>
@@ -3822,7 +4293,6 @@
             </a:r>
           </a:p>
           <a:p>
-            <a:pPr/>
             <a:r>
               <a:rPr sz="1500" b="0">
                 <a:solidFill>
@@ -3833,7 +4303,6 @@
             </a:r>
           </a:p>
           <a:p>
-            <a:pPr/>
             <a:r>
               <a:rPr sz="1500" b="0">
                 <a:solidFill>
@@ -3844,7 +4313,6 @@
             </a:r>
           </a:p>
           <a:p>
-            <a:pPr/>
             <a:r>
               <a:rPr sz="1500" b="0">
                 <a:solidFill>
@@ -3855,7 +4323,6 @@
             </a:r>
           </a:p>
           <a:p>
-            <a:pPr/>
             <a:r>
               <a:rPr sz="1500" b="0">
                 <a:solidFill>
@@ -3918,7 +4385,6 @@
           </a:bodyPr>
           <a:lstStyle/>
           <a:p>
-            <a:pPr/>
             <a:r>
               <a:rPr sz="1100" b="0">
                 <a:solidFill>
@@ -3939,7 +4405,7 @@
 </file>
 
 <file path=ppt/slides/slide13.xml><?xml version="1.0" encoding="utf-8"?>
-<p:sld xmlns:a="http://schemas.openxmlformats.org/drawingml/2006/main" xmlns:p="http://schemas.openxmlformats.org/presentationml/2006/main" xmlns:r="http://schemas.openxmlformats.org/officeDocument/2006/relationships">
+<p:sld xmlns:a="http://schemas.openxmlformats.org/drawingml/2006/main" xmlns:r="http://schemas.openxmlformats.org/officeDocument/2006/relationships" xmlns:p="http://schemas.openxmlformats.org/presentationml/2006/main">
   <p:cSld>
     <p:spTree>
       <p:nvGrpSpPr>
@@ -3947,7 +4413,14 @@
         <p:cNvGrpSpPr/>
         <p:nvPr/>
       </p:nvGrpSpPr>
-      <p:grpSpPr/>
+      <p:grpSpPr>
+        <a:xfrm>
+          <a:off x="0" y="0"/>
+          <a:ext cx="0" cy="0"/>
+          <a:chOff x="0" y="0"/>
+          <a:chExt cx="0" cy="0"/>
+        </a:xfrm>
+      </p:grpSpPr>
       <p:sp>
         <p:nvSpPr>
           <p:cNvPr id="2" name="Rectangle 1"/>
@@ -3988,6 +4461,7 @@
           <a:lstStyle/>
           <a:p>
             <a:pPr algn="ctr"/>
+            <a:endParaRPr/>
           </a:p>
         </p:txBody>
       </p:sp>
@@ -4013,7 +4487,6 @@
           </a:bodyPr>
           <a:lstStyle/>
           <a:p>
-            <a:pPr/>
             <a:r>
               <a:rPr sz="3600" b="1">
                 <a:solidFill>
@@ -4024,7 +4497,6 @@
             </a:r>
           </a:p>
           <a:p>
-            <a:pPr/>
             <a:r>
               <a:rPr sz="2000" b="0">
                 <a:solidFill>
@@ -4035,7 +4507,6 @@
             </a:r>
           </a:p>
           <a:p>
-            <a:pPr/>
             <a:r>
               <a:rPr sz="1600" b="0">
                 <a:solidFill>
@@ -4046,7 +4517,6 @@
             </a:r>
           </a:p>
           <a:p>
-            <a:pPr/>
             <a:r>
               <a:rPr sz="1400" b="0">
                 <a:solidFill>
@@ -4067,7 +4537,7 @@
 </file>
 
 <file path=ppt/slides/slide2.xml><?xml version="1.0" encoding="utf-8"?>
-<p:sld xmlns:a="http://schemas.openxmlformats.org/drawingml/2006/main" xmlns:p="http://schemas.openxmlformats.org/presentationml/2006/main" xmlns:r="http://schemas.openxmlformats.org/officeDocument/2006/relationships">
+<p:sld xmlns:a="http://schemas.openxmlformats.org/drawingml/2006/main" xmlns:r="http://schemas.openxmlformats.org/officeDocument/2006/relationships" xmlns:p="http://schemas.openxmlformats.org/presentationml/2006/main">
   <p:cSld>
     <p:spTree>
       <p:nvGrpSpPr>
@@ -4075,7 +4545,14 @@
         <p:cNvGrpSpPr/>
         <p:nvPr/>
       </p:nvGrpSpPr>
-      <p:grpSpPr/>
+      <p:grpSpPr>
+        <a:xfrm>
+          <a:off x="0" y="0"/>
+          <a:ext cx="0" cy="0"/>
+          <a:chOff x="0" y="0"/>
+          <a:chExt cx="0" cy="0"/>
+        </a:xfrm>
+      </p:grpSpPr>
       <p:sp>
         <p:nvSpPr>
           <p:cNvPr id="2" name="Rectangle 1"/>
@@ -4116,6 +4593,7 @@
           <a:lstStyle/>
           <a:p>
             <a:pPr algn="ctr"/>
+            <a:endParaRPr/>
           </a:p>
         </p:txBody>
       </p:sp>
@@ -4141,7 +4619,6 @@
           </a:bodyPr>
           <a:lstStyle/>
           <a:p>
-            <a:pPr/>
             <a:r>
               <a:rPr sz="2800" b="1">
                 <a:solidFill>
@@ -4175,7 +4652,6 @@
           </a:bodyPr>
           <a:lstStyle/>
           <a:p>
-            <a:pPr/>
             <a:r>
               <a:rPr sz="1500" b="0">
                 <a:solidFill>
@@ -4186,7 +4662,6 @@
             </a:r>
           </a:p>
           <a:p>
-            <a:pPr/>
             <a:r>
               <a:rPr sz="1500" b="0">
                 <a:solidFill>
@@ -4197,7 +4672,6 @@
             </a:r>
           </a:p>
           <a:p>
-            <a:pPr/>
             <a:r>
               <a:rPr sz="1500" b="0">
                 <a:solidFill>
@@ -4208,7 +4682,6 @@
             </a:r>
           </a:p>
           <a:p>
-            <a:pPr/>
             <a:r>
               <a:rPr sz="1500" b="0">
                 <a:solidFill>
@@ -4219,7 +4692,6 @@
             </a:r>
           </a:p>
           <a:p>
-            <a:pPr/>
             <a:r>
               <a:rPr sz="1500" b="0">
                 <a:solidFill>
@@ -4230,7 +4702,6 @@
             </a:r>
           </a:p>
           <a:p>
-            <a:pPr/>
             <a:r>
               <a:rPr sz="1500" b="0">
                 <a:solidFill>
@@ -4293,7 +4764,6 @@
           </a:bodyPr>
           <a:lstStyle/>
           <a:p>
-            <a:pPr/>
             <a:r>
               <a:rPr sz="1100" b="0">
                 <a:solidFill>
@@ -4314,7 +4784,7 @@
 </file>
 
 <file path=ppt/slides/slide3.xml><?xml version="1.0" encoding="utf-8"?>
-<p:sld xmlns:a="http://schemas.openxmlformats.org/drawingml/2006/main" xmlns:p="http://schemas.openxmlformats.org/presentationml/2006/main" xmlns:r="http://schemas.openxmlformats.org/officeDocument/2006/relationships">
+<p:sld xmlns:a="http://schemas.openxmlformats.org/drawingml/2006/main" xmlns:r="http://schemas.openxmlformats.org/officeDocument/2006/relationships" xmlns:p="http://schemas.openxmlformats.org/presentationml/2006/main">
   <p:cSld>
     <p:spTree>
       <p:nvGrpSpPr>
@@ -4322,7 +4792,14 @@
         <p:cNvGrpSpPr/>
         <p:nvPr/>
       </p:nvGrpSpPr>
-      <p:grpSpPr/>
+      <p:grpSpPr>
+        <a:xfrm>
+          <a:off x="0" y="0"/>
+          <a:ext cx="0" cy="0"/>
+          <a:chOff x="0" y="0"/>
+          <a:chExt cx="0" cy="0"/>
+        </a:xfrm>
+      </p:grpSpPr>
       <p:sp>
         <p:nvSpPr>
           <p:cNvPr id="2" name="TextBox 1"/>
@@ -4345,7 +4822,6 @@
           </a:bodyPr>
           <a:lstStyle/>
           <a:p>
-            <a:pPr/>
             <a:r>
               <a:rPr sz="2800" b="1">
                 <a:solidFill>
@@ -4376,10 +4852,34 @@
                 <a:tableStyleId>{5C22544A-7EE6-4342-B048-85BDC9FD1C3A}</a:tableStyleId>
               </a:tblPr>
               <a:tblGrid>
-                <a:gridCol w="2773603"/>
-                <a:gridCol w="2773603"/>
-                <a:gridCol w="2773603"/>
-                <a:gridCol w="2773606"/>
+                <a:gridCol w="2773603">
+                  <a:extLst>
+                    <a:ext uri="{9D8B030D-6E8A-4147-A177-3AD203B41FA5}">
+                      <a16:colId xmlns:a16="http://schemas.microsoft.com/office/drawing/2014/main" val="20000"/>
+                    </a:ext>
+                  </a:extLst>
+                </a:gridCol>
+                <a:gridCol w="2773603">
+                  <a:extLst>
+                    <a:ext uri="{9D8B030D-6E8A-4147-A177-3AD203B41FA5}">
+                      <a16:colId xmlns:a16="http://schemas.microsoft.com/office/drawing/2014/main" val="20001"/>
+                    </a:ext>
+                  </a:extLst>
+                </a:gridCol>
+                <a:gridCol w="2773603">
+                  <a:extLst>
+                    <a:ext uri="{9D8B030D-6E8A-4147-A177-3AD203B41FA5}">
+                      <a16:colId xmlns:a16="http://schemas.microsoft.com/office/drawing/2014/main" val="20002"/>
+                    </a:ext>
+                  </a:extLst>
+                </a:gridCol>
+                <a:gridCol w="2773606">
+                  <a:extLst>
+                    <a:ext uri="{9D8B030D-6E8A-4147-A177-3AD203B41FA5}">
+                      <a16:colId xmlns:a16="http://schemas.microsoft.com/office/drawing/2014/main" val="20003"/>
+                    </a:ext>
+                  </a:extLst>
+                </a:gridCol>
               </a:tblGrid>
               <a:tr h="950976">
                 <a:tc>
@@ -4434,6 +4934,11 @@
                   </a:txBody>
                   <a:tcPr/>
                 </a:tc>
+                <a:extLst>
+                  <a:ext uri="{0D108BD9-81ED-4DB2-BD59-A6C34878D82A}">
+                    <a16:rowId xmlns:a16="http://schemas.microsoft.com/office/drawing/2014/main" val="10000"/>
+                  </a:ext>
+                </a:extLst>
               </a:tr>
               <a:tr h="950976">
                 <a:tc>
@@ -4488,6 +4993,11 @@
                   </a:txBody>
                   <a:tcPr/>
                 </a:tc>
+                <a:extLst>
+                  <a:ext uri="{0D108BD9-81ED-4DB2-BD59-A6C34878D82A}">
+                    <a16:rowId xmlns:a16="http://schemas.microsoft.com/office/drawing/2014/main" val="10001"/>
+                  </a:ext>
+                </a:extLst>
               </a:tr>
               <a:tr h="950976">
                 <a:tc>
@@ -4542,6 +5052,11 @@
                   </a:txBody>
                   <a:tcPr/>
                 </a:tc>
+                <a:extLst>
+                  <a:ext uri="{0D108BD9-81ED-4DB2-BD59-A6C34878D82A}">
+                    <a16:rowId xmlns:a16="http://schemas.microsoft.com/office/drawing/2014/main" val="10002"/>
+                  </a:ext>
+                </a:extLst>
               </a:tr>
               <a:tr h="950976">
                 <a:tc>
@@ -4596,6 +5111,11 @@
                   </a:txBody>
                   <a:tcPr/>
                 </a:tc>
+                <a:extLst>
+                  <a:ext uri="{0D108BD9-81ED-4DB2-BD59-A6C34878D82A}">
+                    <a16:rowId xmlns:a16="http://schemas.microsoft.com/office/drawing/2014/main" val="10003"/>
+                  </a:ext>
+                </a:extLst>
               </a:tr>
               <a:tr h="950976">
                 <a:tc>
@@ -4650,6 +5170,11 @@
                   </a:txBody>
                   <a:tcPr/>
                 </a:tc>
+                <a:extLst>
+                  <a:ext uri="{0D108BD9-81ED-4DB2-BD59-A6C34878D82A}">
+                    <a16:rowId xmlns:a16="http://schemas.microsoft.com/office/drawing/2014/main" val="10004"/>
+                  </a:ext>
+                </a:extLst>
               </a:tr>
             </a:tbl>
           </a:graphicData>
@@ -4664,7 +5189,7 @@
 </file>
 
 <file path=ppt/slides/slide4.xml><?xml version="1.0" encoding="utf-8"?>
-<p:sld xmlns:a="http://schemas.openxmlformats.org/drawingml/2006/main" xmlns:p="http://schemas.openxmlformats.org/presentationml/2006/main" xmlns:r="http://schemas.openxmlformats.org/officeDocument/2006/relationships">
+<p:sld xmlns:a="http://schemas.openxmlformats.org/drawingml/2006/main" xmlns:r="http://schemas.openxmlformats.org/officeDocument/2006/relationships" xmlns:p="http://schemas.openxmlformats.org/presentationml/2006/main">
   <p:cSld>
     <p:spTree>
       <p:nvGrpSpPr>
@@ -4672,7 +5197,14 @@
         <p:cNvGrpSpPr/>
         <p:nvPr/>
       </p:nvGrpSpPr>
-      <p:grpSpPr/>
+      <p:grpSpPr>
+        <a:xfrm>
+          <a:off x="0" y="0"/>
+          <a:ext cx="0" cy="0"/>
+          <a:chOff x="0" y="0"/>
+          <a:chExt cx="0" cy="0"/>
+        </a:xfrm>
+      </p:grpSpPr>
       <p:sp>
         <p:nvSpPr>
           <p:cNvPr id="2" name="Rectangle 1"/>
@@ -4713,6 +5245,7 @@
           <a:lstStyle/>
           <a:p>
             <a:pPr algn="ctr"/>
+            <a:endParaRPr/>
           </a:p>
         </p:txBody>
       </p:sp>
@@ -4738,7 +5271,6 @@
           </a:bodyPr>
           <a:lstStyle/>
           <a:p>
-            <a:pPr/>
             <a:r>
               <a:rPr sz="2800" b="1">
                 <a:solidFill>
@@ -4772,7 +5304,6 @@
           </a:bodyPr>
           <a:lstStyle/>
           <a:p>
-            <a:pPr/>
             <a:r>
               <a:rPr sz="1500" b="0">
                 <a:solidFill>
@@ -4783,7 +5314,6 @@
             </a:r>
           </a:p>
           <a:p>
-            <a:pPr/>
             <a:r>
               <a:rPr sz="1500" b="0">
                 <a:solidFill>
@@ -4794,7 +5324,6 @@
             </a:r>
           </a:p>
           <a:p>
-            <a:pPr/>
             <a:r>
               <a:rPr sz="1500" b="0">
                 <a:solidFill>
@@ -4805,7 +5334,6 @@
             </a:r>
           </a:p>
           <a:p>
-            <a:pPr/>
             <a:r>
               <a:rPr sz="1500" b="0">
                 <a:solidFill>
@@ -4816,7 +5344,6 @@
             </a:r>
           </a:p>
           <a:p>
-            <a:pPr/>
             <a:r>
               <a:rPr sz="1500" b="0">
                 <a:solidFill>
@@ -4827,7 +5354,6 @@
             </a:r>
           </a:p>
           <a:p>
-            <a:pPr/>
             <a:r>
               <a:rPr sz="1500" b="0">
                 <a:solidFill>
@@ -4890,7 +5416,6 @@
           </a:bodyPr>
           <a:lstStyle/>
           <a:p>
-            <a:pPr/>
             <a:r>
               <a:rPr sz="1100" b="0">
                 <a:solidFill>
@@ -4911,7 +5436,7 @@
 </file>
 
 <file path=ppt/slides/slide5.xml><?xml version="1.0" encoding="utf-8"?>
-<p:sld xmlns:a="http://schemas.openxmlformats.org/drawingml/2006/main" xmlns:p="http://schemas.openxmlformats.org/presentationml/2006/main" xmlns:r="http://schemas.openxmlformats.org/officeDocument/2006/relationships">
+<p:sld xmlns:a="http://schemas.openxmlformats.org/drawingml/2006/main" xmlns:r="http://schemas.openxmlformats.org/officeDocument/2006/relationships" xmlns:p="http://schemas.openxmlformats.org/presentationml/2006/main">
   <p:cSld>
     <p:spTree>
       <p:nvGrpSpPr>
@@ -4919,7 +5444,14 @@
         <p:cNvGrpSpPr/>
         <p:nvPr/>
       </p:nvGrpSpPr>
-      <p:grpSpPr/>
+      <p:grpSpPr>
+        <a:xfrm>
+          <a:off x="0" y="0"/>
+          <a:ext cx="0" cy="0"/>
+          <a:chOff x="0" y="0"/>
+          <a:chExt cx="0" cy="0"/>
+        </a:xfrm>
+      </p:grpSpPr>
       <p:sp>
         <p:nvSpPr>
           <p:cNvPr id="2" name="Rectangle 1"/>
@@ -4960,6 +5492,7 @@
           <a:lstStyle/>
           <a:p>
             <a:pPr algn="ctr"/>
+            <a:endParaRPr/>
           </a:p>
         </p:txBody>
       </p:sp>
@@ -4985,7 +5518,6 @@
           </a:bodyPr>
           <a:lstStyle/>
           <a:p>
-            <a:pPr/>
             <a:r>
               <a:rPr sz="2800" b="1">
                 <a:solidFill>
@@ -5019,7 +5551,6 @@
           </a:bodyPr>
           <a:lstStyle/>
           <a:p>
-            <a:pPr/>
             <a:r>
               <a:rPr sz="1500" b="0">
                 <a:solidFill>
@@ -5030,7 +5561,6 @@
             </a:r>
           </a:p>
           <a:p>
-            <a:pPr/>
             <a:r>
               <a:rPr sz="1500" b="0">
                 <a:solidFill>
@@ -5041,7 +5571,6 @@
             </a:r>
           </a:p>
           <a:p>
-            <a:pPr/>
             <a:r>
               <a:rPr sz="1500" b="0">
                 <a:solidFill>
@@ -5052,7 +5581,6 @@
             </a:r>
           </a:p>
           <a:p>
-            <a:pPr/>
             <a:r>
               <a:rPr sz="1500" b="0">
                 <a:solidFill>
@@ -5063,7 +5591,6 @@
             </a:r>
           </a:p>
           <a:p>
-            <a:pPr/>
             <a:r>
               <a:rPr sz="1500" b="0">
                 <a:solidFill>
@@ -5074,7 +5601,6 @@
             </a:r>
           </a:p>
           <a:p>
-            <a:pPr/>
             <a:r>
               <a:rPr sz="1500" b="0">
                 <a:solidFill>
@@ -5137,7 +5663,6 @@
           </a:bodyPr>
           <a:lstStyle/>
           <a:p>
-            <a:pPr/>
             <a:r>
               <a:rPr sz="1100" b="0">
                 <a:solidFill>
@@ -5158,7 +5683,7 @@
 </file>
 
 <file path=ppt/slides/slide6.xml><?xml version="1.0" encoding="utf-8"?>
-<p:sld xmlns:a="http://schemas.openxmlformats.org/drawingml/2006/main" xmlns:p="http://schemas.openxmlformats.org/presentationml/2006/main" xmlns:r="http://schemas.openxmlformats.org/officeDocument/2006/relationships">
+<p:sld xmlns:a="http://schemas.openxmlformats.org/drawingml/2006/main" xmlns:r="http://schemas.openxmlformats.org/officeDocument/2006/relationships" xmlns:p="http://schemas.openxmlformats.org/presentationml/2006/main">
   <p:cSld>
     <p:spTree>
       <p:nvGrpSpPr>
@@ -5166,7 +5691,14 @@
         <p:cNvGrpSpPr/>
         <p:nvPr/>
       </p:nvGrpSpPr>
-      <p:grpSpPr/>
+      <p:grpSpPr>
+        <a:xfrm>
+          <a:off x="0" y="0"/>
+          <a:ext cx="0" cy="0"/>
+          <a:chOff x="0" y="0"/>
+          <a:chExt cx="0" cy="0"/>
+        </a:xfrm>
+      </p:grpSpPr>
       <p:sp>
         <p:nvSpPr>
           <p:cNvPr id="2" name="Rectangle 1"/>
@@ -5207,6 +5739,7 @@
           <a:lstStyle/>
           <a:p>
             <a:pPr algn="ctr"/>
+            <a:endParaRPr/>
           </a:p>
         </p:txBody>
       </p:sp>
@@ -5232,7 +5765,6 @@
           </a:bodyPr>
           <a:lstStyle/>
           <a:p>
-            <a:pPr/>
             <a:r>
               <a:rPr sz="2800" b="1">
                 <a:solidFill>
@@ -5266,7 +5798,6 @@
           </a:bodyPr>
           <a:lstStyle/>
           <a:p>
-            <a:pPr/>
             <a:r>
               <a:rPr sz="1500" b="0">
                 <a:solidFill>
@@ -5277,7 +5808,6 @@
             </a:r>
           </a:p>
           <a:p>
-            <a:pPr/>
             <a:r>
               <a:rPr sz="1500" b="0">
                 <a:solidFill>
@@ -5288,7 +5818,6 @@
             </a:r>
           </a:p>
           <a:p>
-            <a:pPr/>
             <a:r>
               <a:rPr sz="1500" b="0">
                 <a:solidFill>
@@ -5299,7 +5828,6 @@
             </a:r>
           </a:p>
           <a:p>
-            <a:pPr/>
             <a:r>
               <a:rPr sz="1500" b="0">
                 <a:solidFill>
@@ -5310,7 +5838,6 @@
             </a:r>
           </a:p>
           <a:p>
-            <a:pPr/>
             <a:r>
               <a:rPr sz="1500" b="0">
                 <a:solidFill>
@@ -5321,7 +5848,6 @@
             </a:r>
           </a:p>
           <a:p>
-            <a:pPr/>
             <a:r>
               <a:rPr sz="1500" b="0">
                 <a:solidFill>
@@ -5384,7 +5910,6 @@
           </a:bodyPr>
           <a:lstStyle/>
           <a:p>
-            <a:pPr/>
             <a:r>
               <a:rPr sz="1100" b="0">
                 <a:solidFill>
@@ -5405,7 +5930,7 @@
 </file>
 
 <file path=ppt/slides/slide7.xml><?xml version="1.0" encoding="utf-8"?>
-<p:sld xmlns:a="http://schemas.openxmlformats.org/drawingml/2006/main" xmlns:p="http://schemas.openxmlformats.org/presentationml/2006/main" xmlns:r="http://schemas.openxmlformats.org/officeDocument/2006/relationships">
+<p:sld xmlns:a="http://schemas.openxmlformats.org/drawingml/2006/main" xmlns:r="http://schemas.openxmlformats.org/officeDocument/2006/relationships" xmlns:p="http://schemas.openxmlformats.org/presentationml/2006/main">
   <p:cSld>
     <p:spTree>
       <p:nvGrpSpPr>
@@ -5413,7 +5938,14 @@
         <p:cNvGrpSpPr/>
         <p:nvPr/>
       </p:nvGrpSpPr>
-      <p:grpSpPr/>
+      <p:grpSpPr>
+        <a:xfrm>
+          <a:off x="0" y="0"/>
+          <a:ext cx="0" cy="0"/>
+          <a:chOff x="0" y="0"/>
+          <a:chExt cx="0" cy="0"/>
+        </a:xfrm>
+      </p:grpSpPr>
       <p:sp>
         <p:nvSpPr>
           <p:cNvPr id="2" name="Rectangle 1"/>
@@ -5454,6 +5986,7 @@
           <a:lstStyle/>
           <a:p>
             <a:pPr algn="ctr"/>
+            <a:endParaRPr/>
           </a:p>
         </p:txBody>
       </p:sp>
@@ -5479,7 +6012,6 @@
           </a:bodyPr>
           <a:lstStyle/>
           <a:p>
-            <a:pPr/>
             <a:r>
               <a:rPr sz="2800" b="1">
                 <a:solidFill>
@@ -5513,7 +6045,6 @@
           </a:bodyPr>
           <a:lstStyle/>
           <a:p>
-            <a:pPr/>
             <a:r>
               <a:rPr sz="1500" b="0">
                 <a:solidFill>
@@ -5524,7 +6055,6 @@
             </a:r>
           </a:p>
           <a:p>
-            <a:pPr/>
             <a:r>
               <a:rPr sz="1500" b="0">
                 <a:solidFill>
@@ -5535,7 +6065,6 @@
             </a:r>
           </a:p>
           <a:p>
-            <a:pPr/>
             <a:r>
               <a:rPr sz="1500" b="0">
                 <a:solidFill>
@@ -5546,7 +6075,6 @@
             </a:r>
           </a:p>
           <a:p>
-            <a:pPr/>
             <a:r>
               <a:rPr sz="1500" b="0">
                 <a:solidFill>
@@ -5557,7 +6085,6 @@
             </a:r>
           </a:p>
           <a:p>
-            <a:pPr/>
             <a:r>
               <a:rPr sz="1500" b="0">
                 <a:solidFill>
@@ -5620,7 +6147,6 @@
           </a:bodyPr>
           <a:lstStyle/>
           <a:p>
-            <a:pPr/>
             <a:r>
               <a:rPr sz="1100" b="0">
                 <a:solidFill>
@@ -5641,7 +6167,7 @@
 </file>
 
 <file path=ppt/slides/slide8.xml><?xml version="1.0" encoding="utf-8"?>
-<p:sld xmlns:a="http://schemas.openxmlformats.org/drawingml/2006/main" xmlns:p="http://schemas.openxmlformats.org/presentationml/2006/main" xmlns:r="http://schemas.openxmlformats.org/officeDocument/2006/relationships">
+<p:sld xmlns:a="http://schemas.openxmlformats.org/drawingml/2006/main" xmlns:r="http://schemas.openxmlformats.org/officeDocument/2006/relationships" xmlns:p="http://schemas.openxmlformats.org/presentationml/2006/main">
   <p:cSld>
     <p:spTree>
       <p:nvGrpSpPr>
@@ -5649,7 +6175,14 @@
         <p:cNvGrpSpPr/>
         <p:nvPr/>
       </p:nvGrpSpPr>
-      <p:grpSpPr/>
+      <p:grpSpPr>
+        <a:xfrm>
+          <a:off x="0" y="0"/>
+          <a:ext cx="0" cy="0"/>
+          <a:chOff x="0" y="0"/>
+          <a:chExt cx="0" cy="0"/>
+        </a:xfrm>
+      </p:grpSpPr>
       <p:sp>
         <p:nvSpPr>
           <p:cNvPr id="2" name="Rectangle 1"/>
@@ -5690,6 +6223,7 @@
           <a:lstStyle/>
           <a:p>
             <a:pPr algn="ctr"/>
+            <a:endParaRPr/>
           </a:p>
         </p:txBody>
       </p:sp>
@@ -5715,7 +6249,6 @@
           </a:bodyPr>
           <a:lstStyle/>
           <a:p>
-            <a:pPr/>
             <a:r>
               <a:rPr sz="2800" b="1">
                 <a:solidFill>
@@ -5749,7 +6282,6 @@
           </a:bodyPr>
           <a:lstStyle/>
           <a:p>
-            <a:pPr/>
             <a:r>
               <a:rPr sz="1500" b="0">
                 <a:solidFill>
@@ -5760,7 +6292,6 @@
             </a:r>
           </a:p>
           <a:p>
-            <a:pPr/>
             <a:r>
               <a:rPr sz="1500" b="0">
                 <a:solidFill>
@@ -5771,7 +6302,6 @@
             </a:r>
           </a:p>
           <a:p>
-            <a:pPr/>
             <a:r>
               <a:rPr sz="1500" b="0">
                 <a:solidFill>
@@ -5782,7 +6312,6 @@
             </a:r>
           </a:p>
           <a:p>
-            <a:pPr/>
             <a:r>
               <a:rPr sz="1500" b="0">
                 <a:solidFill>
@@ -5793,7 +6322,6 @@
             </a:r>
           </a:p>
           <a:p>
-            <a:pPr/>
             <a:r>
               <a:rPr sz="1500" b="0">
                 <a:solidFill>
@@ -5856,7 +6384,6 @@
           </a:bodyPr>
           <a:lstStyle/>
           <a:p>
-            <a:pPr/>
             <a:r>
               <a:rPr sz="1100" b="0">
                 <a:solidFill>
@@ -5877,7 +6404,7 @@
 </file>
 
 <file path=ppt/slides/slide9.xml><?xml version="1.0" encoding="utf-8"?>
-<p:sld xmlns:a="http://schemas.openxmlformats.org/drawingml/2006/main" xmlns:p="http://schemas.openxmlformats.org/presentationml/2006/main" xmlns:r="http://schemas.openxmlformats.org/officeDocument/2006/relationships">
+<p:sld xmlns:a="http://schemas.openxmlformats.org/drawingml/2006/main" xmlns:r="http://schemas.openxmlformats.org/officeDocument/2006/relationships" xmlns:p="http://schemas.openxmlformats.org/presentationml/2006/main">
   <p:cSld>
     <p:spTree>
       <p:nvGrpSpPr>
@@ -5885,7 +6412,14 @@
         <p:cNvGrpSpPr/>
         <p:nvPr/>
       </p:nvGrpSpPr>
-      <p:grpSpPr/>
+      <p:grpSpPr>
+        <a:xfrm>
+          <a:off x="0" y="0"/>
+          <a:ext cx="0" cy="0"/>
+          <a:chOff x="0" y="0"/>
+          <a:chExt cx="0" cy="0"/>
+        </a:xfrm>
+      </p:grpSpPr>
       <p:sp>
         <p:nvSpPr>
           <p:cNvPr id="2" name="Rectangle 1"/>
@@ -5926,6 +6460,7 @@
           <a:lstStyle/>
           <a:p>
             <a:pPr algn="ctr"/>
+            <a:endParaRPr/>
           </a:p>
         </p:txBody>
       </p:sp>
@@ -5951,7 +6486,6 @@
           </a:bodyPr>
           <a:lstStyle/>
           <a:p>
-            <a:pPr/>
             <a:r>
               <a:rPr sz="2800" b="1">
                 <a:solidFill>
@@ -5985,7 +6519,6 @@
           </a:bodyPr>
           <a:lstStyle/>
           <a:p>
-            <a:pPr/>
             <a:r>
               <a:rPr sz="1500" b="0">
                 <a:solidFill>
@@ -5996,7 +6529,6 @@
             </a:r>
           </a:p>
           <a:p>
-            <a:pPr/>
             <a:r>
               <a:rPr sz="1500" b="0">
                 <a:solidFill>
@@ -6007,7 +6539,6 @@
             </a:r>
           </a:p>
           <a:p>
-            <a:pPr/>
             <a:r>
               <a:rPr sz="1500" b="0">
                 <a:solidFill>
@@ -6018,7 +6549,6 @@
             </a:r>
           </a:p>
           <a:p>
-            <a:pPr/>
             <a:r>
               <a:rPr sz="1500" b="0">
                 <a:solidFill>
@@ -6029,7 +6559,6 @@
             </a:r>
           </a:p>
           <a:p>
-            <a:pPr/>
             <a:r>
               <a:rPr sz="1500" b="0">
                 <a:solidFill>
@@ -6040,7 +6569,6 @@
             </a:r>
           </a:p>
           <a:p>
-            <a:pPr/>
             <a:r>
               <a:rPr sz="1500" b="0">
                 <a:solidFill>
@@ -6103,7 +6631,6 @@
           </a:bodyPr>
           <a:lstStyle/>
           <a:p>
-            <a:pPr/>
             <a:r>
               <a:rPr sz="1100" b="0">
                 <a:solidFill>

</xml_diff>

<commit_message>
feat(roles): xoa vai tro phong_gd theo chinh quyen dia phuong 2 cap (CR-017)
Can cu: ND 142/2025, TT 13&15/2025/TT-BGDDT - Phong GD&DT cap huyen
bai bo tu 1/7/2025; chuyen mon -> So GD&DT, hanh chinh/dia ban ->
UBND cap xa (Phong VHXH).

- Code: bo phong_gd khoi Role, ROLE_HOME, STAFF_ROLES, nav,
  requireRoles dept/*, dept-brief, login demo list
- DB: scn_is_dept() bo 'phong_gd'; profiles_role_check cap nhat;
  xoa profile + auth user phonggd@demo.scn; reparent UBND -> So,
  xoa org_unit loai 'phong'
- Tests: qa-full-coverage + qa-e2e bo phong_gd khoi matrix
- Docs: ROLE-MATRIX, user guide, MO-TA-CHUC-NANG, PPTX/DOCX regen
- CR doc: docs/project/CR-017-remove-phong-gd.md

Generated with [Devin](https://devin.ai)

Co-Authored-By: Devin <158243242+devin-ai-integration[bot]@users.noreply.github.com>
</commit_message>
<xml_diff>
--- a/docs/user-guide/SO-CHU-NHIEM-SO-GIOI-THIEU.pptx
+++ b/docs/user-guide/SO-CHU-NHIEM-SO-GIOI-THIEU.pptx
@@ -5,21 +5,21 @@
     <p:sldMasterId id="2147483648" r:id="rId1"/>
   </p:sldMasterIdLst>
   <p:sldIdLst>
-    <p:sldId id="256" r:id="rId2"/>
-    <p:sldId id="257" r:id="rId3"/>
-    <p:sldId id="258" r:id="rId4"/>
-    <p:sldId id="259" r:id="rId5"/>
-    <p:sldId id="260" r:id="rId6"/>
-    <p:sldId id="261" r:id="rId7"/>
-    <p:sldId id="262" r:id="rId8"/>
-    <p:sldId id="263" r:id="rId9"/>
-    <p:sldId id="264" r:id="rId10"/>
-    <p:sldId id="265" r:id="rId11"/>
-    <p:sldId id="266" r:id="rId12"/>
-    <p:sldId id="267" r:id="rId13"/>
-    <p:sldId id="268" r:id="rId14"/>
+    <p:sldId id="256" r:id="rId7"/>
+    <p:sldId id="257" r:id="rId8"/>
+    <p:sldId id="258" r:id="rId9"/>
+    <p:sldId id="259" r:id="rId10"/>
+    <p:sldId id="260" r:id="rId11"/>
+    <p:sldId id="261" r:id="rId12"/>
+    <p:sldId id="262" r:id="rId13"/>
+    <p:sldId id="263" r:id="rId14"/>
+    <p:sldId id="264" r:id="rId15"/>
+    <p:sldId id="265" r:id="rId16"/>
+    <p:sldId id="266" r:id="rId17"/>
+    <p:sldId id="267" r:id="rId18"/>
+    <p:sldId id="268" r:id="rId19"/>
   </p:sldIdLst>
-  <p:sldSz cx="12192000" cy="6858000"/>
+  <p:sldSz cx="12191695" cy="6858000" type="screen4x3"/>
   <p:notesSz cx="6858000" cy="9144000"/>
   <p:defaultTextStyle>
     <a:defPPr>
@@ -116,22 +116,6 @@
       </a:defRPr>
     </a:lvl9pPr>
   </p:defaultTextStyle>
-  <p:extLst>
-    <p:ext uri="{EFAFB233-063F-42B5-8137-9DF3F51BA10A}">
-      <p15:sldGuideLst xmlns:p15="http://schemas.microsoft.com/office/powerpoint/2012/main">
-        <p15:guide id="1" orient="horz" pos="2160">
-          <p15:clr>
-            <a:srgbClr val="A4A3A4"/>
-          </p15:clr>
-        </p15:guide>
-        <p15:guide id="2" pos="2880">
-          <p15:clr>
-            <a:srgbClr val="A4A3A4"/>
-          </p15:clr>
-        </p15:guide>
-      </p15:sldGuideLst>
-    </p:ext>
-  </p:extLst>
 </p:presentation>
 </file>
 
@@ -173,9 +157,10 @@
           <a:lstStyle/>
           <a:p>
             <a:r>
-              <a:rPr lang="en-US"/>
+              <a:rPr lang="en-US" smtClean="0"/>
               <a:t>Click to edit Master title style</a:t>
             </a:r>
+            <a:endParaRPr lang="en-US"/>
           </a:p>
         </p:txBody>
       </p:sp>
@@ -291,9 +276,10 @@
           </a:lstStyle>
           <a:p>
             <a:r>
-              <a:rPr lang="en-US"/>
+              <a:rPr lang="en-US" smtClean="0"/>
               <a:t>Click to edit Master subtitle style</a:t>
             </a:r>
+            <a:endParaRPr lang="en-US"/>
           </a:p>
         </p:txBody>
       </p:sp>
@@ -314,7 +300,7 @@
           <a:p>
             <a:fld id="{5BCAD085-E8A6-8845-BD4E-CB4CCA059FC4}" type="datetimeFigureOut">
               <a:rPr lang="en-US" smtClean="0"/>
-              <a:t>9/23/26</a:t>
+              <a:t>1/27/13</a:t>
             </a:fld>
             <a:endParaRPr lang="en-US"/>
           </a:p>
@@ -408,9 +394,10 @@
           <a:lstStyle/>
           <a:p>
             <a:r>
-              <a:rPr lang="en-US"/>
+              <a:rPr lang="en-US" smtClean="0"/>
               <a:t>Click to edit Master title style</a:t>
             </a:r>
+            <a:endParaRPr lang="en-US"/>
           </a:p>
         </p:txBody>
       </p:sp>
@@ -431,37 +418,38 @@
           <a:p>
             <a:pPr lvl="0"/>
             <a:r>
-              <a:rPr lang="en-US"/>
+              <a:rPr lang="en-US" smtClean="0"/>
               <a:t>Click to edit Master text styles</a:t>
             </a:r>
           </a:p>
           <a:p>
             <a:pPr lvl="1"/>
             <a:r>
-              <a:rPr lang="en-US"/>
+              <a:rPr lang="en-US" smtClean="0"/>
               <a:t>Second level</a:t>
             </a:r>
           </a:p>
           <a:p>
             <a:pPr lvl="2"/>
             <a:r>
-              <a:rPr lang="en-US"/>
+              <a:rPr lang="en-US" smtClean="0"/>
               <a:t>Third level</a:t>
             </a:r>
           </a:p>
           <a:p>
             <a:pPr lvl="3"/>
             <a:r>
-              <a:rPr lang="en-US"/>
+              <a:rPr lang="en-US" smtClean="0"/>
               <a:t>Fourth level</a:t>
             </a:r>
           </a:p>
           <a:p>
             <a:pPr lvl="4"/>
             <a:r>
-              <a:rPr lang="en-US"/>
+              <a:rPr lang="en-US" smtClean="0"/>
               <a:t>Fifth level</a:t>
             </a:r>
+            <a:endParaRPr lang="en-US"/>
           </a:p>
         </p:txBody>
       </p:sp>
@@ -482,7 +470,7 @@
           <a:p>
             <a:fld id="{5BCAD085-E8A6-8845-BD4E-CB4CCA059FC4}" type="datetimeFigureOut">
               <a:rPr lang="en-US" smtClean="0"/>
-              <a:t>9/23/26</a:t>
+              <a:t>1/27/13</a:t>
             </a:fld>
             <a:endParaRPr lang="en-US"/>
           </a:p>
@@ -581,9 +569,10 @@
           <a:lstStyle/>
           <a:p>
             <a:r>
-              <a:rPr lang="en-US"/>
+              <a:rPr lang="en-US" smtClean="0"/>
               <a:t>Click to edit Master title style</a:t>
             </a:r>
+            <a:endParaRPr lang="en-US"/>
           </a:p>
         </p:txBody>
       </p:sp>
@@ -609,37 +598,38 @@
           <a:p>
             <a:pPr lvl="0"/>
             <a:r>
-              <a:rPr lang="en-US"/>
+              <a:rPr lang="en-US" smtClean="0"/>
               <a:t>Click to edit Master text styles</a:t>
             </a:r>
           </a:p>
           <a:p>
             <a:pPr lvl="1"/>
             <a:r>
-              <a:rPr lang="en-US"/>
+              <a:rPr lang="en-US" smtClean="0"/>
               <a:t>Second level</a:t>
             </a:r>
           </a:p>
           <a:p>
             <a:pPr lvl="2"/>
             <a:r>
-              <a:rPr lang="en-US"/>
+              <a:rPr lang="en-US" smtClean="0"/>
               <a:t>Third level</a:t>
             </a:r>
           </a:p>
           <a:p>
             <a:pPr lvl="3"/>
             <a:r>
-              <a:rPr lang="en-US"/>
+              <a:rPr lang="en-US" smtClean="0"/>
               <a:t>Fourth level</a:t>
             </a:r>
           </a:p>
           <a:p>
             <a:pPr lvl="4"/>
             <a:r>
-              <a:rPr lang="en-US"/>
+              <a:rPr lang="en-US" smtClean="0"/>
               <a:t>Fifth level</a:t>
             </a:r>
+            <a:endParaRPr lang="en-US"/>
           </a:p>
         </p:txBody>
       </p:sp>
@@ -660,7 +650,7 @@
           <a:p>
             <a:fld id="{5BCAD085-E8A6-8845-BD4E-CB4CCA059FC4}" type="datetimeFigureOut">
               <a:rPr lang="en-US" smtClean="0"/>
-              <a:t>9/23/26</a:t>
+              <a:t>1/27/13</a:t>
             </a:fld>
             <a:endParaRPr lang="en-US"/>
           </a:p>
@@ -754,9 +744,10 @@
           <a:lstStyle/>
           <a:p>
             <a:r>
-              <a:rPr lang="en-US"/>
+              <a:rPr lang="en-US" smtClean="0"/>
               <a:t>Click to edit Master title style</a:t>
             </a:r>
+            <a:endParaRPr lang="en-US"/>
           </a:p>
         </p:txBody>
       </p:sp>
@@ -777,37 +768,38 @@
           <a:p>
             <a:pPr lvl="0"/>
             <a:r>
-              <a:rPr lang="en-US"/>
+              <a:rPr lang="en-US" smtClean="0"/>
               <a:t>Click to edit Master text styles</a:t>
             </a:r>
           </a:p>
           <a:p>
             <a:pPr lvl="1"/>
             <a:r>
-              <a:rPr lang="en-US"/>
+              <a:rPr lang="en-US" smtClean="0"/>
               <a:t>Second level</a:t>
             </a:r>
           </a:p>
           <a:p>
             <a:pPr lvl="2"/>
             <a:r>
-              <a:rPr lang="en-US"/>
+              <a:rPr lang="en-US" smtClean="0"/>
               <a:t>Third level</a:t>
             </a:r>
           </a:p>
           <a:p>
             <a:pPr lvl="3"/>
             <a:r>
-              <a:rPr lang="en-US"/>
+              <a:rPr lang="en-US" smtClean="0"/>
               <a:t>Fourth level</a:t>
             </a:r>
           </a:p>
           <a:p>
             <a:pPr lvl="4"/>
             <a:r>
-              <a:rPr lang="en-US"/>
+              <a:rPr lang="en-US" smtClean="0"/>
               <a:t>Fifth level</a:t>
             </a:r>
+            <a:endParaRPr lang="en-US"/>
           </a:p>
         </p:txBody>
       </p:sp>
@@ -828,7 +820,7 @@
           <a:p>
             <a:fld id="{5BCAD085-E8A6-8845-BD4E-CB4CCA059FC4}" type="datetimeFigureOut">
               <a:rPr lang="en-US" smtClean="0"/>
-              <a:t>9/23/26</a:t>
+              <a:t>1/27/13</a:t>
             </a:fld>
             <a:endParaRPr lang="en-US"/>
           </a:p>
@@ -931,9 +923,10 @@
           </a:lstStyle>
           <a:p>
             <a:r>
-              <a:rPr lang="en-US"/>
+              <a:rPr lang="en-US" smtClean="0"/>
               <a:t>Click to edit Master title style</a:t>
             </a:r>
+            <a:endParaRPr lang="en-US"/>
           </a:p>
         </p:txBody>
       </p:sp>
@@ -1050,7 +1043,7 @@
           <a:p>
             <a:pPr lvl="0"/>
             <a:r>
-              <a:rPr lang="en-US"/>
+              <a:rPr lang="en-US" smtClean="0"/>
               <a:t>Click to edit Master text styles</a:t>
             </a:r>
           </a:p>
@@ -1073,7 +1066,7 @@
           <a:p>
             <a:fld id="{5BCAD085-E8A6-8845-BD4E-CB4CCA059FC4}" type="datetimeFigureOut">
               <a:rPr lang="en-US" smtClean="0"/>
-              <a:t>9/23/26</a:t>
+              <a:t>1/27/13</a:t>
             </a:fld>
             <a:endParaRPr lang="en-US"/>
           </a:p>
@@ -1167,9 +1160,10 @@
           <a:lstStyle/>
           <a:p>
             <a:r>
-              <a:rPr lang="en-US"/>
+              <a:rPr lang="en-US" smtClean="0"/>
               <a:t>Click to edit Master title style</a:t>
             </a:r>
+            <a:endParaRPr lang="en-US"/>
           </a:p>
         </p:txBody>
       </p:sp>
@@ -1223,37 +1217,38 @@
           <a:p>
             <a:pPr lvl="0"/>
             <a:r>
-              <a:rPr lang="en-US"/>
+              <a:rPr lang="en-US" smtClean="0"/>
               <a:t>Click to edit Master text styles</a:t>
             </a:r>
           </a:p>
           <a:p>
             <a:pPr lvl="1"/>
             <a:r>
-              <a:rPr lang="en-US"/>
+              <a:rPr lang="en-US" smtClean="0"/>
               <a:t>Second level</a:t>
             </a:r>
           </a:p>
           <a:p>
             <a:pPr lvl="2"/>
             <a:r>
-              <a:rPr lang="en-US"/>
+              <a:rPr lang="en-US" smtClean="0"/>
               <a:t>Third level</a:t>
             </a:r>
           </a:p>
           <a:p>
             <a:pPr lvl="3"/>
             <a:r>
-              <a:rPr lang="en-US"/>
+              <a:rPr lang="en-US" smtClean="0"/>
               <a:t>Fourth level</a:t>
             </a:r>
           </a:p>
           <a:p>
             <a:pPr lvl="4"/>
             <a:r>
-              <a:rPr lang="en-US"/>
+              <a:rPr lang="en-US" smtClean="0"/>
               <a:t>Fifth level</a:t>
             </a:r>
+            <a:endParaRPr lang="en-US"/>
           </a:p>
         </p:txBody>
       </p:sp>
@@ -1307,37 +1302,38 @@
           <a:p>
             <a:pPr lvl="0"/>
             <a:r>
-              <a:rPr lang="en-US"/>
+              <a:rPr lang="en-US" smtClean="0"/>
               <a:t>Click to edit Master text styles</a:t>
             </a:r>
           </a:p>
           <a:p>
             <a:pPr lvl="1"/>
             <a:r>
-              <a:rPr lang="en-US"/>
+              <a:rPr lang="en-US" smtClean="0"/>
               <a:t>Second level</a:t>
             </a:r>
           </a:p>
           <a:p>
             <a:pPr lvl="2"/>
             <a:r>
-              <a:rPr lang="en-US"/>
+              <a:rPr lang="en-US" smtClean="0"/>
               <a:t>Third level</a:t>
             </a:r>
           </a:p>
           <a:p>
             <a:pPr lvl="3"/>
             <a:r>
-              <a:rPr lang="en-US"/>
+              <a:rPr lang="en-US" smtClean="0"/>
               <a:t>Fourth level</a:t>
             </a:r>
           </a:p>
           <a:p>
             <a:pPr lvl="4"/>
             <a:r>
-              <a:rPr lang="en-US"/>
+              <a:rPr lang="en-US" smtClean="0"/>
               <a:t>Fifth level</a:t>
             </a:r>
+            <a:endParaRPr lang="en-US"/>
           </a:p>
         </p:txBody>
       </p:sp>
@@ -1358,7 +1354,7 @@
           <a:p>
             <a:fld id="{5BCAD085-E8A6-8845-BD4E-CB4CCA059FC4}" type="datetimeFigureOut">
               <a:rPr lang="en-US" smtClean="0"/>
-              <a:t>9/23/26</a:t>
+              <a:t>1/27/13</a:t>
             </a:fld>
             <a:endParaRPr lang="en-US"/>
           </a:p>
@@ -1456,9 +1452,10 @@
           </a:lstStyle>
           <a:p>
             <a:r>
-              <a:rPr lang="en-US"/>
+              <a:rPr lang="en-US" smtClean="0"/>
               <a:t>Click to edit Master title style</a:t>
             </a:r>
+            <a:endParaRPr lang="en-US"/>
           </a:p>
         </p:txBody>
       </p:sp>
@@ -1521,7 +1518,7 @@
           <a:p>
             <a:pPr lvl="0"/>
             <a:r>
-              <a:rPr lang="en-US"/>
+              <a:rPr lang="en-US" smtClean="0"/>
               <a:t>Click to edit Master text styles</a:t>
             </a:r>
           </a:p>
@@ -1577,37 +1574,38 @@
           <a:p>
             <a:pPr lvl="0"/>
             <a:r>
-              <a:rPr lang="en-US"/>
+              <a:rPr lang="en-US" smtClean="0"/>
               <a:t>Click to edit Master text styles</a:t>
             </a:r>
           </a:p>
           <a:p>
             <a:pPr lvl="1"/>
             <a:r>
-              <a:rPr lang="en-US"/>
+              <a:rPr lang="en-US" smtClean="0"/>
               <a:t>Second level</a:t>
             </a:r>
           </a:p>
           <a:p>
             <a:pPr lvl="2"/>
             <a:r>
-              <a:rPr lang="en-US"/>
+              <a:rPr lang="en-US" smtClean="0"/>
               <a:t>Third level</a:t>
             </a:r>
           </a:p>
           <a:p>
             <a:pPr lvl="3"/>
             <a:r>
-              <a:rPr lang="en-US"/>
+              <a:rPr lang="en-US" smtClean="0"/>
               <a:t>Fourth level</a:t>
             </a:r>
           </a:p>
           <a:p>
             <a:pPr lvl="4"/>
             <a:r>
-              <a:rPr lang="en-US"/>
+              <a:rPr lang="en-US" smtClean="0"/>
               <a:t>Fifth level</a:t>
             </a:r>
+            <a:endParaRPr lang="en-US"/>
           </a:p>
         </p:txBody>
       </p:sp>
@@ -1670,7 +1668,7 @@
           <a:p>
             <a:pPr lvl="0"/>
             <a:r>
-              <a:rPr lang="en-US"/>
+              <a:rPr lang="en-US" smtClean="0"/>
               <a:t>Click to edit Master text styles</a:t>
             </a:r>
           </a:p>
@@ -1726,37 +1724,38 @@
           <a:p>
             <a:pPr lvl="0"/>
             <a:r>
-              <a:rPr lang="en-US"/>
+              <a:rPr lang="en-US" smtClean="0"/>
               <a:t>Click to edit Master text styles</a:t>
             </a:r>
           </a:p>
           <a:p>
             <a:pPr lvl="1"/>
             <a:r>
-              <a:rPr lang="en-US"/>
+              <a:rPr lang="en-US" smtClean="0"/>
               <a:t>Second level</a:t>
             </a:r>
           </a:p>
           <a:p>
             <a:pPr lvl="2"/>
             <a:r>
-              <a:rPr lang="en-US"/>
+              <a:rPr lang="en-US" smtClean="0"/>
               <a:t>Third level</a:t>
             </a:r>
           </a:p>
           <a:p>
             <a:pPr lvl="3"/>
             <a:r>
-              <a:rPr lang="en-US"/>
+              <a:rPr lang="en-US" smtClean="0"/>
               <a:t>Fourth level</a:t>
             </a:r>
           </a:p>
           <a:p>
             <a:pPr lvl="4"/>
             <a:r>
-              <a:rPr lang="en-US"/>
+              <a:rPr lang="en-US" smtClean="0"/>
               <a:t>Fifth level</a:t>
             </a:r>
+            <a:endParaRPr lang="en-US"/>
           </a:p>
         </p:txBody>
       </p:sp>
@@ -1777,7 +1776,7 @@
           <a:p>
             <a:fld id="{5BCAD085-E8A6-8845-BD4E-CB4CCA059FC4}" type="datetimeFigureOut">
               <a:rPr lang="en-US" smtClean="0"/>
-              <a:t>9/23/26</a:t>
+              <a:t>1/27/13</a:t>
             </a:fld>
             <a:endParaRPr lang="en-US"/>
           </a:p>
@@ -1871,9 +1870,10 @@
           <a:lstStyle/>
           <a:p>
             <a:r>
-              <a:rPr lang="en-US"/>
+              <a:rPr lang="en-US" smtClean="0"/>
               <a:t>Click to edit Master title style</a:t>
             </a:r>
+            <a:endParaRPr lang="en-US"/>
           </a:p>
         </p:txBody>
       </p:sp>
@@ -1894,7 +1894,7 @@
           <a:p>
             <a:fld id="{5BCAD085-E8A6-8845-BD4E-CB4CCA059FC4}" type="datetimeFigureOut">
               <a:rPr lang="en-US" smtClean="0"/>
-              <a:t>9/23/26</a:t>
+              <a:t>1/27/13</a:t>
             </a:fld>
             <a:endParaRPr lang="en-US"/>
           </a:p>
@@ -1989,7 +1989,7 @@
           <a:p>
             <a:fld id="{5BCAD085-E8A6-8845-BD4E-CB4CCA059FC4}" type="datetimeFigureOut">
               <a:rPr lang="en-US" smtClean="0"/>
-              <a:t>9/23/26</a:t>
+              <a:t>1/27/13</a:t>
             </a:fld>
             <a:endParaRPr lang="en-US"/>
           </a:p>
@@ -2092,9 +2092,10 @@
           </a:lstStyle>
           <a:p>
             <a:r>
-              <a:rPr lang="en-US"/>
+              <a:rPr lang="en-US" smtClean="0"/>
               <a:t>Click to edit Master title style</a:t>
             </a:r>
+            <a:endParaRPr lang="en-US"/>
           </a:p>
         </p:txBody>
       </p:sp>
@@ -2148,37 +2149,38 @@
           <a:p>
             <a:pPr lvl="0"/>
             <a:r>
-              <a:rPr lang="en-US"/>
+              <a:rPr lang="en-US" smtClean="0"/>
               <a:t>Click to edit Master text styles</a:t>
             </a:r>
           </a:p>
           <a:p>
             <a:pPr lvl="1"/>
             <a:r>
-              <a:rPr lang="en-US"/>
+              <a:rPr lang="en-US" smtClean="0"/>
               <a:t>Second level</a:t>
             </a:r>
           </a:p>
           <a:p>
             <a:pPr lvl="2"/>
             <a:r>
-              <a:rPr lang="en-US"/>
+              <a:rPr lang="en-US" smtClean="0"/>
               <a:t>Third level</a:t>
             </a:r>
           </a:p>
           <a:p>
             <a:pPr lvl="3"/>
             <a:r>
-              <a:rPr lang="en-US"/>
+              <a:rPr lang="en-US" smtClean="0"/>
               <a:t>Fourth level</a:t>
             </a:r>
           </a:p>
           <a:p>
             <a:pPr lvl="4"/>
             <a:r>
-              <a:rPr lang="en-US"/>
+              <a:rPr lang="en-US" smtClean="0"/>
               <a:t>Fifth level</a:t>
             </a:r>
+            <a:endParaRPr lang="en-US"/>
           </a:p>
         </p:txBody>
       </p:sp>
@@ -2241,7 +2243,7 @@
           <a:p>
             <a:pPr lvl="0"/>
             <a:r>
-              <a:rPr lang="en-US"/>
+              <a:rPr lang="en-US" smtClean="0"/>
               <a:t>Click to edit Master text styles</a:t>
             </a:r>
           </a:p>
@@ -2264,7 +2266,7 @@
           <a:p>
             <a:fld id="{5BCAD085-E8A6-8845-BD4E-CB4CCA059FC4}" type="datetimeFigureOut">
               <a:rPr lang="en-US" smtClean="0"/>
-              <a:t>9/23/26</a:t>
+              <a:t>1/27/13</a:t>
             </a:fld>
             <a:endParaRPr lang="en-US"/>
           </a:p>
@@ -2367,9 +2369,10 @@
           </a:lstStyle>
           <a:p>
             <a:r>
-              <a:rPr lang="en-US"/>
+              <a:rPr lang="en-US" smtClean="0"/>
               <a:t>Click to edit Master title style</a:t>
             </a:r>
+            <a:endParaRPr lang="en-US"/>
           </a:p>
         </p:txBody>
       </p:sp>
@@ -2493,7 +2496,7 @@
           <a:p>
             <a:pPr lvl="0"/>
             <a:r>
-              <a:rPr lang="en-US"/>
+              <a:rPr lang="en-US" smtClean="0"/>
               <a:t>Click to edit Master text styles</a:t>
             </a:r>
           </a:p>
@@ -2516,7 +2519,7 @@
           <a:p>
             <a:fld id="{5BCAD085-E8A6-8845-BD4E-CB4CCA059FC4}" type="datetimeFigureOut">
               <a:rPr lang="en-US" smtClean="0"/>
-              <a:t>9/23/26</a:t>
+              <a:t>1/27/13</a:t>
             </a:fld>
             <a:endParaRPr lang="en-US"/>
           </a:p>
@@ -2625,9 +2628,10 @@
           <a:lstStyle/>
           <a:p>
             <a:r>
-              <a:rPr lang="en-US"/>
+              <a:rPr lang="en-US" smtClean="0"/>
               <a:t>Click to edit Master title style</a:t>
             </a:r>
+            <a:endParaRPr lang="en-US"/>
           </a:p>
         </p:txBody>
       </p:sp>
@@ -2658,37 +2662,38 @@
           <a:p>
             <a:pPr lvl="0"/>
             <a:r>
-              <a:rPr lang="en-US"/>
+              <a:rPr lang="en-US" smtClean="0"/>
               <a:t>Click to edit Master text styles</a:t>
             </a:r>
           </a:p>
           <a:p>
             <a:pPr lvl="1"/>
             <a:r>
-              <a:rPr lang="en-US"/>
+              <a:rPr lang="en-US" smtClean="0"/>
               <a:t>Second level</a:t>
             </a:r>
           </a:p>
           <a:p>
             <a:pPr lvl="2"/>
             <a:r>
-              <a:rPr lang="en-US"/>
+              <a:rPr lang="en-US" smtClean="0"/>
               <a:t>Third level</a:t>
             </a:r>
           </a:p>
           <a:p>
             <a:pPr lvl="3"/>
             <a:r>
-              <a:rPr lang="en-US"/>
+              <a:rPr lang="en-US" smtClean="0"/>
               <a:t>Fourth level</a:t>
             </a:r>
           </a:p>
           <a:p>
             <a:pPr lvl="4"/>
             <a:r>
-              <a:rPr lang="en-US"/>
+              <a:rPr lang="en-US" smtClean="0"/>
               <a:t>Fifth level</a:t>
             </a:r>
+            <a:endParaRPr lang="en-US"/>
           </a:p>
         </p:txBody>
       </p:sp>
@@ -2727,7 +2732,7 @@
           <a:p>
             <a:fld id="{5BCAD085-E8A6-8845-BD4E-CB4CCA059FC4}" type="datetimeFigureOut">
               <a:rPr lang="en-US" smtClean="0"/>
-              <a:t>9/23/26</a:t>
+              <a:t>1/27/13</a:t>
             </a:fld>
             <a:endParaRPr lang="en-US"/>
           </a:p>
@@ -3086,7 +3091,7 @@
 </file>
 
 <file path=ppt/slides/slide1.xml><?xml version="1.0" encoding="utf-8"?>
-<p:sld xmlns:a="http://schemas.openxmlformats.org/drawingml/2006/main" xmlns:r="http://schemas.openxmlformats.org/officeDocument/2006/relationships" xmlns:p="http://schemas.openxmlformats.org/presentationml/2006/main">
+<p:sld xmlns:a="http://schemas.openxmlformats.org/drawingml/2006/main" xmlns:p="http://schemas.openxmlformats.org/presentationml/2006/main" xmlns:r="http://schemas.openxmlformats.org/officeDocument/2006/relationships">
   <p:cSld>
     <p:spTree>
       <p:nvGrpSpPr>
@@ -3094,14 +3099,7 @@
         <p:cNvGrpSpPr/>
         <p:nvPr/>
       </p:nvGrpSpPr>
-      <p:grpSpPr>
-        <a:xfrm>
-          <a:off x="0" y="0"/>
-          <a:ext cx="0" cy="0"/>
-          <a:chOff x="0" y="0"/>
-          <a:chExt cx="0" cy="0"/>
-        </a:xfrm>
-      </p:grpSpPr>
+      <p:grpSpPr/>
       <p:sp>
         <p:nvSpPr>
           <p:cNvPr id="2" name="Rectangle 1"/>
@@ -3142,7 +3140,6 @@
           <a:lstStyle/>
           <a:p>
             <a:pPr algn="ctr"/>
-            <a:endParaRPr/>
           </a:p>
         </p:txBody>
       </p:sp>
@@ -3168,6 +3165,7 @@
           </a:bodyPr>
           <a:lstStyle/>
           <a:p>
+            <a:pPr/>
             <a:r>
               <a:rPr sz="4400" b="1">
                 <a:solidFill>
@@ -3178,6 +3176,7 @@
             </a:r>
           </a:p>
           <a:p>
+            <a:pPr/>
             <a:r>
               <a:rPr sz="2000" b="0">
                 <a:solidFill>
@@ -3211,6 +3210,7 @@
           </a:bodyPr>
           <a:lstStyle/>
           <a:p>
+            <a:pPr/>
             <a:r>
               <a:rPr sz="1400" b="0">
                 <a:solidFill>
@@ -3231,7 +3231,7 @@
 </file>
 
 <file path=ppt/slides/slide10.xml><?xml version="1.0" encoding="utf-8"?>
-<p:sld xmlns:a="http://schemas.openxmlformats.org/drawingml/2006/main" xmlns:r="http://schemas.openxmlformats.org/officeDocument/2006/relationships" xmlns:p="http://schemas.openxmlformats.org/presentationml/2006/main">
+<p:sld xmlns:a="http://schemas.openxmlformats.org/drawingml/2006/main" xmlns:p="http://schemas.openxmlformats.org/presentationml/2006/main" xmlns:r="http://schemas.openxmlformats.org/officeDocument/2006/relationships">
   <p:cSld>
     <p:spTree>
       <p:nvGrpSpPr>
@@ -3239,14 +3239,7 @@
         <p:cNvGrpSpPr/>
         <p:nvPr/>
       </p:nvGrpSpPr>
-      <p:grpSpPr>
-        <a:xfrm>
-          <a:off x="0" y="0"/>
-          <a:ext cx="0" cy="0"/>
-          <a:chOff x="0" y="0"/>
-          <a:chExt cx="0" cy="0"/>
-        </a:xfrm>
-      </p:grpSpPr>
+      <p:grpSpPr/>
       <p:sp>
         <p:nvSpPr>
           <p:cNvPr id="2" name="Rectangle 1"/>
@@ -3287,7 +3280,6 @@
           <a:lstStyle/>
           <a:p>
             <a:pPr algn="ctr"/>
-            <a:endParaRPr/>
           </a:p>
         </p:txBody>
       </p:sp>
@@ -3313,6 +3305,7 @@
           </a:bodyPr>
           <a:lstStyle/>
           <a:p>
+            <a:pPr/>
             <a:r>
               <a:rPr sz="2800" b="1">
                 <a:solidFill>
@@ -3346,6 +3339,7 @@
           </a:bodyPr>
           <a:lstStyle/>
           <a:p>
+            <a:pPr/>
             <a:r>
               <a:rPr sz="1500" b="0">
                 <a:solidFill>
@@ -3356,6 +3350,7 @@
             </a:r>
           </a:p>
           <a:p>
+            <a:pPr/>
             <a:r>
               <a:rPr sz="1500" b="0">
                 <a:solidFill>
@@ -3366,6 +3361,7 @@
             </a:r>
           </a:p>
           <a:p>
+            <a:pPr/>
             <a:r>
               <a:rPr sz="1500" b="0">
                 <a:solidFill>
@@ -3376,6 +3372,7 @@
             </a:r>
           </a:p>
           <a:p>
+            <a:pPr/>
             <a:r>
               <a:rPr sz="1500" b="0">
                 <a:solidFill>
@@ -3386,6 +3383,7 @@
             </a:r>
           </a:p>
           <a:p>
+            <a:pPr/>
             <a:r>
               <a:rPr sz="1500" b="0">
                 <a:solidFill>
@@ -3396,6 +3394,7 @@
             </a:r>
           </a:p>
           <a:p>
+            <a:pPr/>
             <a:r>
               <a:rPr sz="1500" b="0">
                 <a:solidFill>
@@ -3458,6 +3457,7 @@
           </a:bodyPr>
           <a:lstStyle/>
           <a:p>
+            <a:pPr/>
             <a:r>
               <a:rPr sz="1100" b="0">
                 <a:solidFill>
@@ -3478,7 +3478,7 @@
 </file>
 
 <file path=ppt/slides/slide11.xml><?xml version="1.0" encoding="utf-8"?>
-<p:sld xmlns:a="http://schemas.openxmlformats.org/drawingml/2006/main" xmlns:r="http://schemas.openxmlformats.org/officeDocument/2006/relationships" xmlns:p="http://schemas.openxmlformats.org/presentationml/2006/main">
+<p:sld xmlns:a="http://schemas.openxmlformats.org/drawingml/2006/main" xmlns:p="http://schemas.openxmlformats.org/presentationml/2006/main" xmlns:r="http://schemas.openxmlformats.org/officeDocument/2006/relationships">
   <p:cSld>
     <p:spTree>
       <p:nvGrpSpPr>
@@ -3486,14 +3486,7 @@
         <p:cNvGrpSpPr/>
         <p:nvPr/>
       </p:nvGrpSpPr>
-      <p:grpSpPr>
-        <a:xfrm>
-          <a:off x="0" y="0"/>
-          <a:ext cx="0" cy="0"/>
-          <a:chOff x="0" y="0"/>
-          <a:chExt cx="0" cy="0"/>
-        </a:xfrm>
-      </p:grpSpPr>
+      <p:grpSpPr/>
       <p:sp>
         <p:nvSpPr>
           <p:cNvPr id="2" name="Rectangle 1"/>
@@ -3534,7 +3527,6 @@
           <a:lstStyle/>
           <a:p>
             <a:pPr algn="ctr"/>
-            <a:endParaRPr/>
           </a:p>
         </p:txBody>
       </p:sp>
@@ -3560,6 +3552,7 @@
           </a:bodyPr>
           <a:lstStyle/>
           <a:p>
+            <a:pPr/>
             <a:r>
               <a:rPr sz="2800" b="1">
                 <a:solidFill>
@@ -3580,7 +3573,7 @@
         <p:spPr>
           <a:xfrm>
             <a:off x="548640" y="1234440"/>
-            <a:ext cx="5120640" cy="784830"/>
+            <a:ext cx="5120640" cy="5303520"/>
           </a:xfrm>
           <a:prstGeom prst="rect">
             <a:avLst/>
@@ -3593,507 +3586,48 @@
           </a:bodyPr>
           <a:lstStyle/>
           <a:p>
-            <a:r>
-              <a:rPr sz="1500" b="0" dirty="0">
+            <a:pPr/>
+            <a:r>
+              <a:rPr sz="1500" b="0">
                 <a:solidFill>
                   <a:srgbClr val="1F2937"/>
                 </a:solidFill>
               </a:rPr>
-              <a:t>- </a:t>
-            </a:r>
-            <a:r>
-              <a:rPr sz="1500" b="0" dirty="0" err="1">
+              <a:t>- Tuyến 1: LLM cấu hình qua env - Gemini / OpenAI / Anthropic, đổi provider bằng AI_PROVIDER + AI_MODEL</a:t>
+            </a:r>
+          </a:p>
+          <a:p>
+            <a:pPr/>
+            <a:r>
+              <a:rPr sz="1500" b="0">
                 <a:solidFill>
                   <a:srgbClr val="1F2937"/>
                 </a:solidFill>
               </a:rPr>
-              <a:t>Ứng</a:t>
-            </a:r>
-            <a:r>
-              <a:rPr sz="1500" b="0" dirty="0">
+              <a:t>- Tuyến 2: Devin async - hết quota LLM thì tạo session xử lý, callback trả kết quả</a:t>
+            </a:r>
+          </a:p>
+          <a:p>
+            <a:pPr/>
+            <a:r>
+              <a:rPr sz="1500" b="0">
                 <a:solidFill>
                   <a:srgbClr val="1F2937"/>
                 </a:solidFill>
               </a:rPr>
-              <a:t> </a:t>
-            </a:r>
-            <a:r>
-              <a:rPr sz="1500" b="0" dirty="0" err="1">
+              <a:t>- Tuyến 3: rule-based fallback - luôn có câu trả lời hữu ích kể cả khi mọi backend chết</a:t>
+            </a:r>
+          </a:p>
+          <a:p>
+            <a:pPr/>
+            <a:r>
+              <a:rPr sz="1500" b="0">
                 <a:solidFill>
                   <a:srgbClr val="1F2937"/>
                 </a:solidFill>
               </a:rPr>
-              <a:t>dụng</a:t>
-            </a:r>
-            <a:r>
-              <a:rPr sz="1500" b="0" dirty="0">
-                <a:solidFill>
-                  <a:srgbClr val="1F2937"/>
-                </a:solidFill>
-              </a:rPr>
-              <a:t>: </a:t>
-            </a:r>
-            <a:r>
-              <a:rPr sz="1500" b="0" dirty="0" err="1">
-                <a:solidFill>
-                  <a:srgbClr val="1F2937"/>
-                </a:solidFill>
-              </a:rPr>
-              <a:t>báo</a:t>
-            </a:r>
-            <a:r>
-              <a:rPr sz="1500" b="0" dirty="0">
-                <a:solidFill>
-                  <a:srgbClr val="1F2937"/>
-                </a:solidFill>
-              </a:rPr>
-              <a:t> </a:t>
-            </a:r>
-            <a:r>
-              <a:rPr sz="1500" b="0" dirty="0" err="1">
-                <a:solidFill>
-                  <a:srgbClr val="1F2937"/>
-                </a:solidFill>
-              </a:rPr>
-              <a:t>cáo</a:t>
-            </a:r>
-            <a:r>
-              <a:rPr sz="1500" b="0" dirty="0">
-                <a:solidFill>
-                  <a:srgbClr val="1F2937"/>
-                </a:solidFill>
-              </a:rPr>
-              <a:t> </a:t>
-            </a:r>
-            <a:r>
-              <a:rPr sz="1500" b="0" dirty="0" err="1">
-                <a:solidFill>
-                  <a:srgbClr val="1F2937"/>
-                </a:solidFill>
-              </a:rPr>
-              <a:t>hồ</a:t>
-            </a:r>
-            <a:r>
-              <a:rPr sz="1500" b="0" dirty="0">
-                <a:solidFill>
-                  <a:srgbClr val="1F2937"/>
-                </a:solidFill>
-              </a:rPr>
-              <a:t> </a:t>
-            </a:r>
-            <a:r>
-              <a:rPr sz="1500" b="0" dirty="0" err="1">
-                <a:solidFill>
-                  <a:srgbClr val="1F2937"/>
-                </a:solidFill>
-              </a:rPr>
-              <a:t>sơ</a:t>
-            </a:r>
-            <a:r>
-              <a:rPr sz="1500" b="0" dirty="0">
-                <a:solidFill>
-                  <a:srgbClr val="1F2937"/>
-                </a:solidFill>
-              </a:rPr>
-              <a:t> </a:t>
-            </a:r>
-            <a:r>
-              <a:rPr sz="1500" b="0" dirty="0" err="1">
-                <a:solidFill>
-                  <a:srgbClr val="1F2937"/>
-                </a:solidFill>
-              </a:rPr>
-              <a:t>lớp</a:t>
-            </a:r>
-            <a:r>
-              <a:rPr sz="1500" b="0" dirty="0">
-                <a:solidFill>
-                  <a:srgbClr val="1F2937"/>
-                </a:solidFill>
-              </a:rPr>
-              <a:t>, </a:t>
-            </a:r>
-            <a:r>
-              <a:rPr sz="1500" b="0" dirty="0" err="1">
-                <a:solidFill>
-                  <a:srgbClr val="1F2937"/>
-                </a:solidFill>
-              </a:rPr>
-              <a:t>nhận</a:t>
-            </a:r>
-            <a:r>
-              <a:rPr sz="1500" b="0" dirty="0">
-                <a:solidFill>
-                  <a:srgbClr val="1F2937"/>
-                </a:solidFill>
-              </a:rPr>
-              <a:t> </a:t>
-            </a:r>
-            <a:r>
-              <a:rPr sz="1500" b="0" dirty="0" err="1">
-                <a:solidFill>
-                  <a:srgbClr val="1F2937"/>
-                </a:solidFill>
-              </a:rPr>
-              <a:t>xét</a:t>
-            </a:r>
-            <a:r>
-              <a:rPr sz="1500" b="0" dirty="0">
-                <a:solidFill>
-                  <a:srgbClr val="1F2937"/>
-                </a:solidFill>
-              </a:rPr>
-              <a:t> </a:t>
-            </a:r>
-            <a:r>
-              <a:rPr sz="1500" b="0" dirty="0" err="1">
-                <a:solidFill>
-                  <a:srgbClr val="1F2937"/>
-                </a:solidFill>
-              </a:rPr>
-              <a:t>giáo</a:t>
-            </a:r>
-            <a:r>
-              <a:rPr sz="1500" b="0" dirty="0">
-                <a:solidFill>
-                  <a:srgbClr val="1F2937"/>
-                </a:solidFill>
-              </a:rPr>
-              <a:t> </a:t>
-            </a:r>
-            <a:r>
-              <a:rPr sz="1500" b="0" dirty="0" err="1">
-                <a:solidFill>
-                  <a:srgbClr val="1F2937"/>
-                </a:solidFill>
-              </a:rPr>
-              <a:t>án</a:t>
-            </a:r>
-            <a:r>
-              <a:rPr sz="1500" b="0" dirty="0">
-                <a:solidFill>
-                  <a:srgbClr val="1F2937"/>
-                </a:solidFill>
-              </a:rPr>
-              <a:t>, </a:t>
-            </a:r>
-            <a:r>
-              <a:rPr sz="1500" b="0" dirty="0" err="1">
-                <a:solidFill>
-                  <a:srgbClr val="1F2937"/>
-                </a:solidFill>
-              </a:rPr>
-              <a:t>gợi</a:t>
-            </a:r>
-            <a:r>
-              <a:rPr sz="1500" b="0" dirty="0">
-                <a:solidFill>
-                  <a:srgbClr val="1F2937"/>
-                </a:solidFill>
-              </a:rPr>
-              <a:t> </a:t>
-            </a:r>
-            <a:r>
-              <a:rPr sz="1500" b="0" dirty="0" err="1">
-                <a:solidFill>
-                  <a:srgbClr val="1F2937"/>
-                </a:solidFill>
-              </a:rPr>
-              <a:t>ý</a:t>
-            </a:r>
-            <a:r>
-              <a:rPr sz="1500" b="0" dirty="0">
-                <a:solidFill>
-                  <a:srgbClr val="1F2937"/>
-                </a:solidFill>
-              </a:rPr>
-              <a:t> </a:t>
-            </a:r>
-            <a:r>
-              <a:rPr sz="1500" b="0" dirty="0" err="1">
-                <a:solidFill>
-                  <a:srgbClr val="1F2937"/>
-                </a:solidFill>
-              </a:rPr>
-              <a:t>cảnh</a:t>
-            </a:r>
-            <a:r>
-              <a:rPr sz="1500" b="0" dirty="0">
-                <a:solidFill>
-                  <a:srgbClr val="1F2937"/>
-                </a:solidFill>
-              </a:rPr>
-              <a:t> </a:t>
-            </a:r>
-            <a:r>
-              <a:rPr sz="1500" b="0" dirty="0" err="1">
-                <a:solidFill>
-                  <a:srgbClr val="1F2937"/>
-                </a:solidFill>
-              </a:rPr>
-              <a:t>báo</a:t>
-            </a:r>
-            <a:r>
-              <a:rPr sz="1500" b="0" dirty="0">
-                <a:solidFill>
-                  <a:srgbClr val="1F2937"/>
-                </a:solidFill>
-              </a:rPr>
-              <a:t>, </a:t>
-            </a:r>
-            <a:r>
-              <a:rPr sz="1500" b="0" dirty="0" err="1">
-                <a:solidFill>
-                  <a:srgbClr val="1F2937"/>
-                </a:solidFill>
-              </a:rPr>
-              <a:t>trợ</a:t>
-            </a:r>
-            <a:r>
-              <a:rPr sz="1500" b="0" dirty="0">
-                <a:solidFill>
-                  <a:srgbClr val="1F2937"/>
-                </a:solidFill>
-              </a:rPr>
-              <a:t> </a:t>
-            </a:r>
-            <a:r>
-              <a:rPr sz="1500" b="0" dirty="0" err="1">
-                <a:solidFill>
-                  <a:srgbClr val="1F2937"/>
-                </a:solidFill>
-              </a:rPr>
-              <a:t>lý</a:t>
-            </a:r>
-            <a:r>
-              <a:rPr sz="1500" b="0" dirty="0">
-                <a:solidFill>
-                  <a:srgbClr val="1F2937"/>
-                </a:solidFill>
-              </a:rPr>
-              <a:t> </a:t>
-            </a:r>
-            <a:r>
-              <a:rPr sz="1500" b="0" dirty="0" err="1">
-                <a:solidFill>
-                  <a:srgbClr val="1F2937"/>
-                </a:solidFill>
-              </a:rPr>
-              <a:t>điều</a:t>
-            </a:r>
-            <a:r>
-              <a:rPr sz="1500" b="0" dirty="0">
-                <a:solidFill>
-                  <a:srgbClr val="1F2937"/>
-                </a:solidFill>
-              </a:rPr>
-              <a:t> </a:t>
-            </a:r>
-            <a:r>
-              <a:rPr sz="1500" b="0" dirty="0" err="1">
-                <a:solidFill>
-                  <a:srgbClr val="1F2937"/>
-                </a:solidFill>
-              </a:rPr>
-              <a:t>hành</a:t>
-            </a:r>
-            <a:r>
-              <a:rPr sz="1500" b="0" dirty="0">
-                <a:solidFill>
-                  <a:srgbClr val="1F2937"/>
-                </a:solidFill>
-              </a:rPr>
-              <a:t>, </a:t>
-            </a:r>
-            <a:r>
-              <a:rPr sz="1500" b="0" dirty="0" err="1">
-                <a:solidFill>
-                  <a:srgbClr val="1F2937"/>
-                </a:solidFill>
-              </a:rPr>
-              <a:t>phân</a:t>
-            </a:r>
-            <a:r>
-              <a:rPr sz="1500" b="0" dirty="0">
-                <a:solidFill>
-                  <a:srgbClr val="1F2937"/>
-                </a:solidFill>
-              </a:rPr>
-              <a:t> </a:t>
-            </a:r>
-            <a:r>
-              <a:rPr sz="1500" b="0" dirty="0" err="1">
-                <a:solidFill>
-                  <a:srgbClr val="1F2937"/>
-                </a:solidFill>
-              </a:rPr>
-              <a:t>tích</a:t>
-            </a:r>
-            <a:r>
-              <a:rPr sz="1500" b="0" dirty="0">
-                <a:solidFill>
-                  <a:srgbClr val="1F2937"/>
-                </a:solidFill>
-              </a:rPr>
-              <a:t> </a:t>
-            </a:r>
-            <a:r>
-              <a:rPr sz="1500" b="0" dirty="0" err="1">
-                <a:solidFill>
-                  <a:srgbClr val="1F2937"/>
-                </a:solidFill>
-              </a:rPr>
-              <a:t>sổ</a:t>
-            </a:r>
-            <a:r>
-              <a:rPr sz="1500" b="0" dirty="0">
-                <a:solidFill>
-                  <a:srgbClr val="1F2937"/>
-                </a:solidFill>
-              </a:rPr>
-              <a:t> </a:t>
-            </a:r>
-            <a:r>
-              <a:rPr sz="1500" b="0" dirty="0" err="1">
-                <a:solidFill>
-                  <a:srgbClr val="1F2937"/>
-                </a:solidFill>
-              </a:rPr>
-              <a:t>đầu</a:t>
-            </a:r>
-            <a:r>
-              <a:rPr sz="1500" b="0" dirty="0">
-                <a:solidFill>
-                  <a:srgbClr val="1F2937"/>
-                </a:solidFill>
-              </a:rPr>
-              <a:t> </a:t>
-            </a:r>
-            <a:r>
-              <a:rPr sz="1500" b="0" dirty="0" err="1">
-                <a:solidFill>
-                  <a:srgbClr val="1F2937"/>
-                </a:solidFill>
-              </a:rPr>
-              <a:t>bài</a:t>
-            </a:r>
-            <a:r>
-              <a:rPr sz="1500" b="0" dirty="0">
-                <a:solidFill>
-                  <a:srgbClr val="1F2937"/>
-                </a:solidFill>
-              </a:rPr>
-              <a:t>, </a:t>
-            </a:r>
-            <a:r>
-              <a:rPr sz="1500" b="0" dirty="0" err="1">
-                <a:solidFill>
-                  <a:srgbClr val="1F2937"/>
-                </a:solidFill>
-              </a:rPr>
-              <a:t>biên</a:t>
-            </a:r>
-            <a:r>
-              <a:rPr sz="1500" b="0" dirty="0">
-                <a:solidFill>
-                  <a:srgbClr val="1F2937"/>
-                </a:solidFill>
-              </a:rPr>
-              <a:t> </a:t>
-            </a:r>
-            <a:r>
-              <a:rPr sz="1500" b="0" dirty="0" err="1">
-                <a:solidFill>
-                  <a:srgbClr val="1F2937"/>
-                </a:solidFill>
-              </a:rPr>
-              <a:t>bản</a:t>
-            </a:r>
-            <a:r>
-              <a:rPr sz="1500" b="0" dirty="0">
-                <a:solidFill>
-                  <a:srgbClr val="1F2937"/>
-                </a:solidFill>
-              </a:rPr>
-              <a:t> </a:t>
-            </a:r>
-            <a:r>
-              <a:rPr sz="1500" b="0" dirty="0" err="1">
-                <a:solidFill>
-                  <a:srgbClr val="1F2937"/>
-                </a:solidFill>
-              </a:rPr>
-              <a:t>sinh</a:t>
-            </a:r>
-            <a:r>
-              <a:rPr sz="1500" b="0" dirty="0">
-                <a:solidFill>
-                  <a:srgbClr val="1F2937"/>
-                </a:solidFill>
-              </a:rPr>
-              <a:t> </a:t>
-            </a:r>
-            <a:r>
-              <a:rPr sz="1500" b="0" dirty="0" err="1">
-                <a:solidFill>
-                  <a:srgbClr val="1F2937"/>
-                </a:solidFill>
-              </a:rPr>
-              <a:t>hoạt</a:t>
-            </a:r>
-            <a:r>
-              <a:rPr sz="1500" b="0" dirty="0">
-                <a:solidFill>
-                  <a:srgbClr val="1F2937"/>
-                </a:solidFill>
-              </a:rPr>
-              <a:t>, </a:t>
-            </a:r>
-            <a:r>
-              <a:rPr sz="1500" b="0" dirty="0" err="1">
-                <a:solidFill>
-                  <a:srgbClr val="1F2937"/>
-                </a:solidFill>
-              </a:rPr>
-              <a:t>báo</a:t>
-            </a:r>
-            <a:r>
-              <a:rPr sz="1500" b="0" dirty="0">
-                <a:solidFill>
-                  <a:srgbClr val="1F2937"/>
-                </a:solidFill>
-              </a:rPr>
-              <a:t> </a:t>
-            </a:r>
-            <a:r>
-              <a:rPr sz="1500" b="0" dirty="0" err="1">
-                <a:solidFill>
-                  <a:srgbClr val="1F2937"/>
-                </a:solidFill>
-              </a:rPr>
-              <a:t>cáo</a:t>
-            </a:r>
-            <a:r>
-              <a:rPr sz="1500" b="0" dirty="0">
-                <a:solidFill>
-                  <a:srgbClr val="1F2937"/>
-                </a:solidFill>
-              </a:rPr>
-              <a:t> </a:t>
-            </a:r>
-            <a:r>
-              <a:rPr sz="1500" b="0" dirty="0" err="1">
-                <a:solidFill>
-                  <a:srgbClr val="1F2937"/>
-                </a:solidFill>
-              </a:rPr>
-              <a:t>Sở</a:t>
-            </a:r>
-            <a:endParaRPr sz="1500" b="0" dirty="0">
-              <a:solidFill>
-                <a:srgbClr val="1F2937"/>
-              </a:solidFill>
-            </a:endParaRPr>
+              <a:t>- Ứng dụng: báo cáo hồ sơ lớp, nhận xét giáo án, gợi ý cảnh báo, trợ lý điều hành, phân tích sổ đầu bài, biên bản sinh hoạt, báo cáo Sở</a:t>
+            </a:r>
           </a:p>
         </p:txBody>
       </p:sp>
@@ -4148,6 +3682,7 @@
           </a:bodyPr>
           <a:lstStyle/>
           <a:p>
+            <a:pPr/>
             <a:r>
               <a:rPr sz="1100" b="0">
                 <a:solidFill>
@@ -4168,7 +3703,7 @@
 </file>
 
 <file path=ppt/slides/slide12.xml><?xml version="1.0" encoding="utf-8"?>
-<p:sld xmlns:a="http://schemas.openxmlformats.org/drawingml/2006/main" xmlns:r="http://schemas.openxmlformats.org/officeDocument/2006/relationships" xmlns:p="http://schemas.openxmlformats.org/presentationml/2006/main">
+<p:sld xmlns:a="http://schemas.openxmlformats.org/drawingml/2006/main" xmlns:p="http://schemas.openxmlformats.org/presentationml/2006/main" xmlns:r="http://schemas.openxmlformats.org/officeDocument/2006/relationships">
   <p:cSld>
     <p:spTree>
       <p:nvGrpSpPr>
@@ -4176,14 +3711,7 @@
         <p:cNvGrpSpPr/>
         <p:nvPr/>
       </p:nvGrpSpPr>
-      <p:grpSpPr>
-        <a:xfrm>
-          <a:off x="0" y="0"/>
-          <a:ext cx="0" cy="0"/>
-          <a:chOff x="0" y="0"/>
-          <a:chExt cx="0" cy="0"/>
-        </a:xfrm>
-      </p:grpSpPr>
+      <p:grpSpPr/>
       <p:sp>
         <p:nvSpPr>
           <p:cNvPr id="2" name="Rectangle 1"/>
@@ -4224,7 +3752,6 @@
           <a:lstStyle/>
           <a:p>
             <a:pPr algn="ctr"/>
-            <a:endParaRPr/>
           </a:p>
         </p:txBody>
       </p:sp>
@@ -4250,6 +3777,7 @@
           </a:bodyPr>
           <a:lstStyle/>
           <a:p>
+            <a:pPr/>
             <a:r>
               <a:rPr sz="2800" b="1">
                 <a:solidFill>
@@ -4283,6 +3811,7 @@
           </a:bodyPr>
           <a:lstStyle/>
           <a:p>
+            <a:pPr/>
             <a:r>
               <a:rPr sz="1500" b="0">
                 <a:solidFill>
@@ -4293,6 +3822,7 @@
             </a:r>
           </a:p>
           <a:p>
+            <a:pPr/>
             <a:r>
               <a:rPr sz="1500" b="0">
                 <a:solidFill>
@@ -4303,6 +3833,7 @@
             </a:r>
           </a:p>
           <a:p>
+            <a:pPr/>
             <a:r>
               <a:rPr sz="1500" b="0">
                 <a:solidFill>
@@ -4313,6 +3844,7 @@
             </a:r>
           </a:p>
           <a:p>
+            <a:pPr/>
             <a:r>
               <a:rPr sz="1500" b="0">
                 <a:solidFill>
@@ -4323,6 +3855,7 @@
             </a:r>
           </a:p>
           <a:p>
+            <a:pPr/>
             <a:r>
               <a:rPr sz="1500" b="0">
                 <a:solidFill>
@@ -4385,6 +3918,7 @@
           </a:bodyPr>
           <a:lstStyle/>
           <a:p>
+            <a:pPr/>
             <a:r>
               <a:rPr sz="1100" b="0">
                 <a:solidFill>
@@ -4405,7 +3939,7 @@
 </file>
 
 <file path=ppt/slides/slide13.xml><?xml version="1.0" encoding="utf-8"?>
-<p:sld xmlns:a="http://schemas.openxmlformats.org/drawingml/2006/main" xmlns:r="http://schemas.openxmlformats.org/officeDocument/2006/relationships" xmlns:p="http://schemas.openxmlformats.org/presentationml/2006/main">
+<p:sld xmlns:a="http://schemas.openxmlformats.org/drawingml/2006/main" xmlns:p="http://schemas.openxmlformats.org/presentationml/2006/main" xmlns:r="http://schemas.openxmlformats.org/officeDocument/2006/relationships">
   <p:cSld>
     <p:spTree>
       <p:nvGrpSpPr>
@@ -4413,14 +3947,7 @@
         <p:cNvGrpSpPr/>
         <p:nvPr/>
       </p:nvGrpSpPr>
-      <p:grpSpPr>
-        <a:xfrm>
-          <a:off x="0" y="0"/>
-          <a:ext cx="0" cy="0"/>
-          <a:chOff x="0" y="0"/>
-          <a:chExt cx="0" cy="0"/>
-        </a:xfrm>
-      </p:grpSpPr>
+      <p:grpSpPr/>
       <p:sp>
         <p:nvSpPr>
           <p:cNvPr id="2" name="Rectangle 1"/>
@@ -4461,7 +3988,6 @@
           <a:lstStyle/>
           <a:p>
             <a:pPr algn="ctr"/>
-            <a:endParaRPr/>
           </a:p>
         </p:txBody>
       </p:sp>
@@ -4487,6 +4013,7 @@
           </a:bodyPr>
           <a:lstStyle/>
           <a:p>
+            <a:pPr/>
             <a:r>
               <a:rPr sz="3600" b="1">
                 <a:solidFill>
@@ -4497,6 +4024,7 @@
             </a:r>
           </a:p>
           <a:p>
+            <a:pPr/>
             <a:r>
               <a:rPr sz="2000" b="0">
                 <a:solidFill>
@@ -4507,6 +4035,7 @@
             </a:r>
           </a:p>
           <a:p>
+            <a:pPr/>
             <a:r>
               <a:rPr sz="1600" b="0">
                 <a:solidFill>
@@ -4517,6 +4046,7 @@
             </a:r>
           </a:p>
           <a:p>
+            <a:pPr/>
             <a:r>
               <a:rPr sz="1400" b="0">
                 <a:solidFill>
@@ -4537,7 +4067,7 @@
 </file>
 
 <file path=ppt/slides/slide2.xml><?xml version="1.0" encoding="utf-8"?>
-<p:sld xmlns:a="http://schemas.openxmlformats.org/drawingml/2006/main" xmlns:r="http://schemas.openxmlformats.org/officeDocument/2006/relationships" xmlns:p="http://schemas.openxmlformats.org/presentationml/2006/main">
+<p:sld xmlns:a="http://schemas.openxmlformats.org/drawingml/2006/main" xmlns:p="http://schemas.openxmlformats.org/presentationml/2006/main" xmlns:r="http://schemas.openxmlformats.org/officeDocument/2006/relationships">
   <p:cSld>
     <p:spTree>
       <p:nvGrpSpPr>
@@ -4545,14 +4075,7 @@
         <p:cNvGrpSpPr/>
         <p:nvPr/>
       </p:nvGrpSpPr>
-      <p:grpSpPr>
-        <a:xfrm>
-          <a:off x="0" y="0"/>
-          <a:ext cx="0" cy="0"/>
-          <a:chOff x="0" y="0"/>
-          <a:chExt cx="0" cy="0"/>
-        </a:xfrm>
-      </p:grpSpPr>
+      <p:grpSpPr/>
       <p:sp>
         <p:nvSpPr>
           <p:cNvPr id="2" name="Rectangle 1"/>
@@ -4593,7 +4116,6 @@
           <a:lstStyle/>
           <a:p>
             <a:pPr algn="ctr"/>
-            <a:endParaRPr/>
           </a:p>
         </p:txBody>
       </p:sp>
@@ -4619,6 +4141,7 @@
           </a:bodyPr>
           <a:lstStyle/>
           <a:p>
+            <a:pPr/>
             <a:r>
               <a:rPr sz="2800" b="1">
                 <a:solidFill>
@@ -4652,6 +4175,7 @@
           </a:bodyPr>
           <a:lstStyle/>
           <a:p>
+            <a:pPr/>
             <a:r>
               <a:rPr sz="1500" b="0">
                 <a:solidFill>
@@ -4662,6 +4186,7 @@
             </a:r>
           </a:p>
           <a:p>
+            <a:pPr/>
             <a:r>
               <a:rPr sz="1500" b="0">
                 <a:solidFill>
@@ -4672,6 +4197,7 @@
             </a:r>
           </a:p>
           <a:p>
+            <a:pPr/>
             <a:r>
               <a:rPr sz="1500" b="0">
                 <a:solidFill>
@@ -4682,6 +4208,7 @@
             </a:r>
           </a:p>
           <a:p>
+            <a:pPr/>
             <a:r>
               <a:rPr sz="1500" b="0">
                 <a:solidFill>
@@ -4692,6 +4219,7 @@
             </a:r>
           </a:p>
           <a:p>
+            <a:pPr/>
             <a:r>
               <a:rPr sz="1500" b="0">
                 <a:solidFill>
@@ -4702,6 +4230,7 @@
             </a:r>
           </a:p>
           <a:p>
+            <a:pPr/>
             <a:r>
               <a:rPr sz="1500" b="0">
                 <a:solidFill>
@@ -4764,6 +4293,7 @@
           </a:bodyPr>
           <a:lstStyle/>
           <a:p>
+            <a:pPr/>
             <a:r>
               <a:rPr sz="1100" b="0">
                 <a:solidFill>
@@ -4784,7 +4314,7 @@
 </file>
 
 <file path=ppt/slides/slide3.xml><?xml version="1.0" encoding="utf-8"?>
-<p:sld xmlns:a="http://schemas.openxmlformats.org/drawingml/2006/main" xmlns:r="http://schemas.openxmlformats.org/officeDocument/2006/relationships" xmlns:p="http://schemas.openxmlformats.org/presentationml/2006/main">
+<p:sld xmlns:a="http://schemas.openxmlformats.org/drawingml/2006/main" xmlns:p="http://schemas.openxmlformats.org/presentationml/2006/main" xmlns:r="http://schemas.openxmlformats.org/officeDocument/2006/relationships">
   <p:cSld>
     <p:spTree>
       <p:nvGrpSpPr>
@@ -4792,14 +4322,7 @@
         <p:cNvGrpSpPr/>
         <p:nvPr/>
       </p:nvGrpSpPr>
-      <p:grpSpPr>
-        <a:xfrm>
-          <a:off x="0" y="0"/>
-          <a:ext cx="0" cy="0"/>
-          <a:chOff x="0" y="0"/>
-          <a:chExt cx="0" cy="0"/>
-        </a:xfrm>
-      </p:grpSpPr>
+      <p:grpSpPr/>
       <p:sp>
         <p:nvSpPr>
           <p:cNvPr id="2" name="TextBox 1"/>
@@ -4822,13 +4345,14 @@
           </a:bodyPr>
           <a:lstStyle/>
           <a:p>
+            <a:pPr/>
             <a:r>
               <a:rPr sz="2800" b="1">
                 <a:solidFill>
                   <a:srgbClr val="1D4ED8"/>
                 </a:solidFill>
               </a:rPr>
-              <a:t>11 vai trò - phạm vi dữ liệu</a:t>
+              <a:t>10 vai trò - phạm vi dữ liệu</a:t>
             </a:r>
           </a:p>
         </p:txBody>
@@ -4852,34 +4376,10 @@
                 <a:tableStyleId>{5C22544A-7EE6-4342-B048-85BDC9FD1C3A}</a:tableStyleId>
               </a:tblPr>
               <a:tblGrid>
-                <a:gridCol w="2773603">
-                  <a:extLst>
-                    <a:ext uri="{9D8B030D-6E8A-4147-A177-3AD203B41FA5}">
-                      <a16:colId xmlns:a16="http://schemas.microsoft.com/office/drawing/2014/main" val="20000"/>
-                    </a:ext>
-                  </a:extLst>
-                </a:gridCol>
-                <a:gridCol w="2773603">
-                  <a:extLst>
-                    <a:ext uri="{9D8B030D-6E8A-4147-A177-3AD203B41FA5}">
-                      <a16:colId xmlns:a16="http://schemas.microsoft.com/office/drawing/2014/main" val="20001"/>
-                    </a:ext>
-                  </a:extLst>
-                </a:gridCol>
-                <a:gridCol w="2773603">
-                  <a:extLst>
-                    <a:ext uri="{9D8B030D-6E8A-4147-A177-3AD203B41FA5}">
-                      <a16:colId xmlns:a16="http://schemas.microsoft.com/office/drawing/2014/main" val="20002"/>
-                    </a:ext>
-                  </a:extLst>
-                </a:gridCol>
-                <a:gridCol w="2773606">
-                  <a:extLst>
-                    <a:ext uri="{9D8B030D-6E8A-4147-A177-3AD203B41FA5}">
-                      <a16:colId xmlns:a16="http://schemas.microsoft.com/office/drawing/2014/main" val="20003"/>
-                    </a:ext>
-                  </a:extLst>
-                </a:gridCol>
+                <a:gridCol w="2773603"/>
+                <a:gridCol w="2773603"/>
+                <a:gridCol w="2773603"/>
+                <a:gridCol w="2773606"/>
               </a:tblGrid>
               <a:tr h="950976">
                 <a:tc>
@@ -4934,11 +4434,6 @@
                   </a:txBody>
                   <a:tcPr/>
                 </a:tc>
-                <a:extLst>
-                  <a:ext uri="{0D108BD9-81ED-4DB2-BD59-A6C34878D82A}">
-                    <a16:rowId xmlns:a16="http://schemas.microsoft.com/office/drawing/2014/main" val="10000"/>
-                  </a:ext>
-                </a:extLst>
               </a:tr>
               <a:tr h="950976">
                 <a:tc>
@@ -4993,11 +4488,6 @@
                   </a:txBody>
                   <a:tcPr/>
                 </a:tc>
-                <a:extLst>
-                  <a:ext uri="{0D108BD9-81ED-4DB2-BD59-A6C34878D82A}">
-                    <a16:rowId xmlns:a16="http://schemas.microsoft.com/office/drawing/2014/main" val="10001"/>
-                  </a:ext>
-                </a:extLst>
               </a:tr>
               <a:tr h="950976">
                 <a:tc>
@@ -5052,11 +4542,6 @@
                   </a:txBody>
                   <a:tcPr/>
                 </a:tc>
-                <a:extLst>
-                  <a:ext uri="{0D108BD9-81ED-4DB2-BD59-A6C34878D82A}">
-                    <a16:rowId xmlns:a16="http://schemas.microsoft.com/office/drawing/2014/main" val="10002"/>
-                  </a:ext>
-                </a:extLst>
               </a:tr>
               <a:tr h="950976">
                 <a:tc>
@@ -5092,7 +4577,7 @@
                     <a:p>
                       <a:r>
                         <a:rPr sz="1400"/>
-                        <a:t>Phòng GD/UBND</a:t>
+                        <a:t>UBND cấp xã</a:t>
                       </a:r>
                     </a:p>
                   </a:txBody>
@@ -5111,11 +4596,6 @@
                   </a:txBody>
                   <a:tcPr/>
                 </a:tc>
-                <a:extLst>
-                  <a:ext uri="{0D108BD9-81ED-4DB2-BD59-A6C34878D82A}">
-                    <a16:rowId xmlns:a16="http://schemas.microsoft.com/office/drawing/2014/main" val="10003"/>
-                  </a:ext>
-                </a:extLst>
               </a:tr>
               <a:tr h="950976">
                 <a:tc>
@@ -5170,11 +4650,6 @@
                   </a:txBody>
                   <a:tcPr/>
                 </a:tc>
-                <a:extLst>
-                  <a:ext uri="{0D108BD9-81ED-4DB2-BD59-A6C34878D82A}">
-                    <a16:rowId xmlns:a16="http://schemas.microsoft.com/office/drawing/2014/main" val="10004"/>
-                  </a:ext>
-                </a:extLst>
               </a:tr>
             </a:tbl>
           </a:graphicData>
@@ -5189,7 +4664,7 @@
 </file>
 
 <file path=ppt/slides/slide4.xml><?xml version="1.0" encoding="utf-8"?>
-<p:sld xmlns:a="http://schemas.openxmlformats.org/drawingml/2006/main" xmlns:r="http://schemas.openxmlformats.org/officeDocument/2006/relationships" xmlns:p="http://schemas.openxmlformats.org/presentationml/2006/main">
+<p:sld xmlns:a="http://schemas.openxmlformats.org/drawingml/2006/main" xmlns:p="http://schemas.openxmlformats.org/presentationml/2006/main" xmlns:r="http://schemas.openxmlformats.org/officeDocument/2006/relationships">
   <p:cSld>
     <p:spTree>
       <p:nvGrpSpPr>
@@ -5197,14 +4672,7 @@
         <p:cNvGrpSpPr/>
         <p:nvPr/>
       </p:nvGrpSpPr>
-      <p:grpSpPr>
-        <a:xfrm>
-          <a:off x="0" y="0"/>
-          <a:ext cx="0" cy="0"/>
-          <a:chOff x="0" y="0"/>
-          <a:chExt cx="0" cy="0"/>
-        </a:xfrm>
-      </p:grpSpPr>
+      <p:grpSpPr/>
       <p:sp>
         <p:nvSpPr>
           <p:cNvPr id="2" name="Rectangle 1"/>
@@ -5245,7 +4713,6 @@
           <a:lstStyle/>
           <a:p>
             <a:pPr algn="ctr"/>
-            <a:endParaRPr/>
           </a:p>
         </p:txBody>
       </p:sp>
@@ -5271,6 +4738,7 @@
           </a:bodyPr>
           <a:lstStyle/>
           <a:p>
+            <a:pPr/>
             <a:r>
               <a:rPr sz="2800" b="1">
                 <a:solidFill>
@@ -5304,6 +4772,7 @@
           </a:bodyPr>
           <a:lstStyle/>
           <a:p>
+            <a:pPr/>
             <a:r>
               <a:rPr sz="1500" b="0">
                 <a:solidFill>
@@ -5314,6 +4783,7 @@
             </a:r>
           </a:p>
           <a:p>
+            <a:pPr/>
             <a:r>
               <a:rPr sz="1500" b="0">
                 <a:solidFill>
@@ -5324,6 +4794,7 @@
             </a:r>
           </a:p>
           <a:p>
+            <a:pPr/>
             <a:r>
               <a:rPr sz="1500" b="0">
                 <a:solidFill>
@@ -5334,6 +4805,7 @@
             </a:r>
           </a:p>
           <a:p>
+            <a:pPr/>
             <a:r>
               <a:rPr sz="1500" b="0">
                 <a:solidFill>
@@ -5344,6 +4816,7 @@
             </a:r>
           </a:p>
           <a:p>
+            <a:pPr/>
             <a:r>
               <a:rPr sz="1500" b="0">
                 <a:solidFill>
@@ -5354,6 +4827,7 @@
             </a:r>
           </a:p>
           <a:p>
+            <a:pPr/>
             <a:r>
               <a:rPr sz="1500" b="0">
                 <a:solidFill>
@@ -5416,6 +4890,7 @@
           </a:bodyPr>
           <a:lstStyle/>
           <a:p>
+            <a:pPr/>
             <a:r>
               <a:rPr sz="1100" b="0">
                 <a:solidFill>
@@ -5436,7 +4911,7 @@
 </file>
 
 <file path=ppt/slides/slide5.xml><?xml version="1.0" encoding="utf-8"?>
-<p:sld xmlns:a="http://schemas.openxmlformats.org/drawingml/2006/main" xmlns:r="http://schemas.openxmlformats.org/officeDocument/2006/relationships" xmlns:p="http://schemas.openxmlformats.org/presentationml/2006/main">
+<p:sld xmlns:a="http://schemas.openxmlformats.org/drawingml/2006/main" xmlns:p="http://schemas.openxmlformats.org/presentationml/2006/main" xmlns:r="http://schemas.openxmlformats.org/officeDocument/2006/relationships">
   <p:cSld>
     <p:spTree>
       <p:nvGrpSpPr>
@@ -5444,14 +4919,7 @@
         <p:cNvGrpSpPr/>
         <p:nvPr/>
       </p:nvGrpSpPr>
-      <p:grpSpPr>
-        <a:xfrm>
-          <a:off x="0" y="0"/>
-          <a:ext cx="0" cy="0"/>
-          <a:chOff x="0" y="0"/>
-          <a:chExt cx="0" cy="0"/>
-        </a:xfrm>
-      </p:grpSpPr>
+      <p:grpSpPr/>
       <p:sp>
         <p:nvSpPr>
           <p:cNvPr id="2" name="Rectangle 1"/>
@@ -5492,7 +4960,6 @@
           <a:lstStyle/>
           <a:p>
             <a:pPr algn="ctr"/>
-            <a:endParaRPr/>
           </a:p>
         </p:txBody>
       </p:sp>
@@ -5518,6 +4985,7 @@
           </a:bodyPr>
           <a:lstStyle/>
           <a:p>
+            <a:pPr/>
             <a:r>
               <a:rPr sz="2800" b="1">
                 <a:solidFill>
@@ -5551,6 +5019,7 @@
           </a:bodyPr>
           <a:lstStyle/>
           <a:p>
+            <a:pPr/>
             <a:r>
               <a:rPr sz="1500" b="0">
                 <a:solidFill>
@@ -5561,6 +5030,7 @@
             </a:r>
           </a:p>
           <a:p>
+            <a:pPr/>
             <a:r>
               <a:rPr sz="1500" b="0">
                 <a:solidFill>
@@ -5571,6 +5041,7 @@
             </a:r>
           </a:p>
           <a:p>
+            <a:pPr/>
             <a:r>
               <a:rPr sz="1500" b="0">
                 <a:solidFill>
@@ -5581,6 +5052,7 @@
             </a:r>
           </a:p>
           <a:p>
+            <a:pPr/>
             <a:r>
               <a:rPr sz="1500" b="0">
                 <a:solidFill>
@@ -5591,6 +5063,7 @@
             </a:r>
           </a:p>
           <a:p>
+            <a:pPr/>
             <a:r>
               <a:rPr sz="1500" b="0">
                 <a:solidFill>
@@ -5601,6 +5074,7 @@
             </a:r>
           </a:p>
           <a:p>
+            <a:pPr/>
             <a:r>
               <a:rPr sz="1500" b="0">
                 <a:solidFill>
@@ -5663,6 +5137,7 @@
           </a:bodyPr>
           <a:lstStyle/>
           <a:p>
+            <a:pPr/>
             <a:r>
               <a:rPr sz="1100" b="0">
                 <a:solidFill>
@@ -5683,7 +5158,7 @@
 </file>
 
 <file path=ppt/slides/slide6.xml><?xml version="1.0" encoding="utf-8"?>
-<p:sld xmlns:a="http://schemas.openxmlformats.org/drawingml/2006/main" xmlns:r="http://schemas.openxmlformats.org/officeDocument/2006/relationships" xmlns:p="http://schemas.openxmlformats.org/presentationml/2006/main">
+<p:sld xmlns:a="http://schemas.openxmlformats.org/drawingml/2006/main" xmlns:p="http://schemas.openxmlformats.org/presentationml/2006/main" xmlns:r="http://schemas.openxmlformats.org/officeDocument/2006/relationships">
   <p:cSld>
     <p:spTree>
       <p:nvGrpSpPr>
@@ -5691,14 +5166,7 @@
         <p:cNvGrpSpPr/>
         <p:nvPr/>
       </p:nvGrpSpPr>
-      <p:grpSpPr>
-        <a:xfrm>
-          <a:off x="0" y="0"/>
-          <a:ext cx="0" cy="0"/>
-          <a:chOff x="0" y="0"/>
-          <a:chExt cx="0" cy="0"/>
-        </a:xfrm>
-      </p:grpSpPr>
+      <p:grpSpPr/>
       <p:sp>
         <p:nvSpPr>
           <p:cNvPr id="2" name="Rectangle 1"/>
@@ -5739,7 +5207,6 @@
           <a:lstStyle/>
           <a:p>
             <a:pPr algn="ctr"/>
-            <a:endParaRPr/>
           </a:p>
         </p:txBody>
       </p:sp>
@@ -5765,6 +5232,7 @@
           </a:bodyPr>
           <a:lstStyle/>
           <a:p>
+            <a:pPr/>
             <a:r>
               <a:rPr sz="2800" b="1">
                 <a:solidFill>
@@ -5798,6 +5266,7 @@
           </a:bodyPr>
           <a:lstStyle/>
           <a:p>
+            <a:pPr/>
             <a:r>
               <a:rPr sz="1500" b="0">
                 <a:solidFill>
@@ -5808,6 +5277,7 @@
             </a:r>
           </a:p>
           <a:p>
+            <a:pPr/>
             <a:r>
               <a:rPr sz="1500" b="0">
                 <a:solidFill>
@@ -5818,6 +5288,7 @@
             </a:r>
           </a:p>
           <a:p>
+            <a:pPr/>
             <a:r>
               <a:rPr sz="1500" b="0">
                 <a:solidFill>
@@ -5828,6 +5299,7 @@
             </a:r>
           </a:p>
           <a:p>
+            <a:pPr/>
             <a:r>
               <a:rPr sz="1500" b="0">
                 <a:solidFill>
@@ -5838,6 +5310,7 @@
             </a:r>
           </a:p>
           <a:p>
+            <a:pPr/>
             <a:r>
               <a:rPr sz="1500" b="0">
                 <a:solidFill>
@@ -5848,6 +5321,7 @@
             </a:r>
           </a:p>
           <a:p>
+            <a:pPr/>
             <a:r>
               <a:rPr sz="1500" b="0">
                 <a:solidFill>
@@ -5910,6 +5384,7 @@
           </a:bodyPr>
           <a:lstStyle/>
           <a:p>
+            <a:pPr/>
             <a:r>
               <a:rPr sz="1100" b="0">
                 <a:solidFill>
@@ -5930,7 +5405,7 @@
 </file>
 
 <file path=ppt/slides/slide7.xml><?xml version="1.0" encoding="utf-8"?>
-<p:sld xmlns:a="http://schemas.openxmlformats.org/drawingml/2006/main" xmlns:r="http://schemas.openxmlformats.org/officeDocument/2006/relationships" xmlns:p="http://schemas.openxmlformats.org/presentationml/2006/main">
+<p:sld xmlns:a="http://schemas.openxmlformats.org/drawingml/2006/main" xmlns:p="http://schemas.openxmlformats.org/presentationml/2006/main" xmlns:r="http://schemas.openxmlformats.org/officeDocument/2006/relationships">
   <p:cSld>
     <p:spTree>
       <p:nvGrpSpPr>
@@ -5938,14 +5413,7 @@
         <p:cNvGrpSpPr/>
         <p:nvPr/>
       </p:nvGrpSpPr>
-      <p:grpSpPr>
-        <a:xfrm>
-          <a:off x="0" y="0"/>
-          <a:ext cx="0" cy="0"/>
-          <a:chOff x="0" y="0"/>
-          <a:chExt cx="0" cy="0"/>
-        </a:xfrm>
-      </p:grpSpPr>
+      <p:grpSpPr/>
       <p:sp>
         <p:nvSpPr>
           <p:cNvPr id="2" name="Rectangle 1"/>
@@ -5986,7 +5454,6 @@
           <a:lstStyle/>
           <a:p>
             <a:pPr algn="ctr"/>
-            <a:endParaRPr/>
           </a:p>
         </p:txBody>
       </p:sp>
@@ -6012,6 +5479,7 @@
           </a:bodyPr>
           <a:lstStyle/>
           <a:p>
+            <a:pPr/>
             <a:r>
               <a:rPr sz="2800" b="1">
                 <a:solidFill>
@@ -6045,6 +5513,7 @@
           </a:bodyPr>
           <a:lstStyle/>
           <a:p>
+            <a:pPr/>
             <a:r>
               <a:rPr sz="1500" b="0">
                 <a:solidFill>
@@ -6055,6 +5524,7 @@
             </a:r>
           </a:p>
           <a:p>
+            <a:pPr/>
             <a:r>
               <a:rPr sz="1500" b="0">
                 <a:solidFill>
@@ -6065,6 +5535,7 @@
             </a:r>
           </a:p>
           <a:p>
+            <a:pPr/>
             <a:r>
               <a:rPr sz="1500" b="0">
                 <a:solidFill>
@@ -6075,6 +5546,7 @@
             </a:r>
           </a:p>
           <a:p>
+            <a:pPr/>
             <a:r>
               <a:rPr sz="1500" b="0">
                 <a:solidFill>
@@ -6085,6 +5557,7 @@
             </a:r>
           </a:p>
           <a:p>
+            <a:pPr/>
             <a:r>
               <a:rPr sz="1500" b="0">
                 <a:solidFill>
@@ -6147,6 +5620,7 @@
           </a:bodyPr>
           <a:lstStyle/>
           <a:p>
+            <a:pPr/>
             <a:r>
               <a:rPr sz="1100" b="0">
                 <a:solidFill>
@@ -6167,7 +5641,7 @@
 </file>
 
 <file path=ppt/slides/slide8.xml><?xml version="1.0" encoding="utf-8"?>
-<p:sld xmlns:a="http://schemas.openxmlformats.org/drawingml/2006/main" xmlns:r="http://schemas.openxmlformats.org/officeDocument/2006/relationships" xmlns:p="http://schemas.openxmlformats.org/presentationml/2006/main">
+<p:sld xmlns:a="http://schemas.openxmlformats.org/drawingml/2006/main" xmlns:p="http://schemas.openxmlformats.org/presentationml/2006/main" xmlns:r="http://schemas.openxmlformats.org/officeDocument/2006/relationships">
   <p:cSld>
     <p:spTree>
       <p:nvGrpSpPr>
@@ -6175,14 +5649,7 @@
         <p:cNvGrpSpPr/>
         <p:nvPr/>
       </p:nvGrpSpPr>
-      <p:grpSpPr>
-        <a:xfrm>
-          <a:off x="0" y="0"/>
-          <a:ext cx="0" cy="0"/>
-          <a:chOff x="0" y="0"/>
-          <a:chExt cx="0" cy="0"/>
-        </a:xfrm>
-      </p:grpSpPr>
+      <p:grpSpPr/>
       <p:sp>
         <p:nvSpPr>
           <p:cNvPr id="2" name="Rectangle 1"/>
@@ -6223,7 +5690,6 @@
           <a:lstStyle/>
           <a:p>
             <a:pPr algn="ctr"/>
-            <a:endParaRPr/>
           </a:p>
         </p:txBody>
       </p:sp>
@@ -6249,6 +5715,7 @@
           </a:bodyPr>
           <a:lstStyle/>
           <a:p>
+            <a:pPr/>
             <a:r>
               <a:rPr sz="2800" b="1">
                 <a:solidFill>
@@ -6282,6 +5749,7 @@
           </a:bodyPr>
           <a:lstStyle/>
           <a:p>
+            <a:pPr/>
             <a:r>
               <a:rPr sz="1500" b="0">
                 <a:solidFill>
@@ -6292,6 +5760,7 @@
             </a:r>
           </a:p>
           <a:p>
+            <a:pPr/>
             <a:r>
               <a:rPr sz="1500" b="0">
                 <a:solidFill>
@@ -6302,6 +5771,7 @@
             </a:r>
           </a:p>
           <a:p>
+            <a:pPr/>
             <a:r>
               <a:rPr sz="1500" b="0">
                 <a:solidFill>
@@ -6312,6 +5782,7 @@
             </a:r>
           </a:p>
           <a:p>
+            <a:pPr/>
             <a:r>
               <a:rPr sz="1500" b="0">
                 <a:solidFill>
@@ -6322,6 +5793,7 @@
             </a:r>
           </a:p>
           <a:p>
+            <a:pPr/>
             <a:r>
               <a:rPr sz="1500" b="0">
                 <a:solidFill>
@@ -6384,6 +5856,7 @@
           </a:bodyPr>
           <a:lstStyle/>
           <a:p>
+            <a:pPr/>
             <a:r>
               <a:rPr sz="1100" b="0">
                 <a:solidFill>
@@ -6404,7 +5877,7 @@
 </file>
 
 <file path=ppt/slides/slide9.xml><?xml version="1.0" encoding="utf-8"?>
-<p:sld xmlns:a="http://schemas.openxmlformats.org/drawingml/2006/main" xmlns:r="http://schemas.openxmlformats.org/officeDocument/2006/relationships" xmlns:p="http://schemas.openxmlformats.org/presentationml/2006/main">
+<p:sld xmlns:a="http://schemas.openxmlformats.org/drawingml/2006/main" xmlns:p="http://schemas.openxmlformats.org/presentationml/2006/main" xmlns:r="http://schemas.openxmlformats.org/officeDocument/2006/relationships">
   <p:cSld>
     <p:spTree>
       <p:nvGrpSpPr>
@@ -6412,14 +5885,7 @@
         <p:cNvGrpSpPr/>
         <p:nvPr/>
       </p:nvGrpSpPr>
-      <p:grpSpPr>
-        <a:xfrm>
-          <a:off x="0" y="0"/>
-          <a:ext cx="0" cy="0"/>
-          <a:chOff x="0" y="0"/>
-          <a:chExt cx="0" cy="0"/>
-        </a:xfrm>
-      </p:grpSpPr>
+      <p:grpSpPr/>
       <p:sp>
         <p:nvSpPr>
           <p:cNvPr id="2" name="Rectangle 1"/>
@@ -6460,7 +5926,6 @@
           <a:lstStyle/>
           <a:p>
             <a:pPr algn="ctr"/>
-            <a:endParaRPr/>
           </a:p>
         </p:txBody>
       </p:sp>
@@ -6486,6 +5951,7 @@
           </a:bodyPr>
           <a:lstStyle/>
           <a:p>
+            <a:pPr/>
             <a:r>
               <a:rPr sz="2800" b="1">
                 <a:solidFill>
@@ -6519,6 +5985,7 @@
           </a:bodyPr>
           <a:lstStyle/>
           <a:p>
+            <a:pPr/>
             <a:r>
               <a:rPr sz="1500" b="0">
                 <a:solidFill>
@@ -6529,6 +5996,7 @@
             </a:r>
           </a:p>
           <a:p>
+            <a:pPr/>
             <a:r>
               <a:rPr sz="1500" b="0">
                 <a:solidFill>
@@ -6539,6 +6007,7 @@
             </a:r>
           </a:p>
           <a:p>
+            <a:pPr/>
             <a:r>
               <a:rPr sz="1500" b="0">
                 <a:solidFill>
@@ -6549,6 +6018,7 @@
             </a:r>
           </a:p>
           <a:p>
+            <a:pPr/>
             <a:r>
               <a:rPr sz="1500" b="0">
                 <a:solidFill>
@@ -6559,6 +6029,7 @@
             </a:r>
           </a:p>
           <a:p>
+            <a:pPr/>
             <a:r>
               <a:rPr sz="1500" b="0">
                 <a:solidFill>
@@ -6569,6 +6040,7 @@
             </a:r>
           </a:p>
           <a:p>
+            <a:pPr/>
             <a:r>
               <a:rPr sz="1500" b="0">
                 <a:solidFill>
@@ -6631,6 +6103,7 @@
           </a:bodyPr>
           <a:lstStyle/>
           <a:p>
+            <a:pPr/>
             <a:r>
               <a:rPr sz="1100" b="0">
                 <a:solidFill>

</xml_diff>

<commit_message>
docs: cap nhat bo tai lieu nguoi dung len trang thai moi nhat
- MO-TA-CHUC-NANG.md: them phan vai tro kiem nhiem + module 3.14
  Studio TVC360 (DC-01..06, ngan hang, duyet 2 lop)
- SO-CHU-NHIEM-SO-GIOI-THIEU.pptx: gen lai 15 slides - URL prod dung,
  slide kiem nhiem + Studio, tai khoan demo day du
- SO-CHU-NHIEM-SO-TAI-LIEU.docx: gen lai tu MD da cap nhat
- README: mo ta lai cac artifact

Generated with [Devin](https://devin.ai)

Co-Authored-By: Devin <158243242+devin-ai-integration[bot]@users.noreply.github.com>
</commit_message>
<xml_diff>
--- a/docs/user-guide/SO-CHU-NHIEM-SO-GIOI-THIEU.pptx
+++ b/docs/user-guide/SO-CHU-NHIEM-SO-GIOI-THIEU.pptx
@@ -18,6 +18,8 @@
     <p:sldId id="266" r:id="rId17"/>
     <p:sldId id="267" r:id="rId18"/>
     <p:sldId id="268" r:id="rId19"/>
+    <p:sldId id="269" r:id="rId20"/>
+    <p:sldId id="270" r:id="rId21"/>
   </p:sldIdLst>
   <p:sldSz cx="12191695" cy="6858000" type="screen4x3"/>
   <p:notesSz cx="6858000" cy="9144000"/>
@@ -3217,7 +3219,7 @@
                   <a:srgbClr val="BFDBFE"/>
                 </a:solidFill>
               </a:rPr>
-              <a:t>https://so-chu-nhiem-so-theta.vercel.app - Demo: chọn vai trò, mật khẩu demo1234</a:t>
+              <a:t>https://sochunhiem.vieschool.com - Demo: *@demo.scn, mật khẩu demo1234</a:t>
             </a:r>
           </a:p>
         </p:txBody>
@@ -3312,7 +3314,7 @@
                   <a:srgbClr val="1D4ED8"/>
                 </a:solidFill>
               </a:rPr>
-              <a:t>Phụ huynh &amp; Học sinh</a:t>
+              <a:t>Rèn luyện - Tư vấn - An toàn</a:t>
             </a:r>
           </a:p>
         </p:txBody>
@@ -3346,7 +3348,7 @@
                   <a:srgbClr val="1F2937"/>
                 </a:solidFill>
               </a:rPr>
-              <a:t>- Phụ huynh nhiều con: bộ chọn con trên đầu portal, dữ liệu tách theo từng em</a:t>
+              <a:t>- Sổ rèn luyện: cộng/trừ điểm theo tiêu chí, nguồn từ sổ đầu bài / sự cố</a:t>
             </a:r>
           </a:p>
           <a:p>
@@ -3357,7 +3359,7 @@
                   <a:srgbClr val="1F2937"/>
                 </a:solidFill>
               </a:rPr>
-              <a:t>- Nhắn tin 2 chiều với GVCN: soạn mới + trả lời, thấy cả tin đã gửi</a:t>
+              <a:t>- Tư vấn học sinh: hồ sơ phiên tư vấn, phân loại, theo dõi tiến triển</a:t>
             </a:r>
           </a:p>
           <a:p>
@@ -3368,7 +3370,7 @@
                   <a:srgbClr val="1F2937"/>
                 </a:solidFill>
               </a:rPr>
-              <a:t>- Đặt lịch hẹn trực tuyến - GVCN xác nhận</a:t>
+              <a:t>- Sự cố an toàn: 6 loại, 4 mức độ, báo cáo lên BGH, audit đầy đủ</a:t>
             </a:r>
           </a:p>
           <a:p>
@@ -3379,7 +3381,7 @@
                   <a:srgbClr val="1F2937"/>
                 </a:solidFill>
               </a:rPr>
-              <a:t>- Đăng ký / báo vắng hoạt động giáo dục cho con</a:t>
+              <a:t>- Thi đua tuần: chấm tiêu chí xếp hạng lớp</a:t>
             </a:r>
           </a:p>
           <a:p>
@@ -3390,25 +3392,14 @@
                   <a:srgbClr val="1F2937"/>
                 </a:solidFill>
               </a:rPr>
-              <a:t>- Học sinh: TKB, điểm số, hạnh kiểu, thông báo</a:t>
-            </a:r>
-          </a:p>
-          <a:p>
-            <a:pPr/>
-            <a:r>
-              <a:rPr sz="1500" b="0">
-                <a:solidFill>
-                  <a:srgbClr val="1F2937"/>
-                </a:solidFill>
-              </a:rPr>
-              <a:t>- Mọi thao tác kiểm tra quyền sở hữu con ở server - không ghi được hồ sơ em khác</a:t>
+              <a:t>- AI đề xuất can thiệp theo hồ sơ</a:t>
             </a:r>
           </a:p>
         </p:txBody>
       </p:sp>
       <p:pic>
         <p:nvPicPr>
-          <p:cNvPr id="5" name="Picture 4" descr="30-parent-portal.png"/>
+          <p:cNvPr id="5" name="Picture 4" descr="15-safety.png"/>
           <p:cNvPicPr>
             <a:picLocks noChangeAspect="1"/>
           </p:cNvPicPr>
@@ -3464,7 +3455,7 @@
                   <a:srgbClr val="6B7280"/>
                 </a:solidFill>
               </a:rPr>
-              <a:t>Portal phụ huynh</a:t>
+              <a:t>Sổ sự cố an toàn</a:t>
             </a:r>
           </a:p>
         </p:txBody>
@@ -3559,7 +3550,7 @@
                   <a:srgbClr val="1D4ED8"/>
                 </a:solidFill>
               </a:rPr>
-              <a:t>AI hỗ trợ - 3 tuyến dự phòng</a:t>
+              <a:t>BGH - điều hành trường</a:t>
             </a:r>
           </a:p>
         </p:txBody>
@@ -3593,7 +3584,7 @@
                   <a:srgbClr val="1F2937"/>
                 </a:solidFill>
               </a:rPr>
-              <a:t>- Tuyến 1: LLM cấu hình qua env - Gemini / OpenAI / Anthropic, đổi provider bằng AI_PROVIDER + AI_MODEL</a:t>
+              <a:t>- Trung tâm phê duyệt: kế hoạch HĐ, giáo án, đánh giá - một nơi xử lý</a:t>
             </a:r>
           </a:p>
           <a:p>
@@ -3604,7 +3595,7 @@
                   <a:srgbClr val="1F2937"/>
                 </a:solidFill>
               </a:rPr>
-              <a:t>- Tuyến 2: Devin async - hết quota LLM thì tạo session xử lý, callback trả kết quả</a:t>
+              <a:t>- Radar cảnh báo sớm: lớp/HS rủi ro theo chuyên cần + điểm + sự cố</a:t>
             </a:r>
           </a:p>
           <a:p>
@@ -3615,7 +3606,7 @@
                   <a:srgbClr val="1F2937"/>
                 </a:solidFill>
               </a:rPr>
-              <a:t>- Tuyến 3: rule-based fallback - luôn có câu trả lời hữu ích kể cả khi mọi backend chết</a:t>
+              <a:t>- Soạn + import TKB toàn trường, xem theo lớp</a:t>
             </a:r>
           </a:p>
           <a:p>
@@ -3626,14 +3617,36 @@
                   <a:srgbClr val="1F2937"/>
                 </a:solidFill>
               </a:rPr>
-              <a:t>- Ứng dụng: báo cáo hồ sơ lớp, nhận xét giáo án, gợi ý cảnh báo, trợ lý điều hành, phân tích sổ đầu bài, biên bản sinh hoạt, báo cáo Sở</a:t>
+              <a:t>- Ký sổ chủ nhiệm: tạo đợt ký - duyệt/từ chối kèm lý do - ký hàng loạt; GVCN không tự ký</a:t>
+            </a:r>
+          </a:p>
+          <a:p>
+            <a:pPr/>
+            <a:r>
+              <a:rPr sz="1500" b="0">
+                <a:solidFill>
+                  <a:srgbClr val="1F2937"/>
+                </a:solidFill>
+              </a:rPr>
+              <a:t>- Chỉ BGH phân công GVCN &amp; lớp năm học</a:t>
+            </a:r>
+          </a:p>
+          <a:p>
+            <a:pPr/>
+            <a:r>
+              <a:rPr sz="1500" b="0">
+                <a:solidFill>
+                  <a:srgbClr val="1F2937"/>
+                </a:solidFill>
+              </a:rPr>
+              <a:t>- Trợ lý AI điều hành hỏi-đáp trên dữ liệu thật</a:t>
             </a:r>
           </a:p>
         </p:txBody>
       </p:sp>
       <p:pic>
         <p:nvPicPr>
-          <p:cNvPr id="5" name="Picture 4" descr="25-bgh-ai.png"/>
+          <p:cNvPr id="5" name="Picture 4" descr="23-bgh-radar.png"/>
           <p:cNvPicPr>
             <a:picLocks noChangeAspect="1"/>
           </p:cNvPicPr>
@@ -3689,7 +3702,7 @@
                   <a:srgbClr val="6B7280"/>
                 </a:solidFill>
               </a:rPr>
-              <a:t>Trợ lý AI điều hành của BGH</a:t>
+              <a:t>Radar cảnh báo sớm toàn trường</a:t>
             </a:r>
           </a:p>
         </p:txBody>
@@ -3784,7 +3797,7 @@
                   <a:srgbClr val="1D4ED8"/>
                 </a:solidFill>
               </a:rPr>
-              <a:t>Báo cáo &amp; bảo mật</a:t>
+              <a:t>Phụ huynh &amp; Học sinh</a:t>
             </a:r>
           </a:p>
         </p:txBody>
@@ -3818,7 +3831,7 @@
                   <a:srgbClr val="1F2937"/>
                 </a:solidFill>
               </a:rPr>
-              <a:t>- Xuất sổ chủ nhiệm, báo cáo Sở/Phòng (CSV/Excel), sổ cá nhân GV</a:t>
+              <a:t>- Phụ huynh nhiều con: bộ chọn con trên đầu portal, dữ liệu tách theo từng em</a:t>
             </a:r>
           </a:p>
           <a:p>
@@ -3829,7 +3842,7 @@
                   <a:srgbClr val="1F2937"/>
                 </a:solidFill>
               </a:rPr>
-              <a:t>- RBAC 3 tầng: UI - route guard - Postgres RLS theo vai trò + quan hệ (lớp CN, tiết dạy, con mình)</a:t>
+              <a:t>- Nhắn tin 2 chiều với GVCN: soạn mới + trả lời, thấy cả tin đã gửi</a:t>
             </a:r>
           </a:p>
           <a:p>
@@ -3840,7 +3853,7 @@
                   <a:srgbClr val="1F2937"/>
                 </a:solidFill>
               </a:rPr>
-              <a:t>- Audit log mọi hành động quan trọng, trang xem cho BGH</a:t>
+              <a:t>- Đặt lịch hẹn trực tuyến - GVCN xác nhận</a:t>
             </a:r>
           </a:p>
           <a:p>
@@ -3851,7 +3864,7 @@
                   <a:srgbClr val="1F2937"/>
                 </a:solidFill>
               </a:rPr>
-              <a:t>- Trang Thông báo chung cho mọi vai trò - chuông trên topbar, đánh dấu đã đọc, link nhảy tới màn hình liên quan</a:t>
+              <a:t>- Đăng ký / báo vắng hoạt động giáo dục cho con</a:t>
             </a:r>
           </a:p>
           <a:p>
@@ -3862,14 +3875,25 @@
                   <a:srgbClr val="1F2937"/>
                 </a:solidFill>
               </a:rPr>
-              <a:t>- Responsive mobile, sắp xếp tên theo quy tắc Việt Nam</a:t>
+              <a:t>- Học sinh: TKB, điểm số, hạnh kiểu, thông báo</a:t>
+            </a:r>
+          </a:p>
+          <a:p>
+            <a:pPr/>
+            <a:r>
+              <a:rPr sz="1500" b="0">
+                <a:solidFill>
+                  <a:srgbClr val="1F2937"/>
+                </a:solidFill>
+              </a:rPr>
+              <a:t>- Mọi thao tác kiểm tra quyền sở hữu con ở server - không ghi được hồ sơ em khác</a:t>
             </a:r>
           </a:p>
         </p:txBody>
       </p:sp>
       <p:pic>
         <p:nvPicPr>
-          <p:cNvPr id="5" name="Picture 4" descr="20-export.png"/>
+          <p:cNvPr id="5" name="Picture 4" descr="30-parent-portal.png"/>
           <p:cNvPicPr>
             <a:picLocks noChangeAspect="1"/>
           </p:cNvPicPr>
@@ -3925,7 +3949,7 @@
                   <a:srgbClr val="6B7280"/>
                 </a:solidFill>
               </a:rPr>
-              <a:t>Xuất sổ &amp; báo cáo</a:t>
+              <a:t>Portal phụ huynh</a:t>
             </a:r>
           </a:p>
         </p:txBody>
@@ -3957,13 +3981,13 @@
         <p:spPr>
           <a:xfrm>
             <a:off x="0" y="0"/>
-            <a:ext cx="12191695" cy="6858000"/>
+            <a:ext cx="12191695" cy="109728"/>
           </a:xfrm>
           <a:prstGeom prst="rect">
             <a:avLst/>
           </a:prstGeom>
           <a:solidFill>
-            <a:srgbClr val="1F2937"/>
+            <a:srgbClr val="1D4ED8"/>
           </a:solidFill>
           <a:ln>
             <a:noFill/>
@@ -3999,8 +4023,8 @@
         </p:nvSpPr>
         <p:spPr>
           <a:xfrm>
-            <a:off x="914400" y="2377440"/>
-            <a:ext cx="10362895" cy="2286000"/>
+            <a:off x="457200" y="274320"/>
+            <a:ext cx="11277295" cy="822960"/>
           </a:xfrm>
           <a:prstGeom prst="rect">
             <a:avLst/>
@@ -4015,6 +4039,467 @@
           <a:p>
             <a:pPr/>
             <a:r>
+              <a:rPr sz="2800" b="1">
+                <a:solidFill>
+                  <a:srgbClr val="1D4ED8"/>
+                </a:solidFill>
+              </a:rPr>
+              <a:t>AI hỗ trợ - 3 tuyến dự phòng</a:t>
+            </a:r>
+          </a:p>
+        </p:txBody>
+      </p:sp>
+      <p:sp>
+        <p:nvSpPr>
+          <p:cNvPr id="4" name="TextBox 3"/>
+          <p:cNvSpPr txBox="1"/>
+          <p:nvPr/>
+        </p:nvSpPr>
+        <p:spPr>
+          <a:xfrm>
+            <a:off x="548640" y="1234440"/>
+            <a:ext cx="5120640" cy="5303520"/>
+          </a:xfrm>
+          <a:prstGeom prst="rect">
+            <a:avLst/>
+          </a:prstGeom>
+          <a:noFill/>
+        </p:spPr>
+        <p:txBody>
+          <a:bodyPr wrap="square">
+            <a:spAutoFit/>
+          </a:bodyPr>
+          <a:lstStyle/>
+          <a:p>
+            <a:pPr/>
+            <a:r>
+              <a:rPr sz="1500" b="0">
+                <a:solidFill>
+                  <a:srgbClr val="1F2937"/>
+                </a:solidFill>
+              </a:rPr>
+              <a:t>- Tuyến 1: LLM cấu hình qua env - Gemini / OpenAI / Anthropic, đổi provider bằng AI_PROVIDER + AI_MODEL</a:t>
+            </a:r>
+          </a:p>
+          <a:p>
+            <a:pPr/>
+            <a:r>
+              <a:rPr sz="1500" b="0">
+                <a:solidFill>
+                  <a:srgbClr val="1F2937"/>
+                </a:solidFill>
+              </a:rPr>
+              <a:t>- Tuyến 2: Devin async - hết quota LLM thì tạo session xử lý, callback trả kết quả</a:t>
+            </a:r>
+          </a:p>
+          <a:p>
+            <a:pPr/>
+            <a:r>
+              <a:rPr sz="1500" b="0">
+                <a:solidFill>
+                  <a:srgbClr val="1F2937"/>
+                </a:solidFill>
+              </a:rPr>
+              <a:t>- Tuyến 3: rule-based fallback - luôn có câu trả lời hữu ích kể cả khi mọi backend chết</a:t>
+            </a:r>
+          </a:p>
+          <a:p>
+            <a:pPr/>
+            <a:r>
+              <a:rPr sz="1500" b="0">
+                <a:solidFill>
+                  <a:srgbClr val="1F2937"/>
+                </a:solidFill>
+              </a:rPr>
+              <a:t>- Ứng dụng: báo cáo hồ sơ lớp, nhận xét giáo án, gợi ý cảnh báo, trợ lý điều hành, phân tích sổ đầu bài, biên bản sinh hoạt, báo cáo Sở</a:t>
+            </a:r>
+          </a:p>
+        </p:txBody>
+      </p:sp>
+      <p:pic>
+        <p:nvPicPr>
+          <p:cNvPr id="5" name="Picture 4" descr="25-bgh-ai.png"/>
+          <p:cNvPicPr>
+            <a:picLocks noChangeAspect="1"/>
+          </p:cNvPicPr>
+          <p:nvPr/>
+        </p:nvPicPr>
+        <p:blipFill>
+          <a:blip r:embed="rId2"/>
+          <a:stretch>
+            <a:fillRect/>
+          </a:stretch>
+        </p:blipFill>
+        <p:spPr>
+          <a:xfrm>
+            <a:off x="5699455" y="1234440"/>
+            <a:ext cx="6035040" cy="3771900"/>
+          </a:xfrm>
+          <a:prstGeom prst="rect">
+            <a:avLst/>
+          </a:prstGeom>
+          <a:ln>
+            <a:solidFill>
+              <a:srgbClr val="D1D5DB"/>
+            </a:solidFill>
+          </a:ln>
+        </p:spPr>
+      </p:pic>
+      <p:sp>
+        <p:nvSpPr>
+          <p:cNvPr id="6" name="TextBox 5"/>
+          <p:cNvSpPr txBox="1"/>
+          <p:nvPr/>
+        </p:nvSpPr>
+        <p:spPr>
+          <a:xfrm>
+            <a:off x="5699455" y="5052060"/>
+            <a:ext cx="6035040" cy="365760"/>
+          </a:xfrm>
+          <a:prstGeom prst="rect">
+            <a:avLst/>
+          </a:prstGeom>
+          <a:noFill/>
+        </p:spPr>
+        <p:txBody>
+          <a:bodyPr wrap="square">
+            <a:spAutoFit/>
+          </a:bodyPr>
+          <a:lstStyle/>
+          <a:p>
+            <a:pPr/>
+            <a:r>
+              <a:rPr sz="1100" b="0">
+                <a:solidFill>
+                  <a:srgbClr val="6B7280"/>
+                </a:solidFill>
+              </a:rPr>
+              <a:t>Trợ lý AI điều hành của BGH</a:t>
+            </a:r>
+          </a:p>
+        </p:txBody>
+      </p:sp>
+    </p:spTree>
+  </p:cSld>
+  <p:clrMapOvr>
+    <a:masterClrMapping/>
+  </p:clrMapOvr>
+</p:sld>
+</file>
+
+<file path=ppt/slides/slide14.xml><?xml version="1.0" encoding="utf-8"?>
+<p:sld xmlns:a="http://schemas.openxmlformats.org/drawingml/2006/main" xmlns:p="http://schemas.openxmlformats.org/presentationml/2006/main" xmlns:r="http://schemas.openxmlformats.org/officeDocument/2006/relationships">
+  <p:cSld>
+    <p:spTree>
+      <p:nvGrpSpPr>
+        <p:cNvPr id="1" name=""/>
+        <p:cNvGrpSpPr/>
+        <p:nvPr/>
+      </p:nvGrpSpPr>
+      <p:grpSpPr/>
+      <p:sp>
+        <p:nvSpPr>
+          <p:cNvPr id="2" name="Rectangle 1"/>
+          <p:cNvSpPr/>
+          <p:nvPr/>
+        </p:nvSpPr>
+        <p:spPr>
+          <a:xfrm>
+            <a:off x="0" y="0"/>
+            <a:ext cx="12191695" cy="109728"/>
+          </a:xfrm>
+          <a:prstGeom prst="rect">
+            <a:avLst/>
+          </a:prstGeom>
+          <a:solidFill>
+            <a:srgbClr val="1D4ED8"/>
+          </a:solidFill>
+          <a:ln>
+            <a:noFill/>
+          </a:ln>
+        </p:spPr>
+        <p:style>
+          <a:lnRef idx="1">
+            <a:schemeClr val="accent1"/>
+          </a:lnRef>
+          <a:fillRef idx="3">
+            <a:schemeClr val="accent1"/>
+          </a:fillRef>
+          <a:effectRef idx="2">
+            <a:schemeClr val="accent1"/>
+          </a:effectRef>
+          <a:fontRef idx="minor">
+            <a:schemeClr val="lt1"/>
+          </a:fontRef>
+        </p:style>
+        <p:txBody>
+          <a:bodyPr rtlCol="0" anchor="ctr"/>
+          <a:lstStyle/>
+          <a:p>
+            <a:pPr algn="ctr"/>
+          </a:p>
+        </p:txBody>
+      </p:sp>
+      <p:sp>
+        <p:nvSpPr>
+          <p:cNvPr id="3" name="TextBox 2"/>
+          <p:cNvSpPr txBox="1"/>
+          <p:nvPr/>
+        </p:nvSpPr>
+        <p:spPr>
+          <a:xfrm>
+            <a:off x="457200" y="274320"/>
+            <a:ext cx="11277295" cy="822960"/>
+          </a:xfrm>
+          <a:prstGeom prst="rect">
+            <a:avLst/>
+          </a:prstGeom>
+          <a:noFill/>
+        </p:spPr>
+        <p:txBody>
+          <a:bodyPr wrap="square">
+            <a:spAutoFit/>
+          </a:bodyPr>
+          <a:lstStyle/>
+          <a:p>
+            <a:pPr/>
+            <a:r>
+              <a:rPr sz="2800" b="1">
+                <a:solidFill>
+                  <a:srgbClr val="1D4ED8"/>
+                </a:solidFill>
+              </a:rPr>
+              <a:t>Báo cáo &amp; bảo mật</a:t>
+            </a:r>
+          </a:p>
+        </p:txBody>
+      </p:sp>
+      <p:sp>
+        <p:nvSpPr>
+          <p:cNvPr id="4" name="TextBox 3"/>
+          <p:cNvSpPr txBox="1"/>
+          <p:nvPr/>
+        </p:nvSpPr>
+        <p:spPr>
+          <a:xfrm>
+            <a:off x="548640" y="1234440"/>
+            <a:ext cx="5120640" cy="5303520"/>
+          </a:xfrm>
+          <a:prstGeom prst="rect">
+            <a:avLst/>
+          </a:prstGeom>
+          <a:noFill/>
+        </p:spPr>
+        <p:txBody>
+          <a:bodyPr wrap="square">
+            <a:spAutoFit/>
+          </a:bodyPr>
+          <a:lstStyle/>
+          <a:p>
+            <a:pPr/>
+            <a:r>
+              <a:rPr sz="1500" b="0">
+                <a:solidFill>
+                  <a:srgbClr val="1F2937"/>
+                </a:solidFill>
+              </a:rPr>
+              <a:t>- Xuất sổ chủ nhiệm, báo cáo Sở/Phòng (CSV/Excel), sổ cá nhân GV</a:t>
+            </a:r>
+          </a:p>
+          <a:p>
+            <a:pPr/>
+            <a:r>
+              <a:rPr sz="1500" b="0">
+                <a:solidFill>
+                  <a:srgbClr val="1F2937"/>
+                </a:solidFill>
+              </a:rPr>
+              <a:t>- RBAC 3 tầng: UI - route guard - Postgres RLS theo vai trò + quan hệ (lớp CN, tiết dạy, con mình)</a:t>
+            </a:r>
+          </a:p>
+          <a:p>
+            <a:pPr/>
+            <a:r>
+              <a:rPr sz="1500" b="0">
+                <a:solidFill>
+                  <a:srgbClr val="1F2937"/>
+                </a:solidFill>
+              </a:rPr>
+              <a:t>- Audit log mọi hành động quan trọng, trang xem cho BGH</a:t>
+            </a:r>
+          </a:p>
+          <a:p>
+            <a:pPr/>
+            <a:r>
+              <a:rPr sz="1500" b="0">
+                <a:solidFill>
+                  <a:srgbClr val="1F2937"/>
+                </a:solidFill>
+              </a:rPr>
+              <a:t>- Trang Thông báo chung cho mọi vai trò - chuông trên topbar, đánh dấu đã đọc, link nhảy tới màn hình liên quan</a:t>
+            </a:r>
+          </a:p>
+          <a:p>
+            <a:pPr/>
+            <a:r>
+              <a:rPr sz="1500" b="0">
+                <a:solidFill>
+                  <a:srgbClr val="1F2937"/>
+                </a:solidFill>
+              </a:rPr>
+              <a:t>- Responsive mobile, sắp xếp tên theo quy tắc Việt Nam</a:t>
+            </a:r>
+          </a:p>
+        </p:txBody>
+      </p:sp>
+      <p:pic>
+        <p:nvPicPr>
+          <p:cNvPr id="5" name="Picture 4" descr="20-export.png"/>
+          <p:cNvPicPr>
+            <a:picLocks noChangeAspect="1"/>
+          </p:cNvPicPr>
+          <p:nvPr/>
+        </p:nvPicPr>
+        <p:blipFill>
+          <a:blip r:embed="rId2"/>
+          <a:stretch>
+            <a:fillRect/>
+          </a:stretch>
+        </p:blipFill>
+        <p:spPr>
+          <a:xfrm>
+            <a:off x="5699455" y="1234440"/>
+            <a:ext cx="6035040" cy="3771900"/>
+          </a:xfrm>
+          <a:prstGeom prst="rect">
+            <a:avLst/>
+          </a:prstGeom>
+          <a:ln>
+            <a:solidFill>
+              <a:srgbClr val="D1D5DB"/>
+            </a:solidFill>
+          </a:ln>
+        </p:spPr>
+      </p:pic>
+      <p:sp>
+        <p:nvSpPr>
+          <p:cNvPr id="6" name="TextBox 5"/>
+          <p:cNvSpPr txBox="1"/>
+          <p:nvPr/>
+        </p:nvSpPr>
+        <p:spPr>
+          <a:xfrm>
+            <a:off x="5699455" y="5052060"/>
+            <a:ext cx="6035040" cy="365760"/>
+          </a:xfrm>
+          <a:prstGeom prst="rect">
+            <a:avLst/>
+          </a:prstGeom>
+          <a:noFill/>
+        </p:spPr>
+        <p:txBody>
+          <a:bodyPr wrap="square">
+            <a:spAutoFit/>
+          </a:bodyPr>
+          <a:lstStyle/>
+          <a:p>
+            <a:pPr/>
+            <a:r>
+              <a:rPr sz="1100" b="0">
+                <a:solidFill>
+                  <a:srgbClr val="6B7280"/>
+                </a:solidFill>
+              </a:rPr>
+              <a:t>Xuất sổ &amp; báo cáo</a:t>
+            </a:r>
+          </a:p>
+        </p:txBody>
+      </p:sp>
+    </p:spTree>
+  </p:cSld>
+  <p:clrMapOvr>
+    <a:masterClrMapping/>
+  </p:clrMapOvr>
+</p:sld>
+</file>
+
+<file path=ppt/slides/slide15.xml><?xml version="1.0" encoding="utf-8"?>
+<p:sld xmlns:a="http://schemas.openxmlformats.org/drawingml/2006/main" xmlns:p="http://schemas.openxmlformats.org/presentationml/2006/main" xmlns:r="http://schemas.openxmlformats.org/officeDocument/2006/relationships">
+  <p:cSld>
+    <p:spTree>
+      <p:nvGrpSpPr>
+        <p:cNvPr id="1" name=""/>
+        <p:cNvGrpSpPr/>
+        <p:nvPr/>
+      </p:nvGrpSpPr>
+      <p:grpSpPr/>
+      <p:sp>
+        <p:nvSpPr>
+          <p:cNvPr id="2" name="Rectangle 1"/>
+          <p:cNvSpPr/>
+          <p:nvPr/>
+        </p:nvSpPr>
+        <p:spPr>
+          <a:xfrm>
+            <a:off x="0" y="0"/>
+            <a:ext cx="12191695" cy="6858000"/>
+          </a:xfrm>
+          <a:prstGeom prst="rect">
+            <a:avLst/>
+          </a:prstGeom>
+          <a:solidFill>
+            <a:srgbClr val="1F2937"/>
+          </a:solidFill>
+          <a:ln>
+            <a:noFill/>
+          </a:ln>
+        </p:spPr>
+        <p:style>
+          <a:lnRef idx="1">
+            <a:schemeClr val="accent1"/>
+          </a:lnRef>
+          <a:fillRef idx="3">
+            <a:schemeClr val="accent1"/>
+          </a:fillRef>
+          <a:effectRef idx="2">
+            <a:schemeClr val="accent1"/>
+          </a:effectRef>
+          <a:fontRef idx="minor">
+            <a:schemeClr val="lt1"/>
+          </a:fontRef>
+        </p:style>
+        <p:txBody>
+          <a:bodyPr rtlCol="0" anchor="ctr"/>
+          <a:lstStyle/>
+          <a:p>
+            <a:pPr algn="ctr"/>
+          </a:p>
+        </p:txBody>
+      </p:sp>
+      <p:sp>
+        <p:nvSpPr>
+          <p:cNvPr id="3" name="TextBox 2"/>
+          <p:cNvSpPr txBox="1"/>
+          <p:nvPr/>
+        </p:nvSpPr>
+        <p:spPr>
+          <a:xfrm>
+            <a:off x="914400" y="2377440"/>
+            <a:ext cx="10362895" cy="2286000"/>
+          </a:xfrm>
+          <a:prstGeom prst="rect">
+            <a:avLst/>
+          </a:prstGeom>
+          <a:noFill/>
+        </p:spPr>
+        <p:txBody>
+          <a:bodyPr wrap="square">
+            <a:spAutoFit/>
+          </a:bodyPr>
+          <a:lstStyle/>
+          <a:p>
+            <a:pPr/>
+            <a:r>
               <a:rPr sz="3600" b="1">
                 <a:solidFill>
                   <a:srgbClr val="FFFFFF"/>
@@ -4031,7 +4516,7 @@
                   <a:srgbClr val="93C5FD"/>
                 </a:solidFill>
               </a:rPr>
-              <a:t>https://so-chu-nhiem-so-theta.vercel.app</a:t>
+              <a:t>https://sochunhiem.vieschool.com</a:t>
             </a:r>
           </a:p>
           <a:p>
@@ -4042,7 +4527,7 @@
                   <a:srgbClr val="D1D5DB"/>
                 </a:solidFill>
               </a:rPr>
-              <a:t>Chọn vai trò demo tại màn hình đăng nhập - mật khẩu: demo1234</a:t>
+              <a:t>Tài khoản demo: bgh / pht / totruong / gvcn / gvbm / ketoan / phuhuynh / hocsinh / sogd / ubnd / admin @demo.scn - mật khẩu: demo1234</a:t>
             </a:r>
           </a:p>
           <a:p>
@@ -4193,6 +4678,28 @@
                   <a:srgbClr val="1F2937"/>
                 </a:solidFill>
               </a:rPr>
+              <a:t>- TVC360 Studio: soạn KHBD (CV 5512), ma trận đề, đề kiểm tra, ngân hàng câu hỏi chung của trường - xuất DOCX/PDF/PPTX</a:t>
+            </a:r>
+          </a:p>
+          <a:p>
+            <a:pPr/>
+            <a:r>
+              <a:rPr sz="1500" b="0">
+                <a:solidFill>
+                  <a:srgbClr val="1F2937"/>
+                </a:solidFill>
+              </a:rPr>
+              <a:t>- Vai trò kiêm nhiệm: GVCN kiêm dạy + tổ trưởng, quyền gộp nhất quán UI - action - RLS</a:t>
+            </a:r>
+          </a:p>
+          <a:p>
+            <a:pPr/>
+            <a:r>
+              <a:rPr sz="1500" b="0">
+                <a:solidFill>
+                  <a:srgbClr val="1F2937"/>
+                </a:solidFill>
+              </a:rPr>
               <a:t>- Một dữ liệu nghiệp vụ - đồng bộ nhiều màn hình (vắng tiết học tự cập nhật điểm danh ngày)</a:t>
             </a:r>
           </a:p>
@@ -4204,7 +4711,7 @@
                   <a:srgbClr val="1F2937"/>
                 </a:solidFill>
               </a:rPr>
-              <a:t>- Phân quyền theo vai trò ở cả UI, route và Row-Level-Security</a:t>
+              <a:t>- Hỗ trợ Tiểu học / THCS / THPT, nhiều cơ sở (phân hiệu); multi-tenant RLS theo trường</a:t>
             </a:r>
           </a:p>
           <a:p>
@@ -4215,18 +4722,7 @@
                   <a:srgbClr val="1F2937"/>
                 </a:solidFill>
               </a:rPr>
-              <a:t>- Hỗ trợ Tiểu học / THCS / THPT, nhiều cơ sở (phân hiệu)</a:t>
-            </a:r>
-          </a:p>
-          <a:p>
-            <a:pPr/>
-            <a:r>
-              <a:rPr sz="1500" b="0">
-                <a:solidFill>
-                  <a:srgbClr val="1F2937"/>
-                </a:solidFill>
-              </a:rPr>
-              <a:t>- AI 3 tuyến: LLM cấu hình được - Devin async - rule-based fallback</a:t>
+              <a:t>- AI 3 tuyến: LLM cấu hình được - engine async - rule-based fallback; sanitizer kiểm chứng nội dung</a:t>
             </a:r>
           </a:p>
           <a:p>
@@ -4644,7 +5140,7 @@
                     <a:p>
                       <a:r>
                         <a:rPr sz="1400"/>
-                        <a:t>TKB, điểm, hạnh kiểu của mình</a:t>
+                        <a:t>TKB, điểm, hạnh kiểm của mình</a:t>
                       </a:r>
                     </a:p>
                   </a:txBody>
@@ -4745,7 +5241,7 @@
                   <a:srgbClr val="1D4ED8"/>
                 </a:solidFill>
               </a:rPr>
-              <a:t>Chuyên cần - điểm danh số</a:t>
+              <a:t>Vai trò kiêm nhiệm - đúng thực tế trường Việt Nam</a:t>
             </a:r>
           </a:p>
         </p:txBody>
@@ -4779,7 +5275,7 @@
                   <a:srgbClr val="1F2937"/>
                 </a:solidFill>
               </a:rPr>
-              <a:t>- 4 trạng thái/em: Có mặt, Vắng CP, Vắng KP, Đi muộn + ghi chú lý do ngay trên dòng</a:t>
+              <a:t>- 1 vai trò chính + nhiều vai trò kiêm nhiệm: GVCN kiêm GVBM + tổ trưởng, PHT/Hiệu trưởng kiêm dạy</a:t>
             </a:r>
           </a:p>
           <a:p>
@@ -4790,7 +5286,7 @@
                   <a:srgbClr val="1F2937"/>
                 </a:solidFill>
               </a:rPr>
-              <a:t>- Chọn ngày bất kỳ để xem lại / sửa điểm danh ngày cũ</a:t>
+              <a:t>- Quyền = hợp mọi vai trò, tính nhất quán 3 tầng: menu gộp + topbar đủ nhãn, server action, 158 RLS policies (my_roles)</a:t>
             </a:r>
           </a:p>
           <a:p>
@@ -4801,7 +5297,7 @@
                   <a:srgbClr val="1F2937"/>
                 </a:solidFill>
               </a:rPr>
-              <a:t>- Sổ vắng-muộn và lịch sử theo khoảng ngày (from - to)</a:t>
+              <a:t>- BGH gán kiêm nhiệm tại /school/users - user tự sửa bị trigger DB chặn (chống leo quyền)</a:t>
             </a:r>
           </a:p>
           <a:p>
@@ -4812,7 +5308,7 @@
                   <a:srgbClr val="1F2937"/>
                 </a:solidFill>
               </a:rPr>
-              <a:t>- Ma trận HS x ngày phát hiện vắng liên tục</a:t>
+              <a:t>- Grant xung đột giữa vai trò kiêm: deny thắng; chỉ vai trò nhân sự được kiêm</a:t>
             </a:r>
           </a:p>
           <a:p>
@@ -4823,25 +5319,14 @@
                   <a:srgbClr val="1F2937"/>
                 </a:solidFill>
               </a:rPr>
-              <a:t>- Thông báo phụ huynh tự động (email + in-app)</a:t>
-            </a:r>
-          </a:p>
-          <a:p>
-            <a:pPr/>
-            <a:r>
-              <a:rPr sz="1500" b="0">
-                <a:solidFill>
-                  <a:srgbClr val="1F2937"/>
-                </a:solidFill>
-              </a:rPr>
-              <a:t>- Đồng bộ 2 chiều với sổ đầu bài tiết học</a:t>
+              <a:t>- Menu chỉ hiện chức năng được cấp - audit tự động bằng check-nav-access (158 links)</a:t>
             </a:r>
           </a:p>
         </p:txBody>
       </p:sp>
       <p:pic>
         <p:nvPicPr>
-          <p:cNvPr id="5" name="Picture 4" descr="03-attendance-daily.png"/>
+          <p:cNvPr id="5" name="Picture 4" descr="26-team-lesson-plans.png"/>
           <p:cNvPicPr>
             <a:picLocks noChangeAspect="1"/>
           </p:cNvPicPr>
@@ -4897,7 +5382,7 @@
                   <a:srgbClr val="6B7280"/>
                 </a:solidFill>
               </a:rPr>
-              <a:t>Điểm danh hàng ngày - 6 thẻ tổng + ghi chú vắng</a:t>
+              <a:t>GVCN kiêm tổ trưởng vào được queue duyệt giáo án</a:t>
             </a:r>
           </a:p>
         </p:txBody>
@@ -4992,7 +5477,7 @@
                   <a:srgbClr val="1D4ED8"/>
                 </a:solidFill>
               </a:rPr>
-              <a:t>Sổ điểm giáo viên - chuẩn TT22</a:t>
+              <a:t>Studio - công cụ số giáo viên (TVC360)</a:t>
             </a:r>
           </a:p>
         </p:txBody>
@@ -5026,7 +5511,7 @@
                   <a:srgbClr val="1F2937"/>
                 </a:solidFill>
               </a:rPr>
-              <a:t>- Cột điểm động: Miệng / 15 phút / 1 tiết (hệ số 1), Giữa kỳ (x2), Cuối kỳ (x3)</a:t>
+              <a:t>- 6 công cụ DC-01..06: KHBĐ khung CV 5512, ma trận đề, đề từ ngân hàng, bộ câu hỏi, phiếu học tập, bài trình chiếu</a:t>
             </a:r>
           </a:p>
           <a:p>
@@ -5037,7 +5522,7 @@
                   <a:srgbClr val="1F2937"/>
                 </a:solidFill>
               </a:rPr>
-              <a:t>- Thêm/xóa cột tự do - mỗi GV tự cấu trúc sổ điểm của mình</a:t>
+              <a:t>- Ngân hàng câu hỏi chung của trường gắn YCCĐ: import tay/Excel/ảnh-PDF, duyệt 2 lớp (tổ → BGH)</a:t>
             </a:r>
           </a:p>
           <a:p>
@@ -5048,7 +5533,7 @@
                   <a:srgbClr val="1F2937"/>
                 </a:solidFill>
               </a:rPr>
-              <a:t>- GV chỉ ghi điểm lớp + môn mình được phân công (RLS kiểm tra ở DB)</a:t>
+              <a:t>- Hình Toán vẽ SVG tham số (deterministic), LaTeX $...$ → Word Equation native khi xuất DOCX</a:t>
             </a:r>
           </a:p>
           <a:p>
@@ -5059,7 +5544,7 @@
                   <a:srgbClr val="1F2937"/>
                 </a:solidFill>
               </a:rPr>
-              <a:t>- Lưu điểm nguyên tử qua transaction - không mất dữ liệu khi lỗi giữa chừng</a:t>
+              <a:t>- AI sinh qua schema + YCCĐ gate + sanitizer; hết quota → fallback engine / rule-based</a:t>
             </a:r>
           </a:p>
           <a:p>
@@ -5070,25 +5555,14 @@
                   <a:srgbClr val="1F2937"/>
                 </a:solidFill>
               </a:rPr>
-              <a:t>- ĐTBm tự tính đúng hệ số TT22, hiển thị HK1 / HK2 / cả năm</a:t>
-            </a:r>
-          </a:p>
-          <a:p>
-            <a:pPr/>
-            <a:r>
-              <a:rPr sz="1500" b="0">
-                <a:solidFill>
-                  <a:srgbClr val="1F2937"/>
-                </a:solidFill>
-              </a:rPr>
-              <a:t>- Import/export Excel, tải template mẫu; môn nhận xét hiển thị Đạt / Chưa đạt</a:t>
+              <a:t>- Xuất DOCX/PDF/PPTX; đề kèm đáp án - hướng dẫn chấm - biên bản phản biện</a:t>
             </a:r>
           </a:p>
         </p:txBody>
       </p:sp>
       <p:pic>
         <p:nvPicPr>
-          <p:cNvPr id="5" name="Picture 4" descr="07-grades.png"/>
+          <p:cNvPr id="5" name="Picture 4" descr="17-exams.png"/>
           <p:cNvPicPr>
             <a:picLocks noChangeAspect="1"/>
           </p:cNvPicPr>
@@ -5144,7 +5618,7 @@
                   <a:srgbClr val="6B7280"/>
                 </a:solidFill>
               </a:rPr>
-              <a:t>Sổ điểm cột động theo Thông tư 22</a:t>
+              <a:t>Ngân hàng câu hỏi và sinh đề theo ma trận</a:t>
             </a:r>
           </a:p>
         </p:txBody>
@@ -5239,7 +5713,7 @@
                   <a:srgbClr val="1D4ED8"/>
                 </a:solidFill>
               </a:rPr>
-              <a:t>Thời khóa biểu &amp; Sổ đầu bài</a:t>
+              <a:t>Chuyên cần - điểm danh số</a:t>
             </a:r>
           </a:p>
         </p:txBody>
@@ -5273,7 +5747,7 @@
                   <a:srgbClr val="1F2937"/>
                 </a:solidFill>
               </a:rPr>
-              <a:t>- 2 chế độ: lịch cá nhân (mọi GV) + theo lớp (GVCN xem lớp CN, BGH toàn trường)</a:t>
+              <a:t>- 4 trạng thái/em: Có mặt, Vắng CP, Vắng KP, Đi muộn + ghi chú lý do ngay trên dòng</a:t>
             </a:r>
           </a:p>
           <a:p>
@@ -5284,7 +5758,7 @@
                   <a:srgbClr val="1F2937"/>
                 </a:solidFill>
               </a:rPr>
-              <a:t>- Ô tiết cá nhân: lớp - môn - phòng; slot xung đột hiển thị đủ và cảnh báo</a:t>
+              <a:t>- Chọn ngày bất kỳ để xem lại / sửa điểm danh ngày cũ</a:t>
             </a:r>
           </a:p>
           <a:p>
@@ -5295,7 +5769,7 @@
                   <a:srgbClr val="1F2937"/>
                 </a:solidFill>
               </a:rPr>
-              <a:t>- Sổ đầu bài: chỉ GV được phân công tiết đó mới ghi - tiết người khác chỉ đọc</a:t>
+              <a:t>- Sổ vắng-muộn và lịch sử theo khoảng ngày (from - to)</a:t>
             </a:r>
           </a:p>
           <a:p>
@@ -5306,7 +5780,7 @@
                   <a:srgbClr val="1F2937"/>
                 </a:solidFill>
               </a:rPr>
-              <a:t>- Điểm danh theo tiết đồng bộ sang chuyên cần ngày</a:t>
+              <a:t>- Ma trận HS x ngày phát hiện vắng liên tục</a:t>
             </a:r>
           </a:p>
           <a:p>
@@ -5317,7 +5791,7 @@
                   <a:srgbClr val="1F2937"/>
                 </a:solidFill>
               </a:rPr>
-              <a:t>- Cộng/trừ điểm rèn luyện ngay trong sổ đầu bài</a:t>
+              <a:t>- Thông báo phụ huynh tự động (email + in-app)</a:t>
             </a:r>
           </a:p>
           <a:p>
@@ -5328,14 +5802,14 @@
                   <a:srgbClr val="1F2937"/>
                 </a:solidFill>
               </a:rPr>
-              <a:t>- BGH import TKB hàng loạt từ Excel</a:t>
+              <a:t>- Đồng bộ 2 chiều với sổ đầu bài tiết học</a:t>
             </a:r>
           </a:p>
         </p:txBody>
       </p:sp>
       <p:pic>
         <p:nvPicPr>
-          <p:cNvPr id="5" name="Picture 4" descr="08-timetable-me.png"/>
+          <p:cNvPr id="5" name="Picture 4" descr="03-attendance-daily.png"/>
           <p:cNvPicPr>
             <a:picLocks noChangeAspect="1"/>
           </p:cNvPicPr>
@@ -5391,7 +5865,7 @@
                   <a:srgbClr val="6B7280"/>
                 </a:solidFill>
               </a:rPr>
-              <a:t>Lịch dạy cá nhân</a:t>
+              <a:t>Điểm danh hàng ngày - 6 thẻ tổng + ghi chú vắng</a:t>
             </a:r>
           </a:p>
         </p:txBody>
@@ -5486,7 +5960,7 @@
                   <a:srgbClr val="1D4ED8"/>
                 </a:solidFill>
               </a:rPr>
-              <a:t>Sơ đồ lớp &amp; hồ sơ học sinh</a:t>
+              <a:t>Sổ điểm giáo viên - chuẩn TT22</a:t>
             </a:r>
           </a:p>
         </p:txBody>
@@ -5520,7 +5994,7 @@
                   <a:srgbClr val="1F2937"/>
                 </a:solidFill>
               </a:rPr>
-              <a:t>- Sơ đồ chỗ ngồi kéo-thả, thêm/bớt hàng cột linh hoạt</a:t>
+              <a:t>- Cột điểm động: Miệng / 15 phút / 1 tiết (hệ số 1), Giữa kỳ (x2), Cuối kỳ (x3)</a:t>
             </a:r>
           </a:p>
           <a:p>
@@ -5531,7 +6005,7 @@
                   <a:srgbClr val="1F2937"/>
                 </a:solidFill>
               </a:rPr>
-              <a:t>- Import danh sách HS Excel (mã HS quốc gia, dân tộc, hoàn cảnh)</a:t>
+              <a:t>- Thêm/xóa cột tự do - mỗi GV tự cấu trúc sổ điểm của mình</a:t>
             </a:r>
           </a:p>
           <a:p>
@@ -5542,7 +6016,7 @@
                   <a:srgbClr val="1F2937"/>
                 </a:solidFill>
               </a:rPr>
-              <a:t>- Chia tổ, ban cán sự, liên kết phụ huynh ngay trên danh sách</a:t>
+              <a:t>- GV chỉ ghi điểm lớp + môn mình được phân công (RLS kiểm tra ở DB)</a:t>
             </a:r>
           </a:p>
           <a:p>
@@ -5553,7 +6027,7 @@
                   <a:srgbClr val="1F2937"/>
                 </a:solidFill>
               </a:rPr>
-              <a:t>- Hồ sơ từng em: định danh, gia đình, sức khỏe - audit mọi thay đổi</a:t>
+              <a:t>- Lưu điểm nguyên tử qua transaction - không mất dữ liệu khi lỗi giữa chừng</a:t>
             </a:r>
           </a:p>
           <a:p>
@@ -5564,14 +6038,25 @@
                   <a:srgbClr val="1F2937"/>
                 </a:solidFill>
               </a:rPr>
-              <a:t>- AI tổng hợp báo cáo hồ sơ lớp</a:t>
+              <a:t>- ĐTBm tự tính đúng hệ số TT22, hiển thị HK1 / HK2 / cả năm</a:t>
+            </a:r>
+          </a:p>
+          <a:p>
+            <a:pPr/>
+            <a:r>
+              <a:rPr sz="1500" b="0">
+                <a:solidFill>
+                  <a:srgbClr val="1F2937"/>
+                </a:solidFill>
+              </a:rPr>
+              <a:t>- Import/export Excel, tải template mẫu; môn nhận xét hiển thị Đạt / Chưa đạt</a:t>
             </a:r>
           </a:p>
         </p:txBody>
       </p:sp>
       <p:pic>
         <p:nvPicPr>
-          <p:cNvPr id="5" name="Picture 4" descr="11-seating.png"/>
+          <p:cNvPr id="5" name="Picture 4" descr="07-grades.png"/>
           <p:cNvPicPr>
             <a:picLocks noChangeAspect="1"/>
           </p:cNvPicPr>
@@ -5627,7 +6112,7 @@
                   <a:srgbClr val="6B7280"/>
                 </a:solidFill>
               </a:rPr>
-              <a:t>Sơ đồ chỗ ngồi - resize hàng/cột</a:t>
+              <a:t>Sổ điểm cột động theo Thông tư 22</a:t>
             </a:r>
           </a:p>
         </p:txBody>
@@ -5722,7 +6207,7 @@
                   <a:srgbClr val="1D4ED8"/>
                 </a:solidFill>
               </a:rPr>
-              <a:t>Rèn luyện - Tư vấn - An toàn</a:t>
+              <a:t>Thời khóa biểu &amp; Sổ đầu bài</a:t>
             </a:r>
           </a:p>
         </p:txBody>
@@ -5756,7 +6241,7 @@
                   <a:srgbClr val="1F2937"/>
                 </a:solidFill>
               </a:rPr>
-              <a:t>- Sổ rèn luyện: cộng/trừ điểm theo tiêu chí, nguồn từ sổ đầu bài / sự cố</a:t>
+              <a:t>- 2 chế độ: lịch cá nhân (mọi GV) + theo lớp (GVCN xem lớp CN, BGH toàn trường)</a:t>
             </a:r>
           </a:p>
           <a:p>
@@ -5767,7 +6252,7 @@
                   <a:srgbClr val="1F2937"/>
                 </a:solidFill>
               </a:rPr>
-              <a:t>- Tư vấn học sinh: hồ sơ phiên tư vấn, phân loại, theo dõi tiến triển</a:t>
+              <a:t>- Ô tiết cá nhân: lớp - môn - phòng; slot xung đột hiển thị đủ và cảnh báo</a:t>
             </a:r>
           </a:p>
           <a:p>
@@ -5778,7 +6263,7 @@
                   <a:srgbClr val="1F2937"/>
                 </a:solidFill>
               </a:rPr>
-              <a:t>- Sự cố an toàn: 6 loại, 4 mức độ, báo cáo lên BGH, audit đầy đủ</a:t>
+              <a:t>- Sổ đầu bài: chỉ GV được phân công tiết đó mới ghi - tiết người khác chỉ đọc</a:t>
             </a:r>
           </a:p>
           <a:p>
@@ -5789,7 +6274,7 @@
                   <a:srgbClr val="1F2937"/>
                 </a:solidFill>
               </a:rPr>
-              <a:t>- Thi đua tuần: chấm tiêu chí xếp hạng lớp</a:t>
+              <a:t>- Điểm danh theo tiết đồng bộ sang chuyên cần ngày</a:t>
             </a:r>
           </a:p>
           <a:p>
@@ -5800,14 +6285,25 @@
                   <a:srgbClr val="1F2937"/>
                 </a:solidFill>
               </a:rPr>
-              <a:t>- AI đề xuất can thiệp theo hồ sơ</a:t>
+              <a:t>- Cộng/trừ điểm rèn luyện ngay trong sổ đầu bài</a:t>
+            </a:r>
+          </a:p>
+          <a:p>
+            <a:pPr/>
+            <a:r>
+              <a:rPr sz="1500" b="0">
+                <a:solidFill>
+                  <a:srgbClr val="1F2937"/>
+                </a:solidFill>
+              </a:rPr>
+              <a:t>- BGH import TKB hàng loạt từ Excel</a:t>
             </a:r>
           </a:p>
         </p:txBody>
       </p:sp>
       <p:pic>
         <p:nvPicPr>
-          <p:cNvPr id="5" name="Picture 4" descr="15-safety.png"/>
+          <p:cNvPr id="5" name="Picture 4" descr="08-timetable-me.png"/>
           <p:cNvPicPr>
             <a:picLocks noChangeAspect="1"/>
           </p:cNvPicPr>
@@ -5863,7 +6359,7 @@
                   <a:srgbClr val="6B7280"/>
                 </a:solidFill>
               </a:rPr>
-              <a:t>Sổ sự cố an toàn</a:t>
+              <a:t>Lịch dạy cá nhân</a:t>
             </a:r>
           </a:p>
         </p:txBody>
@@ -5958,7 +6454,7 @@
                   <a:srgbClr val="1D4ED8"/>
                 </a:solidFill>
               </a:rPr>
-              <a:t>BGH - điều hành trường</a:t>
+              <a:t>Sơ đồ lớp &amp; hồ sơ học sinh</a:t>
             </a:r>
           </a:p>
         </p:txBody>
@@ -5992,7 +6488,7 @@
                   <a:srgbClr val="1F2937"/>
                 </a:solidFill>
               </a:rPr>
-              <a:t>- Trung tâm phê duyệt: kế hoạch HĐ, giáo án, đánh giá - một nơi xử lý</a:t>
+              <a:t>- Sơ đồ chỗ ngồi kéo-thả, thêm/bớt hàng cột linh hoạt</a:t>
             </a:r>
           </a:p>
           <a:p>
@@ -6003,7 +6499,7 @@
                   <a:srgbClr val="1F2937"/>
                 </a:solidFill>
               </a:rPr>
-              <a:t>- Radar cảnh báo sớm: lớp/HS rủi ro theo chuyên cần + điểm + sự cố</a:t>
+              <a:t>- Import danh sách HS Excel (mã HS quốc gia, dân tộc, hoàn cảnh)</a:t>
             </a:r>
           </a:p>
           <a:p>
@@ -6014,7 +6510,7 @@
                   <a:srgbClr val="1F2937"/>
                 </a:solidFill>
               </a:rPr>
-              <a:t>- Soạn + import TKB toàn trường, xem theo lớp</a:t>
+              <a:t>- Chia tổ, ban cán sự, liên kết phụ huynh ngay trên danh sách</a:t>
             </a:r>
           </a:p>
           <a:p>
@@ -6025,7 +6521,7 @@
                   <a:srgbClr val="1F2937"/>
                 </a:solidFill>
               </a:rPr>
-              <a:t>- Ký sổ chủ nhiệm: tạo đợt ký - duyệt/từ chối kèm lý do - ký hàng loạt; GVCN không tự ký</a:t>
+              <a:t>- Hồ sơ từng em: định danh, gia đình, sức khỏe - audit mọi thay đổi</a:t>
             </a:r>
           </a:p>
           <a:p>
@@ -6036,25 +6532,14 @@
                   <a:srgbClr val="1F2937"/>
                 </a:solidFill>
               </a:rPr>
-              <a:t>- Chỉ BGH phân công GVCN &amp; lớp năm học</a:t>
-            </a:r>
-          </a:p>
-          <a:p>
-            <a:pPr/>
-            <a:r>
-              <a:rPr sz="1500" b="0">
-                <a:solidFill>
-                  <a:srgbClr val="1F2937"/>
-                </a:solidFill>
-              </a:rPr>
-              <a:t>- Trợ lý AI điều hành hỏi-đáp trên dữ liệu thật</a:t>
+              <a:t>- AI tổng hợp báo cáo hồ sơ lớp</a:t>
             </a:r>
           </a:p>
         </p:txBody>
       </p:sp>
       <p:pic>
         <p:nvPicPr>
-          <p:cNvPr id="5" name="Picture 4" descr="23-bgh-radar.png"/>
+          <p:cNvPr id="5" name="Picture 4" descr="11-seating.png"/>
           <p:cNvPicPr>
             <a:picLocks noChangeAspect="1"/>
           </p:cNvPicPr>
@@ -6110,7 +6595,7 @@
                   <a:srgbClr val="6B7280"/>
                 </a:solidFill>
               </a:rPr>
-              <a:t>Radar cảnh báo sớm toàn trường</a:t>
+              <a:t>Sơ đồ chỗ ngồi - resize hàng/cột</a:t>
             </a:r>
           </a:p>
         </p:txBody>

</xml_diff>